<commit_message>
Reflect verified Kiro CLI runs in presentation deck
</commit_message>
<xml_diff>
--- a/docs/AI_Agent_Loop.pptx
+++ b/docs/AI_Agent_Loop.pptx
@@ -12,6 +12,9 @@
     <p:sldId id="260" r:id="rId11"/>
     <p:sldId id="261" r:id="rId12"/>
     <p:sldId id="262" r:id="rId13"/>
+    <p:sldId id="267" r:id="rId18"/>
+    <p:sldId id="268" r:id="rId20"/>
+    <p:sldId id="269" r:id="rId21"/>
     <p:sldId id="263" r:id="rId14"/>
     <p:sldId id="264" r:id="rId15"/>
     <p:sldId id="265" r:id="rId16"/>
@@ -115,6 +118,566 @@
     </a:lvl9pPr>
   </p:defaultTextStyle>
 </p:presentation>
+</file>
+
+<file path=ppt/notesMasters/notesMaster1.xml><?xml version="1.0" encoding="utf-8"?>
+<p:notesMaster xmlns:a="http://schemas.openxmlformats.org/drawingml/2006/main" xmlns:p="http://schemas.openxmlformats.org/presentationml/2006/main" xmlns:r="http://schemas.openxmlformats.org/officeDocument/2006/relationships">
+  <p:cSld>
+    <p:bg>
+      <p:bgRef idx="1001">
+        <a:schemeClr val="bg1"/>
+      </p:bgRef>
+    </p:bg>
+    <p:spTree>
+      <p:nvGrpSpPr>
+        <p:cNvPr id="1" name=""/>
+        <p:cNvGrpSpPr/>
+        <p:nvPr/>
+      </p:nvGrpSpPr>
+      <p:grpSpPr>
+        <a:xfrm>
+          <a:off x="0" y="0"/>
+          <a:ext cx="0" cy="0"/>
+          <a:chOff x="0" y="0"/>
+          <a:chExt cx="0" cy="0"/>
+        </a:xfrm>
+      </p:grpSpPr>
+      <p:sp>
+        <p:nvSpPr>
+          <p:cNvPr id="2" name="Header Placeholder 1"/>
+          <p:cNvSpPr>
+            <a:spLocks noGrp="1"/>
+          </p:cNvSpPr>
+          <p:nvPr>
+            <p:ph type="hdr" sz="quarter"/>
+          </p:nvPr>
+        </p:nvSpPr>
+        <p:spPr>
+          <a:xfrm>
+            <a:off x="0" y="0"/>
+            <a:ext cx="2971800" cy="457200"/>
+          </a:xfrm>
+          <a:prstGeom prst="rect">
+            <a:avLst/>
+          </a:prstGeom>
+        </p:spPr>
+        <p:txBody>
+          <a:bodyPr vert="horz" lIns="91440" tIns="45720" rIns="91440" bIns="45720" rtlCol="0"/>
+          <a:lstStyle>
+            <a:lvl1pPr algn="l">
+              <a:defRPr sz="1200"/>
+            </a:lvl1pPr>
+          </a:lstStyle>
+          <a:p>
+            <a:endParaRPr lang="en-US"/>
+          </a:p>
+        </p:txBody>
+      </p:sp>
+      <p:sp>
+        <p:nvSpPr>
+          <p:cNvPr id="3" name="Date Placeholder 2"/>
+          <p:cNvSpPr>
+            <a:spLocks noGrp="1"/>
+          </p:cNvSpPr>
+          <p:nvPr>
+            <p:ph type="dt" idx="1"/>
+          </p:nvPr>
+        </p:nvSpPr>
+        <p:spPr>
+          <a:xfrm>
+            <a:off x="3884613" y="0"/>
+            <a:ext cx="2971800" cy="457200"/>
+          </a:xfrm>
+          <a:prstGeom prst="rect">
+            <a:avLst/>
+          </a:prstGeom>
+        </p:spPr>
+        <p:txBody>
+          <a:bodyPr vert="horz" lIns="91440" tIns="45720" rIns="91440" bIns="45720" rtlCol="0"/>
+          <a:lstStyle>
+            <a:lvl1pPr algn="r">
+              <a:defRPr sz="1200"/>
+            </a:lvl1pPr>
+          </a:lstStyle>
+          <a:p>
+            <a:fld id="{0F89C1C7-3DCD-1040-A9CF-14679D8B5DDD}" type="datetimeFigureOut">
+              <a:rPr lang="en-US" smtClean="0"/>
+              <a:t>10/17/16</a:t>
+            </a:fld>
+            <a:endParaRPr lang="en-US"/>
+          </a:p>
+        </p:txBody>
+      </p:sp>
+      <p:sp>
+        <p:nvSpPr>
+          <p:cNvPr id="4" name="Slide Image Placeholder 3"/>
+          <p:cNvSpPr>
+            <a:spLocks noGrp="1" noRot="1" noChangeAspect="1"/>
+          </p:cNvSpPr>
+          <p:nvPr>
+            <p:ph type="sldImg" idx="2"/>
+          </p:nvPr>
+        </p:nvSpPr>
+        <p:spPr>
+          <a:xfrm>
+            <a:off x="1143000" y="685800"/>
+            <a:ext cx="4572000" cy="3429000"/>
+          </a:xfrm>
+          <a:prstGeom prst="rect">
+            <a:avLst/>
+          </a:prstGeom>
+          <a:noFill/>
+          <a:ln w="12700">
+            <a:solidFill>
+              <a:prstClr val="black"/>
+            </a:solidFill>
+          </a:ln>
+        </p:spPr>
+        <p:txBody>
+          <a:bodyPr vert="horz" lIns="91440" tIns="45720" rIns="91440" bIns="45720" rtlCol="0" anchor="ctr"/>
+          <a:lstStyle/>
+          <a:p>
+            <a:endParaRPr lang="en-US"/>
+          </a:p>
+        </p:txBody>
+      </p:sp>
+      <p:sp>
+        <p:nvSpPr>
+          <p:cNvPr id="5" name="Notes Placeholder 4"/>
+          <p:cNvSpPr>
+            <a:spLocks noGrp="1"/>
+          </p:cNvSpPr>
+          <p:nvPr>
+            <p:ph type="body" sz="quarter" idx="3"/>
+          </p:nvPr>
+        </p:nvSpPr>
+        <p:spPr>
+          <a:xfrm>
+            <a:off x="685800" y="4343400"/>
+            <a:ext cx="5486400" cy="4114800"/>
+          </a:xfrm>
+          <a:prstGeom prst="rect">
+            <a:avLst/>
+          </a:prstGeom>
+        </p:spPr>
+        <p:txBody>
+          <a:bodyPr vert="horz" lIns="91440" tIns="45720" rIns="91440" bIns="45720" rtlCol="0"/>
+          <a:lstStyle/>
+          <a:p>
+            <a:pPr lvl="0"/>
+            <a:r>
+              <a:rPr lang="en-US" smtClean="0"/>
+              <a:t>Click to edit Master text styles</a:t>
+            </a:r>
+          </a:p>
+          <a:p>
+            <a:pPr lvl="1"/>
+            <a:r>
+              <a:rPr lang="en-US" smtClean="0"/>
+              <a:t>Second level</a:t>
+            </a:r>
+          </a:p>
+          <a:p>
+            <a:pPr lvl="2"/>
+            <a:r>
+              <a:rPr lang="en-US" smtClean="0"/>
+              <a:t>Third level</a:t>
+            </a:r>
+          </a:p>
+          <a:p>
+            <a:pPr lvl="3"/>
+            <a:r>
+              <a:rPr lang="en-US" smtClean="0"/>
+              <a:t>Fourth level</a:t>
+            </a:r>
+          </a:p>
+          <a:p>
+            <a:pPr lvl="4"/>
+            <a:r>
+              <a:rPr lang="en-US" smtClean="0"/>
+              <a:t>Fifth level</a:t>
+            </a:r>
+            <a:endParaRPr lang="en-US"/>
+          </a:p>
+        </p:txBody>
+      </p:sp>
+      <p:sp>
+        <p:nvSpPr>
+          <p:cNvPr id="6" name="Footer Placeholder 5"/>
+          <p:cNvSpPr>
+            <a:spLocks noGrp="1"/>
+          </p:cNvSpPr>
+          <p:nvPr>
+            <p:ph type="ftr" sz="quarter" idx="4"/>
+          </p:nvPr>
+        </p:nvSpPr>
+        <p:spPr>
+          <a:xfrm>
+            <a:off x="0" y="8685213"/>
+            <a:ext cx="2971800" cy="457200"/>
+          </a:xfrm>
+          <a:prstGeom prst="rect">
+            <a:avLst/>
+          </a:prstGeom>
+        </p:spPr>
+        <p:txBody>
+          <a:bodyPr vert="horz" lIns="91440" tIns="45720" rIns="91440" bIns="45720" rtlCol="0" anchor="b"/>
+          <a:lstStyle>
+            <a:lvl1pPr algn="l">
+              <a:defRPr sz="1200"/>
+            </a:lvl1pPr>
+          </a:lstStyle>
+          <a:p>
+            <a:endParaRPr lang="en-US"/>
+          </a:p>
+        </p:txBody>
+      </p:sp>
+      <p:sp>
+        <p:nvSpPr>
+          <p:cNvPr id="7" name="Slide Number Placeholder 6"/>
+          <p:cNvSpPr>
+            <a:spLocks noGrp="1"/>
+          </p:cNvSpPr>
+          <p:nvPr>
+            <p:ph type="sldNum" sz="quarter" idx="5"/>
+          </p:nvPr>
+        </p:nvSpPr>
+        <p:spPr>
+          <a:xfrm>
+            <a:off x="3884613" y="8685213"/>
+            <a:ext cx="2971800" cy="457200"/>
+          </a:xfrm>
+          <a:prstGeom prst="rect">
+            <a:avLst/>
+          </a:prstGeom>
+        </p:spPr>
+        <p:txBody>
+          <a:bodyPr vert="horz" lIns="91440" tIns="45720" rIns="91440" bIns="45720" rtlCol="0" anchor="b"/>
+          <a:lstStyle>
+            <a:lvl1pPr algn="r">
+              <a:defRPr sz="1200"/>
+            </a:lvl1pPr>
+          </a:lstStyle>
+          <a:p>
+            <a:fld id="{BB5E49A5-4136-284D-997B-48E1D791AD67}" type="slidenum">
+              <a:rPr lang="en-US" smtClean="0"/>
+              <a:t>‹#›</a:t>
+            </a:fld>
+            <a:endParaRPr lang="en-US"/>
+          </a:p>
+        </p:txBody>
+      </p:sp>
+    </p:spTree>
+    <p:extLst>
+      <p:ext uri="{BB962C8B-B14F-4D97-AF65-F5344CB8AC3E}">
+        <p14:creationId xmlns:p14="http://schemas.microsoft.com/office/powerpoint/2010/main" val="2623252185"/>
+      </p:ext>
+    </p:extLst>
+  </p:cSld>
+  <p:clrMap bg1="lt1" tx1="dk1" bg2="lt2" tx2="dk2" accent1="accent1" accent2="accent2" accent3="accent3" accent4="accent4" accent5="accent5" accent6="accent6" hlink="hlink" folHlink="folHlink"/>
+  <p:notesStyle>
+    <a:lvl1pPr marL="0" algn="l" defTabSz="457200" rtl="0" eaLnBrk="1" latinLnBrk="0" hangingPunct="1">
+      <a:defRPr sz="1200" kern="1200">
+        <a:solidFill>
+          <a:schemeClr val="tx1"/>
+        </a:solidFill>
+        <a:latin typeface="+mn-lt"/>
+        <a:ea typeface="+mn-ea"/>
+        <a:cs typeface="+mn-cs"/>
+      </a:defRPr>
+    </a:lvl1pPr>
+    <a:lvl2pPr marL="457200" algn="l" defTabSz="457200" rtl="0" eaLnBrk="1" latinLnBrk="0" hangingPunct="1">
+      <a:defRPr sz="1200" kern="1200">
+        <a:solidFill>
+          <a:schemeClr val="tx1"/>
+        </a:solidFill>
+        <a:latin typeface="+mn-lt"/>
+        <a:ea typeface="+mn-ea"/>
+        <a:cs typeface="+mn-cs"/>
+      </a:defRPr>
+    </a:lvl2pPr>
+    <a:lvl3pPr marL="914400" algn="l" defTabSz="457200" rtl="0" eaLnBrk="1" latinLnBrk="0" hangingPunct="1">
+      <a:defRPr sz="1200" kern="1200">
+        <a:solidFill>
+          <a:schemeClr val="tx1"/>
+        </a:solidFill>
+        <a:latin typeface="+mn-lt"/>
+        <a:ea typeface="+mn-ea"/>
+        <a:cs typeface="+mn-cs"/>
+      </a:defRPr>
+    </a:lvl3pPr>
+    <a:lvl4pPr marL="1371600" algn="l" defTabSz="457200" rtl="0" eaLnBrk="1" latinLnBrk="0" hangingPunct="1">
+      <a:defRPr sz="1200" kern="1200">
+        <a:solidFill>
+          <a:schemeClr val="tx1"/>
+        </a:solidFill>
+        <a:latin typeface="+mn-lt"/>
+        <a:ea typeface="+mn-ea"/>
+        <a:cs typeface="+mn-cs"/>
+      </a:defRPr>
+    </a:lvl4pPr>
+    <a:lvl5pPr marL="1828800" algn="l" defTabSz="457200" rtl="0" eaLnBrk="1" latinLnBrk="0" hangingPunct="1">
+      <a:defRPr sz="1200" kern="1200">
+        <a:solidFill>
+          <a:schemeClr val="tx1"/>
+        </a:solidFill>
+        <a:latin typeface="+mn-lt"/>
+        <a:ea typeface="+mn-ea"/>
+        <a:cs typeface="+mn-cs"/>
+      </a:defRPr>
+    </a:lvl5pPr>
+    <a:lvl6pPr marL="2286000" algn="l" defTabSz="457200" rtl="0" eaLnBrk="1" latinLnBrk="0" hangingPunct="1">
+      <a:defRPr sz="1200" kern="1200">
+        <a:solidFill>
+          <a:schemeClr val="tx1"/>
+        </a:solidFill>
+        <a:latin typeface="+mn-lt"/>
+        <a:ea typeface="+mn-ea"/>
+        <a:cs typeface="+mn-cs"/>
+      </a:defRPr>
+    </a:lvl6pPr>
+    <a:lvl7pPr marL="2743200" algn="l" defTabSz="457200" rtl="0" eaLnBrk="1" latinLnBrk="0" hangingPunct="1">
+      <a:defRPr sz="1200" kern="1200">
+        <a:solidFill>
+          <a:schemeClr val="tx1"/>
+        </a:solidFill>
+        <a:latin typeface="+mn-lt"/>
+        <a:ea typeface="+mn-ea"/>
+        <a:cs typeface="+mn-cs"/>
+      </a:defRPr>
+    </a:lvl7pPr>
+    <a:lvl8pPr marL="3200400" algn="l" defTabSz="457200" rtl="0" eaLnBrk="1" latinLnBrk="0" hangingPunct="1">
+      <a:defRPr sz="1200" kern="1200">
+        <a:solidFill>
+          <a:schemeClr val="tx1"/>
+        </a:solidFill>
+        <a:latin typeface="+mn-lt"/>
+        <a:ea typeface="+mn-ea"/>
+        <a:cs typeface="+mn-cs"/>
+      </a:defRPr>
+    </a:lvl8pPr>
+    <a:lvl9pPr marL="3657600" algn="l" defTabSz="457200" rtl="0" eaLnBrk="1" latinLnBrk="0" hangingPunct="1">
+      <a:defRPr sz="1200" kern="1200">
+        <a:solidFill>
+          <a:schemeClr val="tx1"/>
+        </a:solidFill>
+        <a:latin typeface="+mn-lt"/>
+        <a:ea typeface="+mn-ea"/>
+        <a:cs typeface="+mn-cs"/>
+      </a:defRPr>
+    </a:lvl9pPr>
+  </p:notesStyle>
+</p:notesMaster>
+</file>
+
+<file path=ppt/notesSlides/notesSlide1.xml><?xml version="1.0" encoding="utf-8"?>
+<p:notes xmlns:a="http://schemas.openxmlformats.org/drawingml/2006/main" xmlns:p="http://schemas.openxmlformats.org/presentationml/2006/main" xmlns:r="http://schemas.openxmlformats.org/officeDocument/2006/relationships">
+  <p:cSld>
+    <p:spTree>
+      <p:nvGrpSpPr>
+        <p:cNvPr id="1" name=""/>
+        <p:cNvGrpSpPr/>
+        <p:nvPr/>
+      </p:nvGrpSpPr>
+      <p:grpSpPr>
+        <a:xfrm>
+          <a:off x="0" y="0"/>
+          <a:ext cx="0" cy="0"/>
+          <a:chOff x="0" y="0"/>
+          <a:chExt cx="0" cy="0"/>
+        </a:xfrm>
+      </p:grpSpPr>
+      <p:sp>
+        <p:nvSpPr>
+          <p:cNvPr id="2" name="Slide Image Placeholder 1"/>
+          <p:cNvSpPr>
+            <a:spLocks noGrp="1"/>
+          </p:cNvSpPr>
+          <p:nvPr>
+            <p:ph type="sldImg" idx="2"/>
+          </p:nvPr>
+        </p:nvSpPr>
+        <p:spPr/>
+      </p:sp>
+      <p:sp>
+        <p:nvSpPr>
+          <p:cNvPr id="3" name="Notes Placeholder 2"/>
+          <p:cNvSpPr>
+            <a:spLocks noGrp="1"/>
+          </p:cNvSpPr>
+          <p:nvPr>
+            <p:ph type="body" idx="3" sz="quarter"/>
+          </p:nvPr>
+        </p:nvSpPr>
+        <p:spPr/>
+        <p:txBody>
+          <a:bodyPr/>
+          <a:lstStyle/>
+          <a:p>
+            <a:r>
+              <a:t>2026-10-20 Mac, kiro-cli 2.32.0 실제 실행 결과 (docs/captures/run-kiro-real.txt). 쉬운 목표는 1회에 끝나는 것이 정상이다. 그래도 완료 판정은 Kiro가 아니라 Controller의 QA Gate가 내렸다는 점을 강조.</a:t>
+            </a:r>
+          </a:p>
+        </p:txBody>
+      </p:sp>
+      <p:sp>
+        <p:nvSpPr>
+          <p:cNvPr id="4" name="Slide Number Placeholder 3"/>
+          <p:cNvSpPr>
+            <a:spLocks noGrp="1"/>
+          </p:cNvSpPr>
+          <p:nvPr>
+            <p:ph type="sldNum" idx="5" sz="quarter"/>
+          </p:nvPr>
+        </p:nvSpPr>
+        <p:spPr/>
+      </p:sp>
+    </p:spTree>
+  </p:cSld>
+  <p:clrMapOvr>
+    <a:masterClrMapping/>
+  </p:clrMapOvr>
+</p:notes>
+</file>
+
+<file path=ppt/notesSlides/notesSlide2.xml><?xml version="1.0" encoding="utf-8"?>
+<p:notes xmlns:a="http://schemas.openxmlformats.org/drawingml/2006/main" xmlns:p="http://schemas.openxmlformats.org/presentationml/2006/main" xmlns:r="http://schemas.openxmlformats.org/officeDocument/2006/relationships">
+  <p:cSld>
+    <p:spTree>
+      <p:nvGrpSpPr>
+        <p:cNvPr id="1" name=""/>
+        <p:cNvGrpSpPr/>
+        <p:nvPr/>
+      </p:nvGrpSpPr>
+      <p:grpSpPr>
+        <a:xfrm>
+          <a:off x="0" y="0"/>
+          <a:ext cx="0" cy="0"/>
+          <a:chOff x="0" y="0"/>
+          <a:chExt cx="0" cy="0"/>
+        </a:xfrm>
+      </p:grpSpPr>
+      <p:sp>
+        <p:nvSpPr>
+          <p:cNvPr id="2" name="Slide Image Placeholder 1"/>
+          <p:cNvSpPr>
+            <a:spLocks noGrp="1"/>
+          </p:cNvSpPr>
+          <p:nvPr>
+            <p:ph type="sldImg" idx="2"/>
+          </p:nvPr>
+        </p:nvSpPr>
+        <p:spPr/>
+      </p:sp>
+      <p:sp>
+        <p:nvSpPr>
+          <p:cNvPr id="3" name="Notes Placeholder 2"/>
+          <p:cNvSpPr>
+            <a:spLocks noGrp="1"/>
+          </p:cNvSpPr>
+          <p:nvPr>
+            <p:ph type="body" idx="3" sz="quarter"/>
+          </p:nvPr>
+        </p:nvSpPr>
+        <p:spPr/>
+        <p:txBody>
+          <a:bodyPr/>
+          <a:lstStyle/>
+          <a:p>
+            <a:r>
+              <a:t>--inject-fault는 명시적 데모 모드다. 1회차에 Kiro는 올바르게 고쳤지만 Controller가 일부러 가격 검증을 지웠다. 이 실패는 AI의 실패가 아니라고 반드시 말할 것. 보여줄 핵심: 사람 입력 없이 실패 로그가 새 Kiro 세션에 전달되고 2회차에 PASS.</a:t>
+            </a:r>
+          </a:p>
+        </p:txBody>
+      </p:sp>
+      <p:sp>
+        <p:nvSpPr>
+          <p:cNvPr id="4" name="Slide Number Placeholder 3"/>
+          <p:cNvSpPr>
+            <a:spLocks noGrp="1"/>
+          </p:cNvSpPr>
+          <p:nvPr>
+            <p:ph type="sldNum" idx="5" sz="quarter"/>
+          </p:nvPr>
+        </p:nvSpPr>
+        <p:spPr/>
+      </p:sp>
+    </p:spTree>
+  </p:cSld>
+  <p:clrMapOvr>
+    <a:masterClrMapping/>
+  </p:clrMapOvr>
+</p:notes>
+</file>
+
+<file path=ppt/notesSlides/notesSlide3.xml><?xml version="1.0" encoding="utf-8"?>
+<p:notes xmlns:a="http://schemas.openxmlformats.org/drawingml/2006/main" xmlns:p="http://schemas.openxmlformats.org/presentationml/2006/main" xmlns:r="http://schemas.openxmlformats.org/officeDocument/2006/relationships">
+  <p:cSld>
+    <p:spTree>
+      <p:nvGrpSpPr>
+        <p:cNvPr id="1" name=""/>
+        <p:cNvGrpSpPr/>
+        <p:nvPr/>
+      </p:nvGrpSpPr>
+      <p:grpSpPr>
+        <a:xfrm>
+          <a:off x="0" y="0"/>
+          <a:ext cx="0" cy="0"/>
+          <a:chOff x="0" y="0"/>
+          <a:chExt cx="0" cy="0"/>
+        </a:xfrm>
+      </p:grpSpPr>
+      <p:sp>
+        <p:nvSpPr>
+          <p:cNvPr id="2" name="Slide Image Placeholder 1"/>
+          <p:cNvSpPr>
+            <a:spLocks noGrp="1"/>
+          </p:cNvSpPr>
+          <p:nvPr>
+            <p:ph type="sldImg" idx="2"/>
+          </p:nvPr>
+        </p:nvSpPr>
+        <p:spPr/>
+      </p:sp>
+      <p:sp>
+        <p:nvSpPr>
+          <p:cNvPr id="3" name="Notes Placeholder 2"/>
+          <p:cNvSpPr>
+            <a:spLocks noGrp="1"/>
+          </p:cNvSpPr>
+          <p:nvPr>
+            <p:ph type="body" idx="3" sz="quarter"/>
+          </p:nvPr>
+        </p:nvSpPr>
+        <p:spPr/>
+        <p:txBody>
+          <a:bodyPr/>
+          <a:lstStyle/>
+          <a:p>
+            <a:r>
+              <a:t>모든 판정과 변경은 .loop/에 남는다 (docs/captures/loop-inject-fault/). 가드레일 검증: 에이전트가 테스트 파일을 바꾸는 상황을 시뮬레이션하자 Controller가 복원하고 GUARDRAIL_STOP(exit 3)으로 종료했다. 단, 이 검사는 보안 샌드박스가 아니다.</a:t>
+            </a:r>
+          </a:p>
+        </p:txBody>
+      </p:sp>
+      <p:sp>
+        <p:nvSpPr>
+          <p:cNvPr id="4" name="Slide Number Placeholder 3"/>
+          <p:cNvSpPr>
+            <a:spLocks noGrp="1"/>
+          </p:cNvSpPr>
+          <p:nvPr>
+            <p:ph type="sldNum" idx="5" sz="quarter"/>
+          </p:nvPr>
+        </p:nvSpPr>
+        <p:spPr/>
+      </p:sp>
+    </p:spTree>
+  </p:cSld>
+  <p:clrMapOvr>
+    <a:masterClrMapping/>
+  </p:clrMapOvr>
+</p:notes>
 </file>
 
 <file path=ppt/slideLayouts/slideLayout1.xml><?xml version="1.0" encoding="utf-8"?>
@@ -3263,7 +3826,7 @@
                   <a:srgbClr val="8397AB"/>
                 </a:solidFill>
               </a:rPr>
-              <a:t>AI Agent Loop · 2026.10.21                                     01 / 11</a:t>
+              <a:t>AI Agent Loop · 2026.10.21                                     01 / 14</a:t>
             </a:r>
           </a:p>
         </p:txBody>
@@ -3481,7 +4044,7 @@
                   <a:srgbClr val="8397AB"/>
                 </a:solidFill>
               </a:rPr>
-              <a:t>AI Agent Loop · 2026.10.21                                     10 / 11</a:t>
+              <a:t>AI Agent Loop · 2026.10.21                                     13 / 14</a:t>
             </a:r>
           </a:p>
         </p:txBody>
@@ -3706,7 +4269,1148 @@
                   <a:srgbClr val="8397AB"/>
                 </a:solidFill>
               </a:rPr>
-              <a:t>AI Agent Loop · 2026.10.21                                     11 / 11</a:t>
+              <a:t>AI Agent Loop · 2026.10.21                                     14 / 14</a:t>
+            </a:r>
+          </a:p>
+        </p:txBody>
+      </p:sp>
+    </p:spTree>
+  </p:cSld>
+  <p:clrMapOvr>
+    <a:masterClrMapping/>
+  </p:clrMapOvr>
+</p:sld>
+</file>
+
+<file path=ppt/slides/slide12.xml><?xml version="1.0" encoding="utf-8"?>
+<p:sld xmlns:a="http://schemas.openxmlformats.org/drawingml/2006/main" xmlns:p="http://schemas.openxmlformats.org/presentationml/2006/main" xmlns:r="http://schemas.openxmlformats.org/officeDocument/2006/relationships">
+  <p:cSld>
+    <p:bg>
+      <p:bgPr>
+        <a:solidFill>
+          <a:srgbClr val="0E1625"/>
+        </a:solidFill>
+        <a:effectLst/>
+      </p:bgPr>
+    </p:bg>
+    <p:spTree>
+      <p:nvGrpSpPr>
+        <p:cNvPr id="1" name=""/>
+        <p:cNvGrpSpPr/>
+        <p:nvPr/>
+      </p:nvGrpSpPr>
+      <p:grpSpPr/>
+      <p:sp>
+        <p:nvSpPr>
+          <p:cNvPr id="2" name="Rectangle 1"/>
+          <p:cNvSpPr/>
+          <p:nvPr/>
+        </p:nvSpPr>
+        <p:spPr>
+          <a:xfrm>
+            <a:off x="594360" y="658368"/>
+            <a:ext cx="82296" cy="585216"/>
+          </a:xfrm>
+          <a:prstGeom prst="rect">
+            <a:avLst/>
+          </a:prstGeom>
+          <a:solidFill>
+            <a:srgbClr val="31D3B1"/>
+          </a:solidFill>
+          <a:ln>
+            <a:noFill/>
+          </a:ln>
+        </p:spPr>
+        <p:style>
+          <a:lnRef idx="1">
+            <a:schemeClr val="accent1"/>
+          </a:lnRef>
+          <a:fillRef idx="3">
+            <a:schemeClr val="accent1"/>
+          </a:fillRef>
+          <a:effectRef idx="2">
+            <a:schemeClr val="accent1"/>
+          </a:effectRef>
+          <a:fontRef idx="minor">
+            <a:schemeClr val="lt1"/>
+          </a:fontRef>
+        </p:style>
+        <p:txBody>
+          <a:bodyPr rtlCol="0" anchor="ctr"/>
+          <a:lstStyle/>
+          <a:p>
+            <a:pPr algn="ctr"/>
+          </a:p>
+        </p:txBody>
+      </p:sp>
+      <p:sp>
+        <p:nvSpPr>
+          <p:cNvPr id="3" name="TextBox 2"/>
+          <p:cNvSpPr txBox="1"/>
+          <p:nvPr/>
+        </p:nvSpPr>
+        <p:spPr>
+          <a:xfrm>
+            <a:off x="868680" y="640080"/>
+            <a:ext cx="10515600" cy="731520"/>
+          </a:xfrm>
+          <a:prstGeom prst="rect">
+            <a:avLst/>
+          </a:prstGeom>
+          <a:noFill/>
+        </p:spPr>
+        <p:txBody>
+          <a:bodyPr wrap="square">
+            <a:spAutoFit/>
+          </a:bodyPr>
+          <a:lstStyle/>
+          <a:p>
+            <a:r>
+              <a:rPr sz="3200" b="1">
+                <a:solidFill>
+                  <a:srgbClr val="F5F8FD"/>
+                </a:solidFill>
+              </a:rPr>
+              <a:t>실제 실행 ①: Kiro가 1회에 해결</a:t>
+            </a:r>
+          </a:p>
+        </p:txBody>
+      </p:sp>
+      <p:sp>
+        <p:nvSpPr>
+          <p:cNvPr id="4" name="TextBox 3"/>
+          <p:cNvSpPr txBox="1"/>
+          <p:nvPr/>
+        </p:nvSpPr>
+        <p:spPr>
+          <a:xfrm>
+            <a:off x="868680" y="6492240"/>
+            <a:ext cx="10515600" cy="201168"/>
+          </a:xfrm>
+          <a:prstGeom prst="rect">
+            <a:avLst/>
+          </a:prstGeom>
+          <a:noFill/>
+        </p:spPr>
+        <p:txBody>
+          <a:bodyPr wrap="square">
+            <a:spAutoFit/>
+          </a:bodyPr>
+          <a:lstStyle/>
+          <a:p>
+            <a:r>
+              <a:rPr sz="1000" b="0">
+                <a:solidFill>
+                  <a:srgbClr val="8397AB"/>
+                </a:solidFill>
+              </a:rPr>
+              <a:t>AI Agent Loop · 2026.10.21                                     08 / 14</a:t>
+            </a:r>
+          </a:p>
+        </p:txBody>
+      </p:sp>
+      <p:sp>
+        <p:nvSpPr>
+          <p:cNvPr id="5" name="Rounded Rectangle 4"/>
+          <p:cNvSpPr/>
+          <p:nvPr/>
+        </p:nvSpPr>
+        <p:spPr>
+          <a:xfrm>
+            <a:off x="868680" y="1463040"/>
+            <a:ext cx="10515600" cy="3840480"/>
+          </a:xfrm>
+          <a:prstGeom prst="roundRect">
+            <a:avLst>
+              <a:gd name="adj" fmla="val 3000"/>
+            </a:avLst>
+          </a:prstGeom>
+          <a:solidFill>
+            <a:srgbClr val="050A12"/>
+          </a:solidFill>
+          <a:ln>
+            <a:solidFill>
+              <a:srgbClr val="2A3B52"/>
+            </a:solidFill>
+          </a:ln>
+        </p:spPr>
+        <p:style>
+          <a:lnRef idx="1">
+            <a:schemeClr val="accent1"/>
+          </a:lnRef>
+          <a:fillRef idx="3">
+            <a:schemeClr val="accent1"/>
+          </a:fillRef>
+          <a:effectRef idx="2">
+            <a:schemeClr val="accent1"/>
+          </a:effectRef>
+          <a:fontRef idx="minor">
+            <a:schemeClr val="lt1"/>
+          </a:fontRef>
+        </p:style>
+        <p:txBody>
+          <a:bodyPr rtlCol="0" anchor="ctr"/>
+          <a:lstStyle/>
+          <a:p/>
+        </p:txBody>
+      </p:sp>
+      <p:sp>
+        <p:nvSpPr>
+          <p:cNvPr id="6" name="TextBox 5"/>
+          <p:cNvSpPr txBox="1"/>
+          <p:nvPr/>
+        </p:nvSpPr>
+        <p:spPr>
+          <a:xfrm>
+            <a:off x="1051560" y="1554480"/>
+            <a:ext cx="10149840" cy="3657600"/>
+          </a:xfrm>
+          <a:prstGeom prst="rect">
+            <a:avLst/>
+          </a:prstGeom>
+          <a:noFill/>
+        </p:spPr>
+        <p:txBody>
+          <a:bodyPr wrap="square">
+            <a:spAutoFit/>
+          </a:bodyPr>
+          <a:lstStyle/>
+          <a:p>
+            <a:r>
+              <a:rPr sz="1300" b="0">
+                <a:solidFill>
+                  <a:srgbClr val="31D3B1"/>
+                </a:solidFill>
+                <a:latin typeface="Menlo"/>
+              </a:rPr>
+              <a:t>$ python3 loop.py --provider kiro --reset</a:t>
+            </a:r>
+          </a:p>
+          <a:p>
+            <a:r>
+              <a:rPr sz="1300" b="0">
+                <a:solidFill>
+                  <a:srgbClr val="FF6B6B"/>
+                </a:solidFill>
+                <a:latin typeface="Menlo"/>
+              </a:rPr>
+              <a:t>[QA GATE] initial: FAIL</a:t>
+            </a:r>
+          </a:p>
+          <a:p>
+            <a:r>
+              <a:rPr sz="1300" b="0">
+                <a:solidFill>
+                  <a:srgbClr val="CFDEEB"/>
+                </a:solidFill>
+                <a:latin typeface="Menlo"/>
+              </a:rPr>
+              <a:t>  AssertionError: Expected IllegalArgumentException for rate=-1</a:t>
+            </a:r>
+          </a:p>
+          <a:p>
+            <a:r>
+              <a:rPr sz="1300" b="0">
+                <a:solidFill>
+                  <a:srgbClr val="31D3B1"/>
+                </a:solidFill>
+                <a:latin typeface="Menlo"/>
+              </a:rPr>
+              <a:t>[LOOP 1/5] starting NEW kiro session (no human input)</a:t>
+            </a:r>
+          </a:p>
+          <a:p>
+            <a:r>
+              <a:rPr sz="1300" b="0">
+                <a:solidFill>
+                  <a:srgbClr val="8397AB"/>
+                </a:solidFill>
+                <a:latin typeface="Menlo"/>
+              </a:rPr>
+              <a:t>  │ [tool] Reading DiscountCalculator.java, DiscountTest.java</a:t>
+            </a:r>
+          </a:p>
+          <a:p>
+            <a:r>
+              <a:rPr sz="1300" b="0">
+                <a:solidFill>
+                  <a:srgbClr val="8397AB"/>
+                </a:solidFill>
+                <a:latin typeface="Menlo"/>
+              </a:rPr>
+              <a:t>  │ [tool] Editing DiscountCalculator.java</a:t>
+            </a:r>
+          </a:p>
+          <a:p>
+            <a:r>
+              <a:rPr sz="1300" b="0">
+                <a:solidFill>
+                  <a:srgbClr val="8397AB"/>
+                </a:solidFill>
+                <a:latin typeface="Menlo"/>
+              </a:rPr>
+              <a:t>  │ Added guards ... rate outside [0,100] or price is negative</a:t>
+            </a:r>
+          </a:p>
+          <a:p>
+            <a:r>
+              <a:rPr sz="1300" b="0">
+                <a:solidFill>
+                  <a:srgbClr val="8397AB"/>
+                </a:solidFill>
+                <a:latin typeface="Menlo"/>
+              </a:rPr>
+              <a:t>  [AGENT] session ended: exit=0 (17.4s). Agent claim is NOT trusted</a:t>
+            </a:r>
+          </a:p>
+          <a:p>
+            <a:r>
+              <a:rPr sz="1300" b="0">
+                <a:solidFill>
+                  <a:srgbClr val="4ADE80"/>
+                </a:solidFill>
+                <a:latin typeface="Menlo"/>
+              </a:rPr>
+              <a:t>[QA GATE] PASS   ALL TESTS PASSED</a:t>
+            </a:r>
+          </a:p>
+          <a:p>
+            <a:r>
+              <a:rPr sz="1300" b="0">
+                <a:solidFill>
+                  <a:srgbClr val="4ADE80"/>
+                </a:solidFill>
+                <a:latin typeface="Menlo"/>
+              </a:rPr>
+              <a:t>SUCCESS: QA Gate passed on iteration 1. Controller stops the loop.</a:t>
+            </a:r>
+          </a:p>
+        </p:txBody>
+      </p:sp>
+      <p:sp>
+        <p:nvSpPr>
+          <p:cNvPr id="7" name="TextBox 6"/>
+          <p:cNvSpPr txBox="1"/>
+          <p:nvPr/>
+        </p:nvSpPr>
+        <p:spPr>
+          <a:xfrm>
+            <a:off x="868680" y="5440680"/>
+            <a:ext cx="10515600" cy="822960"/>
+          </a:xfrm>
+          <a:prstGeom prst="rect">
+            <a:avLst/>
+          </a:prstGeom>
+          <a:noFill/>
+        </p:spPr>
+        <p:txBody>
+          <a:bodyPr wrap="square">
+            <a:spAutoFit/>
+          </a:bodyPr>
+          <a:lstStyle/>
+          <a:p>
+            <a:r>
+              <a:rPr sz="1800" b="0">
+                <a:solidFill>
+                  <a:srgbClr val="CFDEEB"/>
+                </a:solidFill>
+              </a:rPr>
+              <a:t>쉬운 목표는 1회에 끝나는 게 정상 — 그래도 "완료"는 Kiro가 아니라 QA Gate가 승인했다</a:t>
+            </a:r>
+          </a:p>
+        </p:txBody>
+      </p:sp>
+    </p:spTree>
+  </p:cSld>
+  <p:clrMapOvr>
+    <a:masterClrMapping/>
+  </p:clrMapOvr>
+</p:sld>
+</file>
+
+<file path=ppt/slides/slide13.xml><?xml version="1.0" encoding="utf-8"?>
+<p:sld xmlns:a="http://schemas.openxmlformats.org/drawingml/2006/main" xmlns:p="http://schemas.openxmlformats.org/presentationml/2006/main" xmlns:r="http://schemas.openxmlformats.org/officeDocument/2006/relationships">
+  <p:cSld>
+    <p:bg>
+      <p:bgPr>
+        <a:solidFill>
+          <a:srgbClr val="0E1625"/>
+        </a:solidFill>
+        <a:effectLst/>
+      </p:bgPr>
+    </p:bg>
+    <p:spTree>
+      <p:nvGrpSpPr>
+        <p:cNvPr id="1" name=""/>
+        <p:cNvGrpSpPr/>
+        <p:nvPr/>
+      </p:nvGrpSpPr>
+      <p:grpSpPr/>
+      <p:sp>
+        <p:nvSpPr>
+          <p:cNvPr id="2" name="Rectangle 1"/>
+          <p:cNvSpPr/>
+          <p:nvPr/>
+        </p:nvSpPr>
+        <p:spPr>
+          <a:xfrm>
+            <a:off x="594360" y="658368"/>
+            <a:ext cx="82296" cy="585216"/>
+          </a:xfrm>
+          <a:prstGeom prst="rect">
+            <a:avLst/>
+          </a:prstGeom>
+          <a:solidFill>
+            <a:srgbClr val="31D3B1"/>
+          </a:solidFill>
+          <a:ln>
+            <a:noFill/>
+          </a:ln>
+        </p:spPr>
+        <p:style>
+          <a:lnRef idx="1">
+            <a:schemeClr val="accent1"/>
+          </a:lnRef>
+          <a:fillRef idx="3">
+            <a:schemeClr val="accent1"/>
+          </a:fillRef>
+          <a:effectRef idx="2">
+            <a:schemeClr val="accent1"/>
+          </a:effectRef>
+          <a:fontRef idx="minor">
+            <a:schemeClr val="lt1"/>
+          </a:fontRef>
+        </p:style>
+        <p:txBody>
+          <a:bodyPr rtlCol="0" anchor="ctr"/>
+          <a:lstStyle/>
+          <a:p>
+            <a:pPr algn="ctr"/>
+          </a:p>
+        </p:txBody>
+      </p:sp>
+      <p:sp>
+        <p:nvSpPr>
+          <p:cNvPr id="3" name="TextBox 2"/>
+          <p:cNvSpPr txBox="1"/>
+          <p:nvPr/>
+        </p:nvSpPr>
+        <p:spPr>
+          <a:xfrm>
+            <a:off x="868680" y="640080"/>
+            <a:ext cx="10515600" cy="731520"/>
+          </a:xfrm>
+          <a:prstGeom prst="rect">
+            <a:avLst/>
+          </a:prstGeom>
+          <a:noFill/>
+        </p:spPr>
+        <p:txBody>
+          <a:bodyPr wrap="square">
+            <a:spAutoFit/>
+          </a:bodyPr>
+          <a:lstStyle/>
+          <a:p>
+            <a:r>
+              <a:rPr sz="3200" b="1">
+                <a:solidFill>
+                  <a:srgbClr val="F5F8FD"/>
+                </a:solidFill>
+              </a:rPr>
+              <a:t>실제 실행 ②: QA FAIL → 새 세션 자동 실행</a:t>
+            </a:r>
+          </a:p>
+        </p:txBody>
+      </p:sp>
+      <p:sp>
+        <p:nvSpPr>
+          <p:cNvPr id="4" name="TextBox 3"/>
+          <p:cNvSpPr txBox="1"/>
+          <p:nvPr/>
+        </p:nvSpPr>
+        <p:spPr>
+          <a:xfrm>
+            <a:off x="868680" y="6492240"/>
+            <a:ext cx="10515600" cy="201168"/>
+          </a:xfrm>
+          <a:prstGeom prst="rect">
+            <a:avLst/>
+          </a:prstGeom>
+          <a:noFill/>
+        </p:spPr>
+        <p:txBody>
+          <a:bodyPr wrap="square">
+            <a:spAutoFit/>
+          </a:bodyPr>
+          <a:lstStyle/>
+          <a:p>
+            <a:r>
+              <a:rPr sz="1000" b="0">
+                <a:solidFill>
+                  <a:srgbClr val="8397AB"/>
+                </a:solidFill>
+              </a:rPr>
+              <a:t>AI Agent Loop · 2026.10.21                                     09 / 14</a:t>
+            </a:r>
+          </a:p>
+        </p:txBody>
+      </p:sp>
+      <p:sp>
+        <p:nvSpPr>
+          <p:cNvPr id="5" name="Rounded Rectangle 4"/>
+          <p:cNvSpPr/>
+          <p:nvPr/>
+        </p:nvSpPr>
+        <p:spPr>
+          <a:xfrm>
+            <a:off x="868680" y="1371600"/>
+            <a:ext cx="10515600" cy="4206240"/>
+          </a:xfrm>
+          <a:prstGeom prst="roundRect">
+            <a:avLst>
+              <a:gd name="adj" fmla="val 3000"/>
+            </a:avLst>
+          </a:prstGeom>
+          <a:solidFill>
+            <a:srgbClr val="050A12"/>
+          </a:solidFill>
+          <a:ln>
+            <a:solidFill>
+              <a:srgbClr val="2A3B52"/>
+            </a:solidFill>
+          </a:ln>
+        </p:spPr>
+        <p:style>
+          <a:lnRef idx="1">
+            <a:schemeClr val="accent1"/>
+          </a:lnRef>
+          <a:fillRef idx="3">
+            <a:schemeClr val="accent1"/>
+          </a:fillRef>
+          <a:effectRef idx="2">
+            <a:schemeClr val="accent1"/>
+          </a:effectRef>
+          <a:fontRef idx="minor">
+            <a:schemeClr val="lt1"/>
+          </a:fontRef>
+        </p:style>
+        <p:txBody>
+          <a:bodyPr rtlCol="0" anchor="ctr"/>
+          <a:lstStyle/>
+          <a:p/>
+        </p:txBody>
+      </p:sp>
+      <p:sp>
+        <p:nvSpPr>
+          <p:cNvPr id="6" name="TextBox 5"/>
+          <p:cNvSpPr txBox="1"/>
+          <p:nvPr/>
+        </p:nvSpPr>
+        <p:spPr>
+          <a:xfrm>
+            <a:off x="1051560" y="1463040"/>
+            <a:ext cx="10149840" cy="4023360"/>
+          </a:xfrm>
+          <a:prstGeom prst="rect">
+            <a:avLst/>
+          </a:prstGeom>
+          <a:noFill/>
+        </p:spPr>
+        <p:txBody>
+          <a:bodyPr wrap="square">
+            <a:spAutoFit/>
+          </a:bodyPr>
+          <a:lstStyle/>
+          <a:p>
+            <a:r>
+              <a:rPr sz="1200" b="0">
+                <a:solidFill>
+                  <a:srgbClr val="31D3B1"/>
+                </a:solidFill>
+                <a:latin typeface="Menlo"/>
+              </a:rPr>
+              <a:t>$ python3 loop.py --provider kiro --reset --inject-fault</a:t>
+            </a:r>
+          </a:p>
+          <a:p>
+            <a:r>
+              <a:rPr sz="1200" b="0">
+                <a:solidFill>
+                  <a:srgbClr val="31D3B1"/>
+                </a:solidFill>
+                <a:latin typeface="Menlo"/>
+              </a:rPr>
+              <a:t>[LOOP 1/5] starting NEW kiro session (no human input)</a:t>
+            </a:r>
+          </a:p>
+          <a:p>
+            <a:r>
+              <a:rPr sz="1200" b="0">
+                <a:solidFill>
+                  <a:srgbClr val="8397AB"/>
+                </a:solidFill>
+                <a:latin typeface="Menlo"/>
+              </a:rPr>
+              <a:t>  │ [tool] Editing DiscountCalculator.java     (16.5s, exit=0)</a:t>
+            </a:r>
+          </a:p>
+          <a:p>
+            <a:r>
+              <a:rPr sz="1200" b="0">
+                <a:solidFill>
+                  <a:srgbClr val="FACC15"/>
+                </a:solidFill>
+                <a:latin typeface="Menlo"/>
+              </a:rPr>
+              <a:t>[FAULT INJECTION] controller removed price validation (NOT the AI's)</a:t>
+            </a:r>
+          </a:p>
+          <a:p>
+            <a:r>
+              <a:rPr sz="1200" b="0">
+                <a:solidFill>
+                  <a:srgbClr val="FF6B6B"/>
+                </a:solidFill>
+                <a:latin typeface="Menlo"/>
+              </a:rPr>
+              <a:t>[QA GATE] FAIL</a:t>
+            </a:r>
+          </a:p>
+          <a:p>
+            <a:r>
+              <a:rPr sz="1200" b="0">
+                <a:solidFill>
+                  <a:srgbClr val="CFDEEB"/>
+                </a:solidFill>
+                <a:latin typeface="Menlo"/>
+              </a:rPr>
+              <a:t>  AssertionError: Expected IllegalArgumentException for price=-1</a:t>
+            </a:r>
+          </a:p>
+          <a:p>
+            <a:r>
+              <a:rPr sz="1200" b="0">
+                <a:solidFill>
+                  <a:srgbClr val="31D3B1"/>
+                </a:solidFill>
+                <a:latin typeface="Menlo"/>
+              </a:rPr>
+              <a:t>[LOOP] QA failed -&gt; feeding failure log into a NEW session</a:t>
+            </a:r>
+          </a:p>
+          <a:p>
+            <a:r>
+              <a:rPr sz="1200" b="0">
+                <a:solidFill>
+                  <a:srgbClr val="31D3B1"/>
+                </a:solidFill>
+                <a:latin typeface="Menlo"/>
+              </a:rPr>
+              <a:t>[LOOP 2/5] starting NEW kiro session (no human input)</a:t>
+            </a:r>
+          </a:p>
+          <a:p>
+            <a:r>
+              <a:rPr sz="1200" b="0">
+                <a:solidFill>
+                  <a:srgbClr val="8397AB"/>
+                </a:solidFill>
+                <a:latin typeface="Menlo"/>
+              </a:rPr>
+              <a:t>  │ The fix is to add price validation. I'll add a check for price &lt; 0</a:t>
+            </a:r>
+          </a:p>
+          <a:p>
+            <a:r>
+              <a:rPr sz="1200" b="0">
+                <a:solidFill>
+                  <a:srgbClr val="8397AB"/>
+                </a:solidFill>
+                <a:latin typeface="Menlo"/>
+              </a:rPr>
+              <a:t>  │ [tool] Editing DiscountCalculator.java     (17.2s, exit=0)</a:t>
+            </a:r>
+          </a:p>
+          <a:p>
+            <a:r>
+              <a:rPr sz="1200" b="0">
+                <a:solidFill>
+                  <a:srgbClr val="4ADE80"/>
+                </a:solidFill>
+                <a:latin typeface="Menlo"/>
+              </a:rPr>
+              <a:t>[QA GATE] PASS   ALL TESTS PASSED</a:t>
+            </a:r>
+          </a:p>
+          <a:p>
+            <a:r>
+              <a:rPr sz="1200" b="0">
+                <a:solidFill>
+                  <a:srgbClr val="FF6B6B"/>
+                </a:solidFill>
+                <a:latin typeface="Menlo"/>
+              </a:rPr>
+              <a:t>RESULT=PASS  iterations=2   loop 1: FAIL (fault injected) / loop 2: PASS</a:t>
+            </a:r>
+          </a:p>
+        </p:txBody>
+      </p:sp>
+      <p:sp>
+        <p:nvSpPr>
+          <p:cNvPr id="7" name="TextBox 6"/>
+          <p:cNvSpPr txBox="1"/>
+          <p:nvPr/>
+        </p:nvSpPr>
+        <p:spPr>
+          <a:xfrm>
+            <a:off x="868680" y="5669280"/>
+            <a:ext cx="10515600" cy="640080"/>
+          </a:xfrm>
+          <a:prstGeom prst="rect">
+            <a:avLst/>
+          </a:prstGeom>
+          <a:noFill/>
+        </p:spPr>
+        <p:txBody>
+          <a:bodyPr wrap="square">
+            <a:spAutoFit/>
+          </a:bodyPr>
+          <a:lstStyle/>
+          <a:p>
+            <a:r>
+              <a:rPr sz="1600" b="0">
+                <a:solidFill>
+                  <a:srgbClr val="FACC15"/>
+                </a:solidFill>
+              </a:rPr>
+              <a:t>※ 1회차 실패는 Controller가 의도적으로 주입한 것 (AI 실패 아님)</a:t>
+            </a:r>
+          </a:p>
+        </p:txBody>
+      </p:sp>
+    </p:spTree>
+  </p:cSld>
+  <p:clrMapOvr>
+    <a:masterClrMapping/>
+  </p:clrMapOvr>
+</p:sld>
+</file>
+
+<file path=ppt/slides/slide14.xml><?xml version="1.0" encoding="utf-8"?>
+<p:sld xmlns:a="http://schemas.openxmlformats.org/drawingml/2006/main" xmlns:p="http://schemas.openxmlformats.org/presentationml/2006/main" xmlns:r="http://schemas.openxmlformats.org/officeDocument/2006/relationships">
+  <p:cSld>
+    <p:bg>
+      <p:bgPr>
+        <a:solidFill>
+          <a:srgbClr val="0E1625"/>
+        </a:solidFill>
+        <a:effectLst/>
+      </p:bgPr>
+    </p:bg>
+    <p:spTree>
+      <p:nvGrpSpPr>
+        <p:cNvPr id="1" name=""/>
+        <p:cNvGrpSpPr/>
+        <p:nvPr/>
+      </p:nvGrpSpPr>
+      <p:grpSpPr/>
+      <p:sp>
+        <p:nvSpPr>
+          <p:cNvPr id="2" name="Rectangle 1"/>
+          <p:cNvSpPr/>
+          <p:nvPr/>
+        </p:nvSpPr>
+        <p:spPr>
+          <a:xfrm>
+            <a:off x="594360" y="658368"/>
+            <a:ext cx="82296" cy="585216"/>
+          </a:xfrm>
+          <a:prstGeom prst="rect">
+            <a:avLst/>
+          </a:prstGeom>
+          <a:solidFill>
+            <a:srgbClr val="31D3B1"/>
+          </a:solidFill>
+          <a:ln>
+            <a:noFill/>
+          </a:ln>
+        </p:spPr>
+        <p:style>
+          <a:lnRef idx="1">
+            <a:schemeClr val="accent1"/>
+          </a:lnRef>
+          <a:fillRef idx="3">
+            <a:schemeClr val="accent1"/>
+          </a:fillRef>
+          <a:effectRef idx="2">
+            <a:schemeClr val="accent1"/>
+          </a:effectRef>
+          <a:fontRef idx="minor">
+            <a:schemeClr val="lt1"/>
+          </a:fontRef>
+        </p:style>
+        <p:txBody>
+          <a:bodyPr rtlCol="0" anchor="ctr"/>
+          <a:lstStyle/>
+          <a:p>
+            <a:pPr algn="ctr"/>
+          </a:p>
+        </p:txBody>
+      </p:sp>
+      <p:sp>
+        <p:nvSpPr>
+          <p:cNvPr id="3" name="TextBox 2"/>
+          <p:cNvSpPr txBox="1"/>
+          <p:nvPr/>
+        </p:nvSpPr>
+        <p:spPr>
+          <a:xfrm>
+            <a:off x="868680" y="640080"/>
+            <a:ext cx="10515600" cy="731520"/>
+          </a:xfrm>
+          <a:prstGeom prst="rect">
+            <a:avLst/>
+          </a:prstGeom>
+          <a:noFill/>
+        </p:spPr>
+        <p:txBody>
+          <a:bodyPr wrap="square">
+            <a:spAutoFit/>
+          </a:bodyPr>
+          <a:lstStyle/>
+          <a:p>
+            <a:r>
+              <a:rPr sz="3200" b="1">
+                <a:solidFill>
+                  <a:srgbClr val="F5F8FD"/>
+                </a:solidFill>
+              </a:rPr>
+              <a:t>증거: Controller가 남긴 기록</a:t>
+            </a:r>
+          </a:p>
+        </p:txBody>
+      </p:sp>
+      <p:sp>
+        <p:nvSpPr>
+          <p:cNvPr id="4" name="TextBox 3"/>
+          <p:cNvSpPr txBox="1"/>
+          <p:nvPr/>
+        </p:nvSpPr>
+        <p:spPr>
+          <a:xfrm>
+            <a:off x="868680" y="6492240"/>
+            <a:ext cx="10515600" cy="201168"/>
+          </a:xfrm>
+          <a:prstGeom prst="rect">
+            <a:avLst/>
+          </a:prstGeom>
+          <a:noFill/>
+        </p:spPr>
+        <p:txBody>
+          <a:bodyPr wrap="square">
+            <a:spAutoFit/>
+          </a:bodyPr>
+          <a:lstStyle/>
+          <a:p>
+            <a:r>
+              <a:rPr sz="1000" b="0">
+                <a:solidFill>
+                  <a:srgbClr val="8397AB"/>
+                </a:solidFill>
+              </a:rPr>
+              <a:t>AI Agent Loop · 2026.10.21                                     10 / 14</a:t>
+            </a:r>
+          </a:p>
+        </p:txBody>
+      </p:sp>
+      <p:sp>
+        <p:nvSpPr>
+          <p:cNvPr id="5" name="TextBox 4"/>
+          <p:cNvSpPr txBox="1"/>
+          <p:nvPr/>
+        </p:nvSpPr>
+        <p:spPr>
+          <a:xfrm>
+            <a:off x="868680" y="1463040"/>
+            <a:ext cx="4754880" cy="3840480"/>
+          </a:xfrm>
+          <a:prstGeom prst="rect">
+            <a:avLst/>
+          </a:prstGeom>
+          <a:noFill/>
+        </p:spPr>
+        <p:txBody>
+          <a:bodyPr wrap="square">
+            <a:spAutoFit/>
+          </a:bodyPr>
+          <a:lstStyle/>
+          <a:p>
+            <a:r>
+              <a:rPr sz="1800" b="0">
+                <a:solidFill>
+                  <a:srgbClr val="CFDEEB"/>
+                </a:solidFill>
+              </a:rPr>
+              <a:t>.loop/summary.json — 결과·반복 횟수</a:t>
+            </a:r>
+          </a:p>
+          <a:p>
+            <a:r>
+              <a:rPr sz="1800" b="0">
+                <a:solidFill>
+                  <a:srgbClr val="CFDEEB"/>
+                </a:solidFill>
+              </a:rPr>
+              <a:t>iteration-NN.json — 회차별 QA 출력</a:t>
+            </a:r>
+          </a:p>
+          <a:p>
+            <a:r>
+              <a:rPr sz="1800" b="0">
+                <a:solidFill>
+                  <a:srgbClr val="CFDEEB"/>
+                </a:solidFill>
+              </a:rPr>
+              <a:t>agent-NN.log — Kiro 세션 전체 로그</a:t>
+            </a:r>
+          </a:p>
+          <a:p>
+            <a:r>
+              <a:rPr sz="1800" b="0">
+                <a:solidFill>
+                  <a:srgbClr val="CFDEEB"/>
+                </a:solidFill>
+              </a:rPr>
+              <a:t>diff-NN.patch — AI가 바꾼 코드</a:t>
+            </a:r>
+          </a:p>
+          <a:p>
+            <a:r>
+              <a:rPr sz="1800" b="0">
+                <a:solidFill>
+                  <a:srgbClr val="CFDEEB"/>
+                </a:solidFill>
+              </a:rPr>
+              <a:t/>
+            </a:r>
+          </a:p>
+          <a:p>
+            <a:r>
+              <a:rPr sz="1800" b="0">
+                <a:solidFill>
+                  <a:srgbClr val="31D3B1"/>
+                </a:solidFill>
+              </a:rPr>
+              <a:t>보호 파일 변조 시뮬레이션</a:t>
+            </a:r>
+          </a:p>
+          <a:p>
+            <a:r>
+              <a:rPr sz="1800" b="0">
+                <a:solidFill>
+                  <a:srgbClr val="CFDEEB"/>
+                </a:solidFill>
+              </a:rPr>
+              <a:t>→ 자동 복원 + GUARDRAIL_STOP</a:t>
+            </a:r>
+          </a:p>
+          <a:p>
+            <a:r>
+              <a:rPr sz="1800" b="0">
+                <a:solidFill>
+                  <a:srgbClr val="CFDEEB"/>
+                </a:solidFill>
+              </a:rPr>
+              <a:t>셸 도구 요청 → 비대화형 모드에서 거부</a:t>
+            </a:r>
+          </a:p>
+        </p:txBody>
+      </p:sp>
+      <p:sp>
+        <p:nvSpPr>
+          <p:cNvPr id="6" name="Rounded Rectangle 5"/>
+          <p:cNvSpPr/>
+          <p:nvPr/>
+        </p:nvSpPr>
+        <p:spPr>
+          <a:xfrm>
+            <a:off x="6720840" y="1463040"/>
+            <a:ext cx="4663440" cy="3840480"/>
+          </a:xfrm>
+          <a:prstGeom prst="roundRect">
+            <a:avLst>
+              <a:gd name="adj" fmla="val 3000"/>
+            </a:avLst>
+          </a:prstGeom>
+          <a:solidFill>
+            <a:srgbClr val="050A12"/>
+          </a:solidFill>
+          <a:ln>
+            <a:solidFill>
+              <a:srgbClr val="2A3B52"/>
+            </a:solidFill>
+          </a:ln>
+        </p:spPr>
+        <p:style>
+          <a:lnRef idx="1">
+            <a:schemeClr val="accent1"/>
+          </a:lnRef>
+          <a:fillRef idx="3">
+            <a:schemeClr val="accent1"/>
+          </a:fillRef>
+          <a:effectRef idx="2">
+            <a:schemeClr val="accent1"/>
+          </a:effectRef>
+          <a:fontRef idx="minor">
+            <a:schemeClr val="lt1"/>
+          </a:fontRef>
+        </p:style>
+        <p:txBody>
+          <a:bodyPr rtlCol="0" anchor="ctr"/>
+          <a:lstStyle/>
+          <a:p/>
+        </p:txBody>
+      </p:sp>
+      <p:sp>
+        <p:nvSpPr>
+          <p:cNvPr id="7" name="TextBox 6"/>
+          <p:cNvSpPr txBox="1"/>
+          <p:nvPr/>
+        </p:nvSpPr>
+        <p:spPr>
+          <a:xfrm>
+            <a:off x="6903720" y="1554480"/>
+            <a:ext cx="4297680" cy="3657600"/>
+          </a:xfrm>
+          <a:prstGeom prst="rect">
+            <a:avLst/>
+          </a:prstGeom>
+          <a:noFill/>
+        </p:spPr>
+        <p:txBody>
+          <a:bodyPr wrap="square">
+            <a:spAutoFit/>
+          </a:bodyPr>
+          <a:lstStyle/>
+          <a:p>
+            <a:r>
+              <a:rPr sz="1200" b="0">
+                <a:solidFill>
+                  <a:srgbClr val="CFDEEB"/>
+                </a:solidFill>
+                <a:latin typeface="Menlo"/>
+              </a:rPr>
+              <a:t>diff-02.patch  (LOOP 2, Kiro)</a:t>
+            </a:r>
+          </a:p>
+          <a:p>
+            <a:r>
+              <a:rPr sz="1200" b="0">
+                <a:solidFill>
+                  <a:srgbClr val="CFDEEB"/>
+                </a:solidFill>
+                <a:latin typeface="Menlo"/>
+              </a:rPr>
+              <a:t/>
+            </a:r>
+          </a:p>
+          <a:p>
+            <a:r>
+              <a:rPr sz="1200" b="0">
+                <a:solidFill>
+                  <a:srgbClr val="CFDEEB"/>
+                </a:solidFill>
+                <a:latin typeface="Menlo"/>
+              </a:rPr>
+              <a:t>  public static int discount(</a:t>
+            </a:r>
+          </a:p>
+          <a:p>
+            <a:r>
+              <a:rPr sz="1200" b="0">
+                <a:solidFill>
+                  <a:srgbClr val="CFDEEB"/>
+                </a:solidFill>
+                <a:latin typeface="Menlo"/>
+              </a:rPr>
+              <a:t>      int price, int rate) {</a:t>
+            </a:r>
+          </a:p>
+          <a:p>
+            <a:r>
+              <a:rPr sz="1200" b="0">
+                <a:solidFill>
+                  <a:srgbClr val="FF6B6B"/>
+                </a:solidFill>
+                <a:latin typeface="Menlo"/>
+              </a:rPr>
+              <a:t>- // [FAULT INJECTION] price</a:t>
+            </a:r>
+          </a:p>
+          <a:p>
+            <a:r>
+              <a:rPr sz="1200" b="0">
+                <a:solidFill>
+                  <a:srgbClr val="FF6B6B"/>
+                </a:solidFill>
+                <a:latin typeface="Menlo"/>
+              </a:rPr>
+              <a:t>-    validation removed</a:t>
+            </a:r>
+          </a:p>
+          <a:p>
+            <a:r>
+              <a:rPr sz="1200" b="0">
+                <a:solidFill>
+                  <a:srgbClr val="4ADE80"/>
+                </a:solidFill>
+                <a:latin typeface="Menlo"/>
+              </a:rPr>
+              <a:t>+ if (price &lt; 0) throw new</a:t>
+            </a:r>
+          </a:p>
+          <a:p>
+            <a:r>
+              <a:rPr sz="1200" b="0">
+                <a:solidFill>
+                  <a:srgbClr val="4ADE80"/>
+                </a:solidFill>
+                <a:latin typeface="Menlo"/>
+              </a:rPr>
+              <a:t>+   IllegalArgumentException(</a:t>
+            </a:r>
+          </a:p>
+          <a:p>
+            <a:r>
+              <a:rPr sz="1200" b="0">
+                <a:solidFill>
+                  <a:srgbClr val="4ADE80"/>
+                </a:solidFill>
+                <a:latin typeface="Menlo"/>
+              </a:rPr>
+              <a:t>+     "invalid price");</a:t>
+            </a:r>
+          </a:p>
+          <a:p>
+            <a:r>
+              <a:rPr sz="1200" b="0">
+                <a:solidFill>
+                  <a:srgbClr val="CFDEEB"/>
+                </a:solidFill>
+                <a:latin typeface="Menlo"/>
+              </a:rPr>
+              <a:t>  if (rate &lt; 0 || rate &gt; 100)</a:t>
+            </a:r>
+          </a:p>
+          <a:p>
+            <a:r>
+              <a:rPr sz="1200" b="0">
+                <a:solidFill>
+                  <a:srgbClr val="CFDEEB"/>
+                </a:solidFill>
+                <a:latin typeface="Menlo"/>
+              </a:rPr>
+              <a:t>    throw new IllegalArgumentException</a:t>
             </a:r>
           </a:p>
         </p:txBody>
@@ -3909,7 +5613,7 @@
                   <a:srgbClr val="8397AB"/>
                 </a:solidFill>
               </a:rPr>
-              <a:t>AI Agent Loop · 2026.10.21                                     02 / 11</a:t>
+              <a:t>AI Agent Loop · 2026.10.21                                     02 / 14</a:t>
             </a:r>
           </a:p>
         </p:txBody>
@@ -4112,7 +5816,7 @@
                   <a:srgbClr val="8397AB"/>
                 </a:solidFill>
               </a:rPr>
-              <a:t>AI Agent Loop · 2026.10.21                                     03 / 11</a:t>
+              <a:t>AI Agent Loop · 2026.10.21                                     03 / 14</a:t>
             </a:r>
           </a:p>
         </p:txBody>
@@ -4315,7 +6019,7 @@
                   <a:srgbClr val="8397AB"/>
                 </a:solidFill>
               </a:rPr>
-              <a:t>AI Agent Loop · 2026.10.21                                     04 / 11</a:t>
+              <a:t>AI Agent Loop · 2026.10.21                                     04 / 14</a:t>
             </a:r>
           </a:p>
         </p:txBody>
@@ -4455,7 +6159,7 @@
                   <a:srgbClr val="CFDEEB"/>
                 </a:solidFill>
               </a:rPr>
-              <a:t>Goal: 요구사항 / Acceptance: 검증 테스트</a:t>
+              <a:t>Goal: 요구사항 / Acceptance: verify.py (Java 테스트)</a:t>
             </a:r>
           </a:p>
           <a:p>
@@ -4470,7 +6174,7 @@
                   <a:srgbClr val="CFDEEB"/>
                 </a:solidFill>
               </a:rPr>
-              <a:t>Worker: Claude Code 또는 Kiro CLI</a:t>
+              <a:t>Worker: Kiro CLI 2.32.0 (비대화형, 매 회 새 세션)</a:t>
             </a:r>
           </a:p>
           <a:p>
@@ -4500,7 +6204,7 @@
                   <a:srgbClr val="CFDEEB"/>
                 </a:solidFill>
               </a:rPr>
-              <a:t>Memory: 검증 출력 + .loop/ 실행 기록</a:t>
+              <a:t>Memory: QA 실패 출력 + .loop/ 실행 기록·diff</a:t>
             </a:r>
           </a:p>
           <a:p>
@@ -4515,7 +6219,22 @@
                   <a:srgbClr val="CFDEEB"/>
                 </a:solidFill>
               </a:rPr>
-              <a:t>Guardrails: 최대 5회, 세션 타임아웃, 보호 파일 검사</a:t>
+              <a:t>Guardrails: 최대 5회, 세션 타임아웃, 보호 파일 검사,</a:t>
+            </a:r>
+          </a:p>
+          <a:p>
+            <a:pPr>
+              <a:spcAft>
+                <a:spcPts val="1700"/>
+              </a:spcAft>
+            </a:pPr>
+            <a:r>
+              <a:rPr sz="2200">
+                <a:solidFill>
+                  <a:srgbClr val="CFDEEB"/>
+                </a:solidFill>
+              </a:rPr>
+              <a:t>   fs_read/fs_write 도구만 허용</a:t>
             </a:r>
           </a:p>
         </p:txBody>
@@ -4548,7 +6267,7 @@
                   <a:srgbClr val="8397AB"/>
                 </a:solidFill>
               </a:rPr>
-              <a:t>AI Agent Loop · 2026.10.21                                     05 / 11</a:t>
+              <a:t>AI Agent Loop · 2026.10.21                                     05 / 14</a:t>
             </a:r>
           </a:p>
         </p:txBody>
@@ -4703,7 +6422,7 @@
                   <a:srgbClr val="CFDEEB"/>
                 </a:solidFill>
               </a:rPr>
-              <a:t>예외: 할인율 -1%, 101%는 IllegalArgumentException</a:t>
+              <a:t>경계: 0% → 1,000원, 100% → 0원</a:t>
             </a:r>
           </a:p>
           <a:p>
@@ -4718,7 +6437,7 @@
                   <a:srgbClr val="CFDEEB"/>
                 </a:solidFill>
               </a:rPr>
-              <a:t>초기 구현은 잘못된 할인율을 허용한다</a:t>
+              <a:t>예외: 할인율 -1%, 101%, 금액 -1원 → IllegalArgumentException</a:t>
             </a:r>
           </a:p>
           <a:p>
@@ -4733,7 +6452,22 @@
                   <a:srgbClr val="CFDEEB"/>
                 </a:solidFill>
               </a:rPr>
-              <a:t>목표: 테스트를 삭제하지 않고 코드를 고쳐 모두 PASS</a:t>
+              <a:t>초기 구현은 잘못된 입력을 모두 허용한다</a:t>
+            </a:r>
+          </a:p>
+          <a:p>
+            <a:pPr>
+              <a:spcAft>
+                <a:spcPts val="1700"/>
+              </a:spcAft>
+            </a:pPr>
+            <a:r>
+              <a:rPr sz="2200">
+                <a:solidFill>
+                  <a:srgbClr val="CFDEEB"/>
+                </a:solidFill>
+              </a:rPr>
+              <a:t>목표: 테스트를 건드리지 않고 코드를 고쳐 모두 PASS</a:t>
             </a:r>
           </a:p>
         </p:txBody>
@@ -4766,7 +6500,7 @@
                   <a:srgbClr val="8397AB"/>
                 </a:solidFill>
               </a:rPr>
-              <a:t>AI Agent Loop · 2026.10.21                                     06 / 11</a:t>
+              <a:t>AI Agent Loop · 2026.10.21                                     06 / 14</a:t>
             </a:r>
           </a:p>
         </p:txBody>
@@ -4906,7 +6640,7 @@
                   <a:srgbClr val="CFDEEB"/>
                 </a:solidFill>
               </a:rPr>
-              <a:t>1. python verify.py → FAIL 확인</a:t>
+              <a:t>1. python3 verify.py → FAIL 확인</a:t>
             </a:r>
           </a:p>
           <a:p>
@@ -4921,7 +6655,7 @@
                   <a:srgbClr val="CFDEEB"/>
                 </a:solidFill>
               </a:rPr>
-              <a:t>2. python loop.py --provider mock --reset → 2회 반복</a:t>
+              <a:t>2. python3 loop.py --provider mock --reset (리허설)</a:t>
             </a:r>
           </a:p>
           <a:p>
@@ -4936,7 +6670,7 @@
                   <a:srgbClr val="CFDEEB"/>
                 </a:solidFill>
               </a:rPr>
-              <a:t>3. python loop.py --provider claude --reset</a:t>
+              <a:t>3. python3 loop.py --provider kiro --reset</a:t>
             </a:r>
           </a:p>
           <a:p>
@@ -4951,7 +6685,7 @@
                   <a:srgbClr val="CFDEEB"/>
                 </a:solidFill>
               </a:rPr>
-              <a:t>   또는 --provider kiro --reset</a:t>
+              <a:t>4. ... --provider kiro --reset --inject-fault (데모 모드)</a:t>
             </a:r>
           </a:p>
           <a:p>
@@ -4966,7 +6700,7 @@
                   <a:srgbClr val="CFDEEB"/>
                 </a:solidFill>
               </a:rPr>
-              <a:t>4. .loop/iteration-*.json 및 소스 변경 확인</a:t>
+              <a:t>5. .loop/summary.json · iteration-NN.json · diff-NN.patch 확인</a:t>
             </a:r>
           </a:p>
         </p:txBody>
@@ -4999,7 +6733,7 @@
                   <a:srgbClr val="8397AB"/>
                 </a:solidFill>
               </a:rPr>
-              <a:t>AI Agent Loop · 2026.10.21                                     07 / 11</a:t>
+              <a:t>AI Agent Loop · 2026.10.21                                     07 / 14</a:t>
             </a:r>
           </a:p>
         </p:txBody>
@@ -5217,7 +6951,7 @@
                   <a:srgbClr val="8397AB"/>
                 </a:solidFill>
               </a:rPr>
-              <a:t>AI Agent Loop · 2026.10.21                                     08 / 11</a:t>
+              <a:t>AI Agent Loop · 2026.10.21                                     11 / 14</a:t>
             </a:r>
           </a:p>
         </p:txBody>
@@ -5450,7 +7184,7 @@
                   <a:srgbClr val="8397AB"/>
                 </a:solidFill>
               </a:rPr>
-              <a:t>AI Agent Loop · 2026.10.21                                     09 / 11</a:t>
+              <a:t>AI Agent Loop · 2026.10.21                                     12 / 14</a:t>
             </a:r>
           </a:p>
         </p:txBody>
@@ -5781,4 +7515,324 @@
   </a:objectDefaults>
   <a:extraClrSchemeLst/>
 </a:theme>
+</file>
+
+<file path=ppt/theme/theme2.xml><?xml version="1.0" encoding="utf-8"?>
+<a:theme xmlns:a="http://schemas.openxmlformats.org/drawingml/2006/main" name="Office Theme">
+  <a:themeElements>
+    <a:clrScheme name="Office">
+      <a:dk1>
+        <a:sysClr val="windowText" lastClr="000000"/>
+      </a:dk1>
+      <a:lt1>
+        <a:sysClr val="window" lastClr="FFFFFF"/>
+      </a:lt1>
+      <a:dk2>
+        <a:srgbClr val="1F497D"/>
+      </a:dk2>
+      <a:lt2>
+        <a:srgbClr val="EEECE1"/>
+      </a:lt2>
+      <a:accent1>
+        <a:srgbClr val="4F81BD"/>
+      </a:accent1>
+      <a:accent2>
+        <a:srgbClr val="C0504D"/>
+      </a:accent2>
+      <a:accent3>
+        <a:srgbClr val="9BBB59"/>
+      </a:accent3>
+      <a:accent4>
+        <a:srgbClr val="8064A2"/>
+      </a:accent4>
+      <a:accent5>
+        <a:srgbClr val="4BACC6"/>
+      </a:accent5>
+      <a:accent6>
+        <a:srgbClr val="F79646"/>
+      </a:accent6>
+      <a:hlink>
+        <a:srgbClr val="0000FF"/>
+      </a:hlink>
+      <a:folHlink>
+        <a:srgbClr val="800080"/>
+      </a:folHlink>
+    </a:clrScheme>
+    <a:fontScheme name="Office">
+      <a:majorFont>
+        <a:latin typeface="Calibri"/>
+        <a:ea typeface=""/>
+        <a:cs typeface=""/>
+        <a:font script="Jpan" typeface="ＭＳ Ｐゴシック"/>
+        <a:font script="Hang" typeface="맑은 고딕"/>
+        <a:font script="Hans" typeface="宋体"/>
+        <a:font script="Hant" typeface="新細明體"/>
+        <a:font script="Arab" typeface="Times New Roman"/>
+        <a:font script="Hebr" typeface="Times New Roman"/>
+        <a:font script="Thai" typeface="Angsana New"/>
+        <a:font script="Ethi" typeface="Nyala"/>
+        <a:font script="Beng" typeface="Vrinda"/>
+        <a:font script="Gujr" typeface="Shruti"/>
+        <a:font script="Khmr" typeface="MoolBoran"/>
+        <a:font script="Knda" typeface="Tunga"/>
+        <a:font script="Guru" typeface="Raavi"/>
+        <a:font script="Cans" typeface="Euphemia"/>
+        <a:font script="Cher" typeface="Plantagenet Cherokee"/>
+        <a:font script="Yiii" typeface="Microsoft Yi Baiti"/>
+        <a:font script="Tibt" typeface="Microsoft Himalaya"/>
+        <a:font script="Thaa" typeface="MV Boli"/>
+        <a:font script="Deva" typeface="Mangal"/>
+        <a:font script="Telu" typeface="Gautami"/>
+        <a:font script="Taml" typeface="Latha"/>
+        <a:font script="Syrc" typeface="Estrangelo Edessa"/>
+        <a:font script="Orya" typeface="Kalinga"/>
+        <a:font script="Mlym" typeface="Kartika"/>
+        <a:font script="Laoo" typeface="DokChampa"/>
+        <a:font script="Sinh" typeface="Iskoola Pota"/>
+        <a:font script="Mong" typeface="Mongolian Baiti"/>
+        <a:font script="Viet" typeface="Times New Roman"/>
+        <a:font script="Uigh" typeface="Microsoft Uighur"/>
+        <a:font script="Geor" typeface="Sylfaen"/>
+      </a:majorFont>
+      <a:minorFont>
+        <a:latin typeface="Calibri"/>
+        <a:ea typeface=""/>
+        <a:cs typeface=""/>
+        <a:font script="Jpan" typeface="ＭＳ Ｐゴシック"/>
+        <a:font script="Hang" typeface="맑은 고딕"/>
+        <a:font script="Hans" typeface="宋体"/>
+        <a:font script="Hant" typeface="新細明體"/>
+        <a:font script="Arab" typeface="Arial"/>
+        <a:font script="Hebr" typeface="Arial"/>
+        <a:font script="Thai" typeface="Cordia New"/>
+        <a:font script="Ethi" typeface="Nyala"/>
+        <a:font script="Beng" typeface="Vrinda"/>
+        <a:font script="Gujr" typeface="Shruti"/>
+        <a:font script="Khmr" typeface="DaunPenh"/>
+        <a:font script="Knda" typeface="Tunga"/>
+        <a:font script="Guru" typeface="Raavi"/>
+        <a:font script="Cans" typeface="Euphemia"/>
+        <a:font script="Cher" typeface="Plantagenet Cherokee"/>
+        <a:font script="Yiii" typeface="Microsoft Yi Baiti"/>
+        <a:font script="Tibt" typeface="Microsoft Himalaya"/>
+        <a:font script="Thaa" typeface="MV Boli"/>
+        <a:font script="Deva" typeface="Mangal"/>
+        <a:font script="Telu" typeface="Gautami"/>
+        <a:font script="Taml" typeface="Latha"/>
+        <a:font script="Syrc" typeface="Estrangelo Edessa"/>
+        <a:font script="Orya" typeface="Kalinga"/>
+        <a:font script="Mlym" typeface="Kartika"/>
+        <a:font script="Laoo" typeface="DokChampa"/>
+        <a:font script="Sinh" typeface="Iskoola Pota"/>
+        <a:font script="Mong" typeface="Mongolian Baiti"/>
+        <a:font script="Viet" typeface="Arial"/>
+        <a:font script="Uigh" typeface="Microsoft Uighur"/>
+        <a:font script="Geor" typeface="Sylfaen"/>
+      </a:minorFont>
+    </a:fontScheme>
+    <a:fmtScheme name="Office">
+      <a:fillStyleLst>
+        <a:solidFill>
+          <a:schemeClr val="phClr"/>
+        </a:solidFill>
+        <a:gradFill rotWithShape="1">
+          <a:gsLst>
+            <a:gs pos="0">
+              <a:schemeClr val="phClr">
+                <a:tint val="50000"/>
+                <a:satMod val="300000"/>
+              </a:schemeClr>
+            </a:gs>
+            <a:gs pos="35000">
+              <a:schemeClr val="phClr">
+                <a:tint val="37000"/>
+                <a:satMod val="300000"/>
+              </a:schemeClr>
+            </a:gs>
+            <a:gs pos="100000">
+              <a:schemeClr val="phClr">
+                <a:tint val="15000"/>
+                <a:satMod val="350000"/>
+              </a:schemeClr>
+            </a:gs>
+          </a:gsLst>
+          <a:lin ang="16200000" scaled="1"/>
+        </a:gradFill>
+        <a:gradFill rotWithShape="1">
+          <a:gsLst>
+            <a:gs pos="0">
+              <a:schemeClr val="phClr">
+                <a:tint val="100000"/>
+                <a:shade val="100000"/>
+                <a:satMod val="130000"/>
+              </a:schemeClr>
+            </a:gs>
+            <a:gs pos="100000">
+              <a:schemeClr val="phClr">
+                <a:tint val="50000"/>
+                <a:shade val="100000"/>
+                <a:satMod val="350000"/>
+              </a:schemeClr>
+            </a:gs>
+          </a:gsLst>
+          <a:lin ang="16200000" scaled="0"/>
+        </a:gradFill>
+      </a:fillStyleLst>
+      <a:lnStyleLst>
+        <a:ln w="9525" cap="flat" cmpd="sng" algn="ctr">
+          <a:solidFill>
+            <a:schemeClr val="phClr">
+              <a:shade val="95000"/>
+              <a:satMod val="105000"/>
+            </a:schemeClr>
+          </a:solidFill>
+          <a:prstDash val="solid"/>
+        </a:ln>
+        <a:ln w="25400" cap="flat" cmpd="sng" algn="ctr">
+          <a:solidFill>
+            <a:schemeClr val="phClr"/>
+          </a:solidFill>
+          <a:prstDash val="solid"/>
+        </a:ln>
+        <a:ln w="38100" cap="flat" cmpd="sng" algn="ctr">
+          <a:solidFill>
+            <a:schemeClr val="phClr"/>
+          </a:solidFill>
+          <a:prstDash val="solid"/>
+        </a:ln>
+      </a:lnStyleLst>
+      <a:effectStyleLst>
+        <a:effectStyle>
+          <a:effectLst>
+            <a:outerShdw blurRad="40000" dist="20000" dir="5400000" rotWithShape="0">
+              <a:srgbClr val="000000">
+                <a:alpha val="38000"/>
+              </a:srgbClr>
+            </a:outerShdw>
+          </a:effectLst>
+        </a:effectStyle>
+        <a:effectStyle>
+          <a:effectLst>
+            <a:outerShdw blurRad="40000" dist="23000" dir="5400000" rotWithShape="0">
+              <a:srgbClr val="000000">
+                <a:alpha val="35000"/>
+              </a:srgbClr>
+            </a:outerShdw>
+          </a:effectLst>
+        </a:effectStyle>
+        <a:effectStyle>
+          <a:effectLst>
+            <a:outerShdw blurRad="40000" dist="23000" dir="5400000" rotWithShape="0">
+              <a:srgbClr val="000000">
+                <a:alpha val="35000"/>
+              </a:srgbClr>
+            </a:outerShdw>
+          </a:effectLst>
+          <a:scene3d>
+            <a:camera prst="orthographicFront">
+              <a:rot lat="0" lon="0" rev="0"/>
+            </a:camera>
+            <a:lightRig rig="threePt" dir="t">
+              <a:rot lat="0" lon="0" rev="1200000"/>
+            </a:lightRig>
+          </a:scene3d>
+          <a:sp3d>
+            <a:bevelT w="63500" h="25400"/>
+          </a:sp3d>
+        </a:effectStyle>
+      </a:effectStyleLst>
+      <a:bgFillStyleLst>
+        <a:solidFill>
+          <a:schemeClr val="phClr"/>
+        </a:solidFill>
+        <a:gradFill rotWithShape="1">
+          <a:gsLst>
+            <a:gs pos="0">
+              <a:schemeClr val="phClr">
+                <a:tint val="40000"/>
+                <a:satMod val="350000"/>
+              </a:schemeClr>
+            </a:gs>
+            <a:gs pos="40000">
+              <a:schemeClr val="phClr">
+                <a:tint val="45000"/>
+                <a:shade val="99000"/>
+                <a:satMod val="350000"/>
+              </a:schemeClr>
+            </a:gs>
+            <a:gs pos="100000">
+              <a:schemeClr val="phClr">
+                <a:shade val="20000"/>
+                <a:satMod val="255000"/>
+              </a:schemeClr>
+            </a:gs>
+          </a:gsLst>
+          <a:path path="circle">
+            <a:fillToRect l="50000" t="-80000" r="50000" b="180000"/>
+          </a:path>
+        </a:gradFill>
+        <a:gradFill rotWithShape="1">
+          <a:gsLst>
+            <a:gs pos="0">
+              <a:schemeClr val="phClr">
+                <a:tint val="80000"/>
+                <a:satMod val="300000"/>
+              </a:schemeClr>
+            </a:gs>
+            <a:gs pos="100000">
+              <a:schemeClr val="phClr">
+                <a:shade val="30000"/>
+                <a:satMod val="200000"/>
+              </a:schemeClr>
+            </a:gs>
+          </a:gsLst>
+          <a:path path="circle">
+            <a:fillToRect l="50000" t="50000" r="50000" b="50000"/>
+          </a:path>
+        </a:gradFill>
+      </a:bgFillStyleLst>
+    </a:fmtScheme>
+  </a:themeElements>
+  <a:objectDefaults>
+    <a:spDef>
+      <a:spPr/>
+      <a:bodyPr/>
+      <a:lstStyle/>
+      <a:style>
+        <a:lnRef idx="1">
+          <a:schemeClr val="accent1"/>
+        </a:lnRef>
+        <a:fillRef idx="3">
+          <a:schemeClr val="accent1"/>
+        </a:fillRef>
+        <a:effectRef idx="2">
+          <a:schemeClr val="accent1"/>
+        </a:effectRef>
+        <a:fontRef idx="minor">
+          <a:schemeClr val="lt1"/>
+        </a:fontRef>
+      </a:style>
+    </a:spDef>
+    <a:lnDef>
+      <a:spPr/>
+      <a:bodyPr/>
+      <a:lstStyle/>
+      <a:style>
+        <a:lnRef idx="2">
+          <a:schemeClr val="accent1"/>
+        </a:lnRef>
+        <a:fillRef idx="0">
+          <a:schemeClr val="accent1"/>
+        </a:fillRef>
+        <a:effectRef idx="1">
+          <a:schemeClr val="accent1"/>
+        </a:effectRef>
+        <a:fontRef idx="minor">
+          <a:schemeClr val="tx1"/>
+        </a:fontRef>
+      </a:style>
+    </a:lnDef>
+  </a:objectDefaults>
+  <a:extraClrSchemeLst/>
+</a:theme>
 </file>
</xml_diff>

<commit_message>
Add Controller structure and core-logic slides
</commit_message>
<xml_diff>
--- a/docs/AI_Agent_Loop.pptx
+++ b/docs/AI_Agent_Loop.pptx
@@ -11,6 +11,8 @@
     <p:sldId id="259" r:id="rId10"/>
     <p:sldId id="260" r:id="rId11"/>
     <p:sldId id="261" r:id="rId12"/>
+    <p:sldId id="270" r:id="rId22"/>
+    <p:sldId id="271" r:id="rId23"/>
     <p:sldId id="262" r:id="rId13"/>
     <p:sldId id="267" r:id="rId18"/>
     <p:sldId id="268" r:id="rId20"/>
@@ -656,6 +658,146 @@
           <a:p>
             <a:r>
               <a:t>모든 판정과 변경은 .loop/에 남는다 (docs/captures/loop-inject-fault/). 가드레일 검증: 에이전트가 테스트 파일을 바꾸는 상황을 시뮬레이션하자 Controller가 복원하고 GUARDRAIL_STOP(exit 3)으로 종료했다. 단, 이 검사는 보안 샌드박스가 아니다.</a:t>
+            </a:r>
+          </a:p>
+        </p:txBody>
+      </p:sp>
+      <p:sp>
+        <p:nvSpPr>
+          <p:cNvPr id="4" name="Slide Number Placeholder 3"/>
+          <p:cNvSpPr>
+            <a:spLocks noGrp="1"/>
+          </p:cNvSpPr>
+          <p:nvPr>
+            <p:ph type="sldNum" idx="5" sz="quarter"/>
+          </p:nvPr>
+        </p:nvSpPr>
+        <p:spPr/>
+      </p:sp>
+    </p:spTree>
+  </p:cSld>
+  <p:clrMapOvr>
+    <a:masterClrMapping/>
+  </p:clrMapOvr>
+</p:notes>
+</file>
+
+<file path=ppt/notesSlides/notesSlide4.xml><?xml version="1.0" encoding="utf-8"?>
+<p:notes xmlns:a="http://schemas.openxmlformats.org/drawingml/2006/main" xmlns:p="http://schemas.openxmlformats.org/presentationml/2006/main" xmlns:r="http://schemas.openxmlformats.org/officeDocument/2006/relationships">
+  <p:cSld>
+    <p:spTree>
+      <p:nvGrpSpPr>
+        <p:cNvPr id="1" name=""/>
+        <p:cNvGrpSpPr/>
+        <p:nvPr/>
+      </p:nvGrpSpPr>
+      <p:grpSpPr>
+        <a:xfrm>
+          <a:off x="0" y="0"/>
+          <a:ext cx="0" cy="0"/>
+          <a:chOff x="0" y="0"/>
+          <a:chExt cx="0" cy="0"/>
+        </a:xfrm>
+      </p:grpSpPr>
+      <p:sp>
+        <p:nvSpPr>
+          <p:cNvPr id="2" name="Slide Image Placeholder 1"/>
+          <p:cNvSpPr>
+            <a:spLocks noGrp="1"/>
+          </p:cNvSpPr>
+          <p:nvPr>
+            <p:ph type="sldImg" idx="2"/>
+          </p:nvPr>
+        </p:nvSpPr>
+        <p:spPr/>
+      </p:sp>
+      <p:sp>
+        <p:nvSpPr>
+          <p:cNvPr id="3" name="Notes Placeholder 2"/>
+          <p:cNvSpPr>
+            <a:spLocks noGrp="1"/>
+          </p:cNvSpPr>
+          <p:nvPr>
+            <p:ph type="body" idx="3" sz="quarter"/>
+          </p:nvPr>
+        </p:nvSpPr>
+        <p:spPr/>
+        <p:txBody>
+          <a:bodyPr/>
+          <a:lstStyle/>
+          <a:p>
+            <a:r>
+              <a:t>Controller는 코드를 고치지 않는다. 일을 맡기고(②), 검수하고(③④), 다시 시킬지 끝낼지 정한다(⑤). 사람이 하던 "테스트 돌려보고 틀렸으면 다시 시키기"를 프로그램으로 만든 것. CI가 PR마다 테스트를 돌리는 것과 같고, 차이는 실패하면 AI를 다시 부른다는 점. Controller는 AI가 아니라 일반 if문이다 — 그래서 믿을 수 있다. 보라색 ②만 AI(Kiro)이고, 그 안에서 Kiro 자체의 Inner Loop(읽기→수정→답변)가 돈다.</a:t>
+            </a:r>
+          </a:p>
+        </p:txBody>
+      </p:sp>
+      <p:sp>
+        <p:nvSpPr>
+          <p:cNvPr id="4" name="Slide Number Placeholder 3"/>
+          <p:cNvSpPr>
+            <a:spLocks noGrp="1"/>
+          </p:cNvSpPr>
+          <p:nvPr>
+            <p:ph type="sldNum" idx="5" sz="quarter"/>
+          </p:nvPr>
+        </p:nvSpPr>
+        <p:spPr/>
+      </p:sp>
+    </p:spTree>
+  </p:cSld>
+  <p:clrMapOvr>
+    <a:masterClrMapping/>
+  </p:clrMapOvr>
+</p:notes>
+</file>
+
+<file path=ppt/notesSlides/notesSlide5.xml><?xml version="1.0" encoding="utf-8"?>
+<p:notes xmlns:a="http://schemas.openxmlformats.org/drawingml/2006/main" xmlns:p="http://schemas.openxmlformats.org/presentationml/2006/main" xmlns:r="http://schemas.openxmlformats.org/officeDocument/2006/relationships">
+  <p:cSld>
+    <p:spTree>
+      <p:nvGrpSpPr>
+        <p:cNvPr id="1" name=""/>
+        <p:cNvGrpSpPr/>
+        <p:nvPr/>
+      </p:nvGrpSpPr>
+      <p:grpSpPr>
+        <a:xfrm>
+          <a:off x="0" y="0"/>
+          <a:ext cx="0" cy="0"/>
+          <a:chOff x="0" y="0"/>
+          <a:chExt cx="0" cy="0"/>
+        </a:xfrm>
+      </p:grpSpPr>
+      <p:sp>
+        <p:nvSpPr>
+          <p:cNvPr id="2" name="Slide Image Placeholder 1"/>
+          <p:cNvSpPr>
+            <a:spLocks noGrp="1"/>
+          </p:cNvSpPr>
+          <p:nvPr>
+            <p:ph type="sldImg" idx="2"/>
+          </p:nvPr>
+        </p:nvSpPr>
+        <p:spPr/>
+      </p:sp>
+      <p:sp>
+        <p:nvSpPr>
+          <p:cNvPr id="3" name="Notes Placeholder 2"/>
+          <p:cNvSpPr>
+            <a:spLocks noGrp="1"/>
+          </p:cNvSpPr>
+          <p:nvPr>
+            <p:ph type="body" idx="3" sz="quarter"/>
+          </p:nvPr>
+        </p:nvSpPr>
+        <p:spPr/>
+        <p:txBody>
+          <a:bodyPr/>
+          <a:lstStyle/>
+          <a:p>
+            <a:r>
+              <a:t>실제 loop.py는 로그·출력·기록 코드 포함 약 250줄이지만 반복의 뼈대는 이것뿐이다. 중요한 줄은 ④: Kiro가 무엇을 말했든 qa_gate()의 결과만으로 판정한다. 종료 경로는 PASS / GUARDRAIL_STOP / AGENT_ERROR / MAX_ITERATIONS 네 가지이며 모두 Controller가 결정한다.</a:t>
             </a:r>
           </a:p>
         </p:txBody>
@@ -3826,7 +3968,7 @@
                   <a:srgbClr val="8397AB"/>
                 </a:solidFill>
               </a:rPr>
-              <a:t>AI Agent Loop · 2026.10.21                                     01 / 14</a:t>
+              <a:t>AI Agent Loop · 2026.10.21                                     01 / 16</a:t>
             </a:r>
           </a:p>
         </p:txBody>
@@ -3917,7 +4059,7 @@
           <a:noFill/>
         </p:spPr>
         <p:txBody>
-          <a:bodyPr wrap="none">
+          <a:bodyPr wrap="square">
             <a:spAutoFit/>
           </a:bodyPr>
           <a:lstStyle/>
@@ -3928,7 +4070,7 @@
                   <a:srgbClr val="F5F8FD"/>
                 </a:solidFill>
               </a:rPr>
-              <a:t>우리 팀에서 어디에 쓸까?</a:t>
+              <a:t>실제 실행 ①: Kiro가 1회에 해결</a:t>
             </a:r>
           </a:p>
         </p:txBody>
@@ -3941,8 +4083,8 @@
         </p:nvSpPr>
         <p:spPr>
           <a:xfrm>
-            <a:off x="868680" y="1691640"/>
-            <a:ext cx="10515600" cy="4480560"/>
+            <a:off x="868680" y="6492240"/>
+            <a:ext cx="10515600" cy="201168"/>
           </a:xfrm>
           <a:prstGeom prst="rect">
             <a:avLst/>
@@ -3955,77 +4097,72 @@
           </a:bodyPr>
           <a:lstStyle/>
           <a:p>
-            <a:pPr>
-              <a:spcAft>
-                <a:spcPts val="1700"/>
-              </a:spcAft>
-            </a:pPr>
-            <a:r>
-              <a:rPr sz="2200">
-                <a:solidFill>
-                  <a:srgbClr val="CFDEEB"/>
-                </a:solidFill>
-              </a:rPr>
-              <a:t>API 테스트 자동 생성 및 실패 복구 제안</a:t>
-            </a:r>
-          </a:p>
-          <a:p>
-            <a:pPr>
-              <a:spcAft>
-                <a:spcPts val="1700"/>
-              </a:spcAft>
-            </a:pPr>
-            <a:r>
-              <a:rPr sz="2200">
-                <a:solidFill>
-                  <a:srgbClr val="CFDEEB"/>
-                </a:solidFill>
-              </a:rPr>
-              <a:t>CI 실패 원인 분석 → 수정 PR 초안</a:t>
-            </a:r>
-          </a:p>
-          <a:p>
-            <a:pPr>
-              <a:spcAft>
-                <a:spcPts val="1700"/>
-              </a:spcAft>
-            </a:pPr>
-            <a:r>
-              <a:rPr sz="2200">
-                <a:solidFill>
-                  <a:srgbClr val="CFDEEB"/>
-                </a:solidFill>
-              </a:rPr>
-              <a:t>SonarQube 이슈 수정 → 스캔 → 재검증</a:t>
-            </a:r>
-          </a:p>
-          <a:p>
-            <a:pPr>
-              <a:spcAft>
-                <a:spcPts val="1700"/>
-              </a:spcAft>
-            </a:pPr>
-            <a:r>
-              <a:rPr sz="2200">
-                <a:solidFill>
-                  <a:srgbClr val="CFDEEB"/>
-                </a:solidFill>
-              </a:rPr>
-              <a:t>단, 테스트 기준 변경과 배포는 사람이 승인</a:t>
-            </a:r>
-          </a:p>
-        </p:txBody>
-      </p:sp>
-      <p:sp>
-        <p:nvSpPr>
-          <p:cNvPr id="5" name="TextBox 4"/>
+            <a:r>
+              <a:rPr sz="1000" b="0">
+                <a:solidFill>
+                  <a:srgbClr val="8397AB"/>
+                </a:solidFill>
+              </a:rPr>
+              <a:t>AI Agent Loop · 2026.10.21                                     10 / 16</a:t>
+            </a:r>
+          </a:p>
+        </p:txBody>
+      </p:sp>
+      <p:sp>
+        <p:nvSpPr>
+          <p:cNvPr id="5" name="Rounded Rectangle 4"/>
+          <p:cNvSpPr/>
+          <p:nvPr/>
+        </p:nvSpPr>
+        <p:spPr>
+          <a:xfrm>
+            <a:off x="868680" y="1463040"/>
+            <a:ext cx="10515600" cy="3840480"/>
+          </a:xfrm>
+          <a:prstGeom prst="roundRect">
+            <a:avLst>
+              <a:gd name="adj" fmla="val 3000"/>
+            </a:avLst>
+          </a:prstGeom>
+          <a:solidFill>
+            <a:srgbClr val="050A12"/>
+          </a:solidFill>
+          <a:ln>
+            <a:solidFill>
+              <a:srgbClr val="2A3B52"/>
+            </a:solidFill>
+          </a:ln>
+        </p:spPr>
+        <p:style>
+          <a:lnRef idx="1">
+            <a:schemeClr val="accent1"/>
+          </a:lnRef>
+          <a:fillRef idx="3">
+            <a:schemeClr val="accent1"/>
+          </a:fillRef>
+          <a:effectRef idx="2">
+            <a:schemeClr val="accent1"/>
+          </a:effectRef>
+          <a:fontRef idx="minor">
+            <a:schemeClr val="lt1"/>
+          </a:fontRef>
+        </p:style>
+        <p:txBody>
+          <a:bodyPr rtlCol="0" anchor="ctr"/>
+          <a:lstStyle/>
+          <a:p/>
+        </p:txBody>
+      </p:sp>
+      <p:sp>
+        <p:nvSpPr>
+          <p:cNvPr id="6" name="TextBox 5"/>
           <p:cNvSpPr txBox="1"/>
           <p:nvPr/>
         </p:nvSpPr>
         <p:spPr>
           <a:xfrm>
-            <a:off x="868680" y="6492240"/>
-            <a:ext cx="10515600" cy="201168"/>
+            <a:off x="1051560" y="1554480"/>
+            <a:ext cx="10149840" cy="3657600"/>
           </a:xfrm>
           <a:prstGeom prst="rect">
             <a:avLst/>
@@ -4033,18 +4170,161 @@
           <a:noFill/>
         </p:spPr>
         <p:txBody>
-          <a:bodyPr wrap="none">
+          <a:bodyPr wrap="square">
             <a:spAutoFit/>
           </a:bodyPr>
           <a:lstStyle/>
           <a:p>
             <a:r>
-              <a:rPr sz="1000">
+              <a:rPr sz="1300" b="0">
+                <a:solidFill>
+                  <a:srgbClr val="31D3B1"/>
+                </a:solidFill>
+                <a:latin typeface="Menlo"/>
+                <a:ea typeface="Apple SD Gothic Neo"/>
+              </a:rPr>
+              <a:t>$ python3 loop.py --provider kiro --reset</a:t>
+            </a:r>
+          </a:p>
+          <a:p>
+            <a:r>
+              <a:rPr sz="1300" b="0">
+                <a:solidFill>
+                  <a:srgbClr val="FF6B6B"/>
+                </a:solidFill>
+                <a:latin typeface="Menlo"/>
+                <a:ea typeface="Apple SD Gothic Neo"/>
+              </a:rPr>
+              <a:t>[QA GATE] initial: FAIL</a:t>
+            </a:r>
+          </a:p>
+          <a:p>
+            <a:r>
+              <a:rPr sz="1300" b="0">
+                <a:solidFill>
+                  <a:srgbClr val="CFDEEB"/>
+                </a:solidFill>
+                <a:latin typeface="Menlo"/>
+                <a:ea typeface="Apple SD Gothic Neo"/>
+              </a:rPr>
+              <a:t>  AssertionError: Expected IllegalArgumentException for rate=-1</a:t>
+            </a:r>
+          </a:p>
+          <a:p>
+            <a:r>
+              <a:rPr sz="1300" b="0">
+                <a:solidFill>
+                  <a:srgbClr val="31D3B1"/>
+                </a:solidFill>
+                <a:latin typeface="Menlo"/>
+                <a:ea typeface="Apple SD Gothic Neo"/>
+              </a:rPr>
+              <a:t>[LOOP 1/5] starting NEW kiro session (no human input)</a:t>
+            </a:r>
+          </a:p>
+          <a:p>
+            <a:r>
+              <a:rPr sz="1300" b="0">
                 <a:solidFill>
                   <a:srgbClr val="8397AB"/>
                 </a:solidFill>
-              </a:rPr>
-              <a:t>AI Agent Loop · 2026.10.21                                     13 / 14</a:t>
+                <a:latin typeface="Menlo"/>
+                <a:ea typeface="Apple SD Gothic Neo"/>
+              </a:rPr>
+              <a:t>  │ [tool] Reading DiscountCalculator.java, DiscountTest.java</a:t>
+            </a:r>
+          </a:p>
+          <a:p>
+            <a:r>
+              <a:rPr sz="1300" b="0">
+                <a:solidFill>
+                  <a:srgbClr val="8397AB"/>
+                </a:solidFill>
+                <a:latin typeface="Menlo"/>
+                <a:ea typeface="Apple SD Gothic Neo"/>
+              </a:rPr>
+              <a:t>  │ [tool] Editing DiscountCalculator.java</a:t>
+            </a:r>
+          </a:p>
+          <a:p>
+            <a:r>
+              <a:rPr sz="1300" b="0">
+                <a:solidFill>
+                  <a:srgbClr val="8397AB"/>
+                </a:solidFill>
+                <a:latin typeface="Menlo"/>
+                <a:ea typeface="Apple SD Gothic Neo"/>
+              </a:rPr>
+              <a:t>  │ Added guards ... rate outside [0,100] or price is negative</a:t>
+            </a:r>
+          </a:p>
+          <a:p>
+            <a:r>
+              <a:rPr sz="1300" b="0">
+                <a:solidFill>
+                  <a:srgbClr val="8397AB"/>
+                </a:solidFill>
+                <a:latin typeface="Menlo"/>
+                <a:ea typeface="Apple SD Gothic Neo"/>
+              </a:rPr>
+              <a:t>  [AGENT] session ended: exit=0 (17.4s). Agent claim is NOT trusted</a:t>
+            </a:r>
+          </a:p>
+          <a:p>
+            <a:r>
+              <a:rPr sz="1300" b="0">
+                <a:solidFill>
+                  <a:srgbClr val="4ADE80"/>
+                </a:solidFill>
+                <a:latin typeface="Menlo"/>
+                <a:ea typeface="Apple SD Gothic Neo"/>
+              </a:rPr>
+              <a:t>[QA GATE] PASS   ALL TESTS PASSED</a:t>
+            </a:r>
+          </a:p>
+          <a:p>
+            <a:r>
+              <a:rPr sz="1300" b="0">
+                <a:solidFill>
+                  <a:srgbClr val="4ADE80"/>
+                </a:solidFill>
+                <a:latin typeface="Menlo"/>
+                <a:ea typeface="Apple SD Gothic Neo"/>
+              </a:rPr>
+              <a:t>SUCCESS: QA Gate passed on iteration 1. Controller stops the loop.</a:t>
+            </a:r>
+          </a:p>
+        </p:txBody>
+      </p:sp>
+      <p:sp>
+        <p:nvSpPr>
+          <p:cNvPr id="7" name="TextBox 6"/>
+          <p:cNvSpPr txBox="1"/>
+          <p:nvPr/>
+        </p:nvSpPr>
+        <p:spPr>
+          <a:xfrm>
+            <a:off x="868680" y="5440680"/>
+            <a:ext cx="10515600" cy="822960"/>
+          </a:xfrm>
+          <a:prstGeom prst="rect">
+            <a:avLst/>
+          </a:prstGeom>
+          <a:noFill/>
+        </p:spPr>
+        <p:txBody>
+          <a:bodyPr wrap="square">
+            <a:spAutoFit/>
+          </a:bodyPr>
+          <a:lstStyle/>
+          <a:p>
+            <a:r>
+              <a:rPr sz="1800" b="0">
+                <a:solidFill>
+                  <a:srgbClr val="CFDEEB"/>
+                </a:solidFill>
+              </a:rPr>
+              <a:t>쉬운 목표는 1회에 끝나는 게 정상 — 그래도 "완료"는 Kiro가 아니라 QA Gate가 승인했다</a:t>
             </a:r>
           </a:p>
         </p:txBody>
@@ -4135,7 +4415,7 @@
           <a:noFill/>
         </p:spPr>
         <p:txBody>
-          <a:bodyPr wrap="none">
+          <a:bodyPr wrap="square">
             <a:spAutoFit/>
           </a:bodyPr>
           <a:lstStyle/>
@@ -4146,7 +4426,7 @@
                   <a:srgbClr val="F5F8FD"/>
                 </a:solidFill>
               </a:rPr>
-              <a:t>핵심 메시지 &amp; Q&amp;A</a:t>
+              <a:t>실제 실행 ②: QA FAIL → 새 세션 자동 실행</a:t>
             </a:r>
           </a:p>
         </p:txBody>
@@ -4159,8 +4439,8 @@
         </p:nvSpPr>
         <p:spPr>
           <a:xfrm>
-            <a:off x="868680" y="1691640"/>
-            <a:ext cx="10515600" cy="4480560"/>
+            <a:off x="868680" y="6492240"/>
+            <a:ext cx="10515600" cy="201168"/>
           </a:xfrm>
           <a:prstGeom prst="rect">
             <a:avLst/>
@@ -4173,84 +4453,72 @@
           </a:bodyPr>
           <a:lstStyle/>
           <a:p>
-            <a:pPr>
-              <a:spcAft>
-                <a:spcPts val="1700"/>
-              </a:spcAft>
-            </a:pPr>
-            <a:r>
-              <a:rPr sz="2200">
-                <a:solidFill>
-                  <a:srgbClr val="CFDEEB"/>
-                </a:solidFill>
-              </a:rPr>
-              <a:t>Loop = AI를 계속 돌리는 기술이 아니라</a:t>
-            </a:r>
-          </a:p>
-          <a:p>
-            <a:pPr>
-              <a:spcAft>
-                <a:spcPts val="1700"/>
-              </a:spcAft>
-            </a:pPr>
-            <a:r>
-              <a:rPr sz="2200">
-                <a:solidFill>
-                  <a:srgbClr val="CFDEEB"/>
-                </a:solidFill>
-              </a:rPr>
-              <a:t>“목표 → 실행 → 독립 검증 → 피드백”을</a:t>
-            </a:r>
-          </a:p>
-          <a:p>
-            <a:pPr>
-              <a:spcAft>
-                <a:spcPts val="1700"/>
-              </a:spcAft>
-            </a:pPr>
-            <a:r>
-              <a:rPr sz="2200">
-                <a:solidFill>
-                  <a:srgbClr val="CFDEEB"/>
-                </a:solidFill>
-              </a:rPr>
-              <a:t>통제 가능한 시스템으로 만드는 방법</a:t>
-            </a:r>
-          </a:p>
-          <a:p>
-            <a:pPr>
-              <a:spcAft>
-                <a:spcPts val="1700"/>
-              </a:spcAft>
-            </a:pPr>
-          </a:p>
-          <a:p>
-            <a:pPr>
-              <a:spcAft>
-                <a:spcPts val="1700"/>
-              </a:spcAft>
-            </a:pPr>
-            <a:r>
-              <a:rPr sz="2200">
-                <a:solidFill>
-                  <a:srgbClr val="CFDEEB"/>
-                </a:solidFill>
-              </a:rPr>
-              <a:t>질문: 우리 팀의 어떤 작업을 먼저 Loop로 만들까?</a:t>
-            </a:r>
-          </a:p>
-        </p:txBody>
-      </p:sp>
-      <p:sp>
-        <p:nvSpPr>
-          <p:cNvPr id="5" name="TextBox 4"/>
+            <a:r>
+              <a:rPr sz="1000" b="0">
+                <a:solidFill>
+                  <a:srgbClr val="8397AB"/>
+                </a:solidFill>
+              </a:rPr>
+              <a:t>AI Agent Loop · 2026.10.21                                     11 / 16</a:t>
+            </a:r>
+          </a:p>
+        </p:txBody>
+      </p:sp>
+      <p:sp>
+        <p:nvSpPr>
+          <p:cNvPr id="5" name="Rounded Rectangle 4"/>
+          <p:cNvSpPr/>
+          <p:nvPr/>
+        </p:nvSpPr>
+        <p:spPr>
+          <a:xfrm>
+            <a:off x="868680" y="1371600"/>
+            <a:ext cx="10515600" cy="4206240"/>
+          </a:xfrm>
+          <a:prstGeom prst="roundRect">
+            <a:avLst>
+              <a:gd name="adj" fmla="val 3000"/>
+            </a:avLst>
+          </a:prstGeom>
+          <a:solidFill>
+            <a:srgbClr val="050A12"/>
+          </a:solidFill>
+          <a:ln>
+            <a:solidFill>
+              <a:srgbClr val="2A3B52"/>
+            </a:solidFill>
+          </a:ln>
+        </p:spPr>
+        <p:style>
+          <a:lnRef idx="1">
+            <a:schemeClr val="accent1"/>
+          </a:lnRef>
+          <a:fillRef idx="3">
+            <a:schemeClr val="accent1"/>
+          </a:fillRef>
+          <a:effectRef idx="2">
+            <a:schemeClr val="accent1"/>
+          </a:effectRef>
+          <a:fontRef idx="minor">
+            <a:schemeClr val="lt1"/>
+          </a:fontRef>
+        </p:style>
+        <p:txBody>
+          <a:bodyPr rtlCol="0" anchor="ctr"/>
+          <a:lstStyle/>
+          <a:p/>
+        </p:txBody>
+      </p:sp>
+      <p:sp>
+        <p:nvSpPr>
+          <p:cNvPr id="6" name="TextBox 5"/>
           <p:cNvSpPr txBox="1"/>
           <p:nvPr/>
         </p:nvSpPr>
         <p:spPr>
           <a:xfrm>
-            <a:off x="868680" y="6492240"/>
-            <a:ext cx="10515600" cy="201168"/>
+            <a:off x="1051560" y="1463040"/>
+            <a:ext cx="10149840" cy="4023360"/>
           </a:xfrm>
           <a:prstGeom prst="rect">
             <a:avLst/>
@@ -4258,18 +4526,185 @@
           <a:noFill/>
         </p:spPr>
         <p:txBody>
-          <a:bodyPr wrap="none">
+          <a:bodyPr wrap="square">
             <a:spAutoFit/>
           </a:bodyPr>
           <a:lstStyle/>
           <a:p>
             <a:r>
-              <a:rPr sz="1000">
+              <a:rPr sz="1200" b="0">
+                <a:solidFill>
+                  <a:srgbClr val="31D3B1"/>
+                </a:solidFill>
+                <a:latin typeface="Menlo"/>
+                <a:ea typeface="Apple SD Gothic Neo"/>
+              </a:rPr>
+              <a:t>$ python3 loop.py --provider kiro --reset --inject-fault</a:t>
+            </a:r>
+          </a:p>
+          <a:p>
+            <a:r>
+              <a:rPr sz="1200" b="0">
+                <a:solidFill>
+                  <a:srgbClr val="31D3B1"/>
+                </a:solidFill>
+                <a:latin typeface="Menlo"/>
+                <a:ea typeface="Apple SD Gothic Neo"/>
+              </a:rPr>
+              <a:t>[LOOP 1/5] starting NEW kiro session (no human input)</a:t>
+            </a:r>
+          </a:p>
+          <a:p>
+            <a:r>
+              <a:rPr sz="1200" b="0">
                 <a:solidFill>
                   <a:srgbClr val="8397AB"/>
                 </a:solidFill>
-              </a:rPr>
-              <a:t>AI Agent Loop · 2026.10.21                                     14 / 14</a:t>
+                <a:latin typeface="Menlo"/>
+                <a:ea typeface="Apple SD Gothic Neo"/>
+              </a:rPr>
+              <a:t>  │ [tool] Editing DiscountCalculator.java     (16.5s, exit=0)</a:t>
+            </a:r>
+          </a:p>
+          <a:p>
+            <a:r>
+              <a:rPr sz="1200" b="0">
+                <a:solidFill>
+                  <a:srgbClr val="FACC15"/>
+                </a:solidFill>
+                <a:latin typeface="Menlo"/>
+                <a:ea typeface="Apple SD Gothic Neo"/>
+              </a:rPr>
+              <a:t>[FAULT INJECTION] controller removed price validation (NOT the AI's)</a:t>
+            </a:r>
+          </a:p>
+          <a:p>
+            <a:r>
+              <a:rPr sz="1200" b="0">
+                <a:solidFill>
+                  <a:srgbClr val="FF6B6B"/>
+                </a:solidFill>
+                <a:latin typeface="Menlo"/>
+                <a:ea typeface="Apple SD Gothic Neo"/>
+              </a:rPr>
+              <a:t>[QA GATE] FAIL</a:t>
+            </a:r>
+          </a:p>
+          <a:p>
+            <a:r>
+              <a:rPr sz="1200" b="0">
+                <a:solidFill>
+                  <a:srgbClr val="CFDEEB"/>
+                </a:solidFill>
+                <a:latin typeface="Menlo"/>
+                <a:ea typeface="Apple SD Gothic Neo"/>
+              </a:rPr>
+              <a:t>  AssertionError: Expected IllegalArgumentException for price=-1</a:t>
+            </a:r>
+          </a:p>
+          <a:p>
+            <a:r>
+              <a:rPr sz="1200" b="0">
+                <a:solidFill>
+                  <a:srgbClr val="31D3B1"/>
+                </a:solidFill>
+                <a:latin typeface="Menlo"/>
+                <a:ea typeface="Apple SD Gothic Neo"/>
+              </a:rPr>
+              <a:t>[LOOP] QA failed -&gt; feeding failure log into a NEW session</a:t>
+            </a:r>
+          </a:p>
+          <a:p>
+            <a:r>
+              <a:rPr sz="1200" b="0">
+                <a:solidFill>
+                  <a:srgbClr val="31D3B1"/>
+                </a:solidFill>
+                <a:latin typeface="Menlo"/>
+                <a:ea typeface="Apple SD Gothic Neo"/>
+              </a:rPr>
+              <a:t>[LOOP 2/5] starting NEW kiro session (no human input)</a:t>
+            </a:r>
+          </a:p>
+          <a:p>
+            <a:r>
+              <a:rPr sz="1200" b="0">
+                <a:solidFill>
+                  <a:srgbClr val="8397AB"/>
+                </a:solidFill>
+                <a:latin typeface="Menlo"/>
+                <a:ea typeface="Apple SD Gothic Neo"/>
+              </a:rPr>
+              <a:t>  │ The fix is to add price validation. I'll add a check for price &lt; 0</a:t>
+            </a:r>
+          </a:p>
+          <a:p>
+            <a:r>
+              <a:rPr sz="1200" b="0">
+                <a:solidFill>
+                  <a:srgbClr val="8397AB"/>
+                </a:solidFill>
+                <a:latin typeface="Menlo"/>
+                <a:ea typeface="Apple SD Gothic Neo"/>
+              </a:rPr>
+              <a:t>  │ [tool] Editing DiscountCalculator.java     (17.2s, exit=0)</a:t>
+            </a:r>
+          </a:p>
+          <a:p>
+            <a:r>
+              <a:rPr sz="1200" b="0">
+                <a:solidFill>
+                  <a:srgbClr val="4ADE80"/>
+                </a:solidFill>
+                <a:latin typeface="Menlo"/>
+                <a:ea typeface="Apple SD Gothic Neo"/>
+              </a:rPr>
+              <a:t>[QA GATE] PASS   ALL TESTS PASSED</a:t>
+            </a:r>
+          </a:p>
+          <a:p>
+            <a:r>
+              <a:rPr sz="1200" b="0">
+                <a:solidFill>
+                  <a:srgbClr val="FF6B6B"/>
+                </a:solidFill>
+                <a:latin typeface="Menlo"/>
+                <a:ea typeface="Apple SD Gothic Neo"/>
+              </a:rPr>
+              <a:t>RESULT=PASS  iterations=2   loop 1: FAIL (fault injected) / loop 2: PASS</a:t>
+            </a:r>
+          </a:p>
+        </p:txBody>
+      </p:sp>
+      <p:sp>
+        <p:nvSpPr>
+          <p:cNvPr id="7" name="TextBox 6"/>
+          <p:cNvSpPr txBox="1"/>
+          <p:nvPr/>
+        </p:nvSpPr>
+        <p:spPr>
+          <a:xfrm>
+            <a:off x="868680" y="5669280"/>
+            <a:ext cx="10515600" cy="640080"/>
+          </a:xfrm>
+          <a:prstGeom prst="rect">
+            <a:avLst/>
+          </a:prstGeom>
+          <a:noFill/>
+        </p:spPr>
+        <p:txBody>
+          <a:bodyPr wrap="square">
+            <a:spAutoFit/>
+          </a:bodyPr>
+          <a:lstStyle/>
+          <a:p>
+            <a:r>
+              <a:rPr sz="1600" b="0">
+                <a:solidFill>
+                  <a:srgbClr val="FACC15"/>
+                </a:solidFill>
+              </a:rPr>
+              <a:t>※ 1회차 실패는 Controller가 의도적으로 주입한 것 (AI 실패 아님)</a:t>
             </a:r>
           </a:p>
         </p:txBody>
@@ -4371,7 +4806,7 @@
                   <a:srgbClr val="F5F8FD"/>
                 </a:solidFill>
               </a:rPr>
-              <a:t>실제 실행 ①: Kiro가 1회에 해결</a:t>
+              <a:t>증거: Controller가 남긴 기록</a:t>
             </a:r>
           </a:p>
         </p:txBody>
@@ -4404,21 +4839,124 @@
                   <a:srgbClr val="8397AB"/>
                 </a:solidFill>
               </a:rPr>
-              <a:t>AI Agent Loop · 2026.10.21                                     08 / 14</a:t>
-            </a:r>
-          </a:p>
-        </p:txBody>
-      </p:sp>
-      <p:sp>
-        <p:nvSpPr>
-          <p:cNvPr id="5" name="Rounded Rectangle 4"/>
+              <a:t>AI Agent Loop · 2026.10.21                                     12 / 16</a:t>
+            </a:r>
+          </a:p>
+        </p:txBody>
+      </p:sp>
+      <p:sp>
+        <p:nvSpPr>
+          <p:cNvPr id="5" name="TextBox 4"/>
+          <p:cNvSpPr txBox="1"/>
+          <p:nvPr/>
+        </p:nvSpPr>
+        <p:spPr>
+          <a:xfrm>
+            <a:off x="868680" y="1463040"/>
+            <a:ext cx="4754880" cy="3840480"/>
+          </a:xfrm>
+          <a:prstGeom prst="rect">
+            <a:avLst/>
+          </a:prstGeom>
+          <a:noFill/>
+        </p:spPr>
+        <p:txBody>
+          <a:bodyPr wrap="square">
+            <a:spAutoFit/>
+          </a:bodyPr>
+          <a:lstStyle/>
+          <a:p>
+            <a:r>
+              <a:rPr sz="1800" b="0">
+                <a:solidFill>
+                  <a:srgbClr val="CFDEEB"/>
+                </a:solidFill>
+              </a:rPr>
+              <a:t>.loop/summary.json — 결과·반복 횟수</a:t>
+            </a:r>
+          </a:p>
+          <a:p>
+            <a:r>
+              <a:rPr sz="1800" b="0">
+                <a:solidFill>
+                  <a:srgbClr val="CFDEEB"/>
+                </a:solidFill>
+              </a:rPr>
+              <a:t>iteration-NN.json — 회차별 QA 출력</a:t>
+            </a:r>
+          </a:p>
+          <a:p>
+            <a:r>
+              <a:rPr sz="1800" b="0">
+                <a:solidFill>
+                  <a:srgbClr val="CFDEEB"/>
+                </a:solidFill>
+              </a:rPr>
+              <a:t>agent-NN.log — Kiro 세션 전체 로그</a:t>
+            </a:r>
+          </a:p>
+          <a:p>
+            <a:r>
+              <a:rPr sz="1800" b="0">
+                <a:solidFill>
+                  <a:srgbClr val="CFDEEB"/>
+                </a:solidFill>
+              </a:rPr>
+              <a:t>diff-NN.patch — AI가 바꾼 코드</a:t>
+            </a:r>
+          </a:p>
+          <a:p>
+            <a:r>
+              <a:rPr sz="1800" b="0">
+                <a:solidFill>
+                  <a:srgbClr val="CFDEEB"/>
+                </a:solidFill>
+              </a:rPr>
+              <a:t/>
+            </a:r>
+          </a:p>
+          <a:p>
+            <a:r>
+              <a:rPr sz="1800" b="0">
+                <a:solidFill>
+                  <a:srgbClr val="31D3B1"/>
+                </a:solidFill>
+              </a:rPr>
+              <a:t>보호 파일 변조 시뮬레이션</a:t>
+            </a:r>
+          </a:p>
+          <a:p>
+            <a:r>
+              <a:rPr sz="1800" b="0">
+                <a:solidFill>
+                  <a:srgbClr val="CFDEEB"/>
+                </a:solidFill>
+              </a:rPr>
+              <a:t>→ 자동 복원 + GUARDRAIL_STOP</a:t>
+            </a:r>
+          </a:p>
+          <a:p>
+            <a:r>
+              <a:rPr sz="1800" b="0">
+                <a:solidFill>
+                  <a:srgbClr val="CFDEEB"/>
+                </a:solidFill>
+              </a:rPr>
+              <a:t>셸 도구 요청 → 비대화형 모드에서 거부</a:t>
+            </a:r>
+          </a:p>
+        </p:txBody>
+      </p:sp>
+      <p:sp>
+        <p:nvSpPr>
+          <p:cNvPr id="6" name="Rounded Rectangle 5"/>
           <p:cNvSpPr/>
           <p:nvPr/>
         </p:nvSpPr>
         <p:spPr>
           <a:xfrm>
-            <a:off x="868680" y="1463040"/>
-            <a:ext cx="10515600" cy="3840480"/>
+            <a:off x="6720840" y="1463040"/>
+            <a:ext cx="4663440" cy="3840480"/>
           </a:xfrm>
           <a:prstGeom prst="roundRect">
             <a:avLst>
@@ -4456,14 +4994,14 @@
       </p:sp>
       <p:sp>
         <p:nvSpPr>
-          <p:cNvPr id="6" name="TextBox 5"/>
+          <p:cNvPr id="7" name="TextBox 6"/>
           <p:cNvSpPr txBox="1"/>
           <p:nvPr/>
         </p:nvSpPr>
         <p:spPr>
           <a:xfrm>
-            <a:off x="1051560" y="1554480"/>
-            <a:ext cx="10149840" cy="3657600"/>
+            <a:off x="6903720" y="1554480"/>
+            <a:ext cx="4297680" cy="3657600"/>
           </a:xfrm>
           <a:prstGeom prst="rect">
             <a:avLst/>
@@ -4477,145 +5015,134 @@
           <a:lstStyle/>
           <a:p>
             <a:r>
-              <a:rPr sz="1300" b="0">
-                <a:solidFill>
-                  <a:srgbClr val="31D3B1"/>
+              <a:rPr sz="1200" b="0">
+                <a:solidFill>
+                  <a:srgbClr val="CFDEEB"/>
                 </a:solidFill>
                 <a:latin typeface="Menlo"/>
-              </a:rPr>
-              <a:t>$ python3 loop.py --provider kiro --reset</a:t>
-            </a:r>
-          </a:p>
-          <a:p>
-            <a:r>
-              <a:rPr sz="1300" b="0">
+                <a:ea typeface="Apple SD Gothic Neo"/>
+              </a:rPr>
+              <a:t>diff-02.patch  (LOOP 2, Kiro)</a:t>
+            </a:r>
+          </a:p>
+          <a:p>
+            <a:r>
+              <a:rPr sz="1200" b="0">
+                <a:solidFill>
+                  <a:srgbClr val="CFDEEB"/>
+                </a:solidFill>
+                <a:latin typeface="Menlo"/>
+                <a:ea typeface="Apple SD Gothic Neo"/>
+              </a:rPr>
+              <a:t/>
+            </a:r>
+          </a:p>
+          <a:p>
+            <a:r>
+              <a:rPr sz="1200" b="0">
+                <a:solidFill>
+                  <a:srgbClr val="CFDEEB"/>
+                </a:solidFill>
+                <a:latin typeface="Menlo"/>
+                <a:ea typeface="Apple SD Gothic Neo"/>
+              </a:rPr>
+              <a:t>  public static int discount(</a:t>
+            </a:r>
+          </a:p>
+          <a:p>
+            <a:r>
+              <a:rPr sz="1200" b="0">
+                <a:solidFill>
+                  <a:srgbClr val="CFDEEB"/>
+                </a:solidFill>
+                <a:latin typeface="Menlo"/>
+                <a:ea typeface="Apple SD Gothic Neo"/>
+              </a:rPr>
+              <a:t>      int price, int rate) {</a:t>
+            </a:r>
+          </a:p>
+          <a:p>
+            <a:r>
+              <a:rPr sz="1200" b="0">
                 <a:solidFill>
                   <a:srgbClr val="FF6B6B"/>
                 </a:solidFill>
                 <a:latin typeface="Menlo"/>
-              </a:rPr>
-              <a:t>[QA GATE] initial: FAIL</a:t>
-            </a:r>
-          </a:p>
-          <a:p>
-            <a:r>
-              <a:rPr sz="1300" b="0">
+                <a:ea typeface="Apple SD Gothic Neo"/>
+              </a:rPr>
+              <a:t>- // [FAULT INJECTION] price</a:t>
+            </a:r>
+          </a:p>
+          <a:p>
+            <a:r>
+              <a:rPr sz="1200" b="0">
+                <a:solidFill>
+                  <a:srgbClr val="FF6B6B"/>
+                </a:solidFill>
+                <a:latin typeface="Menlo"/>
+                <a:ea typeface="Apple SD Gothic Neo"/>
+              </a:rPr>
+              <a:t>-    validation removed</a:t>
+            </a:r>
+          </a:p>
+          <a:p>
+            <a:r>
+              <a:rPr sz="1200" b="0">
+                <a:solidFill>
+                  <a:srgbClr val="4ADE80"/>
+                </a:solidFill>
+                <a:latin typeface="Menlo"/>
+                <a:ea typeface="Apple SD Gothic Neo"/>
+              </a:rPr>
+              <a:t>+ if (price &lt; 0) throw new</a:t>
+            </a:r>
+          </a:p>
+          <a:p>
+            <a:r>
+              <a:rPr sz="1200" b="0">
+                <a:solidFill>
+                  <a:srgbClr val="4ADE80"/>
+                </a:solidFill>
+                <a:latin typeface="Menlo"/>
+                <a:ea typeface="Apple SD Gothic Neo"/>
+              </a:rPr>
+              <a:t>+   IllegalArgumentException(</a:t>
+            </a:r>
+          </a:p>
+          <a:p>
+            <a:r>
+              <a:rPr sz="1200" b="0">
+                <a:solidFill>
+                  <a:srgbClr val="4ADE80"/>
+                </a:solidFill>
+                <a:latin typeface="Menlo"/>
+                <a:ea typeface="Apple SD Gothic Neo"/>
+              </a:rPr>
+              <a:t>+     "invalid price");</a:t>
+            </a:r>
+          </a:p>
+          <a:p>
+            <a:r>
+              <a:rPr sz="1200" b="0">
                 <a:solidFill>
                   <a:srgbClr val="CFDEEB"/>
                 </a:solidFill>
                 <a:latin typeface="Menlo"/>
-              </a:rPr>
-              <a:t>  AssertionError: Expected IllegalArgumentException for rate=-1</a:t>
-            </a:r>
-          </a:p>
-          <a:p>
-            <a:r>
-              <a:rPr sz="1300" b="0">
-                <a:solidFill>
-                  <a:srgbClr val="31D3B1"/>
+                <a:ea typeface="Apple SD Gothic Neo"/>
+              </a:rPr>
+              <a:t>  if (rate &lt; 0 || rate &gt; 100)</a:t>
+            </a:r>
+          </a:p>
+          <a:p>
+            <a:r>
+              <a:rPr sz="1200" b="0">
+                <a:solidFill>
+                  <a:srgbClr val="CFDEEB"/>
                 </a:solidFill>
                 <a:latin typeface="Menlo"/>
-              </a:rPr>
-              <a:t>[LOOP 1/5] starting NEW kiro session (no human input)</a:t>
-            </a:r>
-          </a:p>
-          <a:p>
-            <a:r>
-              <a:rPr sz="1300" b="0">
-                <a:solidFill>
-                  <a:srgbClr val="8397AB"/>
-                </a:solidFill>
-                <a:latin typeface="Menlo"/>
-              </a:rPr>
-              <a:t>  │ [tool] Reading DiscountCalculator.java, DiscountTest.java</a:t>
-            </a:r>
-          </a:p>
-          <a:p>
-            <a:r>
-              <a:rPr sz="1300" b="0">
-                <a:solidFill>
-                  <a:srgbClr val="8397AB"/>
-                </a:solidFill>
-                <a:latin typeface="Menlo"/>
-              </a:rPr>
-              <a:t>  │ [tool] Editing DiscountCalculator.java</a:t>
-            </a:r>
-          </a:p>
-          <a:p>
-            <a:r>
-              <a:rPr sz="1300" b="0">
-                <a:solidFill>
-                  <a:srgbClr val="8397AB"/>
-                </a:solidFill>
-                <a:latin typeface="Menlo"/>
-              </a:rPr>
-              <a:t>  │ Added guards ... rate outside [0,100] or price is negative</a:t>
-            </a:r>
-          </a:p>
-          <a:p>
-            <a:r>
-              <a:rPr sz="1300" b="0">
-                <a:solidFill>
-                  <a:srgbClr val="8397AB"/>
-                </a:solidFill>
-                <a:latin typeface="Menlo"/>
-              </a:rPr>
-              <a:t>  [AGENT] session ended: exit=0 (17.4s). Agent claim is NOT trusted</a:t>
-            </a:r>
-          </a:p>
-          <a:p>
-            <a:r>
-              <a:rPr sz="1300" b="0">
-                <a:solidFill>
-                  <a:srgbClr val="4ADE80"/>
-                </a:solidFill>
-                <a:latin typeface="Menlo"/>
-              </a:rPr>
-              <a:t>[QA GATE] PASS   ALL TESTS PASSED</a:t>
-            </a:r>
-          </a:p>
-          <a:p>
-            <a:r>
-              <a:rPr sz="1300" b="0">
-                <a:solidFill>
-                  <a:srgbClr val="4ADE80"/>
-                </a:solidFill>
-                <a:latin typeface="Menlo"/>
-              </a:rPr>
-              <a:t>SUCCESS: QA Gate passed on iteration 1. Controller stops the loop.</a:t>
-            </a:r>
-          </a:p>
-        </p:txBody>
-      </p:sp>
-      <p:sp>
-        <p:nvSpPr>
-          <p:cNvPr id="7" name="TextBox 6"/>
-          <p:cNvSpPr txBox="1"/>
-          <p:nvPr/>
-        </p:nvSpPr>
-        <p:spPr>
-          <a:xfrm>
-            <a:off x="868680" y="5440680"/>
-            <a:ext cx="10515600" cy="822960"/>
-          </a:xfrm>
-          <a:prstGeom prst="rect">
-            <a:avLst/>
-          </a:prstGeom>
-          <a:noFill/>
-        </p:spPr>
-        <p:txBody>
-          <a:bodyPr wrap="square">
-            <a:spAutoFit/>
-          </a:bodyPr>
-          <a:lstStyle/>
-          <a:p>
-            <a:r>
-              <a:rPr sz="1800" b="0">
-                <a:solidFill>
-                  <a:srgbClr val="CFDEEB"/>
-                </a:solidFill>
-              </a:rPr>
-              <a:t>쉬운 목표는 1회에 끝나는 게 정상 — 그래도 "완료"는 Kiro가 아니라 QA Gate가 승인했다</a:t>
+                <a:ea typeface="Apple SD Gothic Neo"/>
+              </a:rPr>
+              <a:t>    throw new IllegalArgumentException</a:t>
             </a:r>
           </a:p>
         </p:txBody>
@@ -4706,25 +5233,108 @@
           <a:noFill/>
         </p:spPr>
         <p:txBody>
+          <a:bodyPr wrap="none">
+            <a:spAutoFit/>
+          </a:bodyPr>
+          <a:lstStyle/>
+          <a:p>
+            <a:r>
+              <a:rPr sz="3200" b="1">
+                <a:solidFill>
+                  <a:srgbClr val="F5F8FD"/>
+                </a:solidFill>
+              </a:rPr>
+              <a:t>왜 단순 프롬프트와 다른가?</a:t>
+            </a:r>
+          </a:p>
+        </p:txBody>
+      </p:sp>
+      <p:sp>
+        <p:nvSpPr>
+          <p:cNvPr id="4" name="TextBox 3"/>
+          <p:cNvSpPr txBox="1"/>
+          <p:nvPr/>
+        </p:nvSpPr>
+        <p:spPr>
+          <a:xfrm>
+            <a:off x="868680" y="1691640"/>
+            <a:ext cx="10515600" cy="4480560"/>
+          </a:xfrm>
+          <a:prstGeom prst="rect">
+            <a:avLst/>
+          </a:prstGeom>
+          <a:noFill/>
+        </p:spPr>
+        <p:txBody>
           <a:bodyPr wrap="square">
             <a:spAutoFit/>
           </a:bodyPr>
           <a:lstStyle/>
           <a:p>
-            <a:r>
-              <a:rPr sz="3200" b="1">
-                <a:solidFill>
-                  <a:srgbClr val="F5F8FD"/>
-                </a:solidFill>
-              </a:rPr>
-              <a:t>실제 실행 ②: QA FAIL → 새 세션 자동 실행</a:t>
-            </a:r>
-          </a:p>
-        </p:txBody>
-      </p:sp>
-      <p:sp>
-        <p:nvSpPr>
-          <p:cNvPr id="4" name="TextBox 3"/>
+            <a:pPr>
+              <a:spcAft>
+                <a:spcPts val="1700"/>
+              </a:spcAft>
+            </a:pPr>
+            <a:r>
+              <a:rPr sz="2200">
+                <a:solidFill>
+                  <a:srgbClr val="CFDEEB"/>
+                </a:solidFill>
+              </a:rPr>
+              <a:t>AI 세션이 끝나도 Controller가 결과를 판정한다</a:t>
+            </a:r>
+          </a:p>
+          <a:p>
+            <a:pPr>
+              <a:spcAft>
+                <a:spcPts val="1700"/>
+              </a:spcAft>
+            </a:pPr>
+            <a:r>
+              <a:rPr sz="2200">
+                <a:solidFill>
+                  <a:srgbClr val="CFDEEB"/>
+                </a:solidFill>
+              </a:rPr>
+              <a:t>실패 로그를 다음 새 세션에 전달한다</a:t>
+            </a:r>
+          </a:p>
+          <a:p>
+            <a:pPr>
+              <a:spcAft>
+                <a:spcPts val="1700"/>
+              </a:spcAft>
+            </a:pPr>
+            <a:r>
+              <a:rPr sz="2200">
+                <a:solidFill>
+                  <a:srgbClr val="CFDEEB"/>
+                </a:solidFill>
+              </a:rPr>
+              <a:t>모델이 “성공”이라고 해도 테스트가 실패하면 반복한다</a:t>
+            </a:r>
+          </a:p>
+          <a:p>
+            <a:pPr>
+              <a:spcAft>
+                <a:spcPts val="1700"/>
+              </a:spcAft>
+            </a:pPr>
+            <a:r>
+              <a:rPr sz="2200">
+                <a:solidFill>
+                  <a:srgbClr val="CFDEEB"/>
+                </a:solidFill>
+              </a:rPr>
+              <a:t>최대 반복 횟수에 도달하면 실패로 종료한다</a:t>
+            </a:r>
+          </a:p>
+        </p:txBody>
+      </p:sp>
+      <p:sp>
+        <p:nvSpPr>
+          <p:cNvPr id="5" name="TextBox 4"/>
           <p:cNvSpPr txBox="1"/>
           <p:nvPr/>
         </p:nvSpPr>
@@ -4739,251 +5349,18 @@
           <a:noFill/>
         </p:spPr>
         <p:txBody>
-          <a:bodyPr wrap="square">
+          <a:bodyPr wrap="none">
             <a:spAutoFit/>
           </a:bodyPr>
           <a:lstStyle/>
           <a:p>
             <a:r>
-              <a:rPr sz="1000" b="0">
+              <a:rPr sz="1000">
                 <a:solidFill>
                   <a:srgbClr val="8397AB"/>
                 </a:solidFill>
               </a:rPr>
-              <a:t>AI Agent Loop · 2026.10.21                                     09 / 14</a:t>
-            </a:r>
-          </a:p>
-        </p:txBody>
-      </p:sp>
-      <p:sp>
-        <p:nvSpPr>
-          <p:cNvPr id="5" name="Rounded Rectangle 4"/>
-          <p:cNvSpPr/>
-          <p:nvPr/>
-        </p:nvSpPr>
-        <p:spPr>
-          <a:xfrm>
-            <a:off x="868680" y="1371600"/>
-            <a:ext cx="10515600" cy="4206240"/>
-          </a:xfrm>
-          <a:prstGeom prst="roundRect">
-            <a:avLst>
-              <a:gd name="adj" fmla="val 3000"/>
-            </a:avLst>
-          </a:prstGeom>
-          <a:solidFill>
-            <a:srgbClr val="050A12"/>
-          </a:solidFill>
-          <a:ln>
-            <a:solidFill>
-              <a:srgbClr val="2A3B52"/>
-            </a:solidFill>
-          </a:ln>
-        </p:spPr>
-        <p:style>
-          <a:lnRef idx="1">
-            <a:schemeClr val="accent1"/>
-          </a:lnRef>
-          <a:fillRef idx="3">
-            <a:schemeClr val="accent1"/>
-          </a:fillRef>
-          <a:effectRef idx="2">
-            <a:schemeClr val="accent1"/>
-          </a:effectRef>
-          <a:fontRef idx="minor">
-            <a:schemeClr val="lt1"/>
-          </a:fontRef>
-        </p:style>
-        <p:txBody>
-          <a:bodyPr rtlCol="0" anchor="ctr"/>
-          <a:lstStyle/>
-          <a:p/>
-        </p:txBody>
-      </p:sp>
-      <p:sp>
-        <p:nvSpPr>
-          <p:cNvPr id="6" name="TextBox 5"/>
-          <p:cNvSpPr txBox="1"/>
-          <p:nvPr/>
-        </p:nvSpPr>
-        <p:spPr>
-          <a:xfrm>
-            <a:off x="1051560" y="1463040"/>
-            <a:ext cx="10149840" cy="4023360"/>
-          </a:xfrm>
-          <a:prstGeom prst="rect">
-            <a:avLst/>
-          </a:prstGeom>
-          <a:noFill/>
-        </p:spPr>
-        <p:txBody>
-          <a:bodyPr wrap="square">
-            <a:spAutoFit/>
-          </a:bodyPr>
-          <a:lstStyle/>
-          <a:p>
-            <a:r>
-              <a:rPr sz="1200" b="0">
-                <a:solidFill>
-                  <a:srgbClr val="31D3B1"/>
-                </a:solidFill>
-                <a:latin typeface="Menlo"/>
-              </a:rPr>
-              <a:t>$ python3 loop.py --provider kiro --reset --inject-fault</a:t>
-            </a:r>
-          </a:p>
-          <a:p>
-            <a:r>
-              <a:rPr sz="1200" b="0">
-                <a:solidFill>
-                  <a:srgbClr val="31D3B1"/>
-                </a:solidFill>
-                <a:latin typeface="Menlo"/>
-              </a:rPr>
-              <a:t>[LOOP 1/5] starting NEW kiro session (no human input)</a:t>
-            </a:r>
-          </a:p>
-          <a:p>
-            <a:r>
-              <a:rPr sz="1200" b="0">
-                <a:solidFill>
-                  <a:srgbClr val="8397AB"/>
-                </a:solidFill>
-                <a:latin typeface="Menlo"/>
-              </a:rPr>
-              <a:t>  │ [tool] Editing DiscountCalculator.java     (16.5s, exit=0)</a:t>
-            </a:r>
-          </a:p>
-          <a:p>
-            <a:r>
-              <a:rPr sz="1200" b="0">
-                <a:solidFill>
-                  <a:srgbClr val="FACC15"/>
-                </a:solidFill>
-                <a:latin typeface="Menlo"/>
-              </a:rPr>
-              <a:t>[FAULT INJECTION] controller removed price validation (NOT the AI's)</a:t>
-            </a:r>
-          </a:p>
-          <a:p>
-            <a:r>
-              <a:rPr sz="1200" b="0">
-                <a:solidFill>
-                  <a:srgbClr val="FF6B6B"/>
-                </a:solidFill>
-                <a:latin typeface="Menlo"/>
-              </a:rPr>
-              <a:t>[QA GATE] FAIL</a:t>
-            </a:r>
-          </a:p>
-          <a:p>
-            <a:r>
-              <a:rPr sz="1200" b="0">
-                <a:solidFill>
-                  <a:srgbClr val="CFDEEB"/>
-                </a:solidFill>
-                <a:latin typeface="Menlo"/>
-              </a:rPr>
-              <a:t>  AssertionError: Expected IllegalArgumentException for price=-1</a:t>
-            </a:r>
-          </a:p>
-          <a:p>
-            <a:r>
-              <a:rPr sz="1200" b="0">
-                <a:solidFill>
-                  <a:srgbClr val="31D3B1"/>
-                </a:solidFill>
-                <a:latin typeface="Menlo"/>
-              </a:rPr>
-              <a:t>[LOOP] QA failed -&gt; feeding failure log into a NEW session</a:t>
-            </a:r>
-          </a:p>
-          <a:p>
-            <a:r>
-              <a:rPr sz="1200" b="0">
-                <a:solidFill>
-                  <a:srgbClr val="31D3B1"/>
-                </a:solidFill>
-                <a:latin typeface="Menlo"/>
-              </a:rPr>
-              <a:t>[LOOP 2/5] starting NEW kiro session (no human input)</a:t>
-            </a:r>
-          </a:p>
-          <a:p>
-            <a:r>
-              <a:rPr sz="1200" b="0">
-                <a:solidFill>
-                  <a:srgbClr val="8397AB"/>
-                </a:solidFill>
-                <a:latin typeface="Menlo"/>
-              </a:rPr>
-              <a:t>  │ The fix is to add price validation. I'll add a check for price &lt; 0</a:t>
-            </a:r>
-          </a:p>
-          <a:p>
-            <a:r>
-              <a:rPr sz="1200" b="0">
-                <a:solidFill>
-                  <a:srgbClr val="8397AB"/>
-                </a:solidFill>
-                <a:latin typeface="Menlo"/>
-              </a:rPr>
-              <a:t>  │ [tool] Editing DiscountCalculator.java     (17.2s, exit=0)</a:t>
-            </a:r>
-          </a:p>
-          <a:p>
-            <a:r>
-              <a:rPr sz="1200" b="0">
-                <a:solidFill>
-                  <a:srgbClr val="4ADE80"/>
-                </a:solidFill>
-                <a:latin typeface="Menlo"/>
-              </a:rPr>
-              <a:t>[QA GATE] PASS   ALL TESTS PASSED</a:t>
-            </a:r>
-          </a:p>
-          <a:p>
-            <a:r>
-              <a:rPr sz="1200" b="0">
-                <a:solidFill>
-                  <a:srgbClr val="FF6B6B"/>
-                </a:solidFill>
-                <a:latin typeface="Menlo"/>
-              </a:rPr>
-              <a:t>RESULT=PASS  iterations=2   loop 1: FAIL (fault injected) / loop 2: PASS</a:t>
-            </a:r>
-          </a:p>
-        </p:txBody>
-      </p:sp>
-      <p:sp>
-        <p:nvSpPr>
-          <p:cNvPr id="7" name="TextBox 6"/>
-          <p:cNvSpPr txBox="1"/>
-          <p:nvPr/>
-        </p:nvSpPr>
-        <p:spPr>
-          <a:xfrm>
-            <a:off x="868680" y="5669280"/>
-            <a:ext cx="10515600" cy="640080"/>
-          </a:xfrm>
-          <a:prstGeom prst="rect">
-            <a:avLst/>
-          </a:prstGeom>
-          <a:noFill/>
-        </p:spPr>
-        <p:txBody>
-          <a:bodyPr wrap="square">
-            <a:spAutoFit/>
-          </a:bodyPr>
-          <a:lstStyle/>
-          <a:p>
-            <a:r>
-              <a:rPr sz="1600" b="0">
-                <a:solidFill>
-                  <a:srgbClr val="FACC15"/>
-                </a:solidFill>
-              </a:rPr>
-              <a:t>※ 1회차 실패는 Controller가 의도적으로 주입한 것 (AI 실패 아님)</a:t>
+              <a:t>AI Agent Loop · 2026.10.21                                     13 / 16</a:t>
             </a:r>
           </a:p>
         </p:txBody>
@@ -5074,51 +5451,116 @@
           <a:noFill/>
         </p:spPr>
         <p:txBody>
+          <a:bodyPr wrap="none">
+            <a:spAutoFit/>
+          </a:bodyPr>
+          <a:lstStyle/>
+          <a:p>
+            <a:r>
+              <a:rPr sz="3200" b="1">
+                <a:solidFill>
+                  <a:srgbClr val="F5F8FD"/>
+                </a:solidFill>
+              </a:rPr>
+              <a:t>운영 적용 전 꼭 필요한 것</a:t>
+            </a:r>
+          </a:p>
+        </p:txBody>
+      </p:sp>
+      <p:sp>
+        <p:nvSpPr>
+          <p:cNvPr id="4" name="TextBox 3"/>
+          <p:cNvSpPr txBox="1"/>
+          <p:nvPr/>
+        </p:nvSpPr>
+        <p:spPr>
+          <a:xfrm>
+            <a:off x="868680" y="1691640"/>
+            <a:ext cx="10515600" cy="4480560"/>
+          </a:xfrm>
+          <a:prstGeom prst="rect">
+            <a:avLst/>
+          </a:prstGeom>
+          <a:noFill/>
+        </p:spPr>
+        <p:txBody>
           <a:bodyPr wrap="square">
             <a:spAutoFit/>
           </a:bodyPr>
           <a:lstStyle/>
           <a:p>
-            <a:r>
-              <a:rPr sz="3200" b="1">
-                <a:solidFill>
-                  <a:srgbClr val="F5F8FD"/>
-                </a:solidFill>
-              </a:rPr>
-              <a:t>증거: Controller가 남긴 기록</a:t>
-            </a:r>
-          </a:p>
-        </p:txBody>
-      </p:sp>
-      <p:sp>
-        <p:nvSpPr>
-          <p:cNvPr id="4" name="TextBox 3"/>
-          <p:cNvSpPr txBox="1"/>
-          <p:nvPr/>
-        </p:nvSpPr>
-        <p:spPr>
-          <a:xfrm>
-            <a:off x="868680" y="6492240"/>
-            <a:ext cx="10515600" cy="201168"/>
-          </a:xfrm>
-          <a:prstGeom prst="rect">
-            <a:avLst/>
-          </a:prstGeom>
-          <a:noFill/>
-        </p:spPr>
-        <p:txBody>
-          <a:bodyPr wrap="square">
-            <a:spAutoFit/>
-          </a:bodyPr>
-          <a:lstStyle/>
-          <a:p>
-            <a:r>
-              <a:rPr sz="1000" b="0">
-                <a:solidFill>
-                  <a:srgbClr val="8397AB"/>
-                </a:solidFill>
-              </a:rPr>
-              <a:t>AI Agent Loop · 2026.10.21                                     10 / 14</a:t>
+            <a:pPr>
+              <a:spcAft>
+                <a:spcPts val="1700"/>
+              </a:spcAft>
+            </a:pPr>
+            <a:r>
+              <a:rPr sz="2200">
+                <a:solidFill>
+                  <a:srgbClr val="CFDEEB"/>
+                </a:solidFill>
+              </a:rPr>
+              <a:t>실행 환경 격리 / 최소 권한 / 비밀정보 제거</a:t>
+            </a:r>
+          </a:p>
+          <a:p>
+            <a:pPr>
+              <a:spcAft>
+                <a:spcPts val="1700"/>
+              </a:spcAft>
+            </a:pPr>
+            <a:r>
+              <a:rPr sz="2200">
+                <a:solidFill>
+                  <a:srgbClr val="CFDEEB"/>
+                </a:solidFill>
+              </a:rPr>
+              <a:t>테스트 및 검증기 변조 방지 (데모 검사는 보안 격리 아님)</a:t>
+            </a:r>
+          </a:p>
+          <a:p>
+            <a:pPr>
+              <a:spcAft>
+                <a:spcPts val="1700"/>
+              </a:spcAft>
+            </a:pPr>
+            <a:r>
+              <a:rPr sz="2200">
+                <a:solidFill>
+                  <a:srgbClr val="CFDEEB"/>
+                </a:solidFill>
+              </a:rPr>
+              <a:t>실행 예산과 타임아웃 / 중복 실행 방지</a:t>
+            </a:r>
+          </a:p>
+          <a:p>
+            <a:pPr>
+              <a:spcAft>
+                <a:spcPts val="1700"/>
+              </a:spcAft>
+            </a:pPr>
+            <a:r>
+              <a:rPr sz="2200">
+                <a:solidFill>
+                  <a:srgbClr val="CFDEEB"/>
+                </a:solidFill>
+              </a:rPr>
+              <a:t>관측성: 실패 원인·변경 diff·비용·횟수</a:t>
+            </a:r>
+          </a:p>
+          <a:p>
+            <a:pPr>
+              <a:spcAft>
+                <a:spcPts val="1700"/>
+              </a:spcAft>
+            </a:pPr>
+            <a:r>
+              <a:rPr sz="2200">
+                <a:solidFill>
+                  <a:srgbClr val="CFDEEB"/>
+                </a:solidFill>
+              </a:rPr>
+              <a:t>Human approval: PR 머지·배포·권한 변경</a:t>
             </a:r>
           </a:p>
         </p:txBody>
@@ -5131,8 +5573,8 @@
         </p:nvSpPr>
         <p:spPr>
           <a:xfrm>
-            <a:off x="868680" y="1463040"/>
-            <a:ext cx="4754880" cy="3840480"/>
+            <a:off x="868680" y="6492240"/>
+            <a:ext cx="10515600" cy="201168"/>
           </a:xfrm>
           <a:prstGeom prst="rect">
             <a:avLst/>
@@ -5140,115 +5582,67 @@
           <a:noFill/>
         </p:spPr>
         <p:txBody>
-          <a:bodyPr wrap="square">
+          <a:bodyPr wrap="none">
             <a:spAutoFit/>
           </a:bodyPr>
           <a:lstStyle/>
           <a:p>
             <a:r>
-              <a:rPr sz="1800" b="0">
-                <a:solidFill>
-                  <a:srgbClr val="CFDEEB"/>
-                </a:solidFill>
-              </a:rPr>
-              <a:t>.loop/summary.json — 결과·반복 횟수</a:t>
-            </a:r>
-          </a:p>
-          <a:p>
-            <a:r>
-              <a:rPr sz="1800" b="0">
-                <a:solidFill>
-                  <a:srgbClr val="CFDEEB"/>
-                </a:solidFill>
-              </a:rPr>
-              <a:t>iteration-NN.json — 회차별 QA 출력</a:t>
-            </a:r>
-          </a:p>
-          <a:p>
-            <a:r>
-              <a:rPr sz="1800" b="0">
-                <a:solidFill>
-                  <a:srgbClr val="CFDEEB"/>
-                </a:solidFill>
-              </a:rPr>
-              <a:t>agent-NN.log — Kiro 세션 전체 로그</a:t>
-            </a:r>
-          </a:p>
-          <a:p>
-            <a:r>
-              <a:rPr sz="1800" b="0">
-                <a:solidFill>
-                  <a:srgbClr val="CFDEEB"/>
-                </a:solidFill>
-              </a:rPr>
-              <a:t>diff-NN.patch — AI가 바꾼 코드</a:t>
-            </a:r>
-          </a:p>
-          <a:p>
-            <a:r>
-              <a:rPr sz="1800" b="0">
-                <a:solidFill>
-                  <a:srgbClr val="CFDEEB"/>
-                </a:solidFill>
-              </a:rPr>
-              <a:t/>
-            </a:r>
-          </a:p>
-          <a:p>
-            <a:r>
-              <a:rPr sz="1800" b="0">
-                <a:solidFill>
-                  <a:srgbClr val="31D3B1"/>
-                </a:solidFill>
-              </a:rPr>
-              <a:t>보호 파일 변조 시뮬레이션</a:t>
-            </a:r>
-          </a:p>
-          <a:p>
-            <a:r>
-              <a:rPr sz="1800" b="0">
-                <a:solidFill>
-                  <a:srgbClr val="CFDEEB"/>
-                </a:solidFill>
-              </a:rPr>
-              <a:t>→ 자동 복원 + GUARDRAIL_STOP</a:t>
-            </a:r>
-          </a:p>
-          <a:p>
-            <a:r>
-              <a:rPr sz="1800" b="0">
-                <a:solidFill>
-                  <a:srgbClr val="CFDEEB"/>
-                </a:solidFill>
-              </a:rPr>
-              <a:t>셸 도구 요청 → 비대화형 모드에서 거부</a:t>
-            </a:r>
-          </a:p>
-        </p:txBody>
-      </p:sp>
-      <p:sp>
-        <p:nvSpPr>
-          <p:cNvPr id="6" name="Rounded Rectangle 5"/>
+              <a:rPr sz="1000">
+                <a:solidFill>
+                  <a:srgbClr val="8397AB"/>
+                </a:solidFill>
+              </a:rPr>
+              <a:t>AI Agent Loop · 2026.10.21                                     14 / 16</a:t>
+            </a:r>
+          </a:p>
+        </p:txBody>
+      </p:sp>
+    </p:spTree>
+  </p:cSld>
+  <p:clrMapOvr>
+    <a:masterClrMapping/>
+  </p:clrMapOvr>
+</p:sld>
+</file>
+
+<file path=ppt/slides/slide15.xml><?xml version="1.0" encoding="utf-8"?>
+<p:sld xmlns:a="http://schemas.openxmlformats.org/drawingml/2006/main" xmlns:p="http://schemas.openxmlformats.org/presentationml/2006/main" xmlns:r="http://schemas.openxmlformats.org/officeDocument/2006/relationships">
+  <p:cSld>
+    <p:bg>
+      <p:bgPr>
+        <a:solidFill>
+          <a:srgbClr val="0E1625"/>
+        </a:solidFill>
+        <a:effectLst/>
+      </p:bgPr>
+    </p:bg>
+    <p:spTree>
+      <p:nvGrpSpPr>
+        <p:cNvPr id="1" name=""/>
+        <p:cNvGrpSpPr/>
+        <p:nvPr/>
+      </p:nvGrpSpPr>
+      <p:grpSpPr/>
+      <p:sp>
+        <p:nvSpPr>
+          <p:cNvPr id="2" name="Rectangle 1"/>
           <p:cNvSpPr/>
           <p:nvPr/>
         </p:nvSpPr>
         <p:spPr>
           <a:xfrm>
-            <a:off x="6720840" y="1463040"/>
-            <a:ext cx="4663440" cy="3840480"/>
-          </a:xfrm>
-          <a:prstGeom prst="roundRect">
-            <a:avLst>
-              <a:gd name="adj" fmla="val 3000"/>
-            </a:avLst>
+            <a:off x="594360" y="658368"/>
+            <a:ext cx="82296" cy="585216"/>
+          </a:xfrm>
+          <a:prstGeom prst="rect">
+            <a:avLst/>
           </a:prstGeom>
           <a:solidFill>
-            <a:srgbClr val="050A12"/>
+            <a:srgbClr val="31D3B1"/>
           </a:solidFill>
           <a:ln>
-            <a:solidFill>
-              <a:srgbClr val="2A3B52"/>
-            </a:solidFill>
+            <a:noFill/>
           </a:ln>
         </p:spPr>
         <p:style>
@@ -5268,19 +5662,54 @@
         <p:txBody>
           <a:bodyPr rtlCol="0" anchor="ctr"/>
           <a:lstStyle/>
-          <a:p/>
-        </p:txBody>
-      </p:sp>
-      <p:sp>
-        <p:nvSpPr>
-          <p:cNvPr id="7" name="TextBox 6"/>
+          <a:p>
+            <a:pPr algn="ctr"/>
+          </a:p>
+        </p:txBody>
+      </p:sp>
+      <p:sp>
+        <p:nvSpPr>
+          <p:cNvPr id="3" name="TextBox 2"/>
           <p:cNvSpPr txBox="1"/>
           <p:nvPr/>
         </p:nvSpPr>
         <p:spPr>
           <a:xfrm>
-            <a:off x="6903720" y="1554480"/>
-            <a:ext cx="4297680" cy="3657600"/>
+            <a:off x="868680" y="640080"/>
+            <a:ext cx="10515600" cy="731520"/>
+          </a:xfrm>
+          <a:prstGeom prst="rect">
+            <a:avLst/>
+          </a:prstGeom>
+          <a:noFill/>
+        </p:spPr>
+        <p:txBody>
+          <a:bodyPr wrap="none">
+            <a:spAutoFit/>
+          </a:bodyPr>
+          <a:lstStyle/>
+          <a:p>
+            <a:r>
+              <a:rPr sz="3200" b="1">
+                <a:solidFill>
+                  <a:srgbClr val="F5F8FD"/>
+                </a:solidFill>
+              </a:rPr>
+              <a:t>우리 팀에서 어디에 쓸까?</a:t>
+            </a:r>
+          </a:p>
+        </p:txBody>
+      </p:sp>
+      <p:sp>
+        <p:nvSpPr>
+          <p:cNvPr id="4" name="TextBox 3"/>
+          <p:cNvSpPr txBox="1"/>
+          <p:nvPr/>
+        </p:nvSpPr>
+        <p:spPr>
+          <a:xfrm>
+            <a:off x="868680" y="1691640"/>
+            <a:ext cx="10515600" cy="4480560"/>
           </a:xfrm>
           <a:prstGeom prst="rect">
             <a:avLst/>
@@ -5293,124 +5722,321 @@
           </a:bodyPr>
           <a:lstStyle/>
           <a:p>
-            <a:r>
-              <a:rPr sz="1200" b="0">
+            <a:pPr>
+              <a:spcAft>
+                <a:spcPts val="1700"/>
+              </a:spcAft>
+            </a:pPr>
+            <a:r>
+              <a:rPr sz="2200">
                 <a:solidFill>
                   <a:srgbClr val="CFDEEB"/>
                 </a:solidFill>
-                <a:latin typeface="Menlo"/>
-              </a:rPr>
-              <a:t>diff-02.patch  (LOOP 2, Kiro)</a:t>
-            </a:r>
-          </a:p>
-          <a:p>
-            <a:r>
-              <a:rPr sz="1200" b="0">
+              </a:rPr>
+              <a:t>API 테스트 자동 생성 및 실패 복구 제안</a:t>
+            </a:r>
+          </a:p>
+          <a:p>
+            <a:pPr>
+              <a:spcAft>
+                <a:spcPts val="1700"/>
+              </a:spcAft>
+            </a:pPr>
+            <a:r>
+              <a:rPr sz="2200">
                 <a:solidFill>
                   <a:srgbClr val="CFDEEB"/>
                 </a:solidFill>
-                <a:latin typeface="Menlo"/>
-              </a:rPr>
-              <a:t/>
-            </a:r>
-          </a:p>
-          <a:p>
-            <a:r>
-              <a:rPr sz="1200" b="0">
+              </a:rPr>
+              <a:t>CI 실패 원인 분석 → 수정 PR 초안</a:t>
+            </a:r>
+          </a:p>
+          <a:p>
+            <a:pPr>
+              <a:spcAft>
+                <a:spcPts val="1700"/>
+              </a:spcAft>
+            </a:pPr>
+            <a:r>
+              <a:rPr sz="2200">
                 <a:solidFill>
                   <a:srgbClr val="CFDEEB"/>
                 </a:solidFill>
-                <a:latin typeface="Menlo"/>
-              </a:rPr>
-              <a:t>  public static int discount(</a:t>
-            </a:r>
-          </a:p>
-          <a:p>
-            <a:r>
-              <a:rPr sz="1200" b="0">
+              </a:rPr>
+              <a:t>SonarQube 이슈 수정 → 스캔 → 재검증</a:t>
+            </a:r>
+          </a:p>
+          <a:p>
+            <a:pPr>
+              <a:spcAft>
+                <a:spcPts val="1700"/>
+              </a:spcAft>
+            </a:pPr>
+            <a:r>
+              <a:rPr sz="2200">
                 <a:solidFill>
                   <a:srgbClr val="CFDEEB"/>
                 </a:solidFill>
-                <a:latin typeface="Menlo"/>
-              </a:rPr>
-              <a:t>      int price, int rate) {</a:t>
-            </a:r>
-          </a:p>
-          <a:p>
-            <a:r>
-              <a:rPr sz="1200" b="0">
-                <a:solidFill>
-                  <a:srgbClr val="FF6B6B"/>
-                </a:solidFill>
-                <a:latin typeface="Menlo"/>
-              </a:rPr>
-              <a:t>- // [FAULT INJECTION] price</a:t>
-            </a:r>
-          </a:p>
-          <a:p>
-            <a:r>
-              <a:rPr sz="1200" b="0">
-                <a:solidFill>
-                  <a:srgbClr val="FF6B6B"/>
-                </a:solidFill>
-                <a:latin typeface="Menlo"/>
-              </a:rPr>
-              <a:t>-    validation removed</a:t>
-            </a:r>
-          </a:p>
-          <a:p>
-            <a:r>
-              <a:rPr sz="1200" b="0">
-                <a:solidFill>
-                  <a:srgbClr val="4ADE80"/>
-                </a:solidFill>
-                <a:latin typeface="Menlo"/>
-              </a:rPr>
-              <a:t>+ if (price &lt; 0) throw new</a:t>
-            </a:r>
-          </a:p>
-          <a:p>
-            <a:r>
-              <a:rPr sz="1200" b="0">
-                <a:solidFill>
-                  <a:srgbClr val="4ADE80"/>
-                </a:solidFill>
-                <a:latin typeface="Menlo"/>
-              </a:rPr>
-              <a:t>+   IllegalArgumentException(</a:t>
-            </a:r>
-          </a:p>
-          <a:p>
-            <a:r>
-              <a:rPr sz="1200" b="0">
-                <a:solidFill>
-                  <a:srgbClr val="4ADE80"/>
-                </a:solidFill>
-                <a:latin typeface="Menlo"/>
-              </a:rPr>
-              <a:t>+     "invalid price");</a:t>
-            </a:r>
-          </a:p>
-          <a:p>
-            <a:r>
-              <a:rPr sz="1200" b="0">
+              </a:rPr>
+              <a:t>단, 테스트 기준 변경과 배포는 사람이 승인</a:t>
+            </a:r>
+          </a:p>
+        </p:txBody>
+      </p:sp>
+      <p:sp>
+        <p:nvSpPr>
+          <p:cNvPr id="5" name="TextBox 4"/>
+          <p:cNvSpPr txBox="1"/>
+          <p:nvPr/>
+        </p:nvSpPr>
+        <p:spPr>
+          <a:xfrm>
+            <a:off x="868680" y="6492240"/>
+            <a:ext cx="10515600" cy="201168"/>
+          </a:xfrm>
+          <a:prstGeom prst="rect">
+            <a:avLst/>
+          </a:prstGeom>
+          <a:noFill/>
+        </p:spPr>
+        <p:txBody>
+          <a:bodyPr wrap="none">
+            <a:spAutoFit/>
+          </a:bodyPr>
+          <a:lstStyle/>
+          <a:p>
+            <a:r>
+              <a:rPr sz="1000">
+                <a:solidFill>
+                  <a:srgbClr val="8397AB"/>
+                </a:solidFill>
+              </a:rPr>
+              <a:t>AI Agent Loop · 2026.10.21                                     15 / 16</a:t>
+            </a:r>
+          </a:p>
+        </p:txBody>
+      </p:sp>
+    </p:spTree>
+  </p:cSld>
+  <p:clrMapOvr>
+    <a:masterClrMapping/>
+  </p:clrMapOvr>
+</p:sld>
+</file>
+
+<file path=ppt/slides/slide16.xml><?xml version="1.0" encoding="utf-8"?>
+<p:sld xmlns:a="http://schemas.openxmlformats.org/drawingml/2006/main" xmlns:p="http://schemas.openxmlformats.org/presentationml/2006/main" xmlns:r="http://schemas.openxmlformats.org/officeDocument/2006/relationships">
+  <p:cSld>
+    <p:bg>
+      <p:bgPr>
+        <a:solidFill>
+          <a:srgbClr val="0E1625"/>
+        </a:solidFill>
+        <a:effectLst/>
+      </p:bgPr>
+    </p:bg>
+    <p:spTree>
+      <p:nvGrpSpPr>
+        <p:cNvPr id="1" name=""/>
+        <p:cNvGrpSpPr/>
+        <p:nvPr/>
+      </p:nvGrpSpPr>
+      <p:grpSpPr/>
+      <p:sp>
+        <p:nvSpPr>
+          <p:cNvPr id="2" name="Rectangle 1"/>
+          <p:cNvSpPr/>
+          <p:nvPr/>
+        </p:nvSpPr>
+        <p:spPr>
+          <a:xfrm>
+            <a:off x="594360" y="658368"/>
+            <a:ext cx="82296" cy="585216"/>
+          </a:xfrm>
+          <a:prstGeom prst="rect">
+            <a:avLst/>
+          </a:prstGeom>
+          <a:solidFill>
+            <a:srgbClr val="31D3B1"/>
+          </a:solidFill>
+          <a:ln>
+            <a:noFill/>
+          </a:ln>
+        </p:spPr>
+        <p:style>
+          <a:lnRef idx="1">
+            <a:schemeClr val="accent1"/>
+          </a:lnRef>
+          <a:fillRef idx="3">
+            <a:schemeClr val="accent1"/>
+          </a:fillRef>
+          <a:effectRef idx="2">
+            <a:schemeClr val="accent1"/>
+          </a:effectRef>
+          <a:fontRef idx="minor">
+            <a:schemeClr val="lt1"/>
+          </a:fontRef>
+        </p:style>
+        <p:txBody>
+          <a:bodyPr rtlCol="0" anchor="ctr"/>
+          <a:lstStyle/>
+          <a:p>
+            <a:pPr algn="ctr"/>
+          </a:p>
+        </p:txBody>
+      </p:sp>
+      <p:sp>
+        <p:nvSpPr>
+          <p:cNvPr id="3" name="TextBox 2"/>
+          <p:cNvSpPr txBox="1"/>
+          <p:nvPr/>
+        </p:nvSpPr>
+        <p:spPr>
+          <a:xfrm>
+            <a:off x="868680" y="640080"/>
+            <a:ext cx="10515600" cy="731520"/>
+          </a:xfrm>
+          <a:prstGeom prst="rect">
+            <a:avLst/>
+          </a:prstGeom>
+          <a:noFill/>
+        </p:spPr>
+        <p:txBody>
+          <a:bodyPr wrap="none">
+            <a:spAutoFit/>
+          </a:bodyPr>
+          <a:lstStyle/>
+          <a:p>
+            <a:r>
+              <a:rPr sz="3200" b="1">
+                <a:solidFill>
+                  <a:srgbClr val="F5F8FD"/>
+                </a:solidFill>
+              </a:rPr>
+              <a:t>핵심 메시지 &amp; Q&amp;A</a:t>
+            </a:r>
+          </a:p>
+        </p:txBody>
+      </p:sp>
+      <p:sp>
+        <p:nvSpPr>
+          <p:cNvPr id="4" name="TextBox 3"/>
+          <p:cNvSpPr txBox="1"/>
+          <p:nvPr/>
+        </p:nvSpPr>
+        <p:spPr>
+          <a:xfrm>
+            <a:off x="868680" y="1691640"/>
+            <a:ext cx="10515600" cy="4480560"/>
+          </a:xfrm>
+          <a:prstGeom prst="rect">
+            <a:avLst/>
+          </a:prstGeom>
+          <a:noFill/>
+        </p:spPr>
+        <p:txBody>
+          <a:bodyPr wrap="square">
+            <a:spAutoFit/>
+          </a:bodyPr>
+          <a:lstStyle/>
+          <a:p>
+            <a:pPr>
+              <a:spcAft>
+                <a:spcPts val="1700"/>
+              </a:spcAft>
+            </a:pPr>
+            <a:r>
+              <a:rPr sz="2200">
                 <a:solidFill>
                   <a:srgbClr val="CFDEEB"/>
                 </a:solidFill>
-                <a:latin typeface="Menlo"/>
-              </a:rPr>
-              <a:t>  if (rate &lt; 0 || rate &gt; 100)</a:t>
-            </a:r>
-          </a:p>
-          <a:p>
-            <a:r>
-              <a:rPr sz="1200" b="0">
+              </a:rPr>
+              <a:t>Loop = AI를 계속 돌리는 기술이 아니라</a:t>
+            </a:r>
+          </a:p>
+          <a:p>
+            <a:pPr>
+              <a:spcAft>
+                <a:spcPts val="1700"/>
+              </a:spcAft>
+            </a:pPr>
+            <a:r>
+              <a:rPr sz="2200">
                 <a:solidFill>
                   <a:srgbClr val="CFDEEB"/>
                 </a:solidFill>
-                <a:latin typeface="Menlo"/>
-              </a:rPr>
-              <a:t>    throw new IllegalArgumentException</a:t>
+              </a:rPr>
+              <a:t>“목표 → 실행 → 독립 검증 → 피드백”을</a:t>
+            </a:r>
+          </a:p>
+          <a:p>
+            <a:pPr>
+              <a:spcAft>
+                <a:spcPts val="1700"/>
+              </a:spcAft>
+            </a:pPr>
+            <a:r>
+              <a:rPr sz="2200">
+                <a:solidFill>
+                  <a:srgbClr val="CFDEEB"/>
+                </a:solidFill>
+              </a:rPr>
+              <a:t>통제 가능한 시스템으로 만드는 방법</a:t>
+            </a:r>
+          </a:p>
+          <a:p>
+            <a:pPr>
+              <a:spcAft>
+                <a:spcPts val="1700"/>
+              </a:spcAft>
+            </a:pPr>
+          </a:p>
+          <a:p>
+            <a:pPr>
+              <a:spcAft>
+                <a:spcPts val="1700"/>
+              </a:spcAft>
+            </a:pPr>
+            <a:r>
+              <a:rPr sz="2200">
+                <a:solidFill>
+                  <a:srgbClr val="CFDEEB"/>
+                </a:solidFill>
+              </a:rPr>
+              <a:t>질문: 우리 팀의 어떤 작업을 먼저 Loop로 만들까?</a:t>
+            </a:r>
+          </a:p>
+        </p:txBody>
+      </p:sp>
+      <p:sp>
+        <p:nvSpPr>
+          <p:cNvPr id="5" name="TextBox 4"/>
+          <p:cNvSpPr txBox="1"/>
+          <p:nvPr/>
+        </p:nvSpPr>
+        <p:spPr>
+          <a:xfrm>
+            <a:off x="868680" y="6492240"/>
+            <a:ext cx="10515600" cy="201168"/>
+          </a:xfrm>
+          <a:prstGeom prst="rect">
+            <a:avLst/>
+          </a:prstGeom>
+          <a:noFill/>
+        </p:spPr>
+        <p:txBody>
+          <a:bodyPr wrap="none">
+            <a:spAutoFit/>
+          </a:bodyPr>
+          <a:lstStyle/>
+          <a:p>
+            <a:r>
+              <a:rPr sz="1000">
+                <a:solidFill>
+                  <a:srgbClr val="8397AB"/>
+                </a:solidFill>
+              </a:rPr>
+              <a:t>AI Agent Loop · 2026.10.21                                     16 / 16</a:t>
             </a:r>
           </a:p>
         </p:txBody>
@@ -5613,7 +6239,7 @@
                   <a:srgbClr val="8397AB"/>
                 </a:solidFill>
               </a:rPr>
-              <a:t>AI Agent Loop · 2026.10.21                                     02 / 14</a:t>
+              <a:t>AI Agent Loop · 2026.10.21                                     02 / 16</a:t>
             </a:r>
           </a:p>
         </p:txBody>
@@ -5816,7 +6442,7 @@
                   <a:srgbClr val="8397AB"/>
                 </a:solidFill>
               </a:rPr>
-              <a:t>AI Agent Loop · 2026.10.21                                     03 / 14</a:t>
+              <a:t>AI Agent Loop · 2026.10.21                                     03 / 16</a:t>
             </a:r>
           </a:p>
         </p:txBody>
@@ -6019,7 +6645,7 @@
                   <a:srgbClr val="8397AB"/>
                 </a:solidFill>
               </a:rPr>
-              <a:t>AI Agent Loop · 2026.10.21                                     04 / 14</a:t>
+              <a:t>AI Agent Loop · 2026.10.21                                     04 / 16</a:t>
             </a:r>
           </a:p>
         </p:txBody>
@@ -6267,7 +6893,7 @@
                   <a:srgbClr val="8397AB"/>
                 </a:solidFill>
               </a:rPr>
-              <a:t>AI Agent Loop · 2026.10.21                                     05 / 14</a:t>
+              <a:t>AI Agent Loop · 2026.10.21                                     05 / 16</a:t>
             </a:r>
           </a:p>
         </p:txBody>
@@ -6500,7 +7126,7 @@
                   <a:srgbClr val="8397AB"/>
                 </a:solidFill>
               </a:rPr>
-              <a:t>AI Agent Loop · 2026.10.21                                     06 / 14</a:t>
+              <a:t>AI Agent Loop · 2026.10.21                                     06 / 16</a:t>
             </a:r>
           </a:p>
         </p:txBody>
@@ -6591,7 +7217,7 @@
           <a:noFill/>
         </p:spPr>
         <p:txBody>
-          <a:bodyPr wrap="none">
+          <a:bodyPr wrap="square">
             <a:spAutoFit/>
           </a:bodyPr>
           <a:lstStyle/>
@@ -6602,7 +7228,7 @@
                   <a:srgbClr val="F5F8FD"/>
                 </a:solidFill>
               </a:rPr>
-              <a:t>데모 실행 순서</a:t>
+              <a:t>Controller(loop.py)는 무엇을 하나?</a:t>
             </a:r>
           </a:p>
         </p:txBody>
@@ -6615,8 +7241,8 @@
         </p:nvSpPr>
         <p:spPr>
           <a:xfrm>
-            <a:off x="868680" y="1691640"/>
-            <a:ext cx="10515600" cy="4480560"/>
+            <a:off x="868680" y="6492240"/>
+            <a:ext cx="10515600" cy="201168"/>
           </a:xfrm>
           <a:prstGeom prst="rect">
             <a:avLst/>
@@ -6629,78 +7255,13 @@
           </a:bodyPr>
           <a:lstStyle/>
           <a:p>
-            <a:pPr>
-              <a:spcAft>
-                <a:spcPts val="1700"/>
-              </a:spcAft>
-            </a:pPr>
-            <a:r>
-              <a:rPr sz="2200">
-                <a:solidFill>
-                  <a:srgbClr val="CFDEEB"/>
-                </a:solidFill>
-              </a:rPr>
-              <a:t>1. python3 verify.py → FAIL 확인</a:t>
-            </a:r>
-          </a:p>
-          <a:p>
-            <a:pPr>
-              <a:spcAft>
-                <a:spcPts val="1700"/>
-              </a:spcAft>
-            </a:pPr>
-            <a:r>
-              <a:rPr sz="2200">
-                <a:solidFill>
-                  <a:srgbClr val="CFDEEB"/>
-                </a:solidFill>
-              </a:rPr>
-              <a:t>2. python3 loop.py --provider mock --reset (리허설)</a:t>
-            </a:r>
-          </a:p>
-          <a:p>
-            <a:pPr>
-              <a:spcAft>
-                <a:spcPts val="1700"/>
-              </a:spcAft>
-            </a:pPr>
-            <a:r>
-              <a:rPr sz="2200">
-                <a:solidFill>
-                  <a:srgbClr val="CFDEEB"/>
-                </a:solidFill>
-              </a:rPr>
-              <a:t>3. python3 loop.py --provider kiro --reset</a:t>
-            </a:r>
-          </a:p>
-          <a:p>
-            <a:pPr>
-              <a:spcAft>
-                <a:spcPts val="1700"/>
-              </a:spcAft>
-            </a:pPr>
-            <a:r>
-              <a:rPr sz="2200">
-                <a:solidFill>
-                  <a:srgbClr val="CFDEEB"/>
-                </a:solidFill>
-              </a:rPr>
-              <a:t>4. ... --provider kiro --reset --inject-fault (데모 모드)</a:t>
-            </a:r>
-          </a:p>
-          <a:p>
-            <a:pPr>
-              <a:spcAft>
-                <a:spcPts val="1700"/>
-              </a:spcAft>
-            </a:pPr>
-            <a:r>
-              <a:rPr sz="2200">
-                <a:solidFill>
-                  <a:srgbClr val="CFDEEB"/>
-                </a:solidFill>
-              </a:rPr>
-              <a:t>5. .loop/summary.json · iteration-NN.json · diff-NN.patch 확인</a:t>
+            <a:r>
+              <a:rPr sz="1000" b="0">
+                <a:solidFill>
+                  <a:srgbClr val="8397AB"/>
+                </a:solidFill>
+              </a:rPr>
+              <a:t>AI Agent Loop · 2026.10.21                                     07 / 16</a:t>
             </a:r>
           </a:p>
         </p:txBody>
@@ -6713,8 +7274,8 @@
         </p:nvSpPr>
         <p:spPr>
           <a:xfrm>
-            <a:off x="868680" y="6492240"/>
-            <a:ext cx="10515600" cy="201168"/>
+            <a:off x="868680" y="1325880"/>
+            <a:ext cx="10515600" cy="320040"/>
           </a:xfrm>
           <a:prstGeom prst="rect">
             <a:avLst/>
@@ -6722,22 +7283,1024 @@
           <a:noFill/>
         </p:spPr>
         <p:txBody>
-          <a:bodyPr wrap="none">
+          <a:bodyPr wrap="square">
             <a:spAutoFit/>
           </a:bodyPr>
           <a:lstStyle/>
           <a:p>
             <a:r>
-              <a:rPr sz="1000">
+              <a:rPr sz="1400" b="0">
                 <a:solidFill>
                   <a:srgbClr val="8397AB"/>
                 </a:solidFill>
               </a:rPr>
-              <a:t>AI Agent Loop · 2026.10.21                                     07 / 14</a:t>
-            </a:r>
-          </a:p>
-        </p:txBody>
-      </p:sp>
+              <a:t>감독관 = loop.py (AI 아님, if문)       작업자 = Kiro CLI (AI)</a:t>
+            </a:r>
+          </a:p>
+        </p:txBody>
+      </p:sp>
+      <p:sp>
+        <p:nvSpPr>
+          <p:cNvPr id="6" name="Rounded Rectangle 5"/>
+          <p:cNvSpPr/>
+          <p:nvPr/>
+        </p:nvSpPr>
+        <p:spPr>
+          <a:xfrm>
+            <a:off x="868680" y="1783080"/>
+            <a:ext cx="1828800" cy="1188720"/>
+          </a:xfrm>
+          <a:prstGeom prst="roundRect">
+            <a:avLst>
+              <a:gd name="adj" fmla="val 8000"/>
+            </a:avLst>
+          </a:prstGeom>
+          <a:solidFill>
+            <a:srgbClr val="162236"/>
+          </a:solidFill>
+          <a:ln w="15875">
+            <a:solidFill>
+              <a:srgbClr val="2A3B52"/>
+            </a:solidFill>
+          </a:ln>
+        </p:spPr>
+        <p:style>
+          <a:lnRef idx="1">
+            <a:schemeClr val="accent1"/>
+          </a:lnRef>
+          <a:fillRef idx="3">
+            <a:schemeClr val="accent1"/>
+          </a:fillRef>
+          <a:effectRef idx="2">
+            <a:schemeClr val="accent1"/>
+          </a:effectRef>
+          <a:fontRef idx="minor">
+            <a:schemeClr val="lt1"/>
+          </a:fontRef>
+        </p:style>
+        <p:txBody>
+          <a:bodyPr rtlCol="0" anchor="ctr" wrap="square" lIns="64008" rIns="64008"/>
+          <a:lstStyle/>
+          <a:p>
+            <a:pPr algn="ctr"/>
+            <a:r>
+              <a:rPr sz="1600" b="1">
+                <a:solidFill>
+                  <a:srgbClr val="F5F8FD"/>
+                </a:solidFill>
+              </a:rPr>
+              <a:t>① 검사</a:t>
+            </a:r>
+          </a:p>
+          <a:p>
+            <a:pPr algn="ctr"/>
+            <a:r>
+              <a:rPr sz="1400" b="0">
+                <a:solidFill>
+                  <a:srgbClr val="CFDEEB"/>
+                </a:solidFill>
+              </a:rPr>
+              <a:t>verify.py 실행</a:t>
+            </a:r>
+          </a:p>
+          <a:p>
+            <a:pPr algn="ctr"/>
+            <a:r>
+              <a:rPr sz="1200" b="0">
+                <a:solidFill>
+                  <a:srgbClr val="8397AB"/>
+                </a:solidFill>
+              </a:rPr>
+              <a:t>Java 컴파일+테스트</a:t>
+            </a:r>
+          </a:p>
+        </p:txBody>
+      </p:sp>
+      <p:sp>
+        <p:nvSpPr>
+          <p:cNvPr id="7" name="Rounded Rectangle 6"/>
+          <p:cNvSpPr/>
+          <p:nvPr/>
+        </p:nvSpPr>
+        <p:spPr>
+          <a:xfrm>
+            <a:off x="3040380" y="1783080"/>
+            <a:ext cx="1828800" cy="1188720"/>
+          </a:xfrm>
+          <a:prstGeom prst="roundRect">
+            <a:avLst>
+              <a:gd name="adj" fmla="val 8000"/>
+            </a:avLst>
+          </a:prstGeom>
+          <a:solidFill>
+            <a:srgbClr val="1E183D"/>
+          </a:solidFill>
+          <a:ln w="25400">
+            <a:solidFill>
+              <a:srgbClr val="7C5CFF"/>
+            </a:solidFill>
+          </a:ln>
+        </p:spPr>
+        <p:style>
+          <a:lnRef idx="1">
+            <a:schemeClr val="accent1"/>
+          </a:lnRef>
+          <a:fillRef idx="3">
+            <a:schemeClr val="accent1"/>
+          </a:fillRef>
+          <a:effectRef idx="2">
+            <a:schemeClr val="accent1"/>
+          </a:effectRef>
+          <a:fontRef idx="minor">
+            <a:schemeClr val="lt1"/>
+          </a:fontRef>
+        </p:style>
+        <p:txBody>
+          <a:bodyPr rtlCol="0" anchor="ctr" wrap="square" lIns="64008" rIns="64008"/>
+          <a:lstStyle/>
+          <a:p>
+            <a:pPr algn="ctr"/>
+            <a:r>
+              <a:rPr sz="1600" b="1">
+                <a:solidFill>
+                  <a:srgbClr val="F5F8FD"/>
+                </a:solidFill>
+              </a:rPr>
+              <a:t>② 작업 지시</a:t>
+            </a:r>
+          </a:p>
+          <a:p>
+            <a:pPr algn="ctr"/>
+            <a:r>
+              <a:rPr sz="1400" b="0">
+                <a:solidFill>
+                  <a:srgbClr val="CFDEEB"/>
+                </a:solidFill>
+              </a:rPr>
+              <a:t>새 Kiro 세션 실행</a:t>
+            </a:r>
+          </a:p>
+          <a:p>
+            <a:pPr algn="ctr"/>
+            <a:r>
+              <a:rPr sz="1200" b="0">
+                <a:solidFill>
+                  <a:srgbClr val="8397AB"/>
+                </a:solidFill>
+              </a:rPr>
+              <a:t>요구사항 + 실패 로그</a:t>
+            </a:r>
+          </a:p>
+        </p:txBody>
+      </p:sp>
+      <p:sp>
+        <p:nvSpPr>
+          <p:cNvPr id="8" name="Rounded Rectangle 7"/>
+          <p:cNvSpPr/>
+          <p:nvPr/>
+        </p:nvSpPr>
+        <p:spPr>
+          <a:xfrm>
+            <a:off x="5212080" y="1783080"/>
+            <a:ext cx="1828800" cy="1188720"/>
+          </a:xfrm>
+          <a:prstGeom prst="roundRect">
+            <a:avLst>
+              <a:gd name="adj" fmla="val 8000"/>
+            </a:avLst>
+          </a:prstGeom>
+          <a:solidFill>
+            <a:srgbClr val="162236"/>
+          </a:solidFill>
+          <a:ln w="15875">
+            <a:solidFill>
+              <a:srgbClr val="2A3B52"/>
+            </a:solidFill>
+          </a:ln>
+        </p:spPr>
+        <p:style>
+          <a:lnRef idx="1">
+            <a:schemeClr val="accent1"/>
+          </a:lnRef>
+          <a:fillRef idx="3">
+            <a:schemeClr val="accent1"/>
+          </a:fillRef>
+          <a:effectRef idx="2">
+            <a:schemeClr val="accent1"/>
+          </a:effectRef>
+          <a:fontRef idx="minor">
+            <a:schemeClr val="lt1"/>
+          </a:fontRef>
+        </p:style>
+        <p:txBody>
+          <a:bodyPr rtlCol="0" anchor="ctr" wrap="square" lIns="64008" rIns="64008"/>
+          <a:lstStyle/>
+          <a:p>
+            <a:pPr algn="ctr"/>
+            <a:r>
+              <a:rPr sz="1600" b="1">
+                <a:solidFill>
+                  <a:srgbClr val="F5F8FD"/>
+                </a:solidFill>
+              </a:rPr>
+              <a:t>③ 변조 검사</a:t>
+            </a:r>
+          </a:p>
+          <a:p>
+            <a:pPr algn="ctr"/>
+            <a:r>
+              <a:rPr sz="1400" b="0">
+                <a:solidFill>
+                  <a:srgbClr val="CFDEEB"/>
+                </a:solidFill>
+              </a:rPr>
+              <a:t>테스트·검증기</a:t>
+            </a:r>
+          </a:p>
+          <a:p>
+            <a:pPr algn="ctr"/>
+            <a:r>
+              <a:rPr sz="1200" b="0">
+                <a:solidFill>
+                  <a:srgbClr val="8397AB"/>
+                </a:solidFill>
+              </a:rPr>
+              <a:t>바뀌었으면 복원·중단</a:t>
+            </a:r>
+          </a:p>
+        </p:txBody>
+      </p:sp>
+      <p:sp>
+        <p:nvSpPr>
+          <p:cNvPr id="9" name="Rounded Rectangle 8"/>
+          <p:cNvSpPr/>
+          <p:nvPr/>
+        </p:nvSpPr>
+        <p:spPr>
+          <a:xfrm>
+            <a:off x="7383780" y="1783080"/>
+            <a:ext cx="1828800" cy="1188720"/>
+          </a:xfrm>
+          <a:prstGeom prst="roundRect">
+            <a:avLst>
+              <a:gd name="adj" fmla="val 8000"/>
+            </a:avLst>
+          </a:prstGeom>
+          <a:solidFill>
+            <a:srgbClr val="162236"/>
+          </a:solidFill>
+          <a:ln w="15875">
+            <a:solidFill>
+              <a:srgbClr val="2A3B52"/>
+            </a:solidFill>
+          </a:ln>
+        </p:spPr>
+        <p:style>
+          <a:lnRef idx="1">
+            <a:schemeClr val="accent1"/>
+          </a:lnRef>
+          <a:fillRef idx="3">
+            <a:schemeClr val="accent1"/>
+          </a:fillRef>
+          <a:effectRef idx="2">
+            <a:schemeClr val="accent1"/>
+          </a:effectRef>
+          <a:fontRef idx="minor">
+            <a:schemeClr val="lt1"/>
+          </a:fontRef>
+        </p:style>
+        <p:txBody>
+          <a:bodyPr rtlCol="0" anchor="ctr" wrap="square" lIns="64008" rIns="64008"/>
+          <a:lstStyle/>
+          <a:p>
+            <a:pPr algn="ctr"/>
+            <a:r>
+              <a:rPr sz="1600" b="1">
+                <a:solidFill>
+                  <a:srgbClr val="F5F8FD"/>
+                </a:solidFill>
+              </a:rPr>
+              <a:t>④ 재검사</a:t>
+            </a:r>
+          </a:p>
+          <a:p>
+            <a:pPr algn="ctr"/>
+            <a:r>
+              <a:rPr sz="1400" b="0">
+                <a:solidFill>
+                  <a:srgbClr val="CFDEEB"/>
+                </a:solidFill>
+              </a:rPr>
+              <a:t>verify.py 직접 실행</a:t>
+            </a:r>
+          </a:p>
+          <a:p>
+            <a:pPr algn="ctr"/>
+            <a:r>
+              <a:rPr sz="1200" b="0">
+                <a:solidFill>
+                  <a:srgbClr val="8397AB"/>
+                </a:solidFill>
+              </a:rPr>
+              <a:t>Kiro의 "고쳤다"는 무시</a:t>
+            </a:r>
+          </a:p>
+        </p:txBody>
+      </p:sp>
+      <p:sp>
+        <p:nvSpPr>
+          <p:cNvPr id="10" name="Rounded Rectangle 9"/>
+          <p:cNvSpPr/>
+          <p:nvPr/>
+        </p:nvSpPr>
+        <p:spPr>
+          <a:xfrm>
+            <a:off x="9555480" y="1783080"/>
+            <a:ext cx="1828800" cy="1188720"/>
+          </a:xfrm>
+          <a:prstGeom prst="roundRect">
+            <a:avLst>
+              <a:gd name="adj" fmla="val 8000"/>
+            </a:avLst>
+          </a:prstGeom>
+          <a:solidFill>
+            <a:srgbClr val="162236"/>
+          </a:solidFill>
+          <a:ln w="25400">
+            <a:solidFill>
+              <a:srgbClr val="31D3B1"/>
+            </a:solidFill>
+          </a:ln>
+        </p:spPr>
+        <p:style>
+          <a:lnRef idx="1">
+            <a:schemeClr val="accent1"/>
+          </a:lnRef>
+          <a:fillRef idx="3">
+            <a:schemeClr val="accent1"/>
+          </a:fillRef>
+          <a:effectRef idx="2">
+            <a:schemeClr val="accent1"/>
+          </a:effectRef>
+          <a:fontRef idx="minor">
+            <a:schemeClr val="lt1"/>
+          </a:fontRef>
+        </p:style>
+        <p:txBody>
+          <a:bodyPr rtlCol="0" anchor="ctr" wrap="square" lIns="64008" rIns="64008"/>
+          <a:lstStyle/>
+          <a:p>
+            <a:pPr algn="ctr"/>
+            <a:r>
+              <a:rPr sz="1600" b="1">
+                <a:solidFill>
+                  <a:srgbClr val="F5F8FD"/>
+                </a:solidFill>
+              </a:rPr>
+              <a:t>⑤ 판정</a:t>
+            </a:r>
+          </a:p>
+          <a:p>
+            <a:pPr algn="ctr"/>
+            <a:r>
+              <a:rPr sz="1400" b="1">
+                <a:solidFill>
+                  <a:srgbClr val="4ADE80"/>
+                </a:solidFill>
+              </a:rPr>
+              <a:t>PASS → 종료</a:t>
+            </a:r>
+          </a:p>
+          <a:p>
+            <a:pPr algn="ctr"/>
+            <a:r>
+              <a:rPr sz="1400" b="1">
+                <a:solidFill>
+                  <a:srgbClr val="FF6B6B"/>
+                </a:solidFill>
+              </a:rPr>
+              <a:t>FAIL → ②로</a:t>
+            </a:r>
+          </a:p>
+        </p:txBody>
+      </p:sp>
+      <p:cxnSp>
+        <p:nvCxnSpPr>
+          <p:cNvPr id="11" name="Connector 10"/>
+          <p:cNvCxnSpPr/>
+          <p:nvPr/>
+        </p:nvCxnSpPr>
+        <p:spPr>
+          <a:xfrm>
+            <a:off x="2697480" y="2377440"/>
+            <a:ext cx="342900" cy="0"/>
+          </a:xfrm>
+          <a:prstGeom prst="line">
+            <a:avLst/>
+          </a:prstGeom>
+          <a:ln w="25400">
+            <a:solidFill>
+              <a:srgbClr val="CFDEEB"/>
+            </a:solidFill>
+            <a:tailEnd type="triangle" w="med" len="med"/>
+          </a:ln>
+        </p:spPr>
+        <p:style>
+          <a:lnRef idx="2">
+            <a:schemeClr val="accent1"/>
+          </a:lnRef>
+          <a:fillRef idx="0">
+            <a:schemeClr val="accent1"/>
+          </a:fillRef>
+          <a:effectRef idx="1">
+            <a:schemeClr val="accent1"/>
+          </a:effectRef>
+          <a:fontRef idx="minor">
+            <a:schemeClr val="tx1"/>
+          </a:fontRef>
+        </p:style>
+      </p:cxnSp>
+      <p:cxnSp>
+        <p:nvCxnSpPr>
+          <p:cNvPr id="12" name="Connector 11"/>
+          <p:cNvCxnSpPr/>
+          <p:nvPr/>
+        </p:nvCxnSpPr>
+        <p:spPr>
+          <a:xfrm>
+            <a:off x="4869180" y="2377440"/>
+            <a:ext cx="342900" cy="0"/>
+          </a:xfrm>
+          <a:prstGeom prst="line">
+            <a:avLst/>
+          </a:prstGeom>
+          <a:ln w="25400">
+            <a:solidFill>
+              <a:srgbClr val="CFDEEB"/>
+            </a:solidFill>
+            <a:tailEnd type="triangle" w="med" len="med"/>
+          </a:ln>
+        </p:spPr>
+        <p:style>
+          <a:lnRef idx="2">
+            <a:schemeClr val="accent1"/>
+          </a:lnRef>
+          <a:fillRef idx="0">
+            <a:schemeClr val="accent1"/>
+          </a:fillRef>
+          <a:effectRef idx="1">
+            <a:schemeClr val="accent1"/>
+          </a:effectRef>
+          <a:fontRef idx="minor">
+            <a:schemeClr val="tx1"/>
+          </a:fontRef>
+        </p:style>
+      </p:cxnSp>
+      <p:cxnSp>
+        <p:nvCxnSpPr>
+          <p:cNvPr id="13" name="Connector 12"/>
+          <p:cNvCxnSpPr/>
+          <p:nvPr/>
+        </p:nvCxnSpPr>
+        <p:spPr>
+          <a:xfrm>
+            <a:off x="7040880" y="2377440"/>
+            <a:ext cx="342900" cy="0"/>
+          </a:xfrm>
+          <a:prstGeom prst="line">
+            <a:avLst/>
+          </a:prstGeom>
+          <a:ln w="25400">
+            <a:solidFill>
+              <a:srgbClr val="CFDEEB"/>
+            </a:solidFill>
+            <a:tailEnd type="triangle" w="med" len="med"/>
+          </a:ln>
+        </p:spPr>
+        <p:style>
+          <a:lnRef idx="2">
+            <a:schemeClr val="accent1"/>
+          </a:lnRef>
+          <a:fillRef idx="0">
+            <a:schemeClr val="accent1"/>
+          </a:fillRef>
+          <a:effectRef idx="1">
+            <a:schemeClr val="accent1"/>
+          </a:effectRef>
+          <a:fontRef idx="minor">
+            <a:schemeClr val="tx1"/>
+          </a:fontRef>
+        </p:style>
+      </p:cxnSp>
+      <p:cxnSp>
+        <p:nvCxnSpPr>
+          <p:cNvPr id="14" name="Connector 13"/>
+          <p:cNvCxnSpPr/>
+          <p:nvPr/>
+        </p:nvCxnSpPr>
+        <p:spPr>
+          <a:xfrm>
+            <a:off x="9212580" y="2377440"/>
+            <a:ext cx="342900" cy="0"/>
+          </a:xfrm>
+          <a:prstGeom prst="line">
+            <a:avLst/>
+          </a:prstGeom>
+          <a:ln w="25400">
+            <a:solidFill>
+              <a:srgbClr val="CFDEEB"/>
+            </a:solidFill>
+            <a:tailEnd type="triangle" w="med" len="med"/>
+          </a:ln>
+        </p:spPr>
+        <p:style>
+          <a:lnRef idx="2">
+            <a:schemeClr val="accent1"/>
+          </a:lnRef>
+          <a:fillRef idx="0">
+            <a:schemeClr val="accent1"/>
+          </a:fillRef>
+          <a:effectRef idx="1">
+            <a:schemeClr val="accent1"/>
+          </a:effectRef>
+          <a:fontRef idx="minor">
+            <a:schemeClr val="tx1"/>
+          </a:fontRef>
+        </p:style>
+      </p:cxnSp>
+      <p:cxnSp>
+        <p:nvCxnSpPr>
+          <p:cNvPr id="15" name="Connector 14"/>
+          <p:cNvCxnSpPr/>
+          <p:nvPr/>
+        </p:nvCxnSpPr>
+        <p:spPr>
+          <a:xfrm>
+            <a:off x="10469880" y="2971800"/>
+            <a:ext cx="0" cy="457200"/>
+          </a:xfrm>
+          <a:prstGeom prst="line">
+            <a:avLst/>
+          </a:prstGeom>
+          <a:ln w="25400">
+            <a:solidFill>
+              <a:srgbClr val="FF6B6B"/>
+            </a:solidFill>
+          </a:ln>
+        </p:spPr>
+        <p:style>
+          <a:lnRef idx="2">
+            <a:schemeClr val="accent1"/>
+          </a:lnRef>
+          <a:fillRef idx="0">
+            <a:schemeClr val="accent1"/>
+          </a:fillRef>
+          <a:effectRef idx="1">
+            <a:schemeClr val="accent1"/>
+          </a:effectRef>
+          <a:fontRef idx="minor">
+            <a:schemeClr val="tx1"/>
+          </a:fontRef>
+        </p:style>
+      </p:cxnSp>
+      <p:cxnSp>
+        <p:nvCxnSpPr>
+          <p:cNvPr id="16" name="Connector 15"/>
+          <p:cNvCxnSpPr/>
+          <p:nvPr/>
+        </p:nvCxnSpPr>
+        <p:spPr>
+          <a:xfrm flipH="1">
+            <a:off x="3954780" y="3429000"/>
+            <a:ext cx="6515100" cy="0"/>
+          </a:xfrm>
+          <a:prstGeom prst="line">
+            <a:avLst/>
+          </a:prstGeom>
+          <a:ln w="25400">
+            <a:solidFill>
+              <a:srgbClr val="FF6B6B"/>
+            </a:solidFill>
+          </a:ln>
+        </p:spPr>
+        <p:style>
+          <a:lnRef idx="2">
+            <a:schemeClr val="accent1"/>
+          </a:lnRef>
+          <a:fillRef idx="0">
+            <a:schemeClr val="accent1"/>
+          </a:fillRef>
+          <a:effectRef idx="1">
+            <a:schemeClr val="accent1"/>
+          </a:effectRef>
+          <a:fontRef idx="minor">
+            <a:schemeClr val="tx1"/>
+          </a:fontRef>
+        </p:style>
+      </p:cxnSp>
+      <p:cxnSp>
+        <p:nvCxnSpPr>
+          <p:cNvPr id="17" name="Connector 16"/>
+          <p:cNvCxnSpPr/>
+          <p:nvPr/>
+        </p:nvCxnSpPr>
+        <p:spPr>
+          <a:xfrm flipV="1">
+            <a:off x="3954780" y="2971800"/>
+            <a:ext cx="0" cy="457200"/>
+          </a:xfrm>
+          <a:prstGeom prst="line">
+            <a:avLst/>
+          </a:prstGeom>
+          <a:ln w="25400">
+            <a:solidFill>
+              <a:srgbClr val="FF6B6B"/>
+            </a:solidFill>
+            <a:tailEnd type="triangle" w="med" len="med"/>
+          </a:ln>
+        </p:spPr>
+        <p:style>
+          <a:lnRef idx="2">
+            <a:schemeClr val="accent1"/>
+          </a:lnRef>
+          <a:fillRef idx="0">
+            <a:schemeClr val="accent1"/>
+          </a:fillRef>
+          <a:effectRef idx="1">
+            <a:schemeClr val="accent1"/>
+          </a:effectRef>
+          <a:fontRef idx="minor">
+            <a:schemeClr val="tx1"/>
+          </a:fontRef>
+        </p:style>
+      </p:cxnSp>
+      <p:sp>
+        <p:nvSpPr>
+          <p:cNvPr id="18" name="TextBox 17"/>
+          <p:cNvSpPr txBox="1"/>
+          <p:nvPr/>
+        </p:nvSpPr>
+        <p:spPr>
+          <a:xfrm>
+            <a:off x="4046220" y="3456432"/>
+            <a:ext cx="6515100" cy="320040"/>
+          </a:xfrm>
+          <a:prstGeom prst="rect">
+            <a:avLst/>
+          </a:prstGeom>
+          <a:noFill/>
+        </p:spPr>
+        <p:txBody>
+          <a:bodyPr wrap="square">
+            <a:spAutoFit/>
+          </a:bodyPr>
+          <a:lstStyle/>
+          <a:p>
+            <a:r>
+              <a:rPr sz="1300" b="1">
+                <a:solidFill>
+                  <a:srgbClr val="FF6B6B"/>
+                </a:solidFill>
+              </a:rPr>
+              <a:t>FAIL: 실패 로그를 들고 새 Kiro 세션 시작 (사람 입력 없음)</a:t>
+            </a:r>
+          </a:p>
+        </p:txBody>
+      </p:sp>
+      <p:sp>
+        <p:nvSpPr>
+          <p:cNvPr id="19" name="Rounded Rectangle 18"/>
+          <p:cNvSpPr/>
+          <p:nvPr/>
+        </p:nvSpPr>
+        <p:spPr>
+          <a:xfrm>
+            <a:off x="868680" y="3886200"/>
+            <a:ext cx="4000500" cy="640080"/>
+          </a:xfrm>
+          <a:prstGeom prst="roundRect">
+            <a:avLst>
+              <a:gd name="adj" fmla="val 8000"/>
+            </a:avLst>
+          </a:prstGeom>
+          <a:solidFill>
+            <a:srgbClr val="0E1625"/>
+          </a:solidFill>
+          <a:ln w="15875">
+            <a:solidFill>
+              <a:srgbClr val="7C5CFF"/>
+            </a:solidFill>
+            <a:prstDash val="dash"/>
+          </a:ln>
+        </p:spPr>
+        <p:style>
+          <a:lnRef idx="1">
+            <a:schemeClr val="accent1"/>
+          </a:lnRef>
+          <a:fillRef idx="3">
+            <a:schemeClr val="accent1"/>
+          </a:fillRef>
+          <a:effectRef idx="2">
+            <a:schemeClr val="accent1"/>
+          </a:effectRef>
+          <a:fontRef idx="minor">
+            <a:schemeClr val="lt1"/>
+          </a:fontRef>
+        </p:style>
+        <p:txBody>
+          <a:bodyPr rtlCol="0" anchor="ctr" wrap="square" lIns="64008" rIns="64008"/>
+          <a:lstStyle/>
+          <a:p>
+            <a:pPr algn="ctr"/>
+            <a:r>
+              <a:rPr sz="1300" b="1">
+                <a:solidFill>
+                  <a:srgbClr val="7C5CFF"/>
+                </a:solidFill>
+              </a:rPr>
+              <a:t>Kiro 내부 (Inner Loop)</a:t>
+            </a:r>
+          </a:p>
+          <a:p>
+            <a:pPr algn="ctr"/>
+            <a:r>
+              <a:rPr sz="1300" b="0">
+                <a:solidFill>
+                  <a:srgbClr val="CFDEEB"/>
+                </a:solidFill>
+              </a:rPr>
+              <a:t>파일 읽기 → 수정 → "고쳤습니다" → 종료</a:t>
+            </a:r>
+          </a:p>
+        </p:txBody>
+      </p:sp>
+      <p:sp>
+        <p:nvSpPr>
+          <p:cNvPr id="20" name="Rounded Rectangle 19"/>
+          <p:cNvSpPr/>
+          <p:nvPr/>
+        </p:nvSpPr>
+        <p:spPr>
+          <a:xfrm>
+            <a:off x="868680" y="4709160"/>
+            <a:ext cx="3383280" cy="1005840"/>
+          </a:xfrm>
+          <a:prstGeom prst="roundRect">
+            <a:avLst>
+              <a:gd name="adj" fmla="val 8000"/>
+            </a:avLst>
+          </a:prstGeom>
+          <a:solidFill>
+            <a:srgbClr val="162236"/>
+          </a:solidFill>
+          <a:ln w="15875">
+            <a:solidFill>
+              <a:srgbClr val="2A3B52"/>
+            </a:solidFill>
+          </a:ln>
+        </p:spPr>
+        <p:style>
+          <a:lnRef idx="1">
+            <a:schemeClr val="accent1"/>
+          </a:lnRef>
+          <a:fillRef idx="3">
+            <a:schemeClr val="accent1"/>
+          </a:fillRef>
+          <a:effectRef idx="2">
+            <a:schemeClr val="accent1"/>
+          </a:effectRef>
+          <a:fontRef idx="minor">
+            <a:schemeClr val="lt1"/>
+          </a:fontRef>
+        </p:style>
+        <p:txBody>
+          <a:bodyPr rtlCol="0" anchor="ctr" wrap="square" lIns="64008" rIns="64008"/>
+          <a:lstStyle/>
+          <a:p>
+            <a:pPr algn="ctr"/>
+            <a:r>
+              <a:rPr sz="1400" b="1">
+                <a:solidFill>
+                  <a:srgbClr val="31D3B1"/>
+                </a:solidFill>
+              </a:rPr>
+              <a:t>종료 조건</a:t>
+            </a:r>
+          </a:p>
+          <a:p>
+            <a:pPr algn="ctr"/>
+            <a:r>
+              <a:rPr sz="1300" b="0">
+                <a:solidFill>
+                  <a:srgbClr val="CFDEEB"/>
+                </a:solidFill>
+              </a:rPr>
+              <a:t>PASS · 최대 5회 · 세션 300초</a:t>
+            </a:r>
+          </a:p>
+          <a:p>
+            <a:pPr algn="ctr"/>
+            <a:r>
+              <a:rPr sz="1300" b="0">
+                <a:solidFill>
+                  <a:srgbClr val="CFDEEB"/>
+                </a:solidFill>
+              </a:rPr>
+              <a:t>Kiro 오류 · 보호 파일 변조</a:t>
+            </a:r>
+          </a:p>
+        </p:txBody>
+      </p:sp>
+      <p:sp>
+        <p:nvSpPr>
+          <p:cNvPr id="21" name="Rounded Rectangle 20"/>
+          <p:cNvSpPr/>
+          <p:nvPr/>
+        </p:nvSpPr>
+        <p:spPr>
+          <a:xfrm>
+            <a:off x="4434840" y="4709160"/>
+            <a:ext cx="3383280" cy="1005840"/>
+          </a:xfrm>
+          <a:prstGeom prst="roundRect">
+            <a:avLst>
+              <a:gd name="adj" fmla="val 8000"/>
+            </a:avLst>
+          </a:prstGeom>
+          <a:solidFill>
+            <a:srgbClr val="162236"/>
+          </a:solidFill>
+          <a:ln w="15875">
+            <a:solidFill>
+              <a:srgbClr val="2A3B52"/>
+            </a:solidFill>
+          </a:ln>
+        </p:spPr>
+        <p:style>
+          <a:lnRef idx="1">
+            <a:schemeClr val="accent1"/>
+          </a:lnRef>
+          <a:fillRef idx="3">
+            <a:schemeClr val="accent1"/>
+          </a:fillRef>
+          <a:effectRef idx="2">
+            <a:schemeClr val="accent1"/>
+          </a:effectRef>
+          <a:fontRef idx="minor">
+            <a:schemeClr val="lt1"/>
+          </a:fontRef>
+        </p:style>
+        <p:txBody>
+          <a:bodyPr rtlCol="0" anchor="ctr" wrap="square" lIns="64008" rIns="64008"/>
+          <a:lstStyle/>
+          <a:p>
+            <a:pPr algn="ctr"/>
+            <a:r>
+              <a:rPr sz="1400" b="1">
+                <a:solidFill>
+                  <a:srgbClr val="31D3B1"/>
+                </a:solidFill>
+              </a:rPr>
+              <a:t>기록 .loop/</a:t>
+            </a:r>
+          </a:p>
+          <a:p>
+            <a:pPr algn="ctr"/>
+            <a:r>
+              <a:rPr sz="1300" b="0">
+                <a:solidFill>
+                  <a:srgbClr val="CFDEEB"/>
+                </a:solidFill>
+              </a:rPr>
+              <a:t>회차별 결과 · Kiro 로그</a:t>
+            </a:r>
+          </a:p>
+          <a:p>
+            <a:pPr algn="ctr"/>
+            <a:r>
+              <a:rPr sz="1300" b="0">
+                <a:solidFill>
+                  <a:srgbClr val="CFDEEB"/>
+                </a:solidFill>
+              </a:rPr>
+              <a:t>코드 diff · summary.json</a:t>
+            </a:r>
+          </a:p>
+        </p:txBody>
+      </p:sp>
+      <p:sp>
+        <p:nvSpPr>
+          <p:cNvPr id="22" name="Rounded Rectangle 21"/>
+          <p:cNvSpPr/>
+          <p:nvPr/>
+        </p:nvSpPr>
+        <p:spPr>
+          <a:xfrm>
+            <a:off x="8001000" y="4709160"/>
+            <a:ext cx="3383280" cy="1005840"/>
+          </a:xfrm>
+          <a:prstGeom prst="roundRect">
+            <a:avLst>
+              <a:gd name="adj" fmla="val 8000"/>
+            </a:avLst>
+          </a:prstGeom>
+          <a:solidFill>
+            <a:srgbClr val="162236"/>
+          </a:solidFill>
+          <a:ln w="15875">
+            <a:solidFill>
+              <a:srgbClr val="2A3B52"/>
+            </a:solidFill>
+          </a:ln>
+        </p:spPr>
+        <p:style>
+          <a:lnRef idx="1">
+            <a:schemeClr val="accent1"/>
+          </a:lnRef>
+          <a:fillRef idx="3">
+            <a:schemeClr val="accent1"/>
+          </a:fillRef>
+          <a:effectRef idx="2">
+            <a:schemeClr val="accent1"/>
+          </a:effectRef>
+          <a:fontRef idx="minor">
+            <a:schemeClr val="lt1"/>
+          </a:fontRef>
+        </p:style>
+        <p:txBody>
+          <a:bodyPr rtlCol="0" anchor="ctr" wrap="square" lIns="64008" rIns="64008"/>
+          <a:lstStyle/>
+          <a:p>
+            <a:pPr algn="ctr"/>
+            <a:r>
+              <a:rPr sz="1400" b="1">
+                <a:solidFill>
+                  <a:srgbClr val="31D3B1"/>
+                </a:solidFill>
+              </a:rPr>
+              <a:t>기억</a:t>
+            </a:r>
+          </a:p>
+          <a:p>
+            <a:pPr algn="ctr"/>
+            <a:r>
+              <a:rPr sz="1300" b="0">
+                <a:solidFill>
+                  <a:srgbClr val="CFDEEB"/>
+                </a:solidFill>
+              </a:rPr>
+              <a:t>Kiro는 매번 새 세션(기억 없음)</a:t>
+            </a:r>
+          </a:p>
+          <a:p>
+            <a:pPr algn="ctr"/>
+            <a:r>
+              <a:rPr sz="1300" b="0">
+                <a:solidFill>
+                  <a:srgbClr val="CFDEEB"/>
+                </a:solidFill>
+              </a:rPr>
+              <a:t>다음 세션에 넘기는 실패 로그가 기억</a:t>
+            </a:r>
+          </a:p>
+        </p:txBody>
+      </p:sp>
+      <p:cxnSp>
+        <p:nvCxnSpPr>
+          <p:cNvPr id="23" name="Connector 22"/>
+          <p:cNvCxnSpPr/>
+          <p:nvPr/>
+        </p:nvCxnSpPr>
+        <p:spPr>
+          <a:xfrm>
+            <a:off x="3497580" y="2971800"/>
+            <a:ext cx="0" cy="914400"/>
+          </a:xfrm>
+          <a:prstGeom prst="line">
+            <a:avLst/>
+          </a:prstGeom>
+          <a:ln w="25400">
+            <a:solidFill>
+              <a:srgbClr val="7C5CFF"/>
+            </a:solidFill>
+            <a:prstDash val="dash"/>
+          </a:ln>
+        </p:spPr>
+        <p:style>
+          <a:lnRef idx="2">
+            <a:schemeClr val="accent1"/>
+          </a:lnRef>
+          <a:fillRef idx="0">
+            <a:schemeClr val="accent1"/>
+          </a:fillRef>
+          <a:effectRef idx="1">
+            <a:schemeClr val="accent1"/>
+          </a:effectRef>
+          <a:fontRef idx="minor">
+            <a:schemeClr val="tx1"/>
+          </a:fontRef>
+        </p:style>
+      </p:cxnSp>
     </p:spTree>
   </p:cSld>
   <p:clrMapOvr>
@@ -6824,7 +8387,7 @@
           <a:noFill/>
         </p:spPr>
         <p:txBody>
-          <a:bodyPr wrap="none">
+          <a:bodyPr wrap="square">
             <a:spAutoFit/>
           </a:bodyPr>
           <a:lstStyle/>
@@ -6835,7 +8398,7 @@
                   <a:srgbClr val="F5F8FD"/>
                 </a:solidFill>
               </a:rPr>
-              <a:t>왜 단순 프롬프트와 다른가?</a:t>
+              <a:t>loop.py 핵심 로직 (약 15줄)</a:t>
             </a:r>
           </a:p>
         </p:txBody>
@@ -6848,8 +8411,8 @@
         </p:nvSpPr>
         <p:spPr>
           <a:xfrm>
-            <a:off x="868680" y="1691640"/>
-            <a:ext cx="10515600" cy="4480560"/>
+            <a:off x="868680" y="6492240"/>
+            <a:ext cx="10515600" cy="201168"/>
           </a:xfrm>
           <a:prstGeom prst="rect">
             <a:avLst/>
@@ -6862,77 +8425,74 @@
           </a:bodyPr>
           <a:lstStyle/>
           <a:p>
-            <a:pPr>
-              <a:spcAft>
-                <a:spcPts val="1700"/>
-              </a:spcAft>
-            </a:pPr>
-            <a:r>
-              <a:rPr sz="2200">
-                <a:solidFill>
-                  <a:srgbClr val="CFDEEB"/>
-                </a:solidFill>
-              </a:rPr>
-              <a:t>AI 세션이 끝나도 Controller가 결과를 판정한다</a:t>
-            </a:r>
-          </a:p>
-          <a:p>
-            <a:pPr>
-              <a:spcAft>
-                <a:spcPts val="1700"/>
-              </a:spcAft>
-            </a:pPr>
-            <a:r>
-              <a:rPr sz="2200">
-                <a:solidFill>
-                  <a:srgbClr val="CFDEEB"/>
-                </a:solidFill>
-              </a:rPr>
-              <a:t>실패 로그를 다음 새 세션에 전달한다</a:t>
-            </a:r>
-          </a:p>
-          <a:p>
-            <a:pPr>
-              <a:spcAft>
-                <a:spcPts val="1700"/>
-              </a:spcAft>
-            </a:pPr>
-            <a:r>
-              <a:rPr sz="2200">
-                <a:solidFill>
-                  <a:srgbClr val="CFDEEB"/>
-                </a:solidFill>
-              </a:rPr>
-              <a:t>모델이 “성공”이라고 해도 테스트가 실패하면 반복한다</a:t>
-            </a:r>
-          </a:p>
-          <a:p>
-            <a:pPr>
-              <a:spcAft>
-                <a:spcPts val="1700"/>
-              </a:spcAft>
-            </a:pPr>
-            <a:r>
-              <a:rPr sz="2200">
-                <a:solidFill>
-                  <a:srgbClr val="CFDEEB"/>
-                </a:solidFill>
-              </a:rPr>
-              <a:t>최대 반복 횟수에 도달하면 실패로 종료한다</a:t>
-            </a:r>
-          </a:p>
-        </p:txBody>
-      </p:sp>
-      <p:sp>
-        <p:nvSpPr>
-          <p:cNvPr id="5" name="TextBox 4"/>
+            <a:r>
+              <a:rPr sz="1000" b="0">
+                <a:solidFill>
+                  <a:srgbClr val="8397AB"/>
+                </a:solidFill>
+              </a:rPr>
+              <a:t>AI Agent Loop · 2026.10.21                                     08 / 16</a:t>
+            </a:r>
+          </a:p>
+        </p:txBody>
+      </p:sp>
+      <p:sp>
+        <p:nvSpPr>
+          <p:cNvPr id="5" name="Rounded Rectangle 4"/>
+          <p:cNvSpPr/>
+          <p:nvPr/>
+        </p:nvSpPr>
+        <p:spPr>
+          <a:xfrm>
+            <a:off x="868680" y="1463040"/>
+            <a:ext cx="10515600" cy="4114800"/>
+          </a:xfrm>
+          <a:prstGeom prst="roundRect">
+            <a:avLst>
+              <a:gd name="adj" fmla="val 3000"/>
+            </a:avLst>
+          </a:prstGeom>
+          <a:solidFill>
+            <a:srgbClr val="050A12"/>
+          </a:solidFill>
+          <a:ln>
+            <a:solidFill>
+              <a:srgbClr val="2A3B52"/>
+            </a:solidFill>
+          </a:ln>
+        </p:spPr>
+        <p:style>
+          <a:lnRef idx="1">
+            <a:schemeClr val="accent1"/>
+          </a:lnRef>
+          <a:fillRef idx="3">
+            <a:schemeClr val="accent1"/>
+          </a:fillRef>
+          <a:effectRef idx="2">
+            <a:schemeClr val="accent1"/>
+          </a:effectRef>
+          <a:fontRef idx="minor">
+            <a:schemeClr val="lt1"/>
+          </a:fontRef>
+        </p:style>
+        <p:txBody>
+          <a:bodyPr rtlCol="0" anchor="ctr"/>
+          <a:lstStyle/>
+          <a:p>
+            <a:pPr algn="ctr"/>
+          </a:p>
+        </p:txBody>
+      </p:sp>
+      <p:sp>
+        <p:nvSpPr>
+          <p:cNvPr id="6" name="TextBox 5"/>
           <p:cNvSpPr txBox="1"/>
           <p:nvPr/>
         </p:nvSpPr>
         <p:spPr>
           <a:xfrm>
-            <a:off x="868680" y="6492240"/>
-            <a:ext cx="10515600" cy="201168"/>
+            <a:off x="1097280" y="1554480"/>
+            <a:ext cx="10058400" cy="3931920"/>
           </a:xfrm>
           <a:prstGeom prst="rect">
             <a:avLst/>
@@ -6940,18 +8500,209 @@
           <a:noFill/>
         </p:spPr>
         <p:txBody>
-          <a:bodyPr wrap="none">
+          <a:bodyPr wrap="square">
             <a:spAutoFit/>
           </a:bodyPr>
           <a:lstStyle/>
           <a:p>
             <a:r>
-              <a:rPr sz="1000">
+              <a:rPr sz="1500" b="0">
+                <a:solidFill>
+                  <a:srgbClr val="CFDEEB"/>
+                </a:solidFill>
+                <a:latin typeface="Menlo"/>
+                <a:ea typeface="Apple SD Gothic Neo"/>
+              </a:rPr>
+              <a:t>ok, log = qa_gate()                        # ① 현재 상태 검사 (verify.py)</a:t>
+            </a:r>
+          </a:p>
+          <a:p>
+            <a:r>
+              <a:rPr sz="1500" b="0">
+                <a:solidFill>
+                  <a:srgbClr val="CFDEEB"/>
+                </a:solidFill>
+                <a:latin typeface="Menlo"/>
+                <a:ea typeface="Apple SD Gothic Neo"/>
+              </a:rPr>
+              <a:t>if ok: return "ALREADY_PASSING"</a:t>
+            </a:r>
+          </a:p>
+          <a:p>
+            <a:r>
+              <a:rPr sz="1500" b="0">
+                <a:solidFill>
+                  <a:srgbClr val="CFDEEB"/>
+                </a:solidFill>
+                <a:latin typeface="Menlo"/>
+                <a:ea typeface="Apple SD Gothic Neo"/>
+              </a:rPr>
+              <a:t/>
+            </a:r>
+          </a:p>
+          <a:p>
+            <a:r>
+              <a:rPr sz="1500" b="0">
+                <a:solidFill>
+                  <a:srgbClr val="31D3B1"/>
+                </a:solidFill>
+                <a:latin typeface="Menlo"/>
+                <a:ea typeface="Apple SD Gothic Neo"/>
+              </a:rPr>
+              <a:t>for i in range(1, 6):                      # 최대 5회</a:t>
+            </a:r>
+          </a:p>
+          <a:p>
+            <a:r>
+              <a:rPr sz="1500" b="0">
+                <a:solidFill>
+                  <a:srgbClr val="7C5CFF"/>
+                </a:solidFill>
+                <a:latin typeface="Menlo"/>
+                <a:ea typeface="Apple SD Gothic Neo"/>
+              </a:rPr>
+              <a:t>    run_kiro(prompt + log, timeout=300)    # ② 새 Kiro 세션 = 작업 지시</a:t>
+            </a:r>
+          </a:p>
+          <a:p>
+            <a:r>
+              <a:rPr sz="1500" b="0">
+                <a:solidFill>
+                  <a:srgbClr val="CFDEEB"/>
+                </a:solidFill>
+                <a:latin typeface="Menlo"/>
+                <a:ea typeface="Apple SD Gothic Neo"/>
+              </a:rPr>
+              <a:t>    if protected_files_changed():          # ③ 테스트·검증기 변조 검사</a:t>
+            </a:r>
+          </a:p>
+          <a:p>
+            <a:r>
+              <a:rPr sz="1500" b="0">
+                <a:solidFill>
+                  <a:srgbClr val="FF6B6B"/>
+                </a:solidFill>
+                <a:latin typeface="Menlo"/>
+                <a:ea typeface="Apple SD Gothic Neo"/>
+              </a:rPr>
+              <a:t>        restore(); return "GUARDRAIL_STOP"</a:t>
+            </a:r>
+          </a:p>
+          <a:p>
+            <a:r>
+              <a:rPr sz="1500" b="0">
+                <a:solidFill>
+                  <a:srgbClr val="CFDEEB"/>
+                </a:solidFill>
+                <a:latin typeface="Menlo"/>
+                <a:ea typeface="Apple SD Gothic Neo"/>
+              </a:rPr>
+              <a:t>    ok, log = qa_gate()                    # ④ AI 말 대신 직접 검사</a:t>
+            </a:r>
+          </a:p>
+          <a:p>
+            <a:r>
+              <a:rPr sz="1500" b="0">
+                <a:solidFill>
+                  <a:srgbClr val="CFDEEB"/>
+                </a:solidFill>
+                <a:latin typeface="Menlo"/>
+                <a:ea typeface="Apple SD Gothic Neo"/>
+              </a:rPr>
+              <a:t>    save_record(i, ok, log, diff)          # .loop/ 에 기록</a:t>
+            </a:r>
+          </a:p>
+          <a:p>
+            <a:r>
+              <a:rPr sz="1500" b="0">
+                <a:solidFill>
+                  <a:srgbClr val="4ADE80"/>
+                </a:solidFill>
+                <a:latin typeface="Menlo"/>
+                <a:ea typeface="Apple SD Gothic Neo"/>
+              </a:rPr>
+              <a:t>    if ok: return "PASS"                   # ⑤ 판정: 성공</a:t>
+            </a:r>
+          </a:p>
+          <a:p>
+            <a:r>
+              <a:rPr sz="1500" b="0">
+                <a:solidFill>
+                  <a:srgbClr val="FF6B6B"/>
+                </a:solidFill>
+                <a:latin typeface="Menlo"/>
+                <a:ea typeface="Apple SD Gothic Neo"/>
+              </a:rPr>
+              <a:t>    if kiro_failed: return "AGENT_ERROR"   #    도구·인증·타임아웃 오류</a:t>
+            </a:r>
+          </a:p>
+          <a:p>
+            <a:r>
+              <a:rPr sz="1500" b="0">
                 <a:solidFill>
                   <a:srgbClr val="8397AB"/>
                 </a:solidFill>
-              </a:rPr>
-              <a:t>AI Agent Loop · 2026.10.21                                     11 / 14</a:t>
+                <a:latin typeface="Menlo"/>
+                <a:ea typeface="Apple SD Gothic Neo"/>
+              </a:rPr>
+              <a:t>    # FAIL이면 log를 들고 다음 회차로</a:t>
+            </a:r>
+          </a:p>
+          <a:p>
+            <a:r>
+              <a:rPr sz="1500" b="0">
+                <a:solidFill>
+                  <a:srgbClr val="CFDEEB"/>
+                </a:solidFill>
+                <a:latin typeface="Menlo"/>
+                <a:ea typeface="Apple SD Gothic Neo"/>
+              </a:rPr>
+              <a:t/>
+            </a:r>
+          </a:p>
+          <a:p>
+            <a:r>
+              <a:rPr sz="1500" b="0">
+                <a:solidFill>
+                  <a:srgbClr val="FF6B6B"/>
+                </a:solidFill>
+                <a:latin typeface="Menlo"/>
+                <a:ea typeface="Apple SD Gothic Neo"/>
+              </a:rPr>
+              <a:t>return "MAX_ITERATIONS"                    # 5회 모두 실패</a:t>
+            </a:r>
+          </a:p>
+        </p:txBody>
+      </p:sp>
+      <p:sp>
+        <p:nvSpPr>
+          <p:cNvPr id="7" name="TextBox 6"/>
+          <p:cNvSpPr txBox="1"/>
+          <p:nvPr/>
+        </p:nvSpPr>
+        <p:spPr>
+          <a:xfrm>
+            <a:off x="868680" y="5715000"/>
+            <a:ext cx="10515600" cy="548640"/>
+          </a:xfrm>
+          <a:prstGeom prst="rect">
+            <a:avLst/>
+          </a:prstGeom>
+          <a:noFill/>
+        </p:spPr>
+        <p:txBody>
+          <a:bodyPr wrap="square">
+            <a:spAutoFit/>
+          </a:bodyPr>
+          <a:lstStyle/>
+          <a:p>
+            <a:r>
+              <a:rPr sz="1800" b="0">
+                <a:solidFill>
+                  <a:srgbClr val="CFDEEB"/>
+                </a:solidFill>
+              </a:rPr>
+              <a:t>Controller는 AI가 아니다 — 테스트 결과(PASS/FAIL)만 보고 if문으로 결정한다</a:t>
             </a:r>
           </a:p>
         </p:txBody>
@@ -7053,7 +8804,7 @@
                   <a:srgbClr val="F5F8FD"/>
                 </a:solidFill>
               </a:rPr>
-              <a:t>운영 적용 전 꼭 필요한 것</a:t>
+              <a:t>데모 실행 순서</a:t>
             </a:r>
           </a:p>
         </p:txBody>
@@ -7091,7 +8842,7 @@
                   <a:srgbClr val="CFDEEB"/>
                 </a:solidFill>
               </a:rPr>
-              <a:t>실행 환경 격리 / 최소 권한 / 비밀정보 제거</a:t>
+              <a:t>1. python3 verify.py → FAIL 확인</a:t>
             </a:r>
           </a:p>
           <a:p>
@@ -7106,7 +8857,7 @@
                   <a:srgbClr val="CFDEEB"/>
                 </a:solidFill>
               </a:rPr>
-              <a:t>테스트 및 검증기 변조 방지 (데모 검사는 보안 격리 아님)</a:t>
+              <a:t>2. python3 loop.py --provider mock --reset (리허설)</a:t>
             </a:r>
           </a:p>
           <a:p>
@@ -7121,7 +8872,7 @@
                   <a:srgbClr val="CFDEEB"/>
                 </a:solidFill>
               </a:rPr>
-              <a:t>실행 예산과 타임아웃 / 중복 실행 방지</a:t>
+              <a:t>3. python3 loop.py --provider kiro --reset</a:t>
             </a:r>
           </a:p>
           <a:p>
@@ -7136,7 +8887,7 @@
                   <a:srgbClr val="CFDEEB"/>
                 </a:solidFill>
               </a:rPr>
-              <a:t>관측성: 실패 원인·변경 diff·비용·횟수</a:t>
+              <a:t>4. ... --provider kiro --reset --inject-fault (데모 모드)</a:t>
             </a:r>
           </a:p>
           <a:p>
@@ -7151,7 +8902,7 @@
                   <a:srgbClr val="CFDEEB"/>
                 </a:solidFill>
               </a:rPr>
-              <a:t>Human approval: PR 머지·배포·권한 변경</a:t>
+              <a:t>5. .loop/summary.json · iteration-NN.json · diff-NN.patch 확인</a:t>
             </a:r>
           </a:p>
         </p:txBody>
@@ -7184,7 +8935,7 @@
                   <a:srgbClr val="8397AB"/>
                 </a:solidFill>
               </a:rPr>
-              <a:t>AI Agent Loop · 2026.10.21                                     12 / 14</a:t>
+              <a:t>AI Agent Loop · 2026.10.21                                     09 / 16</a:t>
             </a:r>
           </a:p>
         </p:txBody>

</xml_diff>

<commit_message>
Rework demo scenario slide: buggy code, test table, mission
</commit_message>
<xml_diff>
--- a/docs/AI_Agent_Loop.pptx
+++ b/docs/AI_Agent_Loop.pptx
@@ -798,6 +798,76 @@
           <a:p>
             <a:r>
               <a:t>실제 loop.py는 로그·출력·기록 코드 포함 약 250줄이지만 반복의 뼈대는 이것뿐이다. 중요한 줄은 ④: Kiro가 무엇을 말했든 qa_gate()의 결과만으로 판정한다. 종료 경로는 PASS / GUARDRAIL_STOP / AGENT_ERROR / MAX_ITERATIONS 네 가지이며 모두 Controller가 결정한다.</a:t>
+            </a:r>
+          </a:p>
+        </p:txBody>
+      </p:sp>
+      <p:sp>
+        <p:nvSpPr>
+          <p:cNvPr id="4" name="Slide Number Placeholder 3"/>
+          <p:cNvSpPr>
+            <a:spLocks noGrp="1"/>
+          </p:cNvSpPr>
+          <p:nvPr>
+            <p:ph type="sldNum" idx="5" sz="quarter"/>
+          </p:nvPr>
+        </p:nvSpPr>
+        <p:spPr/>
+      </p:sp>
+    </p:spTree>
+  </p:cSld>
+  <p:clrMapOvr>
+    <a:masterClrMapping/>
+  </p:clrMapOvr>
+</p:notes>
+</file>
+
+<file path=ppt/notesSlides/notesSlide6.xml><?xml version="1.0" encoding="utf-8"?>
+<p:notes xmlns:a="http://schemas.openxmlformats.org/drawingml/2006/main" xmlns:p="http://schemas.openxmlformats.org/presentationml/2006/main" xmlns:r="http://schemas.openxmlformats.org/officeDocument/2006/relationships">
+  <p:cSld>
+    <p:spTree>
+      <p:nvGrpSpPr>
+        <p:cNvPr id="1" name=""/>
+        <p:cNvGrpSpPr/>
+        <p:nvPr/>
+      </p:nvGrpSpPr>
+      <p:grpSpPr>
+        <a:xfrm>
+          <a:off x="0" y="0"/>
+          <a:ext cx="0" cy="0"/>
+          <a:chOff x="0" y="0"/>
+          <a:chExt cx="0" cy="0"/>
+        </a:xfrm>
+      </p:grpSpPr>
+      <p:sp>
+        <p:nvSpPr>
+          <p:cNvPr id="2" name="Slide Image Placeholder 1"/>
+          <p:cNvSpPr>
+            <a:spLocks noGrp="1"/>
+          </p:cNvSpPr>
+          <p:nvPr>
+            <p:ph type="sldImg" idx="2"/>
+          </p:nvPr>
+        </p:nvSpPr>
+        <p:spPr/>
+      </p:sp>
+      <p:sp>
+        <p:nvSpPr>
+          <p:cNvPr id="3" name="Notes Placeholder 2"/>
+          <p:cNvSpPr>
+            <a:spLocks noGrp="1"/>
+          </p:cNvSpPr>
+          <p:nvPr>
+            <p:ph type="body" idx="3" sz="quarter"/>
+          </p:nvPr>
+        </p:nvSpPr>
+        <p:spPr/>
+        <p:txBody>
+          <a:bodyPr/>
+          <a:lstStyle/>
+          <a:p>
+            <a:r>
+              <a:t>할인 계산기: 금액과 할인율을 받아 할인된 가격을 돌려준다. 정상 입력 4개는 이미 맞다. 문제는 잘못된 입력을 거르지 않는 것: -1% 할인이면 1,010원으로 가격이 오르고, 101%면 -10원, 즉 손님에게 돈을 준다. 실제 서비스라면 결제 버그. 이 7개 테스트가 QA Gate이고, Kiro는 테스트를 건드리지 못하고 코드 한 파일만 고칠 수 있다. 정답은 if문 두 줄(잘못된 값이면 IllegalArgumentException)이라 Kiro는 대개 1회에 해결한다.</a:t>
             </a:r>
           </a:p>
         </p:txBody>
@@ -6995,21 +7065,21 @@
                   <a:srgbClr val="F5F8FD"/>
                 </a:solidFill>
               </a:rPr>
-              <a:t>데모 시나리오: 할인 계산</a:t>
-            </a:r>
-          </a:p>
-        </p:txBody>
-      </p:sp>
-      <p:sp>
-        <p:nvSpPr>
-          <p:cNvPr id="4" name="TextBox 3"/>
+              <a:t>데모 시나리오: 할인 계산기 버그 고치기</a:t>
+            </a:r>
+          </a:p>
+        </p:txBody>
+      </p:sp>
+      <p:sp>
+        <p:nvSpPr>
+          <p:cNvPr id="5" name="TextBox 4"/>
           <p:cNvSpPr txBox="1"/>
           <p:nvPr/>
         </p:nvSpPr>
         <p:spPr>
           <a:xfrm>
-            <a:off x="868680" y="1691640"/>
-            <a:ext cx="10515600" cy="4480560"/>
+            <a:off x="868680" y="6492240"/>
+            <a:ext cx="10515600" cy="201168"/>
           </a:xfrm>
           <a:prstGeom prst="rect">
             <a:avLst/>
@@ -7017,97 +7087,32 @@
           <a:noFill/>
         </p:spPr>
         <p:txBody>
-          <a:bodyPr wrap="square">
+          <a:bodyPr wrap="none">
             <a:spAutoFit/>
           </a:bodyPr>
           <a:lstStyle/>
           <a:p>
-            <a:pPr>
-              <a:spcAft>
-                <a:spcPts val="1700"/>
-              </a:spcAft>
-            </a:pPr>
-            <a:r>
-              <a:rPr sz="2200">
-                <a:solidFill>
-                  <a:srgbClr val="CFDEEB"/>
-                </a:solidFill>
-              </a:rPr>
-              <a:t>정상: 1,000원에 10% 할인 → 900원</a:t>
-            </a:r>
-          </a:p>
-          <a:p>
-            <a:pPr>
-              <a:spcAft>
-                <a:spcPts val="1700"/>
-              </a:spcAft>
-            </a:pPr>
-            <a:r>
-              <a:rPr sz="2200">
-                <a:solidFill>
-                  <a:srgbClr val="CFDEEB"/>
-                </a:solidFill>
-              </a:rPr>
-              <a:t>경계: 0% → 1,000원, 100% → 0원</a:t>
-            </a:r>
-          </a:p>
-          <a:p>
-            <a:pPr>
-              <a:spcAft>
-                <a:spcPts val="1700"/>
-              </a:spcAft>
-            </a:pPr>
-            <a:r>
-              <a:rPr sz="2200">
-                <a:solidFill>
-                  <a:srgbClr val="CFDEEB"/>
-                </a:solidFill>
-              </a:rPr>
-              <a:t>예외: 할인율 -1%, 101%, 금액 -1원 → IllegalArgumentException</a:t>
-            </a:r>
-          </a:p>
-          <a:p>
-            <a:pPr>
-              <a:spcAft>
-                <a:spcPts val="1700"/>
-              </a:spcAft>
-            </a:pPr>
-            <a:r>
-              <a:rPr sz="2200">
-                <a:solidFill>
-                  <a:srgbClr val="CFDEEB"/>
-                </a:solidFill>
-              </a:rPr>
-              <a:t>초기 구현은 잘못된 입력을 모두 허용한다</a:t>
-            </a:r>
-          </a:p>
-          <a:p>
-            <a:pPr>
-              <a:spcAft>
-                <a:spcPts val="1700"/>
-              </a:spcAft>
-            </a:pPr>
-            <a:r>
-              <a:rPr sz="2200">
-                <a:solidFill>
-                  <a:srgbClr val="CFDEEB"/>
-                </a:solidFill>
-              </a:rPr>
-              <a:t>목표: 테스트를 건드리지 않고 코드를 고쳐 모두 PASS</a:t>
-            </a:r>
-          </a:p>
-        </p:txBody>
-      </p:sp>
-      <p:sp>
-        <p:nvSpPr>
-          <p:cNvPr id="5" name="TextBox 4"/>
+            <a:r>
+              <a:rPr sz="1000">
+                <a:solidFill>
+                  <a:srgbClr val="8397AB"/>
+                </a:solidFill>
+              </a:rPr>
+              <a:t>AI Agent Loop · 2026.10.21                                     06 / 16</a:t>
+            </a:r>
+          </a:p>
+        </p:txBody>
+      </p:sp>
+      <p:sp>
+        <p:nvSpPr>
+          <p:cNvPr id="6" name="TextBox 5"/>
           <p:cNvSpPr txBox="1"/>
           <p:nvPr/>
         </p:nvSpPr>
         <p:spPr>
           <a:xfrm>
-            <a:off x="868680" y="6492240"/>
-            <a:ext cx="10515600" cy="201168"/>
+            <a:off x="868680" y="1554480"/>
+            <a:ext cx="4206240" cy="320040"/>
           </a:xfrm>
           <a:prstGeom prst="rect">
             <a:avLst/>
@@ -7115,18 +7120,1131 @@
           <a:noFill/>
         </p:spPr>
         <p:txBody>
-          <a:bodyPr wrap="none">
+          <a:bodyPr wrap="square">
             <a:spAutoFit/>
           </a:bodyPr>
           <a:lstStyle/>
           <a:p>
             <a:r>
-              <a:rPr sz="1000">
+              <a:rPr sz="1400" b="1">
                 <a:solidFill>
                   <a:srgbClr val="8397AB"/>
                 </a:solidFill>
               </a:rPr>
-              <a:t>AI Agent Loop · 2026.10.21                                     06 / 16</a:t>
+              <a:t>현재 코드 — 입력 검사가 없다</a:t>
+            </a:r>
+          </a:p>
+        </p:txBody>
+      </p:sp>
+      <p:sp>
+        <p:nvSpPr>
+          <p:cNvPr id="7" name="Rounded Rectangle 6"/>
+          <p:cNvSpPr/>
+          <p:nvPr/>
+        </p:nvSpPr>
+        <p:spPr>
+          <a:xfrm>
+            <a:off x="868680" y="1920240"/>
+            <a:ext cx="4206240" cy="1554480"/>
+          </a:xfrm>
+          <a:prstGeom prst="roundRect">
+            <a:avLst>
+              <a:gd name="adj" fmla="val 5000"/>
+            </a:avLst>
+          </a:prstGeom>
+          <a:solidFill>
+            <a:srgbClr val="050A12"/>
+          </a:solidFill>
+          <a:ln w="15875">
+            <a:solidFill>
+              <a:srgbClr val="2A3B52"/>
+            </a:solidFill>
+          </a:ln>
+        </p:spPr>
+        <p:style>
+          <a:lnRef idx="1">
+            <a:schemeClr val="accent1"/>
+          </a:lnRef>
+          <a:fillRef idx="3">
+            <a:schemeClr val="accent1"/>
+          </a:fillRef>
+          <a:effectRef idx="2">
+            <a:schemeClr val="accent1"/>
+          </a:effectRef>
+          <a:fontRef idx="minor">
+            <a:schemeClr val="lt1"/>
+          </a:fontRef>
+        </p:style>
+        <p:txBody>
+          <a:bodyPr rtlCol="0" anchor="ctr"/>
+          <a:lstStyle/>
+          <a:p>
+            <a:pPr algn="ctr"/>
+          </a:p>
+        </p:txBody>
+      </p:sp>
+      <p:sp>
+        <p:nvSpPr>
+          <p:cNvPr id="8" name="TextBox 7"/>
+          <p:cNvSpPr txBox="1"/>
+          <p:nvPr/>
+        </p:nvSpPr>
+        <p:spPr>
+          <a:xfrm>
+            <a:off x="1005840" y="2011680"/>
+            <a:ext cx="3931920" cy="1371600"/>
+          </a:xfrm>
+          <a:prstGeom prst="rect">
+            <a:avLst/>
+          </a:prstGeom>
+          <a:noFill/>
+        </p:spPr>
+        <p:txBody>
+          <a:bodyPr wrap="square">
+            <a:spAutoFit/>
+          </a:bodyPr>
+          <a:lstStyle/>
+          <a:p>
+            <a:r>
+              <a:rPr sz="1300" b="0">
+                <a:solidFill>
+                  <a:srgbClr val="CFDEEB"/>
+                </a:solidFill>
+                <a:latin typeface="Menlo"/>
+                <a:ea typeface="Apple SD Gothic Neo"/>
+              </a:rPr>
+              <a:t>int discount(int price, int rate) {</a:t>
+            </a:r>
+          </a:p>
+          <a:p>
+            <a:r>
+              <a:rPr sz="1300" b="0">
+                <a:solidFill>
+                  <a:srgbClr val="CFDEEB"/>
+                </a:solidFill>
+                <a:latin typeface="Menlo"/>
+                <a:ea typeface="Apple SD Gothic Neo"/>
+              </a:rPr>
+              <a:t/>
+            </a:r>
+          </a:p>
+          <a:p>
+            <a:r>
+              <a:rPr sz="1300" b="0">
+                <a:solidFill>
+                  <a:srgbClr val="FF6B6B"/>
+                </a:solidFill>
+                <a:latin typeface="Menlo"/>
+                <a:ea typeface="Apple SD Gothic Neo"/>
+              </a:rPr>
+              <a:t>  // 검사 없음: 음수·100% 초과도 계산</a:t>
+            </a:r>
+          </a:p>
+          <a:p>
+            <a:r>
+              <a:rPr sz="1300" b="0">
+                <a:solidFill>
+                  <a:srgbClr val="CFDEEB"/>
+                </a:solidFill>
+                <a:latin typeface="Menlo"/>
+                <a:ea typeface="Apple SD Gothic Neo"/>
+              </a:rPr>
+              <a:t/>
+            </a:r>
+          </a:p>
+          <a:p>
+            <a:r>
+              <a:rPr sz="1300" b="0">
+                <a:solidFill>
+                  <a:srgbClr val="CFDEEB"/>
+                </a:solidFill>
+                <a:latin typeface="Menlo"/>
+                <a:ea typeface="Apple SD Gothic Neo"/>
+              </a:rPr>
+              <a:t>  return price - price*rate/100;</a:t>
+            </a:r>
+          </a:p>
+          <a:p>
+            <a:r>
+              <a:rPr sz="1300" b="0">
+                <a:solidFill>
+                  <a:srgbClr val="CFDEEB"/>
+                </a:solidFill>
+                <a:latin typeface="Menlo"/>
+                <a:ea typeface="Apple SD Gothic Neo"/>
+              </a:rPr>
+              <a:t>}</a:t>
+            </a:r>
+          </a:p>
+        </p:txBody>
+      </p:sp>
+      <p:sp>
+        <p:nvSpPr>
+          <p:cNvPr id="9" name="Rounded Rectangle 8"/>
+          <p:cNvSpPr/>
+          <p:nvPr/>
+        </p:nvSpPr>
+        <p:spPr>
+          <a:xfrm>
+            <a:off x="868680" y="3657600"/>
+            <a:ext cx="4206240" cy="1325880"/>
+          </a:xfrm>
+          <a:prstGeom prst="roundRect">
+            <a:avLst>
+              <a:gd name="adj" fmla="val 5000"/>
+            </a:avLst>
+          </a:prstGeom>
+          <a:solidFill>
+            <a:srgbClr val="162236"/>
+          </a:solidFill>
+          <a:ln w="22225">
+            <a:solidFill>
+              <a:srgbClr val="7C5CFF"/>
+            </a:solidFill>
+          </a:ln>
+        </p:spPr>
+        <p:style>
+          <a:lnRef idx="1">
+            <a:schemeClr val="accent1"/>
+          </a:lnRef>
+          <a:fillRef idx="3">
+            <a:schemeClr val="accent1"/>
+          </a:fillRef>
+          <a:effectRef idx="2">
+            <a:schemeClr val="accent1"/>
+          </a:effectRef>
+          <a:fontRef idx="minor">
+            <a:schemeClr val="lt1"/>
+          </a:fontRef>
+        </p:style>
+        <p:txBody>
+          <a:bodyPr rtlCol="0" anchor="ctr"/>
+          <a:lstStyle/>
+          <a:p>
+            <a:pPr algn="ctr"/>
+          </a:p>
+        </p:txBody>
+      </p:sp>
+      <p:sp>
+        <p:nvSpPr>
+          <p:cNvPr id="10" name="TextBox 9"/>
+          <p:cNvSpPr txBox="1"/>
+          <p:nvPr/>
+        </p:nvSpPr>
+        <p:spPr>
+          <a:xfrm>
+            <a:off x="1005840" y="3749040"/>
+            <a:ext cx="3931920" cy="1143000"/>
+          </a:xfrm>
+          <a:prstGeom prst="rect">
+            <a:avLst/>
+          </a:prstGeom>
+          <a:noFill/>
+        </p:spPr>
+        <p:txBody>
+          <a:bodyPr wrap="square">
+            <a:spAutoFit/>
+          </a:bodyPr>
+          <a:lstStyle/>
+          <a:p>
+            <a:r>
+              <a:rPr sz="1400" b="1">
+                <a:solidFill>
+                  <a:srgbClr val="7C5CFF"/>
+                </a:solidFill>
+              </a:rPr>
+              <a:t>Kiro에게 주는 규칙</a:t>
+            </a:r>
+          </a:p>
+          <a:p>
+            <a:r>
+              <a:rPr sz="1400" b="0">
+                <a:solidFill>
+                  <a:srgbClr val="CFDEEB"/>
+                </a:solidFill>
+              </a:rPr>
+              <a:t>수정 가능: src/DiscountCalculator.java 하나</a:t>
+            </a:r>
+          </a:p>
+          <a:p>
+            <a:r>
+              <a:rPr sz="1400" b="0">
+                <a:solidFill>
+                  <a:srgbClr val="CFDEEB"/>
+                </a:solidFill>
+              </a:rPr>
+              <a:t>수정 금지: 테스트 · verify.py · loop.py</a:t>
+            </a:r>
+          </a:p>
+          <a:p>
+            <a:r>
+              <a:rPr sz="1400" b="0">
+                <a:solidFill>
+                  <a:srgbClr val="CFDEEB"/>
+                </a:solidFill>
+              </a:rPr>
+              <a:t>셸 실행 불가 (파일 읽기/쓰기만 허용)</a:t>
+            </a:r>
+          </a:p>
+        </p:txBody>
+      </p:sp>
+      <p:sp>
+        <p:nvSpPr>
+          <p:cNvPr id="11" name="TextBox 10"/>
+          <p:cNvSpPr txBox="1"/>
+          <p:nvPr/>
+        </p:nvSpPr>
+        <p:spPr>
+          <a:xfrm>
+            <a:off x="5349240" y="1554480"/>
+            <a:ext cx="6035040" cy="320040"/>
+          </a:xfrm>
+          <a:prstGeom prst="rect">
+            <a:avLst/>
+          </a:prstGeom>
+          <a:noFill/>
+        </p:spPr>
+        <p:txBody>
+          <a:bodyPr wrap="square">
+            <a:spAutoFit/>
+          </a:bodyPr>
+          <a:lstStyle/>
+          <a:p>
+            <a:r>
+              <a:rPr sz="1400" b="1">
+                <a:solidFill>
+                  <a:srgbClr val="8397AB"/>
+                </a:solidFill>
+              </a:rPr>
+              <a:t>QA Gate 테스트 7개 — 현재 결과</a:t>
+            </a:r>
+          </a:p>
+        </p:txBody>
+      </p:sp>
+      <p:graphicFrame>
+        <p:nvGraphicFramePr>
+          <p:cNvPr id="12" name="Table 11"/>
+          <p:cNvGraphicFramePr>
+            <a:graphicFrameLocks noGrp="1"/>
+          </p:cNvGraphicFramePr>
+          <p:nvPr/>
+        </p:nvGraphicFramePr>
+        <p:xfrm>
+          <a:off x="5349240" y="1920240"/>
+          <a:ext cx="6035040" cy="3291840"/>
+        </p:xfrm>
+        <a:graphic>
+          <a:graphicData uri="http://schemas.openxmlformats.org/drawingml/2006/table">
+            <a:tbl>
+              <a:tblPr firstRow="0" bandRow="0">
+                <a:tableStyleId>{5C22544A-7EE6-4342-B048-85BDC9FD1C3A}</a:tableStyleId>
+              </a:tblPr>
+              <a:tblGrid>
+                <a:gridCol w="1783080"/>
+                <a:gridCol w="1188720"/>
+                <a:gridCol w="2423160"/>
+                <a:gridCol w="640080"/>
+              </a:tblGrid>
+              <a:tr h="411480">
+                <a:tc>
+                  <a:txBody>
+                    <a:bodyPr/>
+                    <a:lstStyle/>
+                    <a:p>
+                      <a:pPr algn="l"/>
+                      <a:r>
+                        <a:rPr sz="1200" b="1">
+                          <a:solidFill>
+                            <a:srgbClr val="F5F8FD"/>
+                          </a:solidFill>
+                        </a:rPr>
+                        <a:t>입력 (금액, 할인율)</a:t>
+                      </a:r>
+                    </a:p>
+                  </a:txBody>
+                  <a:tcPr anchor="ctr" marL="91440" marR="91440" marT="0" marB="0">
+                    <a:solidFill>
+                      <a:srgbClr val="2A3B52"/>
+                    </a:solidFill>
+                  </a:tcPr>
+                </a:tc>
+                <a:tc>
+                  <a:txBody>
+                    <a:bodyPr/>
+                    <a:lstStyle/>
+                    <a:p>
+                      <a:pPr algn="l"/>
+                      <a:r>
+                        <a:rPr sz="1200" b="1">
+                          <a:solidFill>
+                            <a:srgbClr val="F5F8FD"/>
+                          </a:solidFill>
+                        </a:rPr>
+                        <a:t>기대 결과</a:t>
+                      </a:r>
+                    </a:p>
+                  </a:txBody>
+                  <a:tcPr anchor="ctr" marL="91440" marR="91440" marT="0" marB="0">
+                    <a:solidFill>
+                      <a:srgbClr val="2A3B52"/>
+                    </a:solidFill>
+                  </a:tcPr>
+                </a:tc>
+                <a:tc>
+                  <a:txBody>
+                    <a:bodyPr/>
+                    <a:lstStyle/>
+                    <a:p>
+                      <a:pPr algn="l"/>
+                      <a:r>
+                        <a:rPr sz="1200" b="1">
+                          <a:solidFill>
+                            <a:srgbClr val="F5F8FD"/>
+                          </a:solidFill>
+                        </a:rPr>
+                        <a:t>현재 코드</a:t>
+                      </a:r>
+                    </a:p>
+                  </a:txBody>
+                  <a:tcPr anchor="ctr" marL="91440" marR="91440" marT="0" marB="0">
+                    <a:solidFill>
+                      <a:srgbClr val="2A3B52"/>
+                    </a:solidFill>
+                  </a:tcPr>
+                </a:tc>
+                <a:tc>
+                  <a:txBody>
+                    <a:bodyPr/>
+                    <a:lstStyle/>
+                    <a:p>
+                      <a:pPr algn="ctr"/>
+                      <a:r>
+                        <a:rPr sz="1200" b="1">
+                          <a:solidFill>
+                            <a:srgbClr val="FF6B6B"/>
+                          </a:solidFill>
+                        </a:rPr>
+                        <a:t>판정</a:t>
+                      </a:r>
+                    </a:p>
+                  </a:txBody>
+                  <a:tcPr anchor="ctr" marL="91440" marR="91440" marT="0" marB="0">
+                    <a:solidFill>
+                      <a:srgbClr val="2A3B52"/>
+                    </a:solidFill>
+                  </a:tcPr>
+                </a:tc>
+              </a:tr>
+              <a:tr h="411480">
+                <a:tc>
+                  <a:txBody>
+                    <a:bodyPr/>
+                    <a:lstStyle/>
+                    <a:p>
+                      <a:pPr algn="l"/>
+                      <a:r>
+                        <a:rPr sz="1300" b="0">
+                          <a:solidFill>
+                            <a:srgbClr val="CFDEEB"/>
+                          </a:solidFill>
+                        </a:rPr>
+                        <a:t>1,000원, 10%</a:t>
+                      </a:r>
+                    </a:p>
+                  </a:txBody>
+                  <a:tcPr anchor="ctr" marL="91440" marR="91440" marT="0" marB="0">
+                    <a:solidFill>
+                      <a:srgbClr val="162236"/>
+                    </a:solidFill>
+                  </a:tcPr>
+                </a:tc>
+                <a:tc>
+                  <a:txBody>
+                    <a:bodyPr/>
+                    <a:lstStyle/>
+                    <a:p>
+                      <a:pPr algn="l"/>
+                      <a:r>
+                        <a:rPr sz="1300" b="0">
+                          <a:solidFill>
+                            <a:srgbClr val="CFDEEB"/>
+                          </a:solidFill>
+                        </a:rPr>
+                        <a:t>900원</a:t>
+                      </a:r>
+                    </a:p>
+                  </a:txBody>
+                  <a:tcPr anchor="ctr" marL="91440" marR="91440" marT="0" marB="0">
+                    <a:solidFill>
+                      <a:srgbClr val="162236"/>
+                    </a:solidFill>
+                  </a:tcPr>
+                </a:tc>
+                <a:tc>
+                  <a:txBody>
+                    <a:bodyPr/>
+                    <a:lstStyle/>
+                    <a:p>
+                      <a:pPr algn="l"/>
+                      <a:r>
+                        <a:rPr sz="1300" b="0">
+                          <a:solidFill>
+                            <a:srgbClr val="CFDEEB"/>
+                          </a:solidFill>
+                        </a:rPr>
+                        <a:t>900원</a:t>
+                      </a:r>
+                    </a:p>
+                  </a:txBody>
+                  <a:tcPr anchor="ctr" marL="91440" marR="91440" marT="0" marB="0">
+                    <a:solidFill>
+                      <a:srgbClr val="162236"/>
+                    </a:solidFill>
+                  </a:tcPr>
+                </a:tc>
+                <a:tc>
+                  <a:txBody>
+                    <a:bodyPr/>
+                    <a:lstStyle/>
+                    <a:p>
+                      <a:pPr algn="ctr"/>
+                      <a:r>
+                        <a:rPr sz="1200" b="1">
+                          <a:solidFill>
+                            <a:srgbClr val="4ADE80"/>
+                          </a:solidFill>
+                        </a:rPr>
+                        <a:t>PASS</a:t>
+                      </a:r>
+                    </a:p>
+                  </a:txBody>
+                  <a:tcPr anchor="ctr" marL="91440" marR="91440" marT="0" marB="0">
+                    <a:solidFill>
+                      <a:srgbClr val="162236"/>
+                    </a:solidFill>
+                  </a:tcPr>
+                </a:tc>
+              </a:tr>
+              <a:tr h="411480">
+                <a:tc>
+                  <a:txBody>
+                    <a:bodyPr/>
+                    <a:lstStyle/>
+                    <a:p>
+                      <a:pPr algn="l"/>
+                      <a:r>
+                        <a:rPr sz="1300" b="0">
+                          <a:solidFill>
+                            <a:srgbClr val="CFDEEB"/>
+                          </a:solidFill>
+                        </a:rPr>
+                        <a:t>1,000원, 0%</a:t>
+                      </a:r>
+                    </a:p>
+                  </a:txBody>
+                  <a:tcPr anchor="ctr" marL="91440" marR="91440" marT="0" marB="0">
+                    <a:solidFill>
+                      <a:srgbClr val="162236"/>
+                    </a:solidFill>
+                  </a:tcPr>
+                </a:tc>
+                <a:tc>
+                  <a:txBody>
+                    <a:bodyPr/>
+                    <a:lstStyle/>
+                    <a:p>
+                      <a:pPr algn="l"/>
+                      <a:r>
+                        <a:rPr sz="1300" b="0">
+                          <a:solidFill>
+                            <a:srgbClr val="CFDEEB"/>
+                          </a:solidFill>
+                        </a:rPr>
+                        <a:t>1,000원</a:t>
+                      </a:r>
+                    </a:p>
+                  </a:txBody>
+                  <a:tcPr anchor="ctr" marL="91440" marR="91440" marT="0" marB="0">
+                    <a:solidFill>
+                      <a:srgbClr val="162236"/>
+                    </a:solidFill>
+                  </a:tcPr>
+                </a:tc>
+                <a:tc>
+                  <a:txBody>
+                    <a:bodyPr/>
+                    <a:lstStyle/>
+                    <a:p>
+                      <a:pPr algn="l"/>
+                      <a:r>
+                        <a:rPr sz="1300" b="0">
+                          <a:solidFill>
+                            <a:srgbClr val="CFDEEB"/>
+                          </a:solidFill>
+                        </a:rPr>
+                        <a:t>1,000원</a:t>
+                      </a:r>
+                    </a:p>
+                  </a:txBody>
+                  <a:tcPr anchor="ctr" marL="91440" marR="91440" marT="0" marB="0">
+                    <a:solidFill>
+                      <a:srgbClr val="162236"/>
+                    </a:solidFill>
+                  </a:tcPr>
+                </a:tc>
+                <a:tc>
+                  <a:txBody>
+                    <a:bodyPr/>
+                    <a:lstStyle/>
+                    <a:p>
+                      <a:pPr algn="ctr"/>
+                      <a:r>
+                        <a:rPr sz="1200" b="1">
+                          <a:solidFill>
+                            <a:srgbClr val="4ADE80"/>
+                          </a:solidFill>
+                        </a:rPr>
+                        <a:t>PASS</a:t>
+                      </a:r>
+                    </a:p>
+                  </a:txBody>
+                  <a:tcPr anchor="ctr" marL="91440" marR="91440" marT="0" marB="0">
+                    <a:solidFill>
+                      <a:srgbClr val="162236"/>
+                    </a:solidFill>
+                  </a:tcPr>
+                </a:tc>
+              </a:tr>
+              <a:tr h="411480">
+                <a:tc>
+                  <a:txBody>
+                    <a:bodyPr/>
+                    <a:lstStyle/>
+                    <a:p>
+                      <a:pPr algn="l"/>
+                      <a:r>
+                        <a:rPr sz="1300" b="0">
+                          <a:solidFill>
+                            <a:srgbClr val="CFDEEB"/>
+                          </a:solidFill>
+                        </a:rPr>
+                        <a:t>1,000원, 100%</a:t>
+                      </a:r>
+                    </a:p>
+                  </a:txBody>
+                  <a:tcPr anchor="ctr" marL="91440" marR="91440" marT="0" marB="0">
+                    <a:solidFill>
+                      <a:srgbClr val="162236"/>
+                    </a:solidFill>
+                  </a:tcPr>
+                </a:tc>
+                <a:tc>
+                  <a:txBody>
+                    <a:bodyPr/>
+                    <a:lstStyle/>
+                    <a:p>
+                      <a:pPr algn="l"/>
+                      <a:r>
+                        <a:rPr sz="1300" b="0">
+                          <a:solidFill>
+                            <a:srgbClr val="CFDEEB"/>
+                          </a:solidFill>
+                        </a:rPr>
+                        <a:t>0원</a:t>
+                      </a:r>
+                    </a:p>
+                  </a:txBody>
+                  <a:tcPr anchor="ctr" marL="91440" marR="91440" marT="0" marB="0">
+                    <a:solidFill>
+                      <a:srgbClr val="162236"/>
+                    </a:solidFill>
+                  </a:tcPr>
+                </a:tc>
+                <a:tc>
+                  <a:txBody>
+                    <a:bodyPr/>
+                    <a:lstStyle/>
+                    <a:p>
+                      <a:pPr algn="l"/>
+                      <a:r>
+                        <a:rPr sz="1300" b="0">
+                          <a:solidFill>
+                            <a:srgbClr val="CFDEEB"/>
+                          </a:solidFill>
+                        </a:rPr>
+                        <a:t>0원</a:t>
+                      </a:r>
+                    </a:p>
+                  </a:txBody>
+                  <a:tcPr anchor="ctr" marL="91440" marR="91440" marT="0" marB="0">
+                    <a:solidFill>
+                      <a:srgbClr val="162236"/>
+                    </a:solidFill>
+                  </a:tcPr>
+                </a:tc>
+                <a:tc>
+                  <a:txBody>
+                    <a:bodyPr/>
+                    <a:lstStyle/>
+                    <a:p>
+                      <a:pPr algn="ctr"/>
+                      <a:r>
+                        <a:rPr sz="1200" b="1">
+                          <a:solidFill>
+                            <a:srgbClr val="4ADE80"/>
+                          </a:solidFill>
+                        </a:rPr>
+                        <a:t>PASS</a:t>
+                      </a:r>
+                    </a:p>
+                  </a:txBody>
+                  <a:tcPr anchor="ctr" marL="91440" marR="91440" marT="0" marB="0">
+                    <a:solidFill>
+                      <a:srgbClr val="162236"/>
+                    </a:solidFill>
+                  </a:tcPr>
+                </a:tc>
+              </a:tr>
+              <a:tr h="411480">
+                <a:tc>
+                  <a:txBody>
+                    <a:bodyPr/>
+                    <a:lstStyle/>
+                    <a:p>
+                      <a:pPr algn="l"/>
+                      <a:r>
+                        <a:rPr sz="1300" b="0">
+                          <a:solidFill>
+                            <a:srgbClr val="CFDEEB"/>
+                          </a:solidFill>
+                        </a:rPr>
+                        <a:t>0원, 50%</a:t>
+                      </a:r>
+                    </a:p>
+                  </a:txBody>
+                  <a:tcPr anchor="ctr" marL="91440" marR="91440" marT="0" marB="0">
+                    <a:solidFill>
+                      <a:srgbClr val="162236"/>
+                    </a:solidFill>
+                  </a:tcPr>
+                </a:tc>
+                <a:tc>
+                  <a:txBody>
+                    <a:bodyPr/>
+                    <a:lstStyle/>
+                    <a:p>
+                      <a:pPr algn="l"/>
+                      <a:r>
+                        <a:rPr sz="1300" b="0">
+                          <a:solidFill>
+                            <a:srgbClr val="CFDEEB"/>
+                          </a:solidFill>
+                        </a:rPr>
+                        <a:t>0원</a:t>
+                      </a:r>
+                    </a:p>
+                  </a:txBody>
+                  <a:tcPr anchor="ctr" marL="91440" marR="91440" marT="0" marB="0">
+                    <a:solidFill>
+                      <a:srgbClr val="162236"/>
+                    </a:solidFill>
+                  </a:tcPr>
+                </a:tc>
+                <a:tc>
+                  <a:txBody>
+                    <a:bodyPr/>
+                    <a:lstStyle/>
+                    <a:p>
+                      <a:pPr algn="l"/>
+                      <a:r>
+                        <a:rPr sz="1300" b="0">
+                          <a:solidFill>
+                            <a:srgbClr val="CFDEEB"/>
+                          </a:solidFill>
+                        </a:rPr>
+                        <a:t>0원</a:t>
+                      </a:r>
+                    </a:p>
+                  </a:txBody>
+                  <a:tcPr anchor="ctr" marL="91440" marR="91440" marT="0" marB="0">
+                    <a:solidFill>
+                      <a:srgbClr val="162236"/>
+                    </a:solidFill>
+                  </a:tcPr>
+                </a:tc>
+                <a:tc>
+                  <a:txBody>
+                    <a:bodyPr/>
+                    <a:lstStyle/>
+                    <a:p>
+                      <a:pPr algn="ctr"/>
+                      <a:r>
+                        <a:rPr sz="1200" b="1">
+                          <a:solidFill>
+                            <a:srgbClr val="4ADE80"/>
+                          </a:solidFill>
+                        </a:rPr>
+                        <a:t>PASS</a:t>
+                      </a:r>
+                    </a:p>
+                  </a:txBody>
+                  <a:tcPr anchor="ctr" marL="91440" marR="91440" marT="0" marB="0">
+                    <a:solidFill>
+                      <a:srgbClr val="162236"/>
+                    </a:solidFill>
+                  </a:tcPr>
+                </a:tc>
+              </a:tr>
+              <a:tr h="411480">
+                <a:tc>
+                  <a:txBody>
+                    <a:bodyPr/>
+                    <a:lstStyle/>
+                    <a:p>
+                      <a:pPr algn="l"/>
+                      <a:r>
+                        <a:rPr sz="1300" b="0">
+                          <a:solidFill>
+                            <a:srgbClr val="CFDEEB"/>
+                          </a:solidFill>
+                        </a:rPr>
+                        <a:t>1,000원, -1%</a:t>
+                      </a:r>
+                    </a:p>
+                  </a:txBody>
+                  <a:tcPr anchor="ctr" marL="91440" marR="91440" marT="0" marB="0">
+                    <a:solidFill>
+                      <a:srgbClr val="2A161E"/>
+                    </a:solidFill>
+                  </a:tcPr>
+                </a:tc>
+                <a:tc>
+                  <a:txBody>
+                    <a:bodyPr/>
+                    <a:lstStyle/>
+                    <a:p>
+                      <a:pPr algn="l"/>
+                      <a:r>
+                        <a:rPr sz="1300" b="0">
+                          <a:solidFill>
+                            <a:srgbClr val="CFDEEB"/>
+                          </a:solidFill>
+                        </a:rPr>
+                        <a:t>오류 발생</a:t>
+                      </a:r>
+                    </a:p>
+                  </a:txBody>
+                  <a:tcPr anchor="ctr" marL="91440" marR="91440" marT="0" marB="0">
+                    <a:solidFill>
+                      <a:srgbClr val="2A161E"/>
+                    </a:solidFill>
+                  </a:tcPr>
+                </a:tc>
+                <a:tc>
+                  <a:txBody>
+                    <a:bodyPr/>
+                    <a:lstStyle/>
+                    <a:p>
+                      <a:pPr algn="l"/>
+                      <a:r>
+                        <a:rPr sz="1300" b="0">
+                          <a:solidFill>
+                            <a:srgbClr val="FF6B6B"/>
+                          </a:solidFill>
+                        </a:rPr>
+                        <a:t>1,010원  가격이 오름</a:t>
+                      </a:r>
+                    </a:p>
+                  </a:txBody>
+                  <a:tcPr anchor="ctr" marL="91440" marR="91440" marT="0" marB="0">
+                    <a:solidFill>
+                      <a:srgbClr val="2A161E"/>
+                    </a:solidFill>
+                  </a:tcPr>
+                </a:tc>
+                <a:tc>
+                  <a:txBody>
+                    <a:bodyPr/>
+                    <a:lstStyle/>
+                    <a:p>
+                      <a:pPr algn="ctr"/>
+                      <a:r>
+                        <a:rPr sz="1200" b="1">
+                          <a:solidFill>
+                            <a:srgbClr val="FF6B6B"/>
+                          </a:solidFill>
+                        </a:rPr>
+                        <a:t>FAIL</a:t>
+                      </a:r>
+                    </a:p>
+                  </a:txBody>
+                  <a:tcPr anchor="ctr" marL="91440" marR="91440" marT="0" marB="0">
+                    <a:solidFill>
+                      <a:srgbClr val="2A161E"/>
+                    </a:solidFill>
+                  </a:tcPr>
+                </a:tc>
+              </a:tr>
+              <a:tr h="411480">
+                <a:tc>
+                  <a:txBody>
+                    <a:bodyPr/>
+                    <a:lstStyle/>
+                    <a:p>
+                      <a:pPr algn="l"/>
+                      <a:r>
+                        <a:rPr sz="1300" b="0">
+                          <a:solidFill>
+                            <a:srgbClr val="CFDEEB"/>
+                          </a:solidFill>
+                        </a:rPr>
+                        <a:t>1,000원, 101%</a:t>
+                      </a:r>
+                    </a:p>
+                  </a:txBody>
+                  <a:tcPr anchor="ctr" marL="91440" marR="91440" marT="0" marB="0">
+                    <a:solidFill>
+                      <a:srgbClr val="2A161E"/>
+                    </a:solidFill>
+                  </a:tcPr>
+                </a:tc>
+                <a:tc>
+                  <a:txBody>
+                    <a:bodyPr/>
+                    <a:lstStyle/>
+                    <a:p>
+                      <a:pPr algn="l"/>
+                      <a:r>
+                        <a:rPr sz="1300" b="0">
+                          <a:solidFill>
+                            <a:srgbClr val="CFDEEB"/>
+                          </a:solidFill>
+                        </a:rPr>
+                        <a:t>오류 발생</a:t>
+                      </a:r>
+                    </a:p>
+                  </a:txBody>
+                  <a:tcPr anchor="ctr" marL="91440" marR="91440" marT="0" marB="0">
+                    <a:solidFill>
+                      <a:srgbClr val="2A161E"/>
+                    </a:solidFill>
+                  </a:tcPr>
+                </a:tc>
+                <a:tc>
+                  <a:txBody>
+                    <a:bodyPr/>
+                    <a:lstStyle/>
+                    <a:p>
+                      <a:pPr algn="l"/>
+                      <a:r>
+                        <a:rPr sz="1300" b="0">
+                          <a:solidFill>
+                            <a:srgbClr val="FF6B6B"/>
+                          </a:solidFill>
+                        </a:rPr>
+                        <a:t>-10원  돈을 돌려줌</a:t>
+                      </a:r>
+                    </a:p>
+                  </a:txBody>
+                  <a:tcPr anchor="ctr" marL="91440" marR="91440" marT="0" marB="0">
+                    <a:solidFill>
+                      <a:srgbClr val="2A161E"/>
+                    </a:solidFill>
+                  </a:tcPr>
+                </a:tc>
+                <a:tc>
+                  <a:txBody>
+                    <a:bodyPr/>
+                    <a:lstStyle/>
+                    <a:p>
+                      <a:pPr algn="ctr"/>
+                      <a:r>
+                        <a:rPr sz="1200" b="1">
+                          <a:solidFill>
+                            <a:srgbClr val="FF6B6B"/>
+                          </a:solidFill>
+                        </a:rPr>
+                        <a:t>FAIL</a:t>
+                      </a:r>
+                    </a:p>
+                  </a:txBody>
+                  <a:tcPr anchor="ctr" marL="91440" marR="91440" marT="0" marB="0">
+                    <a:solidFill>
+                      <a:srgbClr val="2A161E"/>
+                    </a:solidFill>
+                  </a:tcPr>
+                </a:tc>
+              </a:tr>
+              <a:tr h="411480">
+                <a:tc>
+                  <a:txBody>
+                    <a:bodyPr/>
+                    <a:lstStyle/>
+                    <a:p>
+                      <a:pPr algn="l"/>
+                      <a:r>
+                        <a:rPr sz="1300" b="0">
+                          <a:solidFill>
+                            <a:srgbClr val="CFDEEB"/>
+                          </a:solidFill>
+                        </a:rPr>
+                        <a:t>-1원, 10%</a:t>
+                      </a:r>
+                    </a:p>
+                  </a:txBody>
+                  <a:tcPr anchor="ctr" marL="91440" marR="91440" marT="0" marB="0">
+                    <a:solidFill>
+                      <a:srgbClr val="2A161E"/>
+                    </a:solidFill>
+                  </a:tcPr>
+                </a:tc>
+                <a:tc>
+                  <a:txBody>
+                    <a:bodyPr/>
+                    <a:lstStyle/>
+                    <a:p>
+                      <a:pPr algn="l"/>
+                      <a:r>
+                        <a:rPr sz="1300" b="0">
+                          <a:solidFill>
+                            <a:srgbClr val="CFDEEB"/>
+                          </a:solidFill>
+                        </a:rPr>
+                        <a:t>오류 발생</a:t>
+                      </a:r>
+                    </a:p>
+                  </a:txBody>
+                  <a:tcPr anchor="ctr" marL="91440" marR="91440" marT="0" marB="0">
+                    <a:solidFill>
+                      <a:srgbClr val="2A161E"/>
+                    </a:solidFill>
+                  </a:tcPr>
+                </a:tc>
+                <a:tc>
+                  <a:txBody>
+                    <a:bodyPr/>
+                    <a:lstStyle/>
+                    <a:p>
+                      <a:pPr algn="l"/>
+                      <a:r>
+                        <a:rPr sz="1300" b="0">
+                          <a:solidFill>
+                            <a:srgbClr val="FF6B6B"/>
+                          </a:solidFill>
+                        </a:rPr>
+                        <a:t>-1원  그대로 계산</a:t>
+                      </a:r>
+                    </a:p>
+                  </a:txBody>
+                  <a:tcPr anchor="ctr" marL="91440" marR="91440" marT="0" marB="0">
+                    <a:solidFill>
+                      <a:srgbClr val="2A161E"/>
+                    </a:solidFill>
+                  </a:tcPr>
+                </a:tc>
+                <a:tc>
+                  <a:txBody>
+                    <a:bodyPr/>
+                    <a:lstStyle/>
+                    <a:p>
+                      <a:pPr algn="ctr"/>
+                      <a:r>
+                        <a:rPr sz="1200" b="1">
+                          <a:solidFill>
+                            <a:srgbClr val="FF6B6B"/>
+                          </a:solidFill>
+                        </a:rPr>
+                        <a:t>FAIL</a:t>
+                      </a:r>
+                    </a:p>
+                  </a:txBody>
+                  <a:tcPr anchor="ctr" marL="91440" marR="91440" marT="0" marB="0">
+                    <a:solidFill>
+                      <a:srgbClr val="2A161E"/>
+                    </a:solidFill>
+                  </a:tcPr>
+                </a:tc>
+              </a:tr>
+            </a:tbl>
+          </a:graphicData>
+        </a:graphic>
+      </p:graphicFrame>
+      <p:sp>
+        <p:nvSpPr>
+          <p:cNvPr id="13" name="Rounded Rectangle 12"/>
+          <p:cNvSpPr/>
+          <p:nvPr/>
+        </p:nvSpPr>
+        <p:spPr>
+          <a:xfrm>
+            <a:off x="868680" y="5440680"/>
+            <a:ext cx="10515600" cy="685800"/>
+          </a:xfrm>
+          <a:prstGeom prst="roundRect">
+            <a:avLst>
+              <a:gd name="adj" fmla="val 5000"/>
+            </a:avLst>
+          </a:prstGeom>
+          <a:solidFill>
+            <a:srgbClr val="0F2A2A"/>
+          </a:solidFill>
+          <a:ln w="25400">
+            <a:solidFill>
+              <a:srgbClr val="31D3B1"/>
+            </a:solidFill>
+          </a:ln>
+        </p:spPr>
+        <p:style>
+          <a:lnRef idx="1">
+            <a:schemeClr val="accent1"/>
+          </a:lnRef>
+          <a:fillRef idx="3">
+            <a:schemeClr val="accent1"/>
+          </a:fillRef>
+          <a:effectRef idx="2">
+            <a:schemeClr val="accent1"/>
+          </a:effectRef>
+          <a:fontRef idx="minor">
+            <a:schemeClr val="lt1"/>
+          </a:fontRef>
+        </p:style>
+        <p:txBody>
+          <a:bodyPr rtlCol="0" anchor="ctr"/>
+          <a:lstStyle/>
+          <a:p>
+            <a:pPr algn="ctr"/>
+          </a:p>
+        </p:txBody>
+      </p:sp>
+      <p:sp>
+        <p:nvSpPr>
+          <p:cNvPr id="14" name="TextBox 13"/>
+          <p:cNvSpPr txBox="1"/>
+          <p:nvPr/>
+        </p:nvSpPr>
+        <p:spPr>
+          <a:xfrm>
+            <a:off x="1051560" y="5440680"/>
+            <a:ext cx="10149840" cy="685800"/>
+          </a:xfrm>
+          <a:prstGeom prst="rect">
+            <a:avLst/>
+          </a:prstGeom>
+          <a:noFill/>
+        </p:spPr>
+        <p:txBody>
+          <a:bodyPr wrap="square" anchor="ctr">
+            <a:spAutoFit/>
+          </a:bodyPr>
+          <a:lstStyle/>
+          <a:p>
+            <a:r>
+              <a:rPr sz="1800" b="1">
+                <a:solidFill>
+                  <a:srgbClr val="F5F8FD"/>
+                </a:solidFill>
+              </a:rPr>
+              <a:t>미션: 테스트는 그대로 두고 코드만 고쳐서 FAIL 3개를 PASS로 → QA Gate 통과</a:t>
             </a:r>
           </a:p>
         </p:txBody>

</xml_diff>

<commit_message>
Slides 5/9: add disturbance, align with source, mark interpretation
</commit_message>
<xml_diff>
--- a/docs/AI_Agent_Loop.pptx
+++ b/docs/AI_Agent_Loop.pptx
@@ -596,7 +596,7 @@
           <a:lstStyle/>
           <a:p>
             <a:r>
-              <a:t>Kyle Mistele "Loop Engineering from First Principles". 루프를 제어 이론으로 설명한다. 목표값(set point)과 센서가 잰 현재 상태의 차이가 오차, 컨트롤러가 오차를 보고 작은 보정을 정하고, 실행기(actuator)가 그 보정을 시스템에 적용한다. 그리고 다시 잰다. 온도조절기, Kubernetes 오토스케일링, IaC reconcile이 같은 구조. 코딩 루프에서는 시스템이 코드베이스다. 그의 핵심 주장: 한 번에 최종 상태로 가려 하지 말고 작게 고치고 다시 측정하라(과하게 꺾는 것 방지). 측정 없는 반복은 눈먼 루프다. 또한 리뷰가 막히면 변경 생산을 멈추라고 했다 — 사람이 읽을 수 있는 작은 변경이 중요.</a:t>
+              <a:t>Kyle Mistele "Loop Engineering from First Principles". 루프를 제어 이론으로 설명한다. 목표값(set point)과 센서가 잰 현재 상태의 차이가 오차, 컨트롤러가 오차를 보고 작은 보정을 정하고, 실행기(actuator)가 그 보정을 시스템에 적용한다. 그리고 다시 잰다. 온도조절기, Kubernetes 오토스케일링, IaC reconcile이 같은 구조. 코딩 루프에서는 시스템이 코드베이스다. 그의 핵심 주장: 한 번에 최종 상태로 가려 하지 말고 작게 고치고 다시 측정하라(과하게 꺾는 것 방지). 측정 없는 반복은 눈먼 루프다. 또한 리뷰가 막히면 변경 생산을 멈추라고 했다 — 사람이 읽을 수 있는 작은 변경이 중요. 외부 변화(disturbance): 루프가 고치는 동안에도 다른 사람의 변경 등이 시스템을 계속 흔든다 — 그래서 한 번 고치고 끝이 아니라 계속 다시 측정한다. (그림은 발표 다이어그램을 재구성한 것)</a:t>
             </a:r>
           </a:p>
         </p:txBody>
@@ -806,7 +806,7 @@
           <a:lstStyle/>
           <a:p>
             <a:r>
-              <a:t>5장의 제어 루프 그림에 데모를 그대로 대응시킨 표. 목표값은 테스트 7개 PASS, 센서는 verify.py, 컨트롤러는 loop.py, 실행기가 Kiro CLI. 즉 AI는 실행기 한 칸일 뿐이고, 판정은 AI가 아닌 센서와 컨트롤러가 한다. 정확히 말하면 이것은 swyx 계단의 Goal Loop 하나를 외부 Controller로 구현한 사례이지, Software Factory 전체가 아니다.</a:t>
+              <a:t>5장의 제어 루프 그림에 데모를 그대로 대응시킨 표. 목표값은 테스트 7개 PASS, 센서는 verify.py, 컨트롤러는 loop.py, 실행기가 Kiro CLI. 즉 AI는 실행기 한 칸일 뿐이고, 판정은 AI가 아닌 센서와 컨트롤러가 한다. 정확히 말하면 이것은 swyx 계단의 Goal Loop 하나를 외부 Controller로 구현한 사례이지, Software Factory 전체가 아니다. 주의: 이 대응표는 발표자의 해석이다. Mistele 발표가 이 데모를 다룬 것은 아니다.</a:t>
             </a:r>
           </a:p>
         </p:txBody>
@@ -12173,7 +12173,7 @@
         </p:nvSpPr>
         <p:spPr>
           <a:xfrm>
-            <a:off x="868680" y="2103120"/>
+            <a:off x="868680" y="2331720"/>
             <a:ext cx="1463040" cy="960120"/>
           </a:xfrm>
           <a:prstGeom prst="roundRect">
@@ -12239,7 +12239,7 @@
         </p:nvSpPr>
         <p:spPr>
           <a:xfrm>
-            <a:off x="3074670" y="2240279"/>
+            <a:off x="3074670" y="2468879"/>
             <a:ext cx="685800" cy="685800"/>
           </a:xfrm>
           <a:prstGeom prst="ellipse">
@@ -12292,7 +12292,7 @@
         </p:nvSpPr>
         <p:spPr>
           <a:xfrm>
-            <a:off x="4503420" y="2103120"/>
+            <a:off x="4503420" y="2331720"/>
             <a:ext cx="1737360" cy="960120"/>
           </a:xfrm>
           <a:prstGeom prst="roundRect">
@@ -12358,7 +12358,7 @@
         </p:nvSpPr>
         <p:spPr>
           <a:xfrm>
-            <a:off x="6983729" y="2103120"/>
+            <a:off x="6983729" y="2331720"/>
             <a:ext cx="1737360" cy="960120"/>
           </a:xfrm>
           <a:prstGeom prst="roundRect">
@@ -12424,7 +12424,7 @@
         </p:nvSpPr>
         <p:spPr>
           <a:xfrm>
-            <a:off x="9464040" y="2103120"/>
+            <a:off x="9464040" y="2331720"/>
             <a:ext cx="1920240" cy="960120"/>
           </a:xfrm>
           <a:prstGeom prst="roundRect">
@@ -12489,8 +12489,8 @@
           <p:nvPr/>
         </p:nvCxnSpPr>
         <p:spPr>
-          <a:xfrm>
-            <a:off x="2331720" y="2583179"/>
+          <a:xfrm flipV="1">
+            <a:off x="2331720" y="2811779"/>
             <a:ext cx="742950" cy="0"/>
           </a:xfrm>
           <a:prstGeom prst="line">
@@ -12525,8 +12525,8 @@
           <p:nvPr/>
         </p:nvCxnSpPr>
         <p:spPr>
-          <a:xfrm>
-            <a:off x="3760470" y="2583179"/>
+          <a:xfrm flipV="1">
+            <a:off x="3760470" y="2811779"/>
             <a:ext cx="742950" cy="0"/>
           </a:xfrm>
           <a:prstGeom prst="line">
@@ -12562,7 +12562,7 @@
         </p:nvSpPr>
         <p:spPr>
           <a:xfrm>
-            <a:off x="3669030" y="2199132"/>
+            <a:off x="3669030" y="2427732"/>
             <a:ext cx="925830" cy="274320"/>
           </a:xfrm>
           <a:prstGeom prst="rect">
@@ -12595,8 +12595,8 @@
           <p:nvPr/>
         </p:nvCxnSpPr>
         <p:spPr>
-          <a:xfrm>
-            <a:off x="6240779" y="2583179"/>
+          <a:xfrm flipV="1">
+            <a:off x="6240779" y="2811779"/>
             <a:ext cx="742950" cy="0"/>
           </a:xfrm>
           <a:prstGeom prst="line">
@@ -12632,7 +12632,7 @@
         </p:nvSpPr>
         <p:spPr>
           <a:xfrm>
-            <a:off x="6149340" y="2199132"/>
+            <a:off x="6149340" y="2427732"/>
             <a:ext cx="925830" cy="274320"/>
           </a:xfrm>
           <a:prstGeom prst="rect">
@@ -12665,8 +12665,8 @@
           <p:nvPr/>
         </p:nvCxnSpPr>
         <p:spPr>
-          <a:xfrm>
-            <a:off x="8721090" y="2583179"/>
+          <a:xfrm flipV="1">
+            <a:off x="8721090" y="2811779"/>
             <a:ext cx="742950" cy="0"/>
           </a:xfrm>
           <a:prstGeom prst="line">
@@ -12702,7 +12702,7 @@
         </p:nvSpPr>
         <p:spPr>
           <a:xfrm>
-            <a:off x="8629650" y="2199132"/>
+            <a:off x="8629650" y="2427732"/>
             <a:ext cx="925830" cy="274320"/>
           </a:xfrm>
           <a:prstGeom prst="rect">
@@ -12736,7 +12736,7 @@
         </p:nvSpPr>
         <p:spPr>
           <a:xfrm>
-            <a:off x="5120640" y="3291840"/>
+            <a:off x="5120640" y="3520440"/>
             <a:ext cx="2651760" cy="731520"/>
           </a:xfrm>
           <a:prstGeom prst="roundRect">
@@ -12789,7 +12789,7 @@
                   <a:srgbClr val="8397AB"/>
                 </a:solidFill>
               </a:rPr>
-              <a:t>테스트 · 린트 · 지표로 측정</a:t>
+              <a:t>현재 상태를 측정</a:t>
             </a:r>
           </a:p>
         </p:txBody>
@@ -12802,7 +12802,7 @@
         </p:nvCxnSpPr>
         <p:spPr>
           <a:xfrm>
-            <a:off x="10424160" y="3063239"/>
+            <a:off x="10424160" y="3291839"/>
             <a:ext cx="0" cy="594361"/>
           </a:xfrm>
           <a:prstGeom prst="line">
@@ -12836,8 +12836,8 @@
           <p:nvPr/>
         </p:nvCxnSpPr>
         <p:spPr>
-          <a:xfrm flipH="1">
-            <a:off x="7772400" y="3657600"/>
+          <a:xfrm flipH="1" flipV="1">
+            <a:off x="7772400" y="3886200"/>
             <a:ext cx="2651760" cy="0"/>
           </a:xfrm>
           <a:prstGeom prst="line">
@@ -12872,8 +12872,8 @@
           <p:nvPr/>
         </p:nvCxnSpPr>
         <p:spPr>
-          <a:xfrm flipH="1">
-            <a:off x="3417570" y="3657600"/>
+          <a:xfrm flipH="1" flipV="1">
+            <a:off x="3417570" y="3886200"/>
             <a:ext cx="1703070" cy="0"/>
           </a:xfrm>
           <a:prstGeom prst="line">
@@ -12908,7 +12908,7 @@
         </p:nvCxnSpPr>
         <p:spPr>
           <a:xfrm flipV="1">
-            <a:off x="3417570" y="2926079"/>
+            <a:off x="3417570" y="3154679"/>
             <a:ext cx="0" cy="731521"/>
           </a:xfrm>
           <a:prstGeom prst="line">
@@ -12944,7 +12944,7 @@
         </p:nvSpPr>
         <p:spPr>
           <a:xfrm>
-            <a:off x="3509010" y="3291840"/>
+            <a:off x="3509010" y="3520440"/>
             <a:ext cx="1463040" cy="274320"/>
           </a:xfrm>
           <a:prstGeom prst="rect">
@@ -12977,8 +12977,8 @@
         </p:nvSpPr>
         <p:spPr>
           <a:xfrm>
-            <a:off x="868680" y="4343400"/>
-            <a:ext cx="3352800" cy="1417320"/>
+            <a:off x="868680" y="4526280"/>
+            <a:ext cx="3352800" cy="1234440"/>
           </a:xfrm>
           <a:prstGeom prst="roundRect">
             <a:avLst>
@@ -13051,8 +13051,8 @@
         </p:nvSpPr>
         <p:spPr>
           <a:xfrm>
-            <a:off x="4450080" y="4343400"/>
-            <a:ext cx="3352800" cy="1417320"/>
+            <a:off x="4450080" y="4526280"/>
+            <a:ext cx="3352800" cy="1234440"/>
           </a:xfrm>
           <a:prstGeom prst="roundRect">
             <a:avLst>
@@ -13125,8 +13125,8 @@
         </p:nvSpPr>
         <p:spPr>
           <a:xfrm>
-            <a:off x="8031480" y="4343400"/>
-            <a:ext cx="3352800" cy="1417320"/>
+            <a:off x="8031480" y="4526280"/>
+            <a:ext cx="3352800" cy="1234440"/>
           </a:xfrm>
           <a:prstGeom prst="roundRect">
             <a:avLst>
@@ -13219,7 +13219,7 @@
                   <a:srgbClr val="8397AB"/>
                 </a:solidFill>
               </a:rPr>
-              <a:t>출처: Kyle Mistele, “Loop Engineering from First Principles”, AI Engineer World's Fair 2026 (17:57)</a:t>
+              <a:t>출처: Kyle Mistele, “Loop Engineering from First Principles”, AI Engineer World's Fair 2026 · 발표의 제어 루프 다이어그램을 한국어로 재구성</a:t>
             </a:r>
           </a:p>
         </p:txBody>
@@ -13257,6 +13257,77 @@
           </a:p>
         </p:txBody>
       </p:sp>
+      <p:sp>
+        <p:nvSpPr>
+          <p:cNvPr id="29" name="TextBox 28"/>
+          <p:cNvSpPr txBox="1"/>
+          <p:nvPr/>
+        </p:nvSpPr>
+        <p:spPr>
+          <a:xfrm>
+            <a:off x="9098280" y="1764792"/>
+            <a:ext cx="2651760" cy="274320"/>
+          </a:xfrm>
+          <a:prstGeom prst="rect">
+            <a:avLst/>
+          </a:prstGeom>
+          <a:noFill/>
+        </p:spPr>
+        <p:txBody>
+          <a:bodyPr wrap="square">
+            <a:spAutoFit/>
+          </a:bodyPr>
+          <a:lstStyle/>
+          <a:p>
+            <a:pPr algn="ctr"/>
+            <a:r>
+              <a:rPr sz="1100" b="1">
+                <a:solidFill>
+                  <a:srgbClr val="FACC15"/>
+                </a:solidFill>
+              </a:rPr>
+              <a:t>외부 변화  Disturbance</a:t>
+            </a:r>
+          </a:p>
+        </p:txBody>
+      </p:sp>
+      <p:cxnSp>
+        <p:nvCxnSpPr>
+          <p:cNvPr id="30" name="Connector 29"/>
+          <p:cNvCxnSpPr/>
+          <p:nvPr/>
+        </p:nvCxnSpPr>
+        <p:spPr>
+          <a:xfrm>
+            <a:off x="10424160" y="2029968"/>
+            <a:ext cx="0" cy="301752"/>
+          </a:xfrm>
+          <a:prstGeom prst="line">
+            <a:avLst/>
+          </a:prstGeom>
+          <a:ln w="22225">
+            <a:solidFill>
+              <a:srgbClr val="FACC15"/>
+            </a:solidFill>
+            <a:prstDash val="dash"/>
+            <a:tailEnd type="triangle" w="med" len="med"/>
+          </a:ln>
+        </p:spPr>
+        <p:style>
+          <a:lnRef idx="2">
+            <a:schemeClr val="accent1"/>
+          </a:lnRef>
+          <a:fillRef idx="0">
+            <a:schemeClr val="accent1"/>
+          </a:fillRef>
+          <a:effectRef idx="1">
+            <a:schemeClr val="accent1"/>
+          </a:effectRef>
+          <a:fontRef idx="minor">
+            <a:schemeClr val="tx1"/>
+          </a:fontRef>
+        </p:style>
+      </p:cxnSp>
     </p:spTree>
   </p:cSld>
   <p:clrMapOvr>
@@ -16792,6 +16863,39 @@
           </a:p>
         </p:txBody>
       </p:sp>
+      <p:sp>
+        <p:nvSpPr>
+          <p:cNvPr id="9" name="TextBox 8"/>
+          <p:cNvSpPr txBox="1"/>
+          <p:nvPr/>
+        </p:nvSpPr>
+        <p:spPr>
+          <a:xfrm>
+            <a:off x="868680" y="6080760"/>
+            <a:ext cx="10515600" cy="256032"/>
+          </a:xfrm>
+          <a:prstGeom prst="rect">
+            <a:avLst/>
+          </a:prstGeom>
+          <a:noFill/>
+        </p:spPr>
+        <p:txBody>
+          <a:bodyPr wrap="square">
+            <a:spAutoFit/>
+          </a:bodyPr>
+          <a:lstStyle/>
+          <a:p>
+            <a:r>
+              <a:rPr sz="1000" b="0">
+                <a:solidFill>
+                  <a:srgbClr val="8397AB"/>
+                </a:solidFill>
+              </a:rPr>
+              <a:t>제어 루프 요소와 온도조절기 예시: Kyle Mistele 발표 · 각 칸의 구체적 대응은 발표자 해석</a:t>
+            </a:r>
+          </a:p>
+        </p:txBody>
+      </p:sp>
     </p:spTree>
   </p:cSld>
   <p:clrMapOvr>

</xml_diff>

<commit_message>
Cite Inner/Outer Loop sources on slides 6 and 19; update study guide
</commit_message>
<xml_diff>
--- a/docs/AI_Agent_Loop.pptx
+++ b/docs/AI_Agent_Loop.pptx
@@ -666,7 +666,7 @@
           <a:lstStyle/>
           <a:p>
             <a:r>
-              <a:t>중요: 평소 쓰는 Kiro나 Claude Code도 이미 루프를 돈다. 한 세션 안에서 모델이 도구를 호출하고 결과를 보고 다시 판단하는 반복이 Inner Loop. 그래서 한 번의 프롬프트로 개발·테스트·수정이 다 끝날 수도 있고, 그게 정상이다. "기존 Kiro는 반복을 못 한다"는 사실이 아니다. 차이는 누가 끝을 정하느냐. Inner Loop는 AI가 스스로 완료라고 판단하면 끝난다. Outer Loop는 세션 바깥의 프로그램이 독립적으로 검증하고, 실패하면 사람 개입 없이 새 세션을 시작한다. 오늘 데모는 Outer Loop.</a:t>
+              <a:t>중요: 평소 쓰는 Kiro나 Claude Code도 이미 루프를 돈다. 한 세션 안에서 모델이 도구를 호출하고 결과를 보고 다시 판단하는 반복이 Inner Loop. 그래서 한 번의 프롬프트로 개발·테스트·수정이 다 끝날 수도 있고, 그게 정상이다. "기존 Kiro는 반복을 못 한다"는 사실이 아니다. 차이는 누가 끝을 정하느냐. Inner Loop는 AI가 스스로 완료라고 판단하면 끝난다. Outer Loop는 세션 바깥의 프로그램이 독립적으로 검증하고, 실패하면 사람 개입 없이 새 세션을 시작한다. 오늘 데모는 Outer Loop. [용어 출처] Inner/Outer Loop는 Fair 발표 용어가 아니라 업계 글에서 쓰는 용어다. Philipp Schmid(2026-02-20): inner loop = 한 작업 안에서 에이전트가 코드 작성→테스트→수정 후 응답, outer loop = 여러 턴·세션에 걸쳐 배운 것을 유지(AGENTS.md, 스킬, 핸드오프 문서). The AI Automators(2026-07): 에이전트 자신의 반복이 inner loop이고, loop engineering은 보통 그 바깥에 두는 outer loop — 언제 다시 시작할지, 진행을 어떻게 평가할지, 어떤 피드백을 줄지, 언제 멈출지를 정한다. 오늘 데모는 두 번째 정의에 가깝다. 실패 로그를 다음 세션에 넘기는 점에서 Schmid의 "세션 간 상태 유지"도 일부 해당한다.</a:t>
             </a:r>
           </a:p>
         </p:txBody>
@@ -9721,7 +9721,7 @@
         <p:spPr>
           <a:xfrm>
             <a:off x="868680" y="1417320"/>
-            <a:ext cx="10515600" cy="4480560"/>
+            <a:ext cx="10515600" cy="4572000"/>
           </a:xfrm>
           <a:prstGeom prst="rect">
             <a:avLst/>
@@ -9736,11 +9736,11 @@
           <a:p>
             <a:pPr>
               <a:spcAft>
-                <a:spcPts val="100"/>
+                <a:spcPts val="0"/>
               </a:spcAft>
             </a:pPr>
             <a:r>
-              <a:rPr sz="1400" b="1">
+              <a:rPr sz="1300" b="1">
                 <a:solidFill>
                   <a:srgbClr val="F5F8FD"/>
                 </a:solidFill>
@@ -9751,11 +9751,11 @@
           <a:p>
             <a:pPr>
               <a:spcAft>
-                <a:spcPts val="1000"/>
+                <a:spcPts val="700"/>
               </a:spcAft>
             </a:pPr>
             <a:r>
-              <a:rPr sz="1100" b="0">
+              <a:rPr sz="1000" b="0">
                 <a:solidFill>
                   <a:srgbClr val="31D3B1"/>
                 </a:solidFill>
@@ -9767,11 +9767,11 @@
           <a:p>
             <a:pPr>
               <a:spcAft>
-                <a:spcPts val="100"/>
+                <a:spcPts val="0"/>
               </a:spcAft>
             </a:pPr>
             <a:r>
-              <a:rPr sz="1400" b="1">
+              <a:rPr sz="1300" b="1">
                 <a:solidFill>
                   <a:srgbClr val="F5F8FD"/>
                 </a:solidFill>
@@ -9782,11 +9782,11 @@
           <a:p>
             <a:pPr>
               <a:spcAft>
-                <a:spcPts val="1000"/>
+                <a:spcPts val="700"/>
               </a:spcAft>
             </a:pPr>
             <a:r>
-              <a:rPr sz="1100" b="0">
+              <a:rPr sz="1000" b="0">
                 <a:solidFill>
                   <a:srgbClr val="31D3B1"/>
                 </a:solidFill>
@@ -9798,11 +9798,11 @@
           <a:p>
             <a:pPr>
               <a:spcAft>
-                <a:spcPts val="100"/>
+                <a:spcPts val="0"/>
               </a:spcAft>
             </a:pPr>
             <a:r>
-              <a:rPr sz="1400" b="1">
+              <a:rPr sz="1300" b="1">
                 <a:solidFill>
                   <a:srgbClr val="F5F8FD"/>
                 </a:solidFill>
@@ -9813,11 +9813,11 @@
           <a:p>
             <a:pPr>
               <a:spcAft>
-                <a:spcPts val="1000"/>
+                <a:spcPts val="700"/>
               </a:spcAft>
             </a:pPr>
             <a:r>
-              <a:rPr sz="1100" b="0">
+              <a:rPr sz="1000" b="0">
                 <a:solidFill>
                   <a:srgbClr val="31D3B1"/>
                 </a:solidFill>
@@ -9829,11 +9829,11 @@
           <a:p>
             <a:pPr>
               <a:spcAft>
-                <a:spcPts val="100"/>
+                <a:spcPts val="0"/>
               </a:spcAft>
             </a:pPr>
             <a:r>
-              <a:rPr sz="1400" b="1">
+              <a:rPr sz="1300" b="1">
                 <a:solidFill>
                   <a:srgbClr val="F5F8FD"/>
                 </a:solidFill>
@@ -9844,11 +9844,11 @@
           <a:p>
             <a:pPr>
               <a:spcAft>
-                <a:spcPts val="1000"/>
+                <a:spcPts val="700"/>
               </a:spcAft>
             </a:pPr>
             <a:r>
-              <a:rPr sz="1100" b="0">
+              <a:rPr sz="1000" b="0">
                 <a:solidFill>
                   <a:srgbClr val="31D3B1"/>
                 </a:solidFill>
@@ -9860,11 +9860,11 @@
           <a:p>
             <a:pPr>
               <a:spcAft>
-                <a:spcPts val="100"/>
+                <a:spcPts val="0"/>
               </a:spcAft>
             </a:pPr>
             <a:r>
-              <a:rPr sz="1400" b="1">
+              <a:rPr sz="1300" b="1">
                 <a:solidFill>
                   <a:srgbClr val="F5F8FD"/>
                 </a:solidFill>
@@ -9875,11 +9875,11 @@
           <a:p>
             <a:pPr>
               <a:spcAft>
-                <a:spcPts val="1000"/>
+                <a:spcPts val="700"/>
               </a:spcAft>
             </a:pPr>
             <a:r>
-              <a:rPr sz="1100" b="0">
+              <a:rPr sz="1000" b="0">
                 <a:solidFill>
                   <a:srgbClr val="31D3B1"/>
                 </a:solidFill>
@@ -9891,57 +9891,119 @@
           <a:p>
             <a:pPr>
               <a:spcAft>
-                <a:spcPts val="100"/>
+                <a:spcPts val="0"/>
               </a:spcAft>
             </a:pPr>
             <a:r>
-              <a:rPr sz="1400" b="1">
+              <a:rPr sz="1300" b="1">
                 <a:solidFill>
                   <a:srgbClr val="F5F8FD"/>
                 </a:solidFill>
               </a:rPr>
-              <a:t>Kiro CLI — headless / non-interactive 실행</a:t>
+              <a:t>Philipp Schmid — Agents: Inner Loop vs Outer Loop (2026-02-20)</a:t>
             </a:r>
           </a:p>
           <a:p>
             <a:pPr>
               <a:spcAft>
-                <a:spcPts val="1000"/>
+                <a:spcPts val="700"/>
               </a:spcAft>
             </a:pPr>
             <a:r>
-              <a:rPr sz="1100" b="0">
+              <a:rPr sz="1000" b="0">
                 <a:solidFill>
                   <a:srgbClr val="31D3B1"/>
                 </a:solidFill>
-                <a:hlinkClick r:id="rId8"/>
-              </a:rPr>
-              <a:t>https://kiro.dev/docs/cli/headless/</a:t>
+                <a:hlinkClick r:id="rId10"/>
+              </a:rPr>
+              <a:t>https://www.philschmid.de/inner-loop-vs-outer-loop</a:t>
             </a:r>
           </a:p>
           <a:p>
             <a:pPr>
               <a:spcAft>
-                <a:spcPts val="100"/>
+                <a:spcPts val="0"/>
               </a:spcAft>
             </a:pPr>
             <a:r>
-              <a:rPr sz="1400" b="1">
+              <a:rPr sz="1300" b="1">
                 <a:solidFill>
                   <a:srgbClr val="F5F8FD"/>
                 </a:solidFill>
               </a:rPr>
-              <a:t>데모 저장소 — Java + Kiro CLI Outer Loop</a:t>
+              <a:t>The AI Automators — The 4 Levels of Loop Engineering (2026-07)</a:t>
             </a:r>
           </a:p>
           <a:p>
             <a:pPr>
               <a:spcAft>
-                <a:spcPts val="1000"/>
+                <a:spcPts val="700"/>
               </a:spcAft>
             </a:pPr>
             <a:r>
-              <a:rPr sz="1100" b="0">
+              <a:rPr sz="1000" b="0">
+                <a:solidFill>
+                  <a:srgbClr val="31D3B1"/>
+                </a:solidFill>
+                <a:hlinkClick r:id="rId11"/>
+              </a:rPr>
+              <a:t>https://www.theaiautomators.com/levels-of-loop-engineering/</a:t>
+            </a:r>
+          </a:p>
+          <a:p>
+            <a:pPr>
+              <a:spcAft>
+                <a:spcPts val="0"/>
+              </a:spcAft>
+            </a:pPr>
+            <a:r>
+              <a:rPr sz="1300" b="1">
+                <a:solidFill>
+                  <a:srgbClr val="F5F8FD"/>
+                </a:solidFill>
+              </a:rPr>
+              <a:t>Kiro CLI — headless / non-interactive 실행</a:t>
+            </a:r>
+          </a:p>
+          <a:p>
+            <a:pPr>
+              <a:spcAft>
+                <a:spcPts val="700"/>
+              </a:spcAft>
+            </a:pPr>
+            <a:r>
+              <a:rPr sz="1000" b="0">
+                <a:solidFill>
+                  <a:srgbClr val="31D3B1"/>
+                </a:solidFill>
+                <a:hlinkClick r:id="rId8"/>
+              </a:rPr>
+              <a:t>https://kiro.dev/docs/cli/headless/</a:t>
+            </a:r>
+          </a:p>
+          <a:p>
+            <a:pPr>
+              <a:spcAft>
+                <a:spcPts val="0"/>
+              </a:spcAft>
+            </a:pPr>
+            <a:r>
+              <a:rPr sz="1300" b="1">
+                <a:solidFill>
+                  <a:srgbClr val="F5F8FD"/>
+                </a:solidFill>
+              </a:rPr>
+              <a:t>데모 저장소 — Java + Kiro CLI Outer Loop</a:t>
+            </a:r>
+          </a:p>
+          <a:p>
+            <a:pPr>
+              <a:spcAft>
+                <a:spcPts val="700"/>
+              </a:spcAft>
+            </a:pPr>
+            <a:r>
+              <a:rPr sz="1000" b="0">
                 <a:solidFill>
                   <a:srgbClr val="31D3B1"/>
                 </a:solidFill>
@@ -14159,7 +14221,7 @@
         </p:nvSpPr>
         <p:spPr>
           <a:xfrm>
-            <a:off x="868680" y="5852160"/>
+            <a:off x="868680" y="5779008"/>
             <a:ext cx="10515600" cy="320040"/>
           </a:xfrm>
           <a:prstGeom prst="rect">
@@ -14213,6 +14275,39 @@
                 </a:solidFill>
               </a:rPr>
               <a:t>PART 2 · Loop는 어떻게 생겼나</a:t>
+            </a:r>
+          </a:p>
+        </p:txBody>
+      </p:sp>
+      <p:sp>
+        <p:nvSpPr>
+          <p:cNvPr id="19" name="TextBox 18"/>
+          <p:cNvSpPr txBox="1"/>
+          <p:nvPr/>
+        </p:nvSpPr>
+        <p:spPr>
+          <a:xfrm>
+            <a:off x="868680" y="6080760"/>
+            <a:ext cx="10515600" cy="256032"/>
+          </a:xfrm>
+          <a:prstGeom prst="rect">
+            <a:avLst/>
+          </a:prstGeom>
+          <a:noFill/>
+        </p:spPr>
+        <p:txBody>
+          <a:bodyPr wrap="none">
+            <a:spAutoFit/>
+          </a:bodyPr>
+          <a:lstStyle/>
+          <a:p>
+            <a:r>
+              <a:rPr sz="1000">
+                <a:solidFill>
+                  <a:srgbClr val="8397AB"/>
+                </a:solidFill>
+              </a:rPr>
+              <a:t>용어 출처: Philipp Schmid “Agents: Inner Loop vs Outer Loop” (2026-02-20) · The AI Automators “The 4 Levels of Loop Engineering” (2026-07) — Outer Loop의 정의는 출처마다 조금씩 다름</a:t>
             </a:r>
           </a:p>
         </p:txBody>

</xml_diff>

<commit_message>
Cite Shawn Greyling for Inner/Outer Loop on slides 6 and 19
</commit_message>
<xml_diff>
--- a/docs/AI_Agent_Loop.pptx
+++ b/docs/AI_Agent_Loop.pptx
@@ -666,7 +666,7 @@
           <a:lstStyle/>
           <a:p>
             <a:r>
-              <a:t>중요: 평소 쓰는 Kiro나 Claude Code도 이미 루프를 돈다. 한 세션 안에서 모델이 도구를 호출하고 결과를 보고 다시 판단하는 반복이 Inner Loop. 그래서 한 번의 프롬프트로 개발·테스트·수정이 다 끝날 수도 있고, 그게 정상이다. "기존 Kiro는 반복을 못 한다"는 사실이 아니다. 차이는 누가 끝을 정하느냐. Inner Loop는 AI가 스스로 완료라고 판단하면 끝난다. Outer Loop는 세션 바깥의 프로그램이 독립적으로 검증하고, 실패하면 사람 개입 없이 새 세션을 시작한다. 오늘 데모는 Outer Loop. [용어 출처] Inner/Outer Loop는 Fair 발표 용어가 아니라 업계 글에서 쓰는 용어다. Philipp Schmid(2026-02-20): inner loop = 한 작업 안에서 에이전트가 코드 작성→테스트→수정 후 응답, outer loop = 여러 턴·세션에 걸쳐 배운 것을 유지(AGENTS.md, 스킬, 핸드오프 문서). The AI Automators(2026-07): 에이전트 자신의 반복이 inner loop이고, loop engineering은 보통 그 바깥에 두는 outer loop — 언제 다시 시작할지, 진행을 어떻게 평가할지, 어떤 피드백을 줄지, 언제 멈출지를 정한다. 오늘 데모는 두 번째 정의에 가깝다. 실패 로그를 다음 세션에 넘기는 점에서 Schmid의 "세션 간 상태 유지"도 일부 해당한다.</a:t>
+              <a:t>중요: 평소 쓰는 Kiro나 Claude Code도 이미 루프를 돈다. 한 세션 안에서 모델이 도구를 호출하고 결과를 보고 다시 판단하는 반복이 Inner Loop. 그래서 한 번의 프롬프트로 개발·테스트·수정이 다 끝날 수도 있고, 그게 정상이다. "기존 Kiro는 반복을 못 한다"는 사실이 아니다. 차이는 누가 끝을 정하느냐. Inner Loop는 AI가 스스로 완료라고 판단하면 끝난다. Outer Loop는 세션 바깥의 프로그램이 독립적으로 검증하고, 실패하면 사람 개입 없이 새 세션을 시작한다. 오늘 데모는 Outer Loop. [용어 출처] Inner/Outer Loop는 Fair 발표 용어가 아니라 업계 글에서 쓰는 용어다. Philipp Schmid(2026-02-20): inner loop = 한 작업 안에서 에이전트가 코드 작성→테스트→수정 후 응답, outer loop = 여러 턴·세션에 걸쳐 배운 것을 유지(AGENTS.md, 스킬, 핸드오프 문서). The AI Automators(2026-07): 에이전트 자신의 반복이 inner loop이고, loop engineering은 보통 그 바깥에 두는 outer loop — 언제 다시 시작할지, 진행을 어떻게 평가할지, 어떤 피드백을 줄지, 언제 멈출지를 정한다. 오늘 데모는 두 번째 정의에 가깝다. 실패 로그를 다음 세션에 넘기는 점에서 Schmid의 "세션 간 상태 유지"도 일부 해당한다. Shawn Greyling(2026-06-14)의 정의가 데모와 가장 가깝다: 에이전트는 이미 내부적으로 루프를 돈다(ReAct: 추론→행동→관찰). Outer loop는 그 한 단계 위에서 에이전트를 실행하고, 결과를 검사하고, 상태를 저장하고, 다음 사이클을 시작한다. 한 프롬프트로 끝날 수도 있다 — 그게 정상이고, 오늘 보여줄 것은 그 바깥의 Outer Loop다.</a:t>
             </a:r>
           </a:p>
         </p:txBody>
@@ -9900,6 +9900,37 @@
                   <a:srgbClr val="F5F8FD"/>
                 </a:solidFill>
               </a:rPr>
+              <a:t>Shawn Greyling — Loop engineering: from the inner loop to the outer loop (2026-06-14)</a:t>
+            </a:r>
+          </a:p>
+          <a:p>
+            <a:pPr>
+              <a:spcAft>
+                <a:spcPts val="700"/>
+              </a:spcAft>
+            </a:pPr>
+            <a:r>
+              <a:rPr sz="1000" b="0">
+                <a:solidFill>
+                  <a:srgbClr val="31D3B1"/>
+                </a:solidFill>
+                <a:hlinkClick r:id="rId12"/>
+              </a:rPr>
+              <a:t>https://www.shawngreyling.com/blog/loop-engineering</a:t>
+            </a:r>
+          </a:p>
+          <a:p>
+            <a:pPr>
+              <a:spcAft>
+                <a:spcPts val="0"/>
+              </a:spcAft>
+            </a:pPr>
+            <a:r>
+              <a:rPr sz="1300" b="1">
+                <a:solidFill>
+                  <a:srgbClr val="F5F8FD"/>
+                </a:solidFill>
+              </a:rPr>
               <a:t>Philipp Schmid — Agents: Inner Loop vs Outer Loop (2026-02-20)</a:t>
             </a:r>
           </a:p>
@@ -14238,10 +14269,10 @@
             <a:r>
               <a:rPr sz="1300" b="0">
                 <a:solidFill>
-                  <a:srgbClr val="8397AB"/>
-                </a:solidFill>
-              </a:rPr>
-              <a:t>한 프롬프트로 끝날 수도 있다(정상). 오늘 보여줄 것은 그 바깥, Outer Loop</a:t>
+                  <a:srgbClr val="CFDEEB"/>
+                </a:solidFill>
+              </a:rPr>
+              <a:t>“The inner loop: the agent thinks. The outer loop: you design the machine that runs it.” — Shawn Greyling</a:t>
             </a:r>
           </a:p>
         </p:txBody>
@@ -14307,7 +14338,7 @@
                   <a:srgbClr val="8397AB"/>
                 </a:solidFill>
               </a:rPr>
-              <a:t>용어 출처: Philipp Schmid “Agents: Inner Loop vs Outer Loop” (2026-02-20) · The AI Automators “The 4 Levels of Loop Engineering” (2026-07) — Outer Loop의 정의는 출처마다 조금씩 다름</a:t>
+              <a:t>용어 출처: Shawn Greyling “Loop engineering: from the inner loop to the outer loop” (2026-06-14) · Philipp Schmid “Agents: Inner Loop vs Outer Loop” (2026-02-20) — 정의는 출처마다 조금씩 다름</a:t>
             </a:r>
           </a:p>
         </p:txBody>

</xml_diff>

<commit_message>
Slide 6: cite Osmani AIEWF keynote, add speaker script; slide 19 refs
</commit_message>
<xml_diff>
--- a/docs/AI_Agent_Loop.pptx
+++ b/docs/AI_Agent_Loop.pptx
@@ -666,7 +666,121 @@
           <a:lstStyle/>
           <a:p>
             <a:r>
-              <a:t>중요: 평소 쓰는 Kiro나 Claude Code도 이미 루프를 돈다. 한 세션 안에서 모델이 도구를 호출하고 결과를 보고 다시 판단하는 반복이 Inner Loop. 그래서 한 번의 프롬프트로 개발·테스트·수정이 다 끝날 수도 있고, 그게 정상이다. "기존 Kiro는 반복을 못 한다"는 사실이 아니다. 차이는 누가 끝을 정하느냐. Inner Loop는 AI가 스스로 완료라고 판단하면 끝난다. Outer Loop는 세션 바깥의 프로그램이 독립적으로 검증하고, 실패하면 사람 개입 없이 새 세션을 시작한다. 오늘 데모는 Outer Loop. [용어 출처] Inner/Outer Loop는 Fair 발표 용어가 아니라 업계 글에서 쓰는 용어다. Philipp Schmid(2026-02-20): inner loop = 한 작업 안에서 에이전트가 코드 작성→테스트→수정 후 응답, outer loop = 여러 턴·세션에 걸쳐 배운 것을 유지(AGENTS.md, 스킬, 핸드오프 문서). The AI Automators(2026-07): 에이전트 자신의 반복이 inner loop이고, loop engineering은 보통 그 바깥에 두는 outer loop — 언제 다시 시작할지, 진행을 어떻게 평가할지, 어떤 피드백을 줄지, 언제 멈출지를 정한다. 오늘 데모는 두 번째 정의에 가깝다. 실패 로그를 다음 세션에 넘기는 점에서 Schmid의 "세션 간 상태 유지"도 일부 해당한다. Shawn Greyling(2026-06-14)의 정의가 데모와 가장 가깝다: 에이전트는 이미 내부적으로 루프를 돈다(ReAct: 추론→행동→관찰). Outer loop는 그 한 단계 위에서 에이전트를 실행하고, 결과를 검사하고, 상태를 저장하고, 다음 사이클을 시작한다. 한 프롬프트로 끝날 수도 있다 — 그게 정상이고, 오늘 보여줄 것은 그 바깥의 Outer Loop다.</a:t>
+              <a:t>[발표 스크립트 · 약 2분]</a:t>
+            </a:r>
+          </a:p>
+          <a:p/>
+          <a:p>
+            <a:r>
+              <a:t>(도입)</a:t>
+            </a:r>
+          </a:p>
+          <a:p>
+            <a:r>
+              <a:t>평소 Kiro나 Claude Code에 "이 버그 고쳐줘"라고 하면, AI가 혼자 파일을 읽고, 고치고, 테스트를 돌려 보고, 실패하면 다시 고칩니다. 사실 이미 반복을 하고 있는 거죠. 이게 Inner Loop입니다.</a:t>
+            </a:r>
+          </a:p>
+          <a:p/>
+          <a:p>
+            <a:r>
+              <a:t>(왼쪽 보라색 상자)</a:t>
+            </a:r>
+          </a:p>
+          <a:p>
+            <a:r>
+              <a:t>Inner Loop는 하나의 AI 세션 안에서 돕니다. 모델이 도구를 부르고, 결과를 보고, 다시 판단하는 반복입니다. 여기서 중요한 건, 언제 끝낼지를 AI 자신이 정한다는 점입니다. AI가 "다 됐다"고 판단하면 거기서 끝납니다.</a:t>
+            </a:r>
+          </a:p>
+          <a:p>
+            <a:r>
+              <a:t>그래서 간단한 작업은 프롬프트 한 번에 개발·테스트·수정이 다 끝날 수도 있고, 그게 정상입니다. 기존 도구가 반복을 못 한다는 얘기가 아닙니다.</a:t>
+            </a:r>
+          </a:p>
+          <a:p/>
+          <a:p>
+            <a:r>
+              <a:t>(초록 점선 상자)</a:t>
+            </a:r>
+          </a:p>
+          <a:p>
+            <a:r>
+              <a:t>Outer Loop는 그 세션 바깥에 하나를 더 두는 겁니다. 바깥 프로그램, 오늘 데모에서는 Python Controller가 AI 세션 전체를 한 단위로 보고 반복합니다.</a:t>
+            </a:r>
+          </a:p>
+          <a:p>
+            <a:r>
+              <a:t>세션이 끝나면 Controller가 AI 말을 믿지 않고 테스트를 직접 돌립니다. PASS면 종료하고, FAIL이면 실패 로그를 들고 새 세션을 시작합니다. 이때 사람은 아무것도 입력하지 않습니다(빨간 화살표).</a:t>
+            </a:r>
+          </a:p>
+          <a:p/>
+          <a:p>
+            <a:r>
+              <a:t>(오른쪽 비교)</a:t>
+            </a:r>
+          </a:p>
+          <a:p>
+            <a:r>
+              <a:t>정리하면 차이는 세 가지입니다. 반복 단위가 "도구 호출"이냐 "세션 전체"냐, 끝내는 주체가 "AI 자신"이냐 "외부 Controller"냐, 종료 기준이 "AI의 판단"이냐 "테스트 PASS와 횟수·시간 한도"냐.</a:t>
+            </a:r>
+          </a:p>
+          <a:p/>
+          <a:p>
+            <a:r>
+              <a:t>(하단 인용)</a:t>
+            </a:r>
+          </a:p>
+          <a:p>
+            <a:r>
+              <a:t>이 구분은 World's Fair 키노트에서 Addy Osmani도 말했습니다. "에이전트는 inner loop를 돌리고, 엔지니어는 outer loop를 책임진다." 오늘 데모의 Controller는 엔지니어가 설계한 outer loop입니다. 재시도는 자동이지만, 머지나 배포 같은 최종 판단은 여전히 사람이 합니다.</a:t>
+            </a:r>
+          </a:p>
+          <a:p/>
+          <a:p>
+            <a:r>
+              <a:t>(전환)</a:t>
+            </a:r>
+          </a:p>
+          <a:p>
+            <a:r>
+              <a:t>그럼 왜 굳이 바깥에서 따로 검증해야 할까요? 다음 장에서 보겠습니다.</a:t>
+            </a:r>
+          </a:p>
+          <a:p/>
+          <a:p>
+            <a:r>
+              <a:t>[예상 질문]</a:t>
+            </a:r>
+          </a:p>
+          <a:p>
+            <a:r>
+              <a:t>Q. Kiro 혼자서도 테스트를 돌리는데, 왜 바깥이 필요한가요?</a:t>
+            </a:r>
+          </a:p>
+          <a:p>
+            <a:r>
+              <a:t>A. 돌릴 수 있습니다. 차이는 누가 판정하느냐입니다. AI가 테스트를 건너뛰거나 일부만 돌리고 "통과"라고 해도 Inner Loop 안에서는 알 수 없습니다. 바깥에서는 AI가 아닌 일반 코드가 매번 같은 방식으로 다시 검사합니다.</a:t>
+            </a:r>
+          </a:p>
+          <a:p/>
+          <a:p>
+            <a:r>
+              <a:t>Q. Inner/Outer Loop가 공식 용어인가요?</a:t>
+            </a:r>
+          </a:p>
+          <a:p>
+            <a:r>
+              <a:t>A. 표준 정의는 없지만 통용되는 말입니다. Fair 키노트(Osmani)와 현장 기사(Latent Space)에서 썼고, Shawn Greyling, Philipp Schmid 같은 여러 글에서도 씁니다.</a:t>
+            </a:r>
+          </a:p>
+          <a:p/>
+          <a:p>
+            <a:r>
+              <a:t>Q. 사람마다 Outer Loop 뜻이 다르지 않나요?</a:t>
+            </a:r>
+          </a:p>
+          <a:p>
+            <a:r>
+              <a:t>A. 맞습니다. Osmani는 사람의 판단과 책임 영역, Greyling은 에이전트를 실행·검사·재실행하는 기계, Schmid는 세션 사이에 배운 것을 기억하는 구조로 씁니다. 오늘 데모는 Greyling의 정의를 구현한 것이고, Osmani 말대로 최종 판단은 사람에게 남겨 둡니다.</a:t>
             </a:r>
           </a:p>
         </p:txBody>
@@ -9751,7 +9865,7 @@
           <a:p>
             <a:pPr>
               <a:spcAft>
-                <a:spcPts val="700"/>
+                <a:spcPts val="500"/>
               </a:spcAft>
             </a:pPr>
             <a:r>
@@ -9782,7 +9896,7 @@
           <a:p>
             <a:pPr>
               <a:spcAft>
-                <a:spcPts val="700"/>
+                <a:spcPts val="500"/>
               </a:spcAft>
             </a:pPr>
             <a:r>
@@ -9813,7 +9927,7 @@
           <a:p>
             <a:pPr>
               <a:spcAft>
-                <a:spcPts val="700"/>
+                <a:spcPts val="500"/>
               </a:spcAft>
             </a:pPr>
             <a:r>
@@ -9844,7 +9958,7 @@
           <a:p>
             <a:pPr>
               <a:spcAft>
-                <a:spcPts val="700"/>
+                <a:spcPts val="500"/>
               </a:spcAft>
             </a:pPr>
             <a:r>
@@ -9875,7 +9989,7 @@
           <a:p>
             <a:pPr>
               <a:spcAft>
-                <a:spcPts val="700"/>
+                <a:spcPts val="500"/>
               </a:spcAft>
             </a:pPr>
             <a:r>
@@ -9900,13 +10014,13 @@
                   <a:srgbClr val="F5F8FD"/>
                 </a:solidFill>
               </a:rPr>
-              <a:t>Shawn Greyling — Loop engineering: from the inner loop to the outer loop (2026-06-14)</a:t>
+              <a:t>Addy Osmani — Own the Outer Loop (AIEWF 2026 키노트 글 버전, 2026-07-15)</a:t>
             </a:r>
           </a:p>
           <a:p>
             <a:pPr>
               <a:spcAft>
-                <a:spcPts val="700"/>
+                <a:spcPts val="500"/>
               </a:spcAft>
             </a:pPr>
             <a:r>
@@ -9914,9 +10028,9 @@
                 <a:solidFill>
                   <a:srgbClr val="31D3B1"/>
                 </a:solidFill>
-                <a:hlinkClick r:id="rId12"/>
-              </a:rPr>
-              <a:t>https://www.shawngreyling.com/blog/loop-engineering</a:t>
+                <a:hlinkClick r:id="rId13"/>
+              </a:rPr>
+              <a:t>https://addyosmani.com/blog/own-the-outer-loop/</a:t>
             </a:r>
           </a:p>
           <a:p>
@@ -9931,13 +10045,13 @@
                   <a:srgbClr val="F5F8FD"/>
                 </a:solidFill>
               </a:rPr>
-              <a:t>Philipp Schmid — Agents: Inner Loop vs Outer Loop (2026-02-20)</a:t>
+              <a:t>Latent Space — Autoresearch and the tension between AI and human agency (2026-07-02)</a:t>
             </a:r>
           </a:p>
           <a:p>
             <a:pPr>
               <a:spcAft>
-                <a:spcPts val="700"/>
+                <a:spcPts val="500"/>
               </a:spcAft>
             </a:pPr>
             <a:r>
@@ -9945,9 +10059,9 @@
                 <a:solidFill>
                   <a:srgbClr val="31D3B1"/>
                 </a:solidFill>
-                <a:hlinkClick r:id="rId10"/>
-              </a:rPr>
-              <a:t>https://www.philschmid.de/inner-loop-vs-outer-loop</a:t>
+                <a:hlinkClick r:id="rId14"/>
+              </a:rPr>
+              <a:t>https://www.latent.space/p/aiewf-daily-dispatch-agency</a:t>
             </a:r>
           </a:p>
           <a:p>
@@ -9962,13 +10076,13 @@
                   <a:srgbClr val="F5F8FD"/>
                 </a:solidFill>
               </a:rPr>
-              <a:t>The AI Automators — The 4 Levels of Loop Engineering (2026-07)</a:t>
+              <a:t>Shawn Greyling — Loop engineering: from the inner loop to the outer loop (2026-06-14)</a:t>
             </a:r>
           </a:p>
           <a:p>
             <a:pPr>
               <a:spcAft>
-                <a:spcPts val="700"/>
+                <a:spcPts val="500"/>
               </a:spcAft>
             </a:pPr>
             <a:r>
@@ -9976,9 +10090,9 @@
                 <a:solidFill>
                   <a:srgbClr val="31D3B1"/>
                 </a:solidFill>
-                <a:hlinkClick r:id="rId11"/>
-              </a:rPr>
-              <a:t>https://www.theaiautomators.com/levels-of-loop-engineering/</a:t>
+                <a:hlinkClick r:id="rId12"/>
+              </a:rPr>
+              <a:t>https://www.shawngreyling.com/blog/loop-engineering</a:t>
             </a:r>
           </a:p>
           <a:p>
@@ -9993,13 +10107,13 @@
                   <a:srgbClr val="F5F8FD"/>
                 </a:solidFill>
               </a:rPr>
-              <a:t>Kiro CLI — headless / non-interactive 실행</a:t>
+              <a:t>Philipp Schmid — Agents: Inner Loop vs Outer Loop (2026-02-20)</a:t>
             </a:r>
           </a:p>
           <a:p>
             <a:pPr>
               <a:spcAft>
-                <a:spcPts val="700"/>
+                <a:spcPts val="500"/>
               </a:spcAft>
             </a:pPr>
             <a:r>
@@ -10007,9 +10121,9 @@
                 <a:solidFill>
                   <a:srgbClr val="31D3B1"/>
                 </a:solidFill>
-                <a:hlinkClick r:id="rId8"/>
-              </a:rPr>
-              <a:t>https://kiro.dev/docs/cli/headless/</a:t>
+                <a:hlinkClick r:id="rId10"/>
+              </a:rPr>
+              <a:t>https://www.philschmid.de/inner-loop-vs-outer-loop</a:t>
             </a:r>
           </a:p>
           <a:p>
@@ -10024,13 +10138,75 @@
                   <a:srgbClr val="F5F8FD"/>
                 </a:solidFill>
               </a:rPr>
-              <a:t>데모 저장소 — Java + Kiro CLI Outer Loop</a:t>
+              <a:t>The AI Automators — The 4 Levels of Loop Engineering (2026-07)</a:t>
             </a:r>
           </a:p>
           <a:p>
             <a:pPr>
               <a:spcAft>
-                <a:spcPts val="700"/>
+                <a:spcPts val="500"/>
+              </a:spcAft>
+            </a:pPr>
+            <a:r>
+              <a:rPr sz="1000" b="0">
+                <a:solidFill>
+                  <a:srgbClr val="31D3B1"/>
+                </a:solidFill>
+                <a:hlinkClick r:id="rId11"/>
+              </a:rPr>
+              <a:t>https://www.theaiautomators.com/levels-of-loop-engineering/</a:t>
+            </a:r>
+          </a:p>
+          <a:p>
+            <a:pPr>
+              <a:spcAft>
+                <a:spcPts val="0"/>
+              </a:spcAft>
+            </a:pPr>
+            <a:r>
+              <a:rPr sz="1300" b="1">
+                <a:solidFill>
+                  <a:srgbClr val="F5F8FD"/>
+                </a:solidFill>
+              </a:rPr>
+              <a:t>Kiro CLI — headless / non-interactive 실행</a:t>
+            </a:r>
+          </a:p>
+          <a:p>
+            <a:pPr>
+              <a:spcAft>
+                <a:spcPts val="500"/>
+              </a:spcAft>
+            </a:pPr>
+            <a:r>
+              <a:rPr sz="1000" b="0">
+                <a:solidFill>
+                  <a:srgbClr val="31D3B1"/>
+                </a:solidFill>
+                <a:hlinkClick r:id="rId8"/>
+              </a:rPr>
+              <a:t>https://kiro.dev/docs/cli/headless/</a:t>
+            </a:r>
+          </a:p>
+          <a:p>
+            <a:pPr>
+              <a:spcAft>
+                <a:spcPts val="0"/>
+              </a:spcAft>
+            </a:pPr>
+            <a:r>
+              <a:rPr sz="1300" b="1">
+                <a:solidFill>
+                  <a:srgbClr val="F5F8FD"/>
+                </a:solidFill>
+              </a:rPr>
+              <a:t>데모 저장소 — Java + Kiro CLI Outer Loop</a:t>
+            </a:r>
+          </a:p>
+          <a:p>
+            <a:pPr>
+              <a:spcAft>
+                <a:spcPts val="500"/>
               </a:spcAft>
             </a:pPr>
             <a:r>
@@ -14272,7 +14448,7 @@
                   <a:srgbClr val="CFDEEB"/>
                 </a:solidFill>
               </a:rPr>
-              <a:t>“The inner loop: the agent thinks. The outer loop: you design the machine that runs it.” — Shawn Greyling</a:t>
+              <a:t>“Agents run the inner loop. Engineers own the outer loop.” — Addy Osmani, AI Engineer World's Fair 2026 키노트</a:t>
             </a:r>
           </a:p>
         </p:txBody>
@@ -14338,7 +14514,7 @@
                   <a:srgbClr val="8397AB"/>
                 </a:solidFill>
               </a:rPr>
-              <a:t>용어 출처: Shawn Greyling “Loop engineering: from the inner loop to the outer loop” (2026-06-14) · Philipp Schmid “Agents: Inner Loop vs Outer Loop” (2026-02-20) — 정의는 출처마다 조금씩 다름</a:t>
+              <a:t>용어 출처: Addy Osmani “Own the Outer Loop” (AIEWF 2026 키노트) · 보조: Shawn Greyling (2026-06-14), Philipp Schmid (2026-02-20) — Outer Loop의 의미는 출처마다 조금씩 다름</a:t>
             </a:r>
           </a:p>
         </p:txBody>

</xml_diff>

<commit_message>
Slide 9: redraw as slide-5 control loop with demo components, add script
</commit_message>
<xml_diff>
--- a/docs/AI_Agent_Loop.pptx
+++ b/docs/AI_Agent_Loop.pptx
@@ -920,7 +920,67 @@
           <a:lstStyle/>
           <a:p>
             <a:r>
-              <a:t>5장의 제어 루프 그림에 데모를 그대로 대응시킨 표. 목표값은 테스트 7개 PASS, 센서는 verify.py, 컨트롤러는 loop.py, 실행기가 Kiro CLI. 즉 AI는 실행기 한 칸일 뿐이고, 판정은 AI가 아닌 센서와 컨트롤러가 한다. 정확히 말하면 이것은 swyx 계단의 Goal Loop 하나를 외부 Controller로 구현한 사례이지, Software Factory 전체가 아니다. 주의: 이 대응표는 발표자의 해석이다. Mistele 발표가 이 데모를 다룬 것은 아니다.</a:t>
+              <a:t>[발표 스크립트 · 약 1분 30초]</a:t>
+            </a:r>
+          </a:p>
+          <a:p/>
+          <a:p>
+            <a:r>
+              <a:t>5장에서 본 제어 루프 그림 기억하시죠? 오늘 데모를 그 그림에 그대로 넣어 보겠습니다.</a:t>
+            </a:r>
+          </a:p>
+          <a:p/>
+          <a:p>
+            <a:r>
+              <a:t>(왼쪽부터) 목표값은 테스트 7개가 모두 PASS하는 것입니다.</a:t>
+            </a:r>
+          </a:p>
+          <a:p>
+            <a:r>
+              <a:t>센서는 verify.py입니다. Java를 컴파일하고 테스트를 돌려서 지금 상태를 잽니다.</a:t>
+            </a:r>
+          </a:p>
+          <a:p>
+            <a:r>
+              <a:t>비교해서 FAIL이면, 컨트롤러인 loop.py가 다음 행동을 정합니다. loop.py는 AI가 아니라 그냥 if문입니다. 실패 로그를 들고 새 Kiro 세션을 시작합니다.</a:t>
+            </a:r>
+          </a:p>
+          <a:p>
+            <a:r>
+              <a:t>실행기는 Kiro CLI입니다. 실제로 코드를 고치는 손이죠. 고친 대상, 즉 시스템은 DiscountCalculator.java입니다.</a:t>
+            </a:r>
+          </a:p>
+          <a:p>
+            <a:r>
+              <a:t>그리고 다시 verify.py가 잽니다. 이게 한 바퀴입니다.</a:t>
+            </a:r>
+          </a:p>
+          <a:p/>
+          <a:p>
+            <a:r>
+              <a:t>(노란 화살표) 위에 있는 '외부 변화'는, 루프가 고치는 동안 다른 변경이 끼어드는 상황입니다. 데모의 --inject-fault 모드가 바로 이걸 일부러 만든 겁니다. Kiro가 고친 뒤에 Controller가 일부러 코드를 망가뜨리면, 센서가 다시 FAIL을 잡고 루프가 한 바퀴 더 돕니다.</a:t>
+            </a:r>
+          </a:p>
+          <a:p/>
+          <a:p>
+            <a:r>
+              <a:t>(하단) 여기서 핵심은 AI가 실행기 한 칸뿐이라는 겁니다. 판정은 AI가 아닌 센서와 컨트롤러가 합니다. 그리고 최대 5회, 세션 300초, 보호 파일 검사 같은 안전장치가 루프가 폭주하지 않게 막습니다.</a:t>
+            </a:r>
+          </a:p>
+          <a:p/>
+          <a:p>
+            <a:r>
+              <a:t>[예상 질문]</a:t>
+            </a:r>
+          </a:p>
+          <a:p>
+            <a:r>
+              <a:t>Q. 컨트롤러도 AI로 만들면 안 되나요?</a:t>
+            </a:r>
+          </a:p>
+          <a:p>
+            <a:r>
+              <a:t>A. 할 수 있습니다(예: 별도 모델이 완료 여부를 평가하는 방식). 다만 오늘은 판정을 가장 믿을 수 있게 하려고 결정적인 코드(테스트 종료 코드)로만 판단했습니다.</a:t>
             </a:r>
           </a:p>
         </p:txBody>
@@ -16545,14 +16605,14 @@
       </p:sp>
       <p:sp>
         <p:nvSpPr>
-          <p:cNvPr id="5" name="TextBox 4"/>
+          <p:cNvPr id="8" name="TextBox 7"/>
           <p:cNvSpPr txBox="1"/>
           <p:nvPr/>
         </p:nvSpPr>
         <p:spPr>
           <a:xfrm>
-            <a:off x="868680" y="1371600"/>
-            <a:ext cx="10515600" cy="365760"/>
+            <a:off x="868680" y="329184"/>
+            <a:ext cx="10515600" cy="274320"/>
           </a:xfrm>
           <a:prstGeom prst="rect">
             <a:avLst/>
@@ -16566,501 +16626,1027 @@
           <a:lstStyle/>
           <a:p>
             <a:r>
+              <a:rPr sz="1100" b="1">
+                <a:solidFill>
+                  <a:srgbClr val="31D3B1"/>
+                </a:solidFill>
+              </a:rPr>
+              <a:t>PART 3 · 데모: Kiro로 Goal Loop 만들기</a:t>
+            </a:r>
+          </a:p>
+        </p:txBody>
+      </p:sp>
+      <p:sp>
+        <p:nvSpPr>
+          <p:cNvPr id="6" name="Rounded Rectangle 5"/>
+          <p:cNvSpPr/>
+          <p:nvPr/>
+        </p:nvSpPr>
+        <p:spPr>
+          <a:xfrm>
+            <a:off x="868680" y="2331720"/>
+            <a:ext cx="1463040" cy="960120"/>
+          </a:xfrm>
+          <a:prstGeom prst="roundRect">
+            <a:avLst>
+              <a:gd name="adj" fmla="val 8000"/>
+            </a:avLst>
+          </a:prstGeom>
+          <a:solidFill>
+            <a:srgbClr val="162236"/>
+          </a:solidFill>
+          <a:ln w="15875">
+            <a:solidFill>
+              <a:srgbClr val="2A3B52"/>
+            </a:solidFill>
+          </a:ln>
+        </p:spPr>
+        <p:style>
+          <a:lnRef idx="1">
+            <a:schemeClr val="accent1"/>
+          </a:lnRef>
+          <a:fillRef idx="3">
+            <a:schemeClr val="accent1"/>
+          </a:fillRef>
+          <a:effectRef idx="2">
+            <a:schemeClr val="accent1"/>
+          </a:effectRef>
+          <a:fontRef idx="minor">
+            <a:schemeClr val="lt1"/>
+          </a:fontRef>
+        </p:style>
+        <p:txBody>
+          <a:bodyPr rtlCol="0" anchor="ctr" lIns="109728" rIns="109728" wrap="square"/>
+          <a:lstStyle/>
+          <a:p>
+            <a:pPr algn="ctr"/>
+            <a:r>
+              <a:rPr sz="1100" b="0">
+                <a:solidFill>
+                  <a:srgbClr val="8397AB"/>
+                </a:solidFill>
+              </a:rPr>
+              <a:t>목표값</a:t>
+            </a:r>
+          </a:p>
+          <a:p>
+            <a:pPr algn="ctr"/>
+            <a:r>
+              <a:rPr sz="1600" b="1">
+                <a:solidFill>
+                  <a:srgbClr val="F5F8FD"/>
+                </a:solidFill>
+              </a:rPr>
+              <a:t>테스트 7개</a:t>
+            </a:r>
+          </a:p>
+          <a:p>
+            <a:pPr algn="ctr"/>
+            <a:r>
+              <a:rPr sz="1200" b="0">
+                <a:solidFill>
+                  <a:srgbClr val="CFDEEB"/>
+                </a:solidFill>
+              </a:rPr>
+              <a:t>모두 PASS</a:t>
+            </a:r>
+          </a:p>
+        </p:txBody>
+      </p:sp>
+      <p:sp>
+        <p:nvSpPr>
+          <p:cNvPr id="7" name="Oval 6"/>
+          <p:cNvSpPr/>
+          <p:nvPr/>
+        </p:nvSpPr>
+        <p:spPr>
+          <a:xfrm>
+            <a:off x="3074670" y="2468879"/>
+            <a:ext cx="685800" cy="685800"/>
+          </a:xfrm>
+          <a:prstGeom prst="ellipse">
+            <a:avLst/>
+          </a:prstGeom>
+          <a:solidFill>
+            <a:srgbClr val="162236"/>
+          </a:solidFill>
+          <a:ln w="15875">
+            <a:solidFill>
+              <a:srgbClr val="2A3B52"/>
+            </a:solidFill>
+          </a:ln>
+        </p:spPr>
+        <p:style>
+          <a:lnRef idx="1">
+            <a:schemeClr val="accent1"/>
+          </a:lnRef>
+          <a:fillRef idx="3">
+            <a:schemeClr val="accent1"/>
+          </a:fillRef>
+          <a:effectRef idx="2">
+            <a:schemeClr val="accent1"/>
+          </a:effectRef>
+          <a:fontRef idx="minor">
+            <a:schemeClr val="lt1"/>
+          </a:fontRef>
+        </p:style>
+        <p:txBody>
+          <a:bodyPr rtlCol="0" anchor="ctr" lIns="18288" rIns="18288" wrap="square"/>
+          <a:lstStyle/>
+          <a:p>
+            <a:pPr algn="ctr"/>
+            <a:r>
+              <a:rPr sz="1200" b="1">
+                <a:solidFill>
+                  <a:srgbClr val="F5F8FD"/>
+                </a:solidFill>
+              </a:rPr>
+              <a:t>PASS?</a:t>
+            </a:r>
+          </a:p>
+        </p:txBody>
+      </p:sp>
+      <p:sp>
+        <p:nvSpPr>
+          <p:cNvPr id="8" name="Rounded Rectangle 7"/>
+          <p:cNvSpPr/>
+          <p:nvPr/>
+        </p:nvSpPr>
+        <p:spPr>
+          <a:xfrm>
+            <a:off x="4503420" y="2331720"/>
+            <a:ext cx="1737360" cy="960120"/>
+          </a:xfrm>
+          <a:prstGeom prst="roundRect">
+            <a:avLst>
+              <a:gd name="adj" fmla="val 8000"/>
+            </a:avLst>
+          </a:prstGeom>
+          <a:solidFill>
+            <a:srgbClr val="162236"/>
+          </a:solidFill>
+          <a:ln w="25400">
+            <a:solidFill>
+              <a:srgbClr val="31D3B1"/>
+            </a:solidFill>
+          </a:ln>
+        </p:spPr>
+        <p:style>
+          <a:lnRef idx="1">
+            <a:schemeClr val="accent1"/>
+          </a:lnRef>
+          <a:fillRef idx="3">
+            <a:schemeClr val="accent1"/>
+          </a:fillRef>
+          <a:effectRef idx="2">
+            <a:schemeClr val="accent1"/>
+          </a:effectRef>
+          <a:fontRef idx="minor">
+            <a:schemeClr val="lt1"/>
+          </a:fontRef>
+        </p:style>
+        <p:txBody>
+          <a:bodyPr rtlCol="0" anchor="ctr" lIns="109728" rIns="109728" wrap="square"/>
+          <a:lstStyle/>
+          <a:p>
+            <a:pPr algn="ctr"/>
+            <a:r>
+              <a:rPr sz="1100" b="0">
+                <a:solidFill>
+                  <a:srgbClr val="8397AB"/>
+                </a:solidFill>
+              </a:rPr>
+              <a:t>컨트롤러</a:t>
+            </a:r>
+          </a:p>
+          <a:p>
+            <a:pPr algn="ctr"/>
+            <a:r>
+              <a:rPr sz="1700" b="1">
+                <a:solidFill>
+                  <a:srgbClr val="31D3B1"/>
+                </a:solidFill>
+              </a:rPr>
+              <a:t>loop.py</a:t>
+            </a:r>
+          </a:p>
+          <a:p>
+            <a:pPr algn="ctr"/>
+            <a:r>
+              <a:rPr sz="1200" b="0">
+                <a:solidFill>
+                  <a:srgbClr val="CFDEEB"/>
+                </a:solidFill>
+              </a:rPr>
+              <a:t>if문 · AI 아님</a:t>
+            </a:r>
+          </a:p>
+        </p:txBody>
+      </p:sp>
+      <p:sp>
+        <p:nvSpPr>
+          <p:cNvPr id="9" name="Rounded Rectangle 8"/>
+          <p:cNvSpPr/>
+          <p:nvPr/>
+        </p:nvSpPr>
+        <p:spPr>
+          <a:xfrm>
+            <a:off x="6983729" y="2331720"/>
+            <a:ext cx="1737360" cy="960120"/>
+          </a:xfrm>
+          <a:prstGeom prst="roundRect">
+            <a:avLst>
+              <a:gd name="adj" fmla="val 8000"/>
+            </a:avLst>
+          </a:prstGeom>
+          <a:solidFill>
+            <a:srgbClr val="162236"/>
+          </a:solidFill>
+          <a:ln w="25400">
+            <a:solidFill>
+              <a:srgbClr val="7C5CFF"/>
+            </a:solidFill>
+          </a:ln>
+        </p:spPr>
+        <p:style>
+          <a:lnRef idx="1">
+            <a:schemeClr val="accent1"/>
+          </a:lnRef>
+          <a:fillRef idx="3">
+            <a:schemeClr val="accent1"/>
+          </a:fillRef>
+          <a:effectRef idx="2">
+            <a:schemeClr val="accent1"/>
+          </a:effectRef>
+          <a:fontRef idx="minor">
+            <a:schemeClr val="lt1"/>
+          </a:fontRef>
+        </p:style>
+        <p:txBody>
+          <a:bodyPr rtlCol="0" anchor="ctr" lIns="109728" rIns="109728" wrap="square"/>
+          <a:lstStyle/>
+          <a:p>
+            <a:pPr algn="ctr"/>
+            <a:r>
+              <a:rPr sz="1100" b="0">
+                <a:solidFill>
+                  <a:srgbClr val="8397AB"/>
+                </a:solidFill>
+              </a:rPr>
+              <a:t>실행기</a:t>
+            </a:r>
+          </a:p>
+          <a:p>
+            <a:pPr algn="ctr"/>
+            <a:r>
+              <a:rPr sz="1700" b="1">
+                <a:solidFill>
+                  <a:srgbClr val="7C5CFF"/>
+                </a:solidFill>
+              </a:rPr>
+              <a:t>Kiro CLI</a:t>
+            </a:r>
+          </a:p>
+          <a:p>
+            <a:pPr algn="ctr"/>
+            <a:r>
+              <a:rPr sz="1200" b="0">
+                <a:solidFill>
+                  <a:srgbClr val="CFDEEB"/>
+                </a:solidFill>
+              </a:rPr>
+              <a:t>코드 수정 (새 세션)</a:t>
+            </a:r>
+          </a:p>
+        </p:txBody>
+      </p:sp>
+      <p:sp>
+        <p:nvSpPr>
+          <p:cNvPr id="10" name="Rounded Rectangle 9"/>
+          <p:cNvSpPr/>
+          <p:nvPr/>
+        </p:nvSpPr>
+        <p:spPr>
+          <a:xfrm>
+            <a:off x="9464040" y="2331720"/>
+            <a:ext cx="1920240" cy="960120"/>
+          </a:xfrm>
+          <a:prstGeom prst="roundRect">
+            <a:avLst>
+              <a:gd name="adj" fmla="val 8000"/>
+            </a:avLst>
+          </a:prstGeom>
+          <a:solidFill>
+            <a:srgbClr val="162236"/>
+          </a:solidFill>
+          <a:ln w="15875">
+            <a:solidFill>
+              <a:srgbClr val="2A3B52"/>
+            </a:solidFill>
+          </a:ln>
+        </p:spPr>
+        <p:style>
+          <a:lnRef idx="1">
+            <a:schemeClr val="accent1"/>
+          </a:lnRef>
+          <a:fillRef idx="3">
+            <a:schemeClr val="accent1"/>
+          </a:fillRef>
+          <a:effectRef idx="2">
+            <a:schemeClr val="accent1"/>
+          </a:effectRef>
+          <a:fontRef idx="minor">
+            <a:schemeClr val="lt1"/>
+          </a:fontRef>
+        </p:style>
+        <p:txBody>
+          <a:bodyPr rtlCol="0" anchor="ctr" lIns="109728" rIns="109728" wrap="square"/>
+          <a:lstStyle/>
+          <a:p>
+            <a:pPr algn="ctr"/>
+            <a:r>
+              <a:rPr sz="1100" b="0">
+                <a:solidFill>
+                  <a:srgbClr val="8397AB"/>
+                </a:solidFill>
+              </a:rPr>
+              <a:t>시스템</a:t>
+            </a:r>
+          </a:p>
+          <a:p>
+            <a:pPr algn="ctr"/>
+            <a:r>
+              <a:rPr sz="1600" b="1">
+                <a:solidFill>
+                  <a:srgbClr val="F5F8FD"/>
+                </a:solidFill>
+              </a:rPr>
+              <a:t>Java 코드</a:t>
+            </a:r>
+          </a:p>
+          <a:p>
+            <a:pPr algn="ctr"/>
+            <a:r>
+              <a:rPr sz="1000" b="0">
+                <a:solidFill>
+                  <a:srgbClr val="CFDEEB"/>
+                </a:solidFill>
+              </a:rPr>
+              <a:t>DiscountCalculator.java</a:t>
+            </a:r>
+          </a:p>
+        </p:txBody>
+      </p:sp>
+      <p:cxnSp>
+        <p:nvCxnSpPr>
+          <p:cNvPr id="11" name="Connector 10"/>
+          <p:cNvCxnSpPr/>
+          <p:nvPr/>
+        </p:nvCxnSpPr>
+        <p:spPr>
+          <a:xfrm flipV="1">
+            <a:off x="2331720" y="2811779"/>
+            <a:ext cx="742950" cy="0"/>
+          </a:xfrm>
+          <a:prstGeom prst="line">
+            <a:avLst/>
+          </a:prstGeom>
+          <a:ln w="25400">
+            <a:solidFill>
+              <a:srgbClr val="CFDEEB"/>
+            </a:solidFill>
+            <a:tailEnd type="triangle" w="med" len="med"/>
+          </a:ln>
+        </p:spPr>
+        <p:style>
+          <a:lnRef idx="2">
+            <a:schemeClr val="accent1"/>
+          </a:lnRef>
+          <a:fillRef idx="0">
+            <a:schemeClr val="accent1"/>
+          </a:fillRef>
+          <a:effectRef idx="1">
+            <a:schemeClr val="accent1"/>
+          </a:effectRef>
+          <a:fontRef idx="minor">
+            <a:schemeClr val="tx1"/>
+          </a:fontRef>
+        </p:style>
+      </p:cxnSp>
+      <p:cxnSp>
+        <p:nvCxnSpPr>
+          <p:cNvPr id="12" name="Connector 11"/>
+          <p:cNvCxnSpPr/>
+          <p:nvPr/>
+        </p:nvCxnSpPr>
+        <p:spPr>
+          <a:xfrm flipV="1">
+            <a:off x="3760470" y="2811779"/>
+            <a:ext cx="742950" cy="0"/>
+          </a:xfrm>
+          <a:prstGeom prst="line">
+            <a:avLst/>
+          </a:prstGeom>
+          <a:ln w="25400">
+            <a:solidFill>
+              <a:srgbClr val="CFDEEB"/>
+            </a:solidFill>
+            <a:tailEnd type="triangle" w="med" len="med"/>
+          </a:ln>
+        </p:spPr>
+        <p:style>
+          <a:lnRef idx="2">
+            <a:schemeClr val="accent1"/>
+          </a:lnRef>
+          <a:fillRef idx="0">
+            <a:schemeClr val="accent1"/>
+          </a:fillRef>
+          <a:effectRef idx="1">
+            <a:schemeClr val="accent1"/>
+          </a:effectRef>
+          <a:fontRef idx="minor">
+            <a:schemeClr val="tx1"/>
+          </a:fontRef>
+        </p:style>
+      </p:cxnSp>
+      <p:sp>
+        <p:nvSpPr>
+          <p:cNvPr id="13" name="TextBox 12"/>
+          <p:cNvSpPr txBox="1"/>
+          <p:nvPr/>
+        </p:nvSpPr>
+        <p:spPr>
+          <a:xfrm>
+            <a:off x="3669030" y="2427732"/>
+            <a:ext cx="925830" cy="274320"/>
+          </a:xfrm>
+          <a:prstGeom prst="rect">
+            <a:avLst/>
+          </a:prstGeom>
+          <a:noFill/>
+        </p:spPr>
+        <p:txBody>
+          <a:bodyPr wrap="square">
+            <a:spAutoFit/>
+          </a:bodyPr>
+          <a:lstStyle/>
+          <a:p>
+            <a:pPr algn="ctr"/>
+            <a:r>
+              <a:rPr sz="1100" b="0">
+                <a:solidFill>
+                  <a:srgbClr val="8397AB"/>
+                </a:solidFill>
+              </a:rPr>
+              <a:t>FAIL</a:t>
+            </a:r>
+          </a:p>
+        </p:txBody>
+      </p:sp>
+      <p:cxnSp>
+        <p:nvCxnSpPr>
+          <p:cNvPr id="14" name="Connector 13"/>
+          <p:cNvCxnSpPr/>
+          <p:nvPr/>
+        </p:nvCxnSpPr>
+        <p:spPr>
+          <a:xfrm flipV="1">
+            <a:off x="6240779" y="2811779"/>
+            <a:ext cx="742950" cy="0"/>
+          </a:xfrm>
+          <a:prstGeom prst="line">
+            <a:avLst/>
+          </a:prstGeom>
+          <a:ln w="25400">
+            <a:solidFill>
+              <a:srgbClr val="CFDEEB"/>
+            </a:solidFill>
+            <a:tailEnd type="triangle" w="med" len="med"/>
+          </a:ln>
+        </p:spPr>
+        <p:style>
+          <a:lnRef idx="2">
+            <a:schemeClr val="accent1"/>
+          </a:lnRef>
+          <a:fillRef idx="0">
+            <a:schemeClr val="accent1"/>
+          </a:fillRef>
+          <a:effectRef idx="1">
+            <a:schemeClr val="accent1"/>
+          </a:effectRef>
+          <a:fontRef idx="minor">
+            <a:schemeClr val="tx1"/>
+          </a:fontRef>
+        </p:style>
+      </p:cxnSp>
+      <p:sp>
+        <p:nvSpPr>
+          <p:cNvPr id="15" name="TextBox 14"/>
+          <p:cNvSpPr txBox="1"/>
+          <p:nvPr/>
+        </p:nvSpPr>
+        <p:spPr>
+          <a:xfrm>
+            <a:off x="6149340" y="2427732"/>
+            <a:ext cx="925830" cy="274320"/>
+          </a:xfrm>
+          <a:prstGeom prst="rect">
+            <a:avLst/>
+          </a:prstGeom>
+          <a:noFill/>
+        </p:spPr>
+        <p:txBody>
+          <a:bodyPr wrap="square">
+            <a:spAutoFit/>
+          </a:bodyPr>
+          <a:lstStyle/>
+          <a:p>
+            <a:pPr algn="ctr"/>
+            <a:r>
+              <a:rPr sz="1100" b="0">
+                <a:solidFill>
+                  <a:srgbClr val="8397AB"/>
+                </a:solidFill>
+              </a:rPr>
+              <a:t>지시</a:t>
+            </a:r>
+          </a:p>
+        </p:txBody>
+      </p:sp>
+      <p:cxnSp>
+        <p:nvCxnSpPr>
+          <p:cNvPr id="16" name="Connector 15"/>
+          <p:cNvCxnSpPr/>
+          <p:nvPr/>
+        </p:nvCxnSpPr>
+        <p:spPr>
+          <a:xfrm flipV="1">
+            <a:off x="8721090" y="2811779"/>
+            <a:ext cx="742950" cy="0"/>
+          </a:xfrm>
+          <a:prstGeom prst="line">
+            <a:avLst/>
+          </a:prstGeom>
+          <a:ln w="25400">
+            <a:solidFill>
+              <a:srgbClr val="CFDEEB"/>
+            </a:solidFill>
+            <a:tailEnd type="triangle" w="med" len="med"/>
+          </a:ln>
+        </p:spPr>
+        <p:style>
+          <a:lnRef idx="2">
+            <a:schemeClr val="accent1"/>
+          </a:lnRef>
+          <a:fillRef idx="0">
+            <a:schemeClr val="accent1"/>
+          </a:fillRef>
+          <a:effectRef idx="1">
+            <a:schemeClr val="accent1"/>
+          </a:effectRef>
+          <a:fontRef idx="minor">
+            <a:schemeClr val="tx1"/>
+          </a:fontRef>
+        </p:style>
+      </p:cxnSp>
+      <p:sp>
+        <p:nvSpPr>
+          <p:cNvPr id="17" name="TextBox 16"/>
+          <p:cNvSpPr txBox="1"/>
+          <p:nvPr/>
+        </p:nvSpPr>
+        <p:spPr>
+          <a:xfrm>
+            <a:off x="8629650" y="2427732"/>
+            <a:ext cx="925830" cy="274320"/>
+          </a:xfrm>
+          <a:prstGeom prst="rect">
+            <a:avLst/>
+          </a:prstGeom>
+          <a:noFill/>
+        </p:spPr>
+        <p:txBody>
+          <a:bodyPr wrap="square">
+            <a:spAutoFit/>
+          </a:bodyPr>
+          <a:lstStyle/>
+          <a:p>
+            <a:pPr algn="ctr"/>
+            <a:r>
+              <a:rPr sz="1100" b="0">
+                <a:solidFill>
+                  <a:srgbClr val="8397AB"/>
+                </a:solidFill>
+              </a:rPr>
+              <a:t>수정</a:t>
+            </a:r>
+          </a:p>
+        </p:txBody>
+      </p:sp>
+      <p:sp>
+        <p:nvSpPr>
+          <p:cNvPr id="18" name="Rounded Rectangle 17"/>
+          <p:cNvSpPr/>
+          <p:nvPr/>
+        </p:nvSpPr>
+        <p:spPr>
+          <a:xfrm>
+            <a:off x="5120640" y="3520440"/>
+            <a:ext cx="2651760" cy="731520"/>
+          </a:xfrm>
+          <a:prstGeom prst="roundRect">
+            <a:avLst>
+              <a:gd name="adj" fmla="val 8000"/>
+            </a:avLst>
+          </a:prstGeom>
+          <a:solidFill>
+            <a:srgbClr val="162236"/>
+          </a:solidFill>
+          <a:ln w="15875">
+            <a:solidFill>
+              <a:srgbClr val="2A3B52"/>
+            </a:solidFill>
+          </a:ln>
+        </p:spPr>
+        <p:style>
+          <a:lnRef idx="1">
+            <a:schemeClr val="accent1"/>
+          </a:lnRef>
+          <a:fillRef idx="3">
+            <a:schemeClr val="accent1"/>
+          </a:fillRef>
+          <a:effectRef idx="2">
+            <a:schemeClr val="accent1"/>
+          </a:effectRef>
+          <a:fontRef idx="minor">
+            <a:schemeClr val="lt1"/>
+          </a:fontRef>
+        </p:style>
+        <p:txBody>
+          <a:bodyPr rtlCol="0" anchor="ctr" lIns="109728" rIns="109728" wrap="square"/>
+          <a:lstStyle/>
+          <a:p>
+            <a:pPr algn="ctr"/>
+            <a:r>
+              <a:rPr sz="1500" b="1">
+                <a:solidFill>
+                  <a:srgbClr val="F5F8FD"/>
+                </a:solidFill>
+              </a:rPr>
+              <a:t>센서  verify.py</a:t>
+            </a:r>
+          </a:p>
+          <a:p>
+            <a:pPr algn="ctr"/>
+            <a:r>
+              <a:rPr sz="1200" b="0">
+                <a:solidFill>
+                  <a:srgbClr val="8397AB"/>
+                </a:solidFill>
+              </a:rPr>
+              <a:t>Java 컴파일 + 테스트 실행</a:t>
+            </a:r>
+          </a:p>
+        </p:txBody>
+      </p:sp>
+      <p:cxnSp>
+        <p:nvCxnSpPr>
+          <p:cNvPr id="19" name="Connector 18"/>
+          <p:cNvCxnSpPr/>
+          <p:nvPr/>
+        </p:nvCxnSpPr>
+        <p:spPr>
+          <a:xfrm>
+            <a:off x="10424160" y="3291839"/>
+            <a:ext cx="0" cy="594361"/>
+          </a:xfrm>
+          <a:prstGeom prst="line">
+            <a:avLst/>
+          </a:prstGeom>
+          <a:ln w="25400">
+            <a:solidFill>
+              <a:srgbClr val="CFDEEB"/>
+            </a:solidFill>
+          </a:ln>
+        </p:spPr>
+        <p:style>
+          <a:lnRef idx="2">
+            <a:schemeClr val="accent1"/>
+          </a:lnRef>
+          <a:fillRef idx="0">
+            <a:schemeClr val="accent1"/>
+          </a:fillRef>
+          <a:effectRef idx="1">
+            <a:schemeClr val="accent1"/>
+          </a:effectRef>
+          <a:fontRef idx="minor">
+            <a:schemeClr val="tx1"/>
+          </a:fontRef>
+        </p:style>
+      </p:cxnSp>
+      <p:cxnSp>
+        <p:nvCxnSpPr>
+          <p:cNvPr id="20" name="Connector 19"/>
+          <p:cNvCxnSpPr/>
+          <p:nvPr/>
+        </p:nvCxnSpPr>
+        <p:spPr>
+          <a:xfrm flipH="1" flipV="1">
+            <a:off x="7772400" y="3886200"/>
+            <a:ext cx="2651760" cy="0"/>
+          </a:xfrm>
+          <a:prstGeom prst="line">
+            <a:avLst/>
+          </a:prstGeom>
+          <a:ln w="25400">
+            <a:solidFill>
+              <a:srgbClr val="CFDEEB"/>
+            </a:solidFill>
+            <a:tailEnd type="triangle" w="med" len="med"/>
+          </a:ln>
+        </p:spPr>
+        <p:style>
+          <a:lnRef idx="2">
+            <a:schemeClr val="accent1"/>
+          </a:lnRef>
+          <a:fillRef idx="0">
+            <a:schemeClr val="accent1"/>
+          </a:fillRef>
+          <a:effectRef idx="1">
+            <a:schemeClr val="accent1"/>
+          </a:effectRef>
+          <a:fontRef idx="minor">
+            <a:schemeClr val="tx1"/>
+          </a:fontRef>
+        </p:style>
+      </p:cxnSp>
+      <p:cxnSp>
+        <p:nvCxnSpPr>
+          <p:cNvPr id="21" name="Connector 20"/>
+          <p:cNvCxnSpPr/>
+          <p:nvPr/>
+        </p:nvCxnSpPr>
+        <p:spPr>
+          <a:xfrm flipH="1" flipV="1">
+            <a:off x="3417570" y="3886200"/>
+            <a:ext cx="1703070" cy="0"/>
+          </a:xfrm>
+          <a:prstGeom prst="line">
+            <a:avLst/>
+          </a:prstGeom>
+          <a:ln w="25400">
+            <a:solidFill>
+              <a:srgbClr val="CFDEEB"/>
+            </a:solidFill>
+          </a:ln>
+        </p:spPr>
+        <p:style>
+          <a:lnRef idx="2">
+            <a:schemeClr val="accent1"/>
+          </a:lnRef>
+          <a:fillRef idx="0">
+            <a:schemeClr val="accent1"/>
+          </a:fillRef>
+          <a:effectRef idx="1">
+            <a:schemeClr val="accent1"/>
+          </a:effectRef>
+          <a:fontRef idx="minor">
+            <a:schemeClr val="tx1"/>
+          </a:fontRef>
+        </p:style>
+      </p:cxnSp>
+      <p:cxnSp>
+        <p:nvCxnSpPr>
+          <p:cNvPr id="22" name="Connector 21"/>
+          <p:cNvCxnSpPr/>
+          <p:nvPr/>
+        </p:nvCxnSpPr>
+        <p:spPr>
+          <a:xfrm flipV="1">
+            <a:off x="3417570" y="3154679"/>
+            <a:ext cx="0" cy="731521"/>
+          </a:xfrm>
+          <a:prstGeom prst="line">
+            <a:avLst/>
+          </a:prstGeom>
+          <a:ln w="25400">
+            <a:solidFill>
+              <a:srgbClr val="CFDEEB"/>
+            </a:solidFill>
+            <a:tailEnd type="triangle" w="med" len="med"/>
+          </a:ln>
+        </p:spPr>
+        <p:style>
+          <a:lnRef idx="2">
+            <a:schemeClr val="accent1"/>
+          </a:lnRef>
+          <a:fillRef idx="0">
+            <a:schemeClr val="accent1"/>
+          </a:fillRef>
+          <a:effectRef idx="1">
+            <a:schemeClr val="accent1"/>
+          </a:effectRef>
+          <a:fontRef idx="minor">
+            <a:schemeClr val="tx1"/>
+          </a:fontRef>
+        </p:style>
+      </p:cxnSp>
+      <p:sp>
+        <p:nvSpPr>
+          <p:cNvPr id="23" name="TextBox 22"/>
+          <p:cNvSpPr txBox="1"/>
+          <p:nvPr/>
+        </p:nvSpPr>
+        <p:spPr>
+          <a:xfrm>
+            <a:off x="3509010" y="3520440"/>
+            <a:ext cx="1463040" cy="274320"/>
+          </a:xfrm>
+          <a:prstGeom prst="rect">
+            <a:avLst/>
+          </a:prstGeom>
+          <a:noFill/>
+        </p:spPr>
+        <p:txBody>
+          <a:bodyPr wrap="square">
+            <a:spAutoFit/>
+          </a:bodyPr>
+          <a:lstStyle/>
+          <a:p>
+            <a:pPr algn="l"/>
+            <a:r>
+              <a:rPr sz="1100" b="0">
+                <a:solidFill>
+                  <a:srgbClr val="8397AB"/>
+                </a:solidFill>
+              </a:rPr>
+              <a:t>테스트 결과</a:t>
+            </a:r>
+          </a:p>
+        </p:txBody>
+      </p:sp>
+      <p:sp>
+        <p:nvSpPr>
+          <p:cNvPr id="29" name="TextBox 28"/>
+          <p:cNvSpPr txBox="1"/>
+          <p:nvPr/>
+        </p:nvSpPr>
+        <p:spPr>
+          <a:xfrm>
+            <a:off x="8183880" y="1764792"/>
+            <a:ext cx="3566160" cy="274320"/>
+          </a:xfrm>
+          <a:prstGeom prst="rect">
+            <a:avLst/>
+          </a:prstGeom>
+          <a:noFill/>
+        </p:spPr>
+        <p:txBody>
+          <a:bodyPr wrap="square">
+            <a:spAutoFit/>
+          </a:bodyPr>
+          <a:lstStyle/>
+          <a:p>
+            <a:pPr algn="ctr"/>
+            <a:r>
+              <a:rPr sz="1100" b="1">
+                <a:solidFill>
+                  <a:srgbClr val="FACC15"/>
+                </a:solidFill>
+              </a:rPr>
+              <a:t>외부 변화 = --inject-fault (데모 모드)</a:t>
+            </a:r>
+          </a:p>
+        </p:txBody>
+      </p:sp>
+      <p:cxnSp>
+        <p:nvCxnSpPr>
+          <p:cNvPr id="30" name="Connector 29"/>
+          <p:cNvCxnSpPr/>
+          <p:nvPr/>
+        </p:nvCxnSpPr>
+        <p:spPr>
+          <a:xfrm>
+            <a:off x="10424160" y="2029968"/>
+            <a:ext cx="0" cy="301752"/>
+          </a:xfrm>
+          <a:prstGeom prst="line">
+            <a:avLst/>
+          </a:prstGeom>
+          <a:ln w="22225">
+            <a:solidFill>
+              <a:srgbClr val="FACC15"/>
+            </a:solidFill>
+            <a:prstDash val="dash"/>
+            <a:tailEnd type="triangle" w="med" len="med"/>
+          </a:ln>
+        </p:spPr>
+        <p:style>
+          <a:lnRef idx="2">
+            <a:schemeClr val="accent1"/>
+          </a:lnRef>
+          <a:fillRef idx="0">
+            <a:schemeClr val="accent1"/>
+          </a:fillRef>
+          <a:effectRef idx="1">
+            <a:schemeClr val="accent1"/>
+          </a:effectRef>
+          <a:fontRef idx="minor">
+            <a:schemeClr val="tx1"/>
+          </a:fontRef>
+        </p:style>
+      </p:cxnSp>
+      <p:sp>
+        <p:nvSpPr>
+          <p:cNvPr id="31" name="TextBox 30"/>
+          <p:cNvSpPr txBox="1"/>
+          <p:nvPr/>
+        </p:nvSpPr>
+        <p:spPr>
+          <a:xfrm>
+            <a:off x="868680" y="1371600"/>
+            <a:ext cx="10515600" cy="365760"/>
+          </a:xfrm>
+          <a:prstGeom prst="rect">
+            <a:avLst/>
+          </a:prstGeom>
+          <a:noFill/>
+        </p:spPr>
+        <p:txBody>
+          <a:bodyPr wrap="square">
+            <a:spAutoFit/>
+          </a:bodyPr>
+          <a:lstStyle/>
+          <a:p>
+            <a:r>
               <a:rPr sz="1500" b="0">
                 <a:solidFill>
                   <a:srgbClr val="8397AB"/>
                 </a:solidFill>
               </a:rPr>
-              <a:t>제어 루프의 각 칸에 데모 구성 요소를 대응시키면</a:t>
-            </a:r>
-          </a:p>
-        </p:txBody>
-      </p:sp>
-      <p:graphicFrame>
-        <p:nvGraphicFramePr>
-          <p:cNvPr id="6" name="Table 5"/>
-          <p:cNvGraphicFramePr>
-            <a:graphicFrameLocks noGrp="1"/>
-          </p:cNvGraphicFramePr>
-          <p:nvPr/>
-        </p:nvGraphicFramePr>
-        <p:xfrm>
-          <a:off x="868680" y="1828800"/>
-          <a:ext cx="10515600" cy="3200400"/>
-        </p:xfrm>
-        <a:graphic>
-          <a:graphicData uri="http://schemas.openxmlformats.org/drawingml/2006/table">
-            <a:tbl>
-              <a:tblPr firstRow="0" bandRow="0">
-                <a:tableStyleId>{5C22544A-7EE6-4342-B048-85BDC9FD1C3A}</a:tableStyleId>
-              </a:tblPr>
-              <a:tblGrid>
-                <a:gridCol w="2651760"/>
-                <a:gridCol w="2011680"/>
-                <a:gridCol w="5852160"/>
-              </a:tblGrid>
-              <a:tr h="457200">
-                <a:tc>
-                  <a:txBody>
-                    <a:bodyPr/>
-                    <a:lstStyle/>
-                    <a:p>
-                      <a:r>
-                        <a:rPr sz="1300" b="1">
-                          <a:solidFill>
-                            <a:srgbClr val="F5F8FD"/>
-                          </a:solidFill>
-                        </a:rPr>
-                        <a:t>제어 루프 요소</a:t>
-                      </a:r>
-                    </a:p>
-                  </a:txBody>
-                  <a:tcPr anchor="ctr" marL="137160" marR="137160" marT="0" marB="0">
-                    <a:solidFill>
-                      <a:srgbClr val="2A3B52"/>
-                    </a:solidFill>
-                  </a:tcPr>
-                </a:tc>
-                <a:tc>
-                  <a:txBody>
-                    <a:bodyPr/>
-                    <a:lstStyle/>
-                    <a:p>
-                      <a:r>
-                        <a:rPr sz="1300" b="1">
-                          <a:solidFill>
-                            <a:srgbClr val="F5F8FD"/>
-                          </a:solidFill>
-                        </a:rPr>
-                        <a:t>온도조절기</a:t>
-                      </a:r>
-                    </a:p>
-                  </a:txBody>
-                  <a:tcPr anchor="ctr" marL="137160" marR="137160" marT="0" marB="0">
-                    <a:solidFill>
-                      <a:srgbClr val="2A3B52"/>
-                    </a:solidFill>
-                  </a:tcPr>
-                </a:tc>
-                <a:tc>
-                  <a:txBody>
-                    <a:bodyPr/>
-                    <a:lstStyle/>
-                    <a:p>
-                      <a:r>
-                        <a:rPr sz="1300" b="1">
-                          <a:solidFill>
-                            <a:srgbClr val="F5F8FD"/>
-                          </a:solidFill>
-                        </a:rPr>
-                        <a:t>우리 데모 (Kiro Outer Loop)</a:t>
-                      </a:r>
-                    </a:p>
-                  </a:txBody>
-                  <a:tcPr anchor="ctr" marL="137160" marR="137160" marT="0" marB="0">
-                    <a:solidFill>
-                      <a:srgbClr val="2A3B52"/>
-                    </a:solidFill>
-                  </a:tcPr>
-                </a:tc>
-              </a:tr>
-              <a:tr h="457200">
-                <a:tc>
-                  <a:txBody>
-                    <a:bodyPr/>
-                    <a:lstStyle/>
-                    <a:p>
-                      <a:r>
-                        <a:rPr sz="1500" b="1">
-                          <a:solidFill>
-                            <a:srgbClr val="CFDEEB"/>
-                          </a:solidFill>
-                        </a:rPr>
-                        <a:t>목표값  Set point</a:t>
-                      </a:r>
-                    </a:p>
-                  </a:txBody>
-                  <a:tcPr anchor="ctr" marL="137160" marR="137160" marT="0" marB="0">
-                    <a:solidFill>
-                      <a:srgbClr val="162236"/>
-                    </a:solidFill>
-                  </a:tcPr>
-                </a:tc>
-                <a:tc>
-                  <a:txBody>
-                    <a:bodyPr/>
-                    <a:lstStyle/>
-                    <a:p>
-                      <a:r>
-                        <a:rPr sz="1500" b="0">
-                          <a:solidFill>
-                            <a:srgbClr val="8397AB"/>
-                          </a:solidFill>
-                        </a:rPr>
-                        <a:t>24°C</a:t>
-                      </a:r>
-                    </a:p>
-                  </a:txBody>
-                  <a:tcPr anchor="ctr" marL="137160" marR="137160" marT="0" marB="0">
-                    <a:solidFill>
-                      <a:srgbClr val="162236"/>
-                    </a:solidFill>
-                  </a:tcPr>
-                </a:tc>
-                <a:tc>
-                  <a:txBody>
-                    <a:bodyPr/>
-                    <a:lstStyle/>
-                    <a:p>
-                      <a:r>
-                        <a:rPr sz="1500" b="0">
-                          <a:solidFill>
-                            <a:srgbClr val="CFDEEB"/>
-                          </a:solidFill>
-                        </a:rPr>
-                        <a:t>테스트 7개 모두 PASS</a:t>
-                      </a:r>
-                    </a:p>
-                  </a:txBody>
-                  <a:tcPr anchor="ctr" marL="137160" marR="137160" marT="0" marB="0">
-                    <a:solidFill>
-                      <a:srgbClr val="162236"/>
-                    </a:solidFill>
-                  </a:tcPr>
-                </a:tc>
-              </a:tr>
-              <a:tr h="457200">
-                <a:tc>
-                  <a:txBody>
-                    <a:bodyPr/>
-                    <a:lstStyle/>
-                    <a:p>
-                      <a:r>
-                        <a:rPr sz="1500" b="1">
-                          <a:solidFill>
-                            <a:srgbClr val="CFDEEB"/>
-                          </a:solidFill>
-                        </a:rPr>
-                        <a:t>센서  Sensor</a:t>
-                      </a:r>
-                    </a:p>
-                  </a:txBody>
-                  <a:tcPr anchor="ctr" marL="137160" marR="137160" marT="0" marB="0">
-                    <a:solidFill>
-                      <a:srgbClr val="162236"/>
-                    </a:solidFill>
-                  </a:tcPr>
-                </a:tc>
-                <a:tc>
-                  <a:txBody>
-                    <a:bodyPr/>
-                    <a:lstStyle/>
-                    <a:p>
-                      <a:r>
-                        <a:rPr sz="1500" b="0">
-                          <a:solidFill>
-                            <a:srgbClr val="8397AB"/>
-                          </a:solidFill>
-                        </a:rPr>
-                        <a:t>온도계</a:t>
-                      </a:r>
-                    </a:p>
-                  </a:txBody>
-                  <a:tcPr anchor="ctr" marL="137160" marR="137160" marT="0" marB="0">
-                    <a:solidFill>
-                      <a:srgbClr val="162236"/>
-                    </a:solidFill>
-                  </a:tcPr>
-                </a:tc>
-                <a:tc>
-                  <a:txBody>
-                    <a:bodyPr/>
-                    <a:lstStyle/>
-                    <a:p>
-                      <a:r>
-                        <a:rPr sz="1500" b="0">
-                          <a:solidFill>
-                            <a:srgbClr val="CFDEEB"/>
-                          </a:solidFill>
-                        </a:rPr>
-                        <a:t>verify.py — Java 컴파일 + 테스트 실행</a:t>
-                      </a:r>
-                    </a:p>
-                  </a:txBody>
-                  <a:tcPr anchor="ctr" marL="137160" marR="137160" marT="0" marB="0">
-                    <a:solidFill>
-                      <a:srgbClr val="162236"/>
-                    </a:solidFill>
-                  </a:tcPr>
-                </a:tc>
-              </a:tr>
-              <a:tr h="457200">
-                <a:tc>
-                  <a:txBody>
-                    <a:bodyPr/>
-                    <a:lstStyle/>
-                    <a:p>
-                      <a:r>
-                        <a:rPr sz="1500" b="1">
-                          <a:solidFill>
-                            <a:srgbClr val="CFDEEB"/>
-                          </a:solidFill>
-                        </a:rPr>
-                        <a:t>컨트롤러  Controller</a:t>
-                      </a:r>
-                    </a:p>
-                  </a:txBody>
-                  <a:tcPr anchor="ctr" marL="137160" marR="137160" marT="0" marB="0">
-                    <a:solidFill>
-                      <a:srgbClr val="162236"/>
-                    </a:solidFill>
-                  </a:tcPr>
-                </a:tc>
-                <a:tc>
-                  <a:txBody>
-                    <a:bodyPr/>
-                    <a:lstStyle/>
-                    <a:p>
-                      <a:r>
-                        <a:rPr sz="1500" b="0">
-                          <a:solidFill>
-                            <a:srgbClr val="8397AB"/>
-                          </a:solidFill>
-                        </a:rPr>
-                        <a:t>판단 회로</a:t>
-                      </a:r>
-                    </a:p>
-                  </a:txBody>
-                  <a:tcPr anchor="ctr" marL="137160" marR="137160" marT="0" marB="0">
-                    <a:solidFill>
-                      <a:srgbClr val="162236"/>
-                    </a:solidFill>
-                  </a:tcPr>
-                </a:tc>
-                <a:tc>
-                  <a:txBody>
-                    <a:bodyPr/>
-                    <a:lstStyle/>
-                    <a:p>
-                      <a:r>
-                        <a:rPr sz="1500" b="0">
-                          <a:solidFill>
-                            <a:srgbClr val="31D3B1"/>
-                          </a:solidFill>
-                        </a:rPr>
-                        <a:t>loop.py — 일반 if문 (AI 아님)</a:t>
-                      </a:r>
-                    </a:p>
-                  </a:txBody>
-                  <a:tcPr anchor="ctr" marL="137160" marR="137160" marT="0" marB="0">
-                    <a:solidFill>
-                      <a:srgbClr val="162236"/>
-                    </a:solidFill>
-                  </a:tcPr>
-                </a:tc>
-              </a:tr>
-              <a:tr h="457200">
-                <a:tc>
-                  <a:txBody>
-                    <a:bodyPr/>
-                    <a:lstStyle/>
-                    <a:p>
-                      <a:r>
-                        <a:rPr sz="1500" b="1">
-                          <a:solidFill>
-                            <a:srgbClr val="CFDEEB"/>
-                          </a:solidFill>
-                        </a:rPr>
-                        <a:t>실행기  Actuator</a:t>
-                      </a:r>
-                    </a:p>
-                  </a:txBody>
-                  <a:tcPr anchor="ctr" marL="137160" marR="137160" marT="0" marB="0">
-                    <a:solidFill>
-                      <a:srgbClr val="162236"/>
-                    </a:solidFill>
-                  </a:tcPr>
-                </a:tc>
-                <a:tc>
-                  <a:txBody>
-                    <a:bodyPr/>
-                    <a:lstStyle/>
-                    <a:p>
-                      <a:r>
-                        <a:rPr sz="1500" b="0">
-                          <a:solidFill>
-                            <a:srgbClr val="8397AB"/>
-                          </a:solidFill>
-                        </a:rPr>
-                        <a:t>에어컨</a:t>
-                      </a:r>
-                    </a:p>
-                  </a:txBody>
-                  <a:tcPr anchor="ctr" marL="137160" marR="137160" marT="0" marB="0">
-                    <a:solidFill>
-                      <a:srgbClr val="162236"/>
-                    </a:solidFill>
-                  </a:tcPr>
-                </a:tc>
-                <a:tc>
-                  <a:txBody>
-                    <a:bodyPr/>
-                    <a:lstStyle/>
-                    <a:p>
-                      <a:r>
-                        <a:rPr sz="1500" b="0">
-                          <a:solidFill>
-                            <a:srgbClr val="7C5CFF"/>
-                          </a:solidFill>
-                        </a:rPr>
-                        <a:t>Kiro CLI — 코드 수정 (파일 읽기/쓰기만 허용)</a:t>
-                      </a:r>
-                    </a:p>
-                  </a:txBody>
-                  <a:tcPr anchor="ctr" marL="137160" marR="137160" marT="0" marB="0">
-                    <a:solidFill>
-                      <a:srgbClr val="162236"/>
-                    </a:solidFill>
-                  </a:tcPr>
-                </a:tc>
-              </a:tr>
-              <a:tr h="457200">
-                <a:tc>
-                  <a:txBody>
-                    <a:bodyPr/>
-                    <a:lstStyle/>
-                    <a:p>
-                      <a:r>
-                        <a:rPr sz="1500" b="1">
-                          <a:solidFill>
-                            <a:srgbClr val="CFDEEB"/>
-                          </a:solidFill>
-                        </a:rPr>
-                        <a:t>시스템  System</a:t>
-                      </a:r>
-                    </a:p>
-                  </a:txBody>
-                  <a:tcPr anchor="ctr" marL="137160" marR="137160" marT="0" marB="0">
-                    <a:solidFill>
-                      <a:srgbClr val="162236"/>
-                    </a:solidFill>
-                  </a:tcPr>
-                </a:tc>
-                <a:tc>
-                  <a:txBody>
-                    <a:bodyPr/>
-                    <a:lstStyle/>
-                    <a:p>
-                      <a:r>
-                        <a:rPr sz="1500" b="0">
-                          <a:solidFill>
-                            <a:srgbClr val="8397AB"/>
-                          </a:solidFill>
-                        </a:rPr>
-                        <a:t>방</a:t>
-                      </a:r>
-                    </a:p>
-                  </a:txBody>
-                  <a:tcPr anchor="ctr" marL="137160" marR="137160" marT="0" marB="0">
-                    <a:solidFill>
-                      <a:srgbClr val="162236"/>
-                    </a:solidFill>
-                  </a:tcPr>
-                </a:tc>
-                <a:tc>
-                  <a:txBody>
-                    <a:bodyPr/>
-                    <a:lstStyle/>
-                    <a:p>
-                      <a:r>
-                        <a:rPr sz="1500" b="0">
-                          <a:solidFill>
-                            <a:srgbClr val="CFDEEB"/>
-                          </a:solidFill>
-                        </a:rPr>
-                        <a:t>src/DiscountCalculator.java</a:t>
-                      </a:r>
-                    </a:p>
-                  </a:txBody>
-                  <a:tcPr anchor="ctr" marL="137160" marR="137160" marT="0" marB="0">
-                    <a:solidFill>
-                      <a:srgbClr val="162236"/>
-                    </a:solidFill>
-                  </a:tcPr>
-                </a:tc>
-              </a:tr>
-              <a:tr h="457200">
-                <a:tc>
-                  <a:txBody>
-                    <a:bodyPr/>
-                    <a:lstStyle/>
-                    <a:p>
-                      <a:r>
-                        <a:rPr sz="1500" b="1">
-                          <a:solidFill>
-                            <a:srgbClr val="CFDEEB"/>
-                          </a:solidFill>
-                        </a:rPr>
-                        <a:t>안전장치</a:t>
-                      </a:r>
-                    </a:p>
-                  </a:txBody>
-                  <a:tcPr anchor="ctr" marL="137160" marR="137160" marT="0" marB="0">
-                    <a:solidFill>
-                      <a:srgbClr val="162236"/>
-                    </a:solidFill>
-                  </a:tcPr>
-                </a:tc>
-                <a:tc>
-                  <a:txBody>
-                    <a:bodyPr/>
-                    <a:lstStyle/>
-                    <a:p>
-                      <a:r>
-                        <a:rPr sz="1500" b="0">
-                          <a:solidFill>
-                            <a:srgbClr val="8397AB"/>
-                          </a:solidFill>
-                        </a:rPr>
-                        <a:t>과열 차단</a:t>
-                      </a:r>
-                    </a:p>
-                  </a:txBody>
-                  <a:tcPr anchor="ctr" marL="137160" marR="137160" marT="0" marB="0">
-                    <a:solidFill>
-                      <a:srgbClr val="162236"/>
-                    </a:solidFill>
-                  </a:tcPr>
-                </a:tc>
-                <a:tc>
-                  <a:txBody>
-                    <a:bodyPr/>
-                    <a:lstStyle/>
-                    <a:p>
-                      <a:r>
-                        <a:rPr sz="1500" b="0">
-                          <a:solidFill>
-                            <a:srgbClr val="CFDEEB"/>
-                          </a:solidFill>
-                        </a:rPr>
-                        <a:t>최대 5회 · 세션 300초 · 보호 파일 검사</a:t>
-                      </a:r>
-                    </a:p>
-                  </a:txBody>
-                  <a:tcPr anchor="ctr" marL="137160" marR="137160" marT="0" marB="0">
-                    <a:solidFill>
-                      <a:srgbClr val="162236"/>
-                    </a:solidFill>
-                  </a:tcPr>
-                </a:tc>
-              </a:tr>
-            </a:tbl>
-          </a:graphicData>
-        </a:graphic>
-      </p:graphicFrame>
-      <p:sp>
-        <p:nvSpPr>
-          <p:cNvPr id="7" name="Rounded Rectangle 6"/>
+              <a:t>5장의 제어 루프 그림에 데모 구성 요소를 그대로 넣으면</a:t>
+            </a:r>
+          </a:p>
+        </p:txBody>
+      </p:sp>
+      <p:sp>
+        <p:nvSpPr>
+          <p:cNvPr id="32" name="Rounded Rectangle 31"/>
+          <p:cNvSpPr/>
+          <p:nvPr/>
+        </p:nvSpPr>
+        <p:spPr>
+          <a:xfrm>
+            <a:off x="868680" y="4526280"/>
+            <a:ext cx="10515600" cy="548640"/>
+          </a:xfrm>
+          <a:prstGeom prst="roundRect">
+            <a:avLst>
+              <a:gd name="adj" fmla="val 8000"/>
+            </a:avLst>
+          </a:prstGeom>
+          <a:solidFill>
+            <a:srgbClr val="162236"/>
+          </a:solidFill>
+          <a:ln w="15875">
+            <a:solidFill>
+              <a:srgbClr val="2A3B52"/>
+            </a:solidFill>
+          </a:ln>
+        </p:spPr>
+        <p:style>
+          <a:lnRef idx="1">
+            <a:schemeClr val="accent1"/>
+          </a:lnRef>
+          <a:fillRef idx="3">
+            <a:schemeClr val="accent1"/>
+          </a:fillRef>
+          <a:effectRef idx="2">
+            <a:schemeClr val="accent1"/>
+          </a:effectRef>
+          <a:fontRef idx="minor">
+            <a:schemeClr val="lt1"/>
+          </a:fontRef>
+        </p:style>
+        <p:txBody>
+          <a:bodyPr rtlCol="0" anchor="ctr" wrap="square"/>
+          <a:lstStyle/>
+          <a:p>
+            <a:pPr algn="ctr"/>
+            <a:r>
+              <a:rPr sz="1400" b="0">
+                <a:solidFill>
+                  <a:srgbClr val="CFDEEB"/>
+                </a:solidFill>
+              </a:rPr>
+              <a:t>안전장치:  최대 5회 · 세션 300초 · 테스트/검증기 변조 시 복원·중단 · Kiro는 파일 읽기/쓰기만</a:t>
+            </a:r>
+          </a:p>
+        </p:txBody>
+      </p:sp>
+      <p:sp>
+        <p:nvSpPr>
+          <p:cNvPr id="33" name="Rounded Rectangle 32"/>
           <p:cNvSpPr/>
           <p:nvPr/>
         </p:nvSpPr>
@@ -17098,14 +17684,10 @@
           </a:fontRef>
         </p:style>
         <p:txBody>
-          <a:bodyPr rtlCol="0" anchor="ctr" lIns="109728" rIns="109728" wrap="square"/>
-          <a:lstStyle/>
-          <a:p>
-            <a:pPr algn="ctr">
-              <a:spcAft>
-                <a:spcPts val="200"/>
-              </a:spcAft>
-            </a:pPr>
+          <a:bodyPr rtlCol="0" anchor="ctr" wrap="square"/>
+          <a:lstStyle/>
+          <a:p>
+            <a:pPr algn="ctr"/>
             <a:r>
               <a:rPr sz="1800" b="1">
                 <a:solidFill>
@@ -17116,11 +17698,7 @@
             </a:r>
           </a:p>
           <a:p>
-            <a:pPr algn="ctr">
-              <a:spcAft>
-                <a:spcPts val="200"/>
-              </a:spcAft>
-            </a:pPr>
+            <a:pPr algn="ctr"/>
             <a:r>
               <a:rPr sz="1300" b="0">
                 <a:solidFill>
@@ -17134,14 +17712,14 @@
       </p:sp>
       <p:sp>
         <p:nvSpPr>
-          <p:cNvPr id="8" name="TextBox 7"/>
+          <p:cNvPr id="34" name="TextBox 33"/>
           <p:cNvSpPr txBox="1"/>
           <p:nvPr/>
         </p:nvSpPr>
         <p:spPr>
           <a:xfrm>
-            <a:off x="868680" y="329184"/>
-            <a:ext cx="10515600" cy="274320"/>
+            <a:off x="868680" y="6080760"/>
+            <a:ext cx="10515600" cy="256032"/>
           </a:xfrm>
           <a:prstGeom prst="rect">
             <a:avLst/>
@@ -17155,45 +17733,12 @@
           <a:lstStyle/>
           <a:p>
             <a:r>
-              <a:rPr sz="1100" b="1">
-                <a:solidFill>
-                  <a:srgbClr val="31D3B1"/>
-                </a:solidFill>
-              </a:rPr>
-              <a:t>PART 3 · 데모: Kiro로 Goal Loop 만들기</a:t>
-            </a:r>
-          </a:p>
-        </p:txBody>
-      </p:sp>
-      <p:sp>
-        <p:nvSpPr>
-          <p:cNvPr id="9" name="TextBox 8"/>
-          <p:cNvSpPr txBox="1"/>
-          <p:nvPr/>
-        </p:nvSpPr>
-        <p:spPr>
-          <a:xfrm>
-            <a:off x="868680" y="6080760"/>
-            <a:ext cx="10515600" cy="256032"/>
-          </a:xfrm>
-          <a:prstGeom prst="rect">
-            <a:avLst/>
-          </a:prstGeom>
-          <a:noFill/>
-        </p:spPr>
-        <p:txBody>
-          <a:bodyPr wrap="square">
-            <a:spAutoFit/>
-          </a:bodyPr>
-          <a:lstStyle/>
-          <a:p>
-            <a:r>
               <a:rPr sz="1000" b="0">
                 <a:solidFill>
                   <a:srgbClr val="8397AB"/>
                 </a:solidFill>
               </a:rPr>
-              <a:t>제어 루프 요소와 온도조절기 예시: Kyle Mistele 발표 · 각 칸의 구체적 대응은 발표자 해석</a:t>
+              <a:t>그림: Kyle Mistele 발표의 제어 루프를 재구성 · 각 칸의 데모 대응은 발표자 해석</a:t>
             </a:r>
           </a:p>
         </p:txBody>

</xml_diff>

<commit_message>
Slide 15: simplify debate slide into two views + takeaway, add script
</commit_message>
<xml_diff>
--- a/docs/AI_Agent_Loop.pptx
+++ b/docs/AI_Agent_Loop.pptx
@@ -1050,7 +1050,59 @@
           <a:lstStyle/>
           <a:p>
             <a:r>
-              <a:t>마지막 날 패널. 사회 Allie Howe. 찬성: Ralph Loop 창시자 Geoffrey Huntley, Keycard CEO Ian Livingstone. 신중론: HumanLayer의 Dex Horthy, Subroutine의 Greg Pstrucha. Horthy도 루프 자체를 반대하지 않았다 — Kubernetes도 제어 루프로 돌지만 결정적 루프다. 문제는 과대광고가 규율을 앞지른 것. 그의 조언: 작게 시작해서 직관을 쌓아라. Pstrucha는 비용 지속성 우려. Huntley조차 소프트웨어 팩토리는 아직 시장에서 풀리지 않은 문제라고 했다. 같은 날 발표된 Amplify 설문: 에이전트 사용 95%(전년 약 2배), 에이전트가 데이터를 쓸 수 있는 팀 89%, AI 생성 코드가 장기 부채라는 우려 59%, AI 비용이 사용을 정기적으로 제한한다 40%. "에이전트 통제 계층은 아직 누구도 정립하지 못했다."</a:t>
+              <a:t>[발표 스크립트 · 약 1분 30초]</a:t>
+            </a:r>
+          </a:p>
+          <a:p/>
+          <a:p>
+            <a:r>
+              <a:t>그럼 현장에서는 다들 Loop가 좋다고만 했을까요? 아닙니다. 마지막 날 'The Great Loops Debate'라는 찬반 토론이 있었습니다.</a:t>
+            </a:r>
+          </a:p>
+          <a:p/>
+          <a:p>
+            <a:r>
+              <a:t>(왼쪽 초록) 찬성 쪽은 "이미 왔다"는 입장입니다. Ralph Loop를 만든 Geoffrey Huntley는 "피할 수 없고, 계속 남는다. 손으로 코드 짜던 때로는 안 돌아간다"고 했습니다. 같은 편의 Ian Livingstone은 "코드를 누가 어떻게 만들었든, 결국 핵심은 검증할 수 있느냐"라고 했습니다.</a:t>
+            </a:r>
+          </a:p>
+          <a:p/>
+          <a:p>
+            <a:r>
+              <a:t>(오른쪽 노랑) 신중한 쪽은 "아직 이르다"입니다. Dex Horthy는 "기대(hype)가 실제 엔지니어링 실력보다 앞서 있다"고 했고, Greg Pstrucha는 "토큰을 더 산다고 문제가 해결되진 않는다"며 비용을 걱정했습니다. 재미있는 건 Horthy도 루프 자체를 반대한 게 아니라, 작게 시작해서 감을 쌓으라고 조언했다는 점입니다.</a:t>
+            </a:r>
+          </a:p>
+          <a:p/>
+          <a:p>
+            <a:r>
+              <a:t>(가운데 숫자) 같은 날 발표된 설문을 보면 이 분위기가 그대로 드러납니다. 개발자 95%가 이미 에이전트를 쓰는데, 59%는 AI가 만든 코드가 나중에 짐이 될까 걱정합니다. 다들 쓰고는 있지만, 불안해하고 있다는 거죠.</a:t>
+            </a:r>
+          </a:p>
+          <a:p/>
+          <a:p>
+            <a:r>
+              <a:t>(하단) 그래서 우리 결론은 간단합니다. 거창하게 시작하지 말고, 작게 시작해서 검증과 한도를 붙여 써 보자. 오늘 데모가 바로 그 최소 단위입니다. 테스트로 검증하고, 횟수·시간·권한에 한도를 뒀죠.</a:t>
+            </a:r>
+          </a:p>
+          <a:p/>
+          <a:p>
+            <a:r>
+              <a:t>(참고: 토론 끝에 청중 투표를 했는데, 무대 조명이 너무 밝아서 손든 사람 수를 셀 수 없었다는 웃긴 일화가 있습니다.)</a:t>
+            </a:r>
+          </a:p>
+          <a:p/>
+          <a:p>
+            <a:r>
+              <a:t>[예상 질문]</a:t>
+            </a:r>
+          </a:p>
+          <a:p>
+            <a:r>
+              <a:t>Q. 그럼 결국 써야 하나요, 말아야 하나요?</a:t>
+            </a:r>
+          </a:p>
+          <a:p>
+            <a:r>
+              <a:t>A. 양쪽 모두 "검증"을 강조했습니다. 테스트처럼 결과를 자동으로 확인할 수 있는 작업부터, 작게 써 보는 게 안전한 출발점입니다.</a:t>
             </a:r>
           </a:p>
         </p:txBody>
@@ -8008,7 +8060,7 @@
                   <a:srgbClr val="F5F8FD"/>
                 </a:solidFill>
               </a:rPr>
-              <a:t>The Great Loops Debate: 아직 논쟁 중</a:t>
+              <a:t>현장의 반응: 다들 찬성했을까?</a:t>
             </a:r>
           </a:p>
         </p:txBody>
@@ -8048,14 +8100,14 @@
       </p:sp>
       <p:sp>
         <p:nvSpPr>
-          <p:cNvPr id="5" name="TextBox 4"/>
+          <p:cNvPr id="14" name="TextBox 13"/>
           <p:cNvSpPr txBox="1"/>
           <p:nvPr/>
         </p:nvSpPr>
         <p:spPr>
           <a:xfrm>
-            <a:off x="868680" y="1371600"/>
-            <a:ext cx="10515600" cy="365760"/>
+            <a:off x="868680" y="329184"/>
+            <a:ext cx="10515600" cy="274320"/>
           </a:xfrm>
           <a:prstGeom prst="rect">
             <a:avLst/>
@@ -8069,36 +8121,74 @@
           <a:lstStyle/>
           <a:p>
             <a:r>
-              <a:rPr sz="1400" b="0">
+              <a:rPr sz="1100" b="1">
+                <a:solidFill>
+                  <a:srgbClr val="31D3B1"/>
+                </a:solidFill>
+              </a:rPr>
+              <a:t>PART 4 · 현실과 적용</a:t>
+            </a:r>
+          </a:p>
+        </p:txBody>
+      </p:sp>
+      <p:sp>
+        <p:nvSpPr>
+          <p:cNvPr id="15" name="TextBox 14"/>
+          <p:cNvSpPr txBox="1"/>
+          <p:nvPr/>
+        </p:nvSpPr>
+        <p:spPr>
+          <a:xfrm>
+            <a:off x="868680" y="1371600"/>
+            <a:ext cx="10515600" cy="365760"/>
+          </a:xfrm>
+          <a:prstGeom prst="rect">
+            <a:avLst/>
+          </a:prstGeom>
+          <a:noFill/>
+        </p:spPr>
+        <p:txBody>
+          <a:bodyPr wrap="square">
+            <a:spAutoFit/>
+          </a:bodyPr>
+          <a:lstStyle/>
+          <a:p>
+            <a:pPr algn="l">
+              <a:spcAft>
+                <a:spcPts val="600"/>
+              </a:spcAft>
+            </a:pPr>
+            <a:r>
+              <a:rPr sz="1500" b="0">
                 <a:solidFill>
                   <a:srgbClr val="8397AB"/>
                 </a:solidFill>
               </a:rPr>
-              <a:t>마지막 날 패널 · 사회 Allie Howe: “과대광고와 실제로 되는 것 사이에 차이가 있나?”</a:t>
-            </a:r>
-          </a:p>
-        </p:txBody>
-      </p:sp>
-      <p:sp>
-        <p:nvSpPr>
-          <p:cNvPr id="6" name="Rounded Rectangle 5"/>
+              <a:t>마지막 날 패널 토론 “The Great Loops Debate” — 찬성과 신중론이 맞섰고, 승패는 가리지 못했다</a:t>
+            </a:r>
+          </a:p>
+        </p:txBody>
+      </p:sp>
+      <p:sp>
+        <p:nvSpPr>
+          <p:cNvPr id="16" name="Rounded Rectangle 15"/>
           <p:cNvSpPr/>
           <p:nvPr/>
         </p:nvSpPr>
         <p:spPr>
           <a:xfrm>
             <a:off x="868680" y="1828800"/>
-            <a:ext cx="5120640" cy="1783080"/>
+            <a:ext cx="5120640" cy="2103120"/>
           </a:xfrm>
           <a:prstGeom prst="roundRect">
             <a:avLst>
-              <a:gd name="adj" fmla="val 8000"/>
+              <a:gd name="adj" fmla="val 6000"/>
             </a:avLst>
           </a:prstGeom>
           <a:solidFill>
             <a:srgbClr val="162236"/>
           </a:solidFill>
-          <a:ln w="19050">
+          <a:ln w="22225">
             <a:solidFill>
               <a:srgbClr val="4ADE80"/>
             </a:solidFill>
@@ -8119,7 +8209,306 @@
           </a:fontRef>
         </p:style>
         <p:txBody>
-          <a:bodyPr rtlCol="0" anchor="t" lIns="201168" rIns="201168" wrap="square"/>
+          <a:bodyPr rtlCol="0" anchor="ctr" wrap="square"/>
+          <a:lstStyle/>
+          <a:p>
+            <a:pPr algn="ctr">
+              <a:spcAft>
+                <a:spcPts val="600"/>
+              </a:spcAft>
+            </a:pPr>
+            <a:r>
+              <a:rPr sz="2600" b="1">
+                <a:solidFill>
+                  <a:srgbClr val="4ADE80"/>
+                </a:solidFill>
+              </a:rPr>
+              <a:t>“이미 왔다”</a:t>
+            </a:r>
+          </a:p>
+          <a:p>
+            <a:pPr algn="ctr">
+              <a:spcAft>
+                <a:spcPts val="600"/>
+              </a:spcAft>
+            </a:pPr>
+            <a:r>
+              <a:rPr sz="1700" b="0">
+                <a:solidFill>
+                  <a:srgbClr val="F5F8FD"/>
+                </a:solidFill>
+              </a:rPr>
+              <a:t>손으로 코드 짜던 때로는 돌아가지 않는다</a:t>
+            </a:r>
+          </a:p>
+          <a:p>
+            <a:pPr algn="ctr">
+              <a:spcAft>
+                <a:spcPts val="600"/>
+              </a:spcAft>
+            </a:pPr>
+            <a:r>
+              <a:rPr sz="1700" b="0">
+                <a:solidFill>
+                  <a:srgbClr val="F5F8FD"/>
+                </a:solidFill>
+              </a:rPr>
+              <a:t>핵심은 결과를 검증할 수 있느냐다</a:t>
+            </a:r>
+          </a:p>
+          <a:p>
+            <a:pPr algn="ctr">
+              <a:spcAft>
+                <a:spcPts val="600"/>
+              </a:spcAft>
+            </a:pPr>
+            <a:r>
+              <a:rPr sz="1200" b="0">
+                <a:solidFill>
+                  <a:srgbClr val="8397AB"/>
+                </a:solidFill>
+              </a:rPr>
+              <a:t>Geoffrey Huntley (Ralph Loop 창시자) · Ian Livingstone</a:t>
+            </a:r>
+          </a:p>
+        </p:txBody>
+      </p:sp>
+      <p:sp>
+        <p:nvSpPr>
+          <p:cNvPr id="17" name="Rounded Rectangle 16"/>
+          <p:cNvSpPr/>
+          <p:nvPr/>
+        </p:nvSpPr>
+        <p:spPr>
+          <a:xfrm>
+            <a:off x="6263640" y="1828800"/>
+            <a:ext cx="5120640" cy="2103120"/>
+          </a:xfrm>
+          <a:prstGeom prst="roundRect">
+            <a:avLst>
+              <a:gd name="adj" fmla="val 6000"/>
+            </a:avLst>
+          </a:prstGeom>
+          <a:solidFill>
+            <a:srgbClr val="162236"/>
+          </a:solidFill>
+          <a:ln w="22225">
+            <a:solidFill>
+              <a:srgbClr val="FACC15"/>
+            </a:solidFill>
+          </a:ln>
+        </p:spPr>
+        <p:style>
+          <a:lnRef idx="1">
+            <a:schemeClr val="accent1"/>
+          </a:lnRef>
+          <a:fillRef idx="3">
+            <a:schemeClr val="accent1"/>
+          </a:fillRef>
+          <a:effectRef idx="2">
+            <a:schemeClr val="accent1"/>
+          </a:effectRef>
+          <a:fontRef idx="minor">
+            <a:schemeClr val="lt1"/>
+          </a:fontRef>
+        </p:style>
+        <p:txBody>
+          <a:bodyPr rtlCol="0" anchor="ctr" wrap="square"/>
+          <a:lstStyle/>
+          <a:p>
+            <a:pPr algn="ctr">
+              <a:spcAft>
+                <a:spcPts val="600"/>
+              </a:spcAft>
+            </a:pPr>
+            <a:r>
+              <a:rPr sz="2600" b="1">
+                <a:solidFill>
+                  <a:srgbClr val="FACC15"/>
+                </a:solidFill>
+              </a:rPr>
+              <a:t>“아직 이르다”</a:t>
+            </a:r>
+          </a:p>
+          <a:p>
+            <a:pPr algn="ctr">
+              <a:spcAft>
+                <a:spcPts val="600"/>
+              </a:spcAft>
+            </a:pPr>
+            <a:r>
+              <a:rPr sz="1700" b="0">
+                <a:solidFill>
+                  <a:srgbClr val="F5F8FD"/>
+                </a:solidFill>
+              </a:rPr>
+              <a:t>기대가 실제 실력보다 앞서 있다</a:t>
+            </a:r>
+          </a:p>
+          <a:p>
+            <a:pPr algn="ctr">
+              <a:spcAft>
+                <a:spcPts val="600"/>
+              </a:spcAft>
+            </a:pPr>
+            <a:r>
+              <a:rPr sz="1700" b="0">
+                <a:solidFill>
+                  <a:srgbClr val="F5F8FD"/>
+                </a:solidFill>
+              </a:rPr>
+              <a:t>토큰을 더 산다고 해결되지는 않는다</a:t>
+            </a:r>
+          </a:p>
+          <a:p>
+            <a:pPr algn="ctr">
+              <a:spcAft>
+                <a:spcPts val="600"/>
+              </a:spcAft>
+            </a:pPr>
+            <a:r>
+              <a:rPr sz="1200" b="0">
+                <a:solidFill>
+                  <a:srgbClr val="8397AB"/>
+                </a:solidFill>
+              </a:rPr>
+              <a:t>Dex Horthy (HumanLayer) · Greg Pstrucha</a:t>
+            </a:r>
+          </a:p>
+        </p:txBody>
+      </p:sp>
+      <p:sp>
+        <p:nvSpPr>
+          <p:cNvPr id="18" name="TextBox 17"/>
+          <p:cNvSpPr txBox="1"/>
+          <p:nvPr/>
+        </p:nvSpPr>
+        <p:spPr>
+          <a:xfrm>
+            <a:off x="868680" y="4160520"/>
+            <a:ext cx="10515600" cy="457200"/>
+          </a:xfrm>
+          <a:prstGeom prst="rect">
+            <a:avLst/>
+          </a:prstGeom>
+          <a:noFill/>
+        </p:spPr>
+        <p:txBody>
+          <a:bodyPr wrap="square">
+            <a:spAutoFit/>
+          </a:bodyPr>
+          <a:lstStyle/>
+          <a:p>
+            <a:pPr algn="ctr">
+              <a:spcAft>
+                <a:spcPts val="600"/>
+              </a:spcAft>
+            </a:pPr>
+            <a:r>
+              <a:rPr sz="1600" b="0">
+                <a:solidFill>
+                  <a:srgbClr val="CFDEEB"/>
+                </a:solidFill>
+              </a:rPr>
+              <a:t>개발자 95%가 에이전트를 쓰지만, 59%는 AI가 만든 코드가 나중에 짐이 될까 걱정한다</a:t>
+            </a:r>
+          </a:p>
+        </p:txBody>
+      </p:sp>
+      <p:sp>
+        <p:nvSpPr>
+          <p:cNvPr id="19" name="Rounded Rectangle 18"/>
+          <p:cNvSpPr/>
+          <p:nvPr/>
+        </p:nvSpPr>
+        <p:spPr>
+          <a:xfrm>
+            <a:off x="868680" y="4846320"/>
+            <a:ext cx="10515600" cy="960120"/>
+          </a:xfrm>
+          <a:prstGeom prst="roundRect">
+            <a:avLst>
+              <a:gd name="adj" fmla="val 6000"/>
+            </a:avLst>
+          </a:prstGeom>
+          <a:solidFill>
+            <a:srgbClr val="0F2A2A"/>
+          </a:solidFill>
+          <a:ln w="25400">
+            <a:solidFill>
+              <a:srgbClr val="31D3B1"/>
+            </a:solidFill>
+          </a:ln>
+        </p:spPr>
+        <p:style>
+          <a:lnRef idx="1">
+            <a:schemeClr val="accent1"/>
+          </a:lnRef>
+          <a:fillRef idx="3">
+            <a:schemeClr val="accent1"/>
+          </a:fillRef>
+          <a:effectRef idx="2">
+            <a:schemeClr val="accent1"/>
+          </a:effectRef>
+          <a:fontRef idx="minor">
+            <a:schemeClr val="lt1"/>
+          </a:fontRef>
+        </p:style>
+        <p:txBody>
+          <a:bodyPr rtlCol="0" anchor="ctr" wrap="square"/>
+          <a:lstStyle/>
+          <a:p>
+            <a:pPr algn="ctr">
+              <a:spcAft>
+                <a:spcPts val="600"/>
+              </a:spcAft>
+            </a:pPr>
+            <a:r>
+              <a:rPr sz="2000" b="1">
+                <a:solidFill>
+                  <a:srgbClr val="F5F8FD"/>
+                </a:solidFill>
+              </a:rPr>
+              <a:t>그래서 우리는? 작게 시작하고, 검증과 한도를 붙여서 써 보자</a:t>
+            </a:r>
+          </a:p>
+          <a:p>
+            <a:pPr algn="ctr">
+              <a:spcAft>
+                <a:spcPts val="600"/>
+              </a:spcAft>
+            </a:pPr>
+            <a:r>
+              <a:rPr sz="1400" b="0">
+                <a:solidFill>
+                  <a:srgbClr val="31D3B1"/>
+                </a:solidFill>
+              </a:rPr>
+              <a:t>오늘 데모가 바로 그 최소 단위다 — 테스트로 검증하고, 횟수·시간·권한에 한도를 둔 루프</a:t>
+            </a:r>
+          </a:p>
+        </p:txBody>
+      </p:sp>
+      <p:sp>
+        <p:nvSpPr>
+          <p:cNvPr id="20" name="TextBox 19"/>
+          <p:cNvSpPr txBox="1"/>
+          <p:nvPr/>
+        </p:nvSpPr>
+        <p:spPr>
+          <a:xfrm>
+            <a:off x="868680" y="6080760"/>
+            <a:ext cx="10515600" cy="256032"/>
+          </a:xfrm>
+          <a:prstGeom prst="rect">
+            <a:avLst/>
+          </a:prstGeom>
+          <a:noFill/>
+        </p:spPr>
+        <p:txBody>
+          <a:bodyPr wrap="square">
+            <a:spAutoFit/>
+          </a:bodyPr>
           <a:lstStyle/>
           <a:p>
             <a:pPr algn="l">
@@ -8128,540 +8517,12 @@
               </a:spcAft>
             </a:pPr>
             <a:r>
-              <a:rPr sz="1500" b="1">
-                <a:solidFill>
-                  <a:srgbClr val="4ADE80"/>
-                </a:solidFill>
-              </a:rPr>
-              <a:t>찬성 — Geoffrey Huntley · Ian Livingstone</a:t>
-            </a:r>
-          </a:p>
-          <a:p>
-            <a:pPr algn="l">
-              <a:spcAft>
-                <a:spcPts val="600"/>
-              </a:spcAft>
-            </a:pPr>
-            <a:r>
-              <a:rPr sz="1500" b="1">
-                <a:solidFill>
-                  <a:srgbClr val="F5F8FD"/>
-                </a:solidFill>
-              </a:rPr>
-              <a:t>“It's inevitable, it's here to stay.”</a:t>
-            </a:r>
-          </a:p>
-          <a:p>
-            <a:pPr algn="l">
-              <a:spcAft>
-                <a:spcPts val="600"/>
-              </a:spcAft>
-            </a:pPr>
-            <a:r>
-              <a:rPr sz="1300" b="0">
-                <a:solidFill>
-                  <a:srgbClr val="CFDEEB"/>
-                </a:solidFill>
-              </a:rPr>
-              <a:t>피할 수 없고, 계속 남는다 (Huntley)</a:t>
-            </a:r>
-          </a:p>
-          <a:p>
-            <a:pPr algn="l">
-              <a:spcAft>
-                <a:spcPts val="600"/>
-              </a:spcAft>
-            </a:pPr>
-            <a:r>
-              <a:rPr sz="1300" b="0">
-                <a:solidFill>
-                  <a:srgbClr val="CFDEEB"/>
-                </a:solidFill>
-              </a:rPr>
-              <a:t>핵심은 검증 가능성 — 코드가 어떻게 만들어졌든 (Livingstone)</a:t>
-            </a:r>
-          </a:p>
-        </p:txBody>
-      </p:sp>
-      <p:sp>
-        <p:nvSpPr>
-          <p:cNvPr id="7" name="Rounded Rectangle 6"/>
-          <p:cNvSpPr/>
-          <p:nvPr/>
-        </p:nvSpPr>
-        <p:spPr>
-          <a:xfrm>
-            <a:off x="6263640" y="1828800"/>
-            <a:ext cx="5120640" cy="1783080"/>
-          </a:xfrm>
-          <a:prstGeom prst="roundRect">
-            <a:avLst>
-              <a:gd name="adj" fmla="val 8000"/>
-            </a:avLst>
-          </a:prstGeom>
-          <a:solidFill>
-            <a:srgbClr val="162236"/>
-          </a:solidFill>
-          <a:ln w="19050">
-            <a:solidFill>
-              <a:srgbClr val="FACC15"/>
-            </a:solidFill>
-          </a:ln>
-        </p:spPr>
-        <p:style>
-          <a:lnRef idx="1">
-            <a:schemeClr val="accent1"/>
-          </a:lnRef>
-          <a:fillRef idx="3">
-            <a:schemeClr val="accent1"/>
-          </a:fillRef>
-          <a:effectRef idx="2">
-            <a:schemeClr val="accent1"/>
-          </a:effectRef>
-          <a:fontRef idx="minor">
-            <a:schemeClr val="lt1"/>
-          </a:fontRef>
-        </p:style>
-        <p:txBody>
-          <a:bodyPr rtlCol="0" anchor="t" lIns="201168" rIns="201168" wrap="square"/>
-          <a:lstStyle/>
-          <a:p>
-            <a:pPr algn="l">
-              <a:spcAft>
-                <a:spcPts val="600"/>
-              </a:spcAft>
-            </a:pPr>
-            <a:r>
-              <a:rPr sz="1500" b="1">
-                <a:solidFill>
-                  <a:srgbClr val="FACC15"/>
-                </a:solidFill>
-              </a:rPr>
-              <a:t>신중론 — Dex Horthy · Greg Pstrucha</a:t>
-            </a:r>
-          </a:p>
-          <a:p>
-            <a:pPr algn="l">
-              <a:spcAft>
-                <a:spcPts val="600"/>
-              </a:spcAft>
-            </a:pPr>
-            <a:r>
-              <a:rPr sz="1500" b="1">
-                <a:solidFill>
-                  <a:srgbClr val="F5F8FD"/>
-                </a:solidFill>
-              </a:rPr>
-              <a:t>“The hype is outrunning the discipline.”</a:t>
-            </a:r>
-          </a:p>
-          <a:p>
-            <a:pPr algn="l">
-              <a:spcAft>
-                <a:spcPts val="600"/>
-              </a:spcAft>
-            </a:pPr>
-            <a:r>
-              <a:rPr sz="1300" b="0">
-                <a:solidFill>
-                  <a:srgbClr val="CFDEEB"/>
-                </a:solidFill>
-              </a:rPr>
-              <a:t>과대광고가 엔지니어링 규율을 앞지르고 있다 (Horthy)</a:t>
-            </a:r>
-          </a:p>
-          <a:p>
-            <a:pPr algn="l">
-              <a:spcAft>
-                <a:spcPts val="600"/>
-              </a:spcAft>
-            </a:pPr>
-            <a:r>
-              <a:rPr sz="1300" b="0">
-                <a:solidFill>
-                  <a:srgbClr val="CFDEEB"/>
-                </a:solidFill>
-              </a:rPr>
-              <a:t>토큰을 더 사서 문제를 없앨 수는 없다 (Pstrucha)</a:t>
-            </a:r>
-          </a:p>
-          <a:p>
-            <a:pPr algn="l">
-              <a:spcAft>
-                <a:spcPts val="600"/>
-              </a:spcAft>
-            </a:pPr>
-            <a:r>
-              <a:rPr sz="1300" b="0">
-                <a:solidFill>
-                  <a:srgbClr val="FACC15"/>
-                </a:solidFill>
-              </a:rPr>
-              <a:t>→ 작게 시작해서 직관을 쌓아라</a:t>
-            </a:r>
-          </a:p>
-        </p:txBody>
-      </p:sp>
-      <p:sp>
-        <p:nvSpPr>
-          <p:cNvPr id="8" name="TextBox 7"/>
-          <p:cNvSpPr txBox="1"/>
-          <p:nvPr/>
-        </p:nvSpPr>
-        <p:spPr>
-          <a:xfrm>
-            <a:off x="868680" y="3840480"/>
-            <a:ext cx="10515600" cy="411480"/>
-          </a:xfrm>
-          <a:prstGeom prst="rect">
-            <a:avLst/>
-          </a:prstGeom>
-          <a:noFill/>
-        </p:spPr>
-        <p:txBody>
-          <a:bodyPr wrap="square">
-            <a:spAutoFit/>
-          </a:bodyPr>
-          <a:lstStyle/>
-          <a:p>
-            <a:pPr algn="ctr"/>
-            <a:r>
-              <a:rPr sz="1500" b="0">
-                <a:solidFill>
-                  <a:srgbClr val="CFDEEB"/>
-                </a:solidFill>
-              </a:rPr>
-              <a:t>“우리는 이제 기관사다. 기차를 레일 위에 유지하는 것이 우리 일이다.” — Geoffrey Huntley</a:t>
-            </a:r>
-          </a:p>
-        </p:txBody>
-      </p:sp>
-      <p:sp>
-        <p:nvSpPr>
-          <p:cNvPr id="9" name="Rounded Rectangle 8"/>
-          <p:cNvSpPr/>
-          <p:nvPr/>
-        </p:nvSpPr>
-        <p:spPr>
-          <a:xfrm>
-            <a:off x="868680" y="4526280"/>
-            <a:ext cx="2491740" cy="1234440"/>
-          </a:xfrm>
-          <a:prstGeom prst="roundRect">
-            <a:avLst>
-              <a:gd name="adj" fmla="val 8000"/>
-            </a:avLst>
-          </a:prstGeom>
-          <a:solidFill>
-            <a:srgbClr val="162236"/>
-          </a:solidFill>
-          <a:ln w="15875">
-            <a:solidFill>
-              <a:srgbClr val="2A3B52"/>
-            </a:solidFill>
-          </a:ln>
-        </p:spPr>
-        <p:style>
-          <a:lnRef idx="1">
-            <a:schemeClr val="accent1"/>
-          </a:lnRef>
-          <a:fillRef idx="3">
-            <a:schemeClr val="accent1"/>
-          </a:fillRef>
-          <a:effectRef idx="2">
-            <a:schemeClr val="accent1"/>
-          </a:effectRef>
-          <a:fontRef idx="minor">
-            <a:schemeClr val="lt1"/>
-          </a:fontRef>
-        </p:style>
-        <p:txBody>
-          <a:bodyPr rtlCol="0" anchor="ctr" lIns="73152" rIns="73152" wrap="square"/>
-          <a:lstStyle/>
-          <a:p>
-            <a:pPr algn="ctr"/>
-            <a:r>
-              <a:rPr sz="2400" b="1">
-                <a:solidFill>
-                  <a:srgbClr val="31D3B1"/>
-                </a:solidFill>
-              </a:rPr>
-              <a:t>95%</a:t>
-            </a:r>
-          </a:p>
-          <a:p>
-            <a:pPr algn="ctr"/>
-            <a:r>
-              <a:rPr sz="1100" b="0">
-                <a:solidFill>
-                  <a:srgbClr val="CFDEEB"/>
-                </a:solidFill>
-              </a:rPr>
-              <a:t>에이전트 사용 (전년 약 2배)</a:t>
-            </a:r>
-          </a:p>
-        </p:txBody>
-      </p:sp>
-      <p:sp>
-        <p:nvSpPr>
-          <p:cNvPr id="10" name="Rounded Rectangle 9"/>
-          <p:cNvSpPr/>
-          <p:nvPr/>
-        </p:nvSpPr>
-        <p:spPr>
-          <a:xfrm>
-            <a:off x="3543300" y="4526280"/>
-            <a:ext cx="2491740" cy="1234440"/>
-          </a:xfrm>
-          <a:prstGeom prst="roundRect">
-            <a:avLst>
-              <a:gd name="adj" fmla="val 8000"/>
-            </a:avLst>
-          </a:prstGeom>
-          <a:solidFill>
-            <a:srgbClr val="162236"/>
-          </a:solidFill>
-          <a:ln w="15875">
-            <a:solidFill>
-              <a:srgbClr val="2A3B52"/>
-            </a:solidFill>
-          </a:ln>
-        </p:spPr>
-        <p:style>
-          <a:lnRef idx="1">
-            <a:schemeClr val="accent1"/>
-          </a:lnRef>
-          <a:fillRef idx="3">
-            <a:schemeClr val="accent1"/>
-          </a:fillRef>
-          <a:effectRef idx="2">
-            <a:schemeClr val="accent1"/>
-          </a:effectRef>
-          <a:fontRef idx="minor">
-            <a:schemeClr val="lt1"/>
-          </a:fontRef>
-        </p:style>
-        <p:txBody>
-          <a:bodyPr rtlCol="0" anchor="ctr" lIns="73152" rIns="73152" wrap="square"/>
-          <a:lstStyle/>
-          <a:p>
-            <a:pPr algn="ctr"/>
-            <a:r>
-              <a:rPr sz="2400" b="1">
-                <a:solidFill>
-                  <a:srgbClr val="31D3B1"/>
-                </a:solidFill>
-              </a:rPr>
-              <a:t>89%</a:t>
-            </a:r>
-          </a:p>
-          <a:p>
-            <a:pPr algn="ctr"/>
-            <a:r>
-              <a:rPr sz="1100" b="0">
-                <a:solidFill>
-                  <a:srgbClr val="CFDEEB"/>
-                </a:solidFill>
-              </a:rPr>
-              <a:t>에이전트가 데이터 쓰기 가능</a:t>
-            </a:r>
-          </a:p>
-        </p:txBody>
-      </p:sp>
-      <p:sp>
-        <p:nvSpPr>
-          <p:cNvPr id="11" name="Rounded Rectangle 10"/>
-          <p:cNvSpPr/>
-          <p:nvPr/>
-        </p:nvSpPr>
-        <p:spPr>
-          <a:xfrm>
-            <a:off x="6217920" y="4526280"/>
-            <a:ext cx="2491740" cy="1234440"/>
-          </a:xfrm>
-          <a:prstGeom prst="roundRect">
-            <a:avLst>
-              <a:gd name="adj" fmla="val 8000"/>
-            </a:avLst>
-          </a:prstGeom>
-          <a:solidFill>
-            <a:srgbClr val="162236"/>
-          </a:solidFill>
-          <a:ln w="15875">
-            <a:solidFill>
-              <a:srgbClr val="2A3B52"/>
-            </a:solidFill>
-          </a:ln>
-        </p:spPr>
-        <p:style>
-          <a:lnRef idx="1">
-            <a:schemeClr val="accent1"/>
-          </a:lnRef>
-          <a:fillRef idx="3">
-            <a:schemeClr val="accent1"/>
-          </a:fillRef>
-          <a:effectRef idx="2">
-            <a:schemeClr val="accent1"/>
-          </a:effectRef>
-          <a:fontRef idx="minor">
-            <a:schemeClr val="lt1"/>
-          </a:fontRef>
-        </p:style>
-        <p:txBody>
-          <a:bodyPr rtlCol="0" anchor="ctr" lIns="73152" rIns="73152" wrap="square"/>
-          <a:lstStyle/>
-          <a:p>
-            <a:pPr algn="ctr"/>
-            <a:r>
-              <a:rPr sz="2400" b="1">
-                <a:solidFill>
-                  <a:srgbClr val="31D3B1"/>
-                </a:solidFill>
-              </a:rPr>
-              <a:t>59%</a:t>
-            </a:r>
-          </a:p>
-          <a:p>
-            <a:pPr algn="ctr"/>
-            <a:r>
-              <a:rPr sz="1100" b="0">
-                <a:solidFill>
-                  <a:srgbClr val="CFDEEB"/>
-                </a:solidFill>
-              </a:rPr>
-              <a:t>AI 생성 코드의 장기 부채 우려</a:t>
-            </a:r>
-          </a:p>
-        </p:txBody>
-      </p:sp>
-      <p:sp>
-        <p:nvSpPr>
-          <p:cNvPr id="12" name="Rounded Rectangle 11"/>
-          <p:cNvSpPr/>
-          <p:nvPr/>
-        </p:nvSpPr>
-        <p:spPr>
-          <a:xfrm>
-            <a:off x="8892540" y="4526280"/>
-            <a:ext cx="2491740" cy="1234440"/>
-          </a:xfrm>
-          <a:prstGeom prst="roundRect">
-            <a:avLst>
-              <a:gd name="adj" fmla="val 8000"/>
-            </a:avLst>
-          </a:prstGeom>
-          <a:solidFill>
-            <a:srgbClr val="162236"/>
-          </a:solidFill>
-          <a:ln w="15875">
-            <a:solidFill>
-              <a:srgbClr val="2A3B52"/>
-            </a:solidFill>
-          </a:ln>
-        </p:spPr>
-        <p:style>
-          <a:lnRef idx="1">
-            <a:schemeClr val="accent1"/>
-          </a:lnRef>
-          <a:fillRef idx="3">
-            <a:schemeClr val="accent1"/>
-          </a:fillRef>
-          <a:effectRef idx="2">
-            <a:schemeClr val="accent1"/>
-          </a:effectRef>
-          <a:fontRef idx="minor">
-            <a:schemeClr val="lt1"/>
-          </a:fontRef>
-        </p:style>
-        <p:txBody>
-          <a:bodyPr rtlCol="0" anchor="ctr" lIns="73152" rIns="73152" wrap="square"/>
-          <a:lstStyle/>
-          <a:p>
-            <a:pPr algn="ctr"/>
-            <a:r>
-              <a:rPr sz="2400" b="1">
-                <a:solidFill>
-                  <a:srgbClr val="31D3B1"/>
-                </a:solidFill>
-              </a:rPr>
-              <a:t>미정</a:t>
-            </a:r>
-          </a:p>
-          <a:p>
-            <a:pPr algn="ctr"/>
-            <a:r>
-              <a:rPr sz="1100" b="0">
-                <a:solidFill>
-                  <a:srgbClr val="CFDEEB"/>
-                </a:solidFill>
-              </a:rPr>
-              <a:t>에이전트 통제 계층 (아무도 정립 못 함)</a:t>
-            </a:r>
-          </a:p>
-        </p:txBody>
-      </p:sp>
-      <p:sp>
-        <p:nvSpPr>
-          <p:cNvPr id="13" name="TextBox 12"/>
-          <p:cNvSpPr txBox="1"/>
-          <p:nvPr/>
-        </p:nvSpPr>
-        <p:spPr>
-          <a:xfrm>
-            <a:off x="868680" y="6053328"/>
-            <a:ext cx="10515600" cy="274320"/>
-          </a:xfrm>
-          <a:prstGeom prst="rect">
-            <a:avLst/>
-          </a:prstGeom>
-          <a:noFill/>
-        </p:spPr>
-        <p:txBody>
-          <a:bodyPr wrap="square">
-            <a:spAutoFit/>
-          </a:bodyPr>
-          <a:lstStyle/>
-          <a:p>
-            <a:r>
               <a:rPr sz="1000" b="0">
                 <a:solidFill>
                   <a:srgbClr val="8397AB"/>
                 </a:solidFill>
               </a:rPr>
-              <a:t>출처: Latent Space “The great loops debate and the state of AI engineering” (2026-07-03) · 수치: Amplify 2026 AI Engineer Survey (Barr Yaron)</a:t>
-            </a:r>
-          </a:p>
-        </p:txBody>
-      </p:sp>
-      <p:sp>
-        <p:nvSpPr>
-          <p:cNvPr id="14" name="TextBox 13"/>
-          <p:cNvSpPr txBox="1"/>
-          <p:nvPr/>
-        </p:nvSpPr>
-        <p:spPr>
-          <a:xfrm>
-            <a:off x="868680" y="329184"/>
-            <a:ext cx="10515600" cy="274320"/>
-          </a:xfrm>
-          <a:prstGeom prst="rect">
-            <a:avLst/>
-          </a:prstGeom>
-          <a:noFill/>
-        </p:spPr>
-        <p:txBody>
-          <a:bodyPr wrap="square">
-            <a:spAutoFit/>
-          </a:bodyPr>
-          <a:lstStyle/>
-          <a:p>
-            <a:r>
-              <a:rPr sz="1100" b="1">
-                <a:solidFill>
-                  <a:srgbClr val="31D3B1"/>
-                </a:solidFill>
-              </a:rPr>
-              <a:t>PART 4 · 현실과 적용</a:t>
+              <a:t>출처: Latent Space “The great loops debate and the state of AI engineering” (2026-07-03) · 수치: Amplify 2026 AI Engineer Survey</a:t>
             </a:r>
           </a:p>
         </p:txBody>

</xml_diff>

<commit_message>
Slide 19: keep only core references
</commit_message>
<xml_diff>
--- a/docs/AI_Agent_Loop.pptx
+++ b/docs/AI_Agent_Loop.pptx
@@ -9755,8 +9755,8 @@
         </p:nvSpPr>
         <p:spPr>
           <a:xfrm>
-            <a:off x="868680" y="1417320"/>
-            <a:ext cx="10515600" cy="4572000"/>
+            <a:off x="868680" y="1600200"/>
+            <a:ext cx="10515600" cy="4206240"/>
           </a:xfrm>
           <a:prstGeom prst="rect">
             <a:avLst/>
@@ -9775,363 +9775,166 @@
               </a:spcAft>
             </a:pPr>
             <a:r>
-              <a:rPr sz="1300" b="1">
+              <a:rPr sz="2000" b="1">
                 <a:solidFill>
                   <a:srgbClr val="F5F8FD"/>
                 </a:solidFill>
               </a:rPr>
-              <a:t>swyx — The Highest Loop (AI Engineer World's Fair 2026 오프닝 키노트)</a:t>
+              <a:t>swyx — The Highest Loop</a:t>
+            </a:r>
+            <a:r>
+              <a:rPr sz="1400" b="0">
+                <a:solidFill>
+                  <a:srgbClr val="8397AB"/>
+                </a:solidFill>
+              </a:rPr>
+              <a:t>   AIEWF 2026 오프닝 키노트</a:t>
             </a:r>
           </a:p>
           <a:p>
             <a:pPr>
               <a:spcAft>
-                <a:spcPts val="500"/>
+                <a:spcPts val="1600"/>
               </a:spcAft>
             </a:pPr>
             <a:r>
-              <a:rPr sz="1000" b="0">
+              <a:rPr sz="1200">
                 <a:solidFill>
                   <a:srgbClr val="31D3B1"/>
                 </a:solidFill>
                 <a:hlinkClick r:id="rId3"/>
               </a:rPr>
               <a:t>https://github-main-preview.ai.engineer/talks/Fva8hFosqyQ-highest-loop-swyx</a:t>
+            </a:r>
+          </a:p>
+          <a:p>
+            <a:r>
+              <a:rPr sz="2000" b="1">
+                <a:solidFill>
+                  <a:srgbClr val="F5F8FD"/>
+                </a:solidFill>
+              </a:rPr>
+              <a:t>Kyle Mistele — Loop Engineering from First Principles</a:t>
+            </a:r>
+            <a:r>
+              <a:rPr sz="1400" b="0">
+                <a:solidFill>
+                  <a:srgbClr val="8397AB"/>
+                </a:solidFill>
+              </a:rPr>
+              <a:t>   AIEWF 2026 발표</a:t>
             </a:r>
           </a:p>
           <a:p>
             <a:pPr>
               <a:spcAft>
-                <a:spcPts val="0"/>
+                <a:spcPts val="1600"/>
               </a:spcAft>
             </a:pPr>
             <a:r>
-              <a:rPr sz="1300" b="1">
+              <a:rPr sz="1200">
+                <a:solidFill>
+                  <a:srgbClr val="31D3B1"/>
+                </a:solidFill>
+                <a:hlinkClick r:id="rId4"/>
+              </a:rPr>
+              <a:t>https://github-main-preview.ai.engineer/talks/xIt_mTQp6mY-loop-engineering-from-first-principles</a:t>
+            </a:r>
+          </a:p>
+          <a:p>
+            <a:r>
+              <a:rPr sz="2000" b="1">
                 <a:solidFill>
                   <a:srgbClr val="F5F8FD"/>
                 </a:solidFill>
               </a:rPr>
-              <a:t>Kyle Mistele — Loop Engineering from First Principles</a:t>
+              <a:t>Addy Osmani — Own the Outer Loop</a:t>
+            </a:r>
+            <a:r>
+              <a:rPr sz="1400" b="0">
+                <a:solidFill>
+                  <a:srgbClr val="8397AB"/>
+                </a:solidFill>
+              </a:rPr>
+              <a:t>   AIEWF 2026 키노트 (글 버전)</a:t>
             </a:r>
           </a:p>
           <a:p>
             <a:pPr>
               <a:spcAft>
-                <a:spcPts val="500"/>
+                <a:spcPts val="1600"/>
               </a:spcAft>
             </a:pPr>
             <a:r>
-              <a:rPr sz="1000" b="0">
+              <a:rPr sz="1200">
                 <a:solidFill>
                   <a:srgbClr val="31D3B1"/>
                 </a:solidFill>
-                <a:hlinkClick r:id="rId4"/>
-              </a:rPr>
-              <a:t>https://github-main-preview.ai.engineer/talks/xIt_mTQp6mY-loop-engineering-from-first-principles</a:t>
+                <a:hlinkClick r:id="rId13"/>
+              </a:rPr>
+              <a:t>https://addyosmani.com/blog/own-the-outer-loop/</a:t>
+            </a:r>
+          </a:p>
+          <a:p>
+            <a:r>
+              <a:rPr sz="2000" b="1">
+                <a:solidFill>
+                  <a:srgbClr val="F5F8FD"/>
+                </a:solidFill>
+              </a:rPr>
+              <a:t>The Great Loops Debate</a:t>
+            </a:r>
+            <a:r>
+              <a:rPr sz="1400" b="0">
+                <a:solidFill>
+                  <a:srgbClr val="8397AB"/>
+                </a:solidFill>
+              </a:rPr>
+              <a:t>   Latent Space 현장 기사</a:t>
             </a:r>
           </a:p>
           <a:p>
             <a:pPr>
               <a:spcAft>
-                <a:spcPts val="0"/>
+                <a:spcPts val="1600"/>
               </a:spcAft>
             </a:pPr>
             <a:r>
-              <a:rPr sz="1300" b="1">
+              <a:rPr sz="1200">
+                <a:solidFill>
+                  <a:srgbClr val="31D3B1"/>
+                </a:solidFill>
+                <a:hlinkClick r:id="rId6"/>
+              </a:rPr>
+              <a:t>https://www.latent.space/p/aiewf-daily-dispatch-locomotives</a:t>
+            </a:r>
+          </a:p>
+          <a:p>
+            <a:r>
+              <a:rPr sz="2000" b="1">
                 <a:solidFill>
                   <a:srgbClr val="F5F8FD"/>
                 </a:solidFill>
               </a:rPr>
-              <a:t>Latent Space — AIEWF Daily Dispatch: Loops, Software Factories &amp; FDEs (2026-07-01)</a:t>
+              <a:t>데모 저장소</a:t>
+            </a:r>
+            <a:r>
+              <a:rPr sz="1400" b="0">
+                <a:solidFill>
+                  <a:srgbClr val="8397AB"/>
+                </a:solidFill>
+              </a:rPr>
+              <a:t>   Java + Kiro CLI Outer Loop</a:t>
             </a:r>
           </a:p>
           <a:p>
             <a:pPr>
               <a:spcAft>
-                <a:spcPts val="500"/>
+                <a:spcPts val="1600"/>
               </a:spcAft>
             </a:pPr>
             <a:r>
-              <a:rPr sz="1000" b="0">
-                <a:solidFill>
-                  <a:srgbClr val="31D3B1"/>
-                </a:solidFill>
-                <a:hlinkClick r:id="rId5"/>
-              </a:rPr>
-              <a:t>https://www.latent.space/p/aiewf-daily-dispatch-loops</a:t>
-            </a:r>
-          </a:p>
-          <a:p>
-            <a:pPr>
-              <a:spcAft>
-                <a:spcPts val="0"/>
-              </a:spcAft>
-            </a:pPr>
-            <a:r>
-              <a:rPr sz="1300" b="1">
-                <a:solidFill>
-                  <a:srgbClr val="F5F8FD"/>
-                </a:solidFill>
-              </a:rPr>
-              <a:t>Latent Space — The great loops debate and the state of AI engineering (2026-07-03)</a:t>
-            </a:r>
-          </a:p>
-          <a:p>
-            <a:pPr>
-              <a:spcAft>
-                <a:spcPts val="500"/>
-              </a:spcAft>
-            </a:pPr>
-            <a:r>
-              <a:rPr sz="1000" b="0">
-                <a:solidFill>
-                  <a:srgbClr val="31D3B1"/>
-                </a:solidFill>
-                <a:hlinkClick r:id="rId6"/>
-              </a:rPr>
-              <a:t>https://www.latent.space/p/aiewf-daily-dispatch-locomotives</a:t>
-            </a:r>
-          </a:p>
-          <a:p>
-            <a:pPr>
-              <a:spcAft>
-                <a:spcPts val="0"/>
-              </a:spcAft>
-            </a:pPr>
-            <a:r>
-              <a:rPr sz="1300" b="1">
-                <a:solidFill>
-                  <a:srgbClr val="F5F8FD"/>
-                </a:solidFill>
-              </a:rPr>
-              <a:t>Business Insider — Forget prompt engineering: ‘Loop engineering’ is all the rage now (2026-06-20)</a:t>
-            </a:r>
-          </a:p>
-          <a:p>
-            <a:pPr>
-              <a:spcAft>
-                <a:spcPts val="500"/>
-              </a:spcAft>
-            </a:pPr>
-            <a:r>
-              <a:rPr sz="1000" b="0">
-                <a:solidFill>
-                  <a:srgbClr val="31D3B1"/>
-                </a:solidFill>
-                <a:hlinkClick r:id="rId7"/>
-              </a:rPr>
-              <a:t>https://www.businessinsider.com/what-are-loops-ai-engineering-tips-2026-6</a:t>
-            </a:r>
-          </a:p>
-          <a:p>
-            <a:pPr>
-              <a:spcAft>
-                <a:spcPts val="0"/>
-              </a:spcAft>
-            </a:pPr>
-            <a:r>
-              <a:rPr sz="1300" b="1">
-                <a:solidFill>
-                  <a:srgbClr val="F5F8FD"/>
-                </a:solidFill>
-              </a:rPr>
-              <a:t>Addy Osmani — Own the Outer Loop (AIEWF 2026 키노트 글 버전, 2026-07-15)</a:t>
-            </a:r>
-          </a:p>
-          <a:p>
-            <a:pPr>
-              <a:spcAft>
-                <a:spcPts val="500"/>
-              </a:spcAft>
-            </a:pPr>
-            <a:r>
-              <a:rPr sz="1000" b="0">
-                <a:solidFill>
-                  <a:srgbClr val="31D3B1"/>
-                </a:solidFill>
-                <a:hlinkClick r:id="rId13"/>
-              </a:rPr>
-              <a:t>https://addyosmani.com/blog/own-the-outer-loop/</a:t>
-            </a:r>
-          </a:p>
-          <a:p>
-            <a:pPr>
-              <a:spcAft>
-                <a:spcPts val="0"/>
-              </a:spcAft>
-            </a:pPr>
-            <a:r>
-              <a:rPr sz="1300" b="1">
-                <a:solidFill>
-                  <a:srgbClr val="F5F8FD"/>
-                </a:solidFill>
-              </a:rPr>
-              <a:t>Latent Space — Autoresearch and the tension between AI and human agency (2026-07-02)</a:t>
-            </a:r>
-          </a:p>
-          <a:p>
-            <a:pPr>
-              <a:spcAft>
-                <a:spcPts val="500"/>
-              </a:spcAft>
-            </a:pPr>
-            <a:r>
-              <a:rPr sz="1000" b="0">
-                <a:solidFill>
-                  <a:srgbClr val="31D3B1"/>
-                </a:solidFill>
-                <a:hlinkClick r:id="rId14"/>
-              </a:rPr>
-              <a:t>https://www.latent.space/p/aiewf-daily-dispatch-agency</a:t>
-            </a:r>
-          </a:p>
-          <a:p>
-            <a:pPr>
-              <a:spcAft>
-                <a:spcPts val="0"/>
-              </a:spcAft>
-            </a:pPr>
-            <a:r>
-              <a:rPr sz="1300" b="1">
-                <a:solidFill>
-                  <a:srgbClr val="F5F8FD"/>
-                </a:solidFill>
-              </a:rPr>
-              <a:t>Shawn Greyling — Loop engineering: from the inner loop to the outer loop (2026-06-14)</a:t>
-            </a:r>
-          </a:p>
-          <a:p>
-            <a:pPr>
-              <a:spcAft>
-                <a:spcPts val="500"/>
-              </a:spcAft>
-            </a:pPr>
-            <a:r>
-              <a:rPr sz="1000" b="0">
-                <a:solidFill>
-                  <a:srgbClr val="31D3B1"/>
-                </a:solidFill>
-                <a:hlinkClick r:id="rId12"/>
-              </a:rPr>
-              <a:t>https://www.shawngreyling.com/blog/loop-engineering</a:t>
-            </a:r>
-          </a:p>
-          <a:p>
-            <a:pPr>
-              <a:spcAft>
-                <a:spcPts val="0"/>
-              </a:spcAft>
-            </a:pPr>
-            <a:r>
-              <a:rPr sz="1300" b="1">
-                <a:solidFill>
-                  <a:srgbClr val="F5F8FD"/>
-                </a:solidFill>
-              </a:rPr>
-              <a:t>Philipp Schmid — Agents: Inner Loop vs Outer Loop (2026-02-20)</a:t>
-            </a:r>
-          </a:p>
-          <a:p>
-            <a:pPr>
-              <a:spcAft>
-                <a:spcPts val="500"/>
-              </a:spcAft>
-            </a:pPr>
-            <a:r>
-              <a:rPr sz="1000" b="0">
-                <a:solidFill>
-                  <a:srgbClr val="31D3B1"/>
-                </a:solidFill>
-                <a:hlinkClick r:id="rId10"/>
-              </a:rPr>
-              <a:t>https://www.philschmid.de/inner-loop-vs-outer-loop</a:t>
-            </a:r>
-          </a:p>
-          <a:p>
-            <a:pPr>
-              <a:spcAft>
-                <a:spcPts val="0"/>
-              </a:spcAft>
-            </a:pPr>
-            <a:r>
-              <a:rPr sz="1300" b="1">
-                <a:solidFill>
-                  <a:srgbClr val="F5F8FD"/>
-                </a:solidFill>
-              </a:rPr>
-              <a:t>The AI Automators — The 4 Levels of Loop Engineering (2026-07)</a:t>
-            </a:r>
-          </a:p>
-          <a:p>
-            <a:pPr>
-              <a:spcAft>
-                <a:spcPts val="500"/>
-              </a:spcAft>
-            </a:pPr>
-            <a:r>
-              <a:rPr sz="1000" b="0">
-                <a:solidFill>
-                  <a:srgbClr val="31D3B1"/>
-                </a:solidFill>
-                <a:hlinkClick r:id="rId11"/>
-              </a:rPr>
-              <a:t>https://www.theaiautomators.com/levels-of-loop-engineering/</a:t>
-            </a:r>
-          </a:p>
-          <a:p>
-            <a:pPr>
-              <a:spcAft>
-                <a:spcPts val="0"/>
-              </a:spcAft>
-            </a:pPr>
-            <a:r>
-              <a:rPr sz="1300" b="1">
-                <a:solidFill>
-                  <a:srgbClr val="F5F8FD"/>
-                </a:solidFill>
-              </a:rPr>
-              <a:t>Kiro CLI — headless / non-interactive 실행</a:t>
-            </a:r>
-          </a:p>
-          <a:p>
-            <a:pPr>
-              <a:spcAft>
-                <a:spcPts val="500"/>
-              </a:spcAft>
-            </a:pPr>
-            <a:r>
-              <a:rPr sz="1000" b="0">
-                <a:solidFill>
-                  <a:srgbClr val="31D3B1"/>
-                </a:solidFill>
-                <a:hlinkClick r:id="rId8"/>
-              </a:rPr>
-              <a:t>https://kiro.dev/docs/cli/headless/</a:t>
-            </a:r>
-          </a:p>
-          <a:p>
-            <a:pPr>
-              <a:spcAft>
-                <a:spcPts val="0"/>
-              </a:spcAft>
-            </a:pPr>
-            <a:r>
-              <a:rPr sz="1300" b="1">
-                <a:solidFill>
-                  <a:srgbClr val="F5F8FD"/>
-                </a:solidFill>
-              </a:rPr>
-              <a:t>데모 저장소 — Java + Kiro CLI Outer Loop</a:t>
-            </a:r>
-          </a:p>
-          <a:p>
-            <a:pPr>
-              <a:spcAft>
-                <a:spcPts val="500"/>
-              </a:spcAft>
-            </a:pPr>
-            <a:r>
-              <a:rPr sz="1000" b="0">
+              <a:rPr sz="1200">
                 <a:solidFill>
                   <a:srgbClr val="31D3B1"/>
                 </a:solidFill>

</xml_diff>

<commit_message>
Remove duplicate Controller slide; move its points into core-logic script
</commit_message>
<xml_diff>
--- a/docs/AI_Agent_Loop.pptx
+++ b/docs/AI_Agent_Loop.pptx
@@ -14,7 +14,6 @@
     <p:sldId id="277" r:id="rId29"/>
     <p:sldId id="261" r:id="rId12"/>
     <p:sldId id="278" r:id="rId30"/>
-    <p:sldId id="270" r:id="rId22"/>
     <p:sldId id="271" r:id="rId23"/>
     <p:sldId id="267" r:id="rId18"/>
     <p:sldId id="268" r:id="rId20"/>
@@ -1477,76 +1476,6 @@
 </p:notes>
 </file>
 
-<file path=ppt/notesSlides/notesSlide4.xml><?xml version="1.0" encoding="utf-8"?>
-<p:notes xmlns:a="http://schemas.openxmlformats.org/drawingml/2006/main" xmlns:p="http://schemas.openxmlformats.org/presentationml/2006/main" xmlns:r="http://schemas.openxmlformats.org/officeDocument/2006/relationships">
-  <p:cSld>
-    <p:spTree>
-      <p:nvGrpSpPr>
-        <p:cNvPr id="1" name=""/>
-        <p:cNvGrpSpPr/>
-        <p:nvPr/>
-      </p:nvGrpSpPr>
-      <p:grpSpPr>
-        <a:xfrm>
-          <a:off x="0" y="0"/>
-          <a:ext cx="0" cy="0"/>
-          <a:chOff x="0" y="0"/>
-          <a:chExt cx="0" cy="0"/>
-        </a:xfrm>
-      </p:grpSpPr>
-      <p:sp>
-        <p:nvSpPr>
-          <p:cNvPr id="2" name="Slide Image Placeholder 1"/>
-          <p:cNvSpPr>
-            <a:spLocks noGrp="1"/>
-          </p:cNvSpPr>
-          <p:nvPr>
-            <p:ph type="sldImg" idx="2"/>
-          </p:nvPr>
-        </p:nvSpPr>
-        <p:spPr/>
-      </p:sp>
-      <p:sp>
-        <p:nvSpPr>
-          <p:cNvPr id="3" name="Notes Placeholder 2"/>
-          <p:cNvSpPr>
-            <a:spLocks noGrp="1"/>
-          </p:cNvSpPr>
-          <p:nvPr>
-            <p:ph type="body" idx="3" sz="quarter"/>
-          </p:nvPr>
-        </p:nvSpPr>
-        <p:spPr/>
-        <p:txBody>
-          <a:bodyPr/>
-          <a:lstStyle/>
-          <a:p>
-            <a:r>
-              <a:t>Controller는 코드를 고치지 않는다. 일을 맡기고(②), 검수하고(③④), 다시 시킬지 끝낼지 정한다(⑤). 사람이 하던 "테스트 돌려보고 틀렸으면 다시 시키기"를 프로그램으로 만든 것. CI가 PR마다 테스트를 돌리는 것과 같고, 차이는 실패하면 AI를 다시 부른다는 점. Controller는 AI가 아니라 일반 if문이다 — 그래서 믿을 수 있다. 보라색 ②만 AI(Kiro)이고, 그 안에서 Kiro 자체의 Inner Loop(읽기→수정→답변)가 돈다.</a:t>
-            </a:r>
-          </a:p>
-        </p:txBody>
-      </p:sp>
-      <p:sp>
-        <p:nvSpPr>
-          <p:cNvPr id="4" name="Slide Number Placeholder 3"/>
-          <p:cNvSpPr>
-            <a:spLocks noGrp="1"/>
-          </p:cNvSpPr>
-          <p:nvPr>
-            <p:ph type="sldNum" idx="5" sz="quarter"/>
-          </p:nvPr>
-        </p:nvSpPr>
-        <p:spPr/>
-      </p:sp>
-    </p:spTree>
-  </p:cSld>
-  <p:clrMapOvr>
-    <a:masterClrMapping/>
-  </p:clrMapOvr>
-</p:notes>
-</file>
-
 <file path=ppt/notesSlides/notesSlide5.xml><?xml version="1.0" encoding="utf-8"?>
 <p:notes xmlns:a="http://schemas.openxmlformats.org/drawingml/2006/main" xmlns:p="http://schemas.openxmlformats.org/presentationml/2006/main" xmlns:r="http://schemas.openxmlformats.org/officeDocument/2006/relationships">
   <p:cSld>
@@ -1592,7 +1521,77 @@
           <a:lstStyle/>
           <a:p>
             <a:r>
-              <a:t>실제 loop.py는 로그·출력·기록 코드 포함 약 250줄이지만 반복의 뼈대는 이것뿐이다. 중요한 줄은 ④: Kiro가 무엇을 말했든 qa_gate()의 결과만으로 판정한다. 종료 경로는 PASS / GUARDRAIL_STOP / AGENT_ERROR / MAX_ITERATIONS 네 가지이며 모두 Controller가 결정한다.</a:t>
+              <a:t>[발표 스크립트 · 약 1분 30초]</a:t>
+            </a:r>
+          </a:p>
+          <a:p/>
+          <a:p>
+            <a:r>
+              <a:t>방금 본 그림에서 컨트롤러 칸, loop.py가 실제로 무슨 일을 하는지 코드로 보겠습니다. 길어 보이지만 뼈대는 이 15줄이 전부입니다. (실제 파일은 로그·기록 코드까지 약 250줄)</a:t>
+            </a:r>
+          </a:p>
+          <a:p/>
+          <a:p>
+            <a:r>
+              <a:t>① 먼저 verify.py로 현재 상태를 잽니다. 이미 PASS면 할 일이 없으니 끝냅니다.</a:t>
+            </a:r>
+          </a:p>
+          <a:p>
+            <a:r>
+              <a:t>그리고 최대 5번까지 반복합니다.</a:t>
+            </a:r>
+          </a:p>
+          <a:p>
+            <a:r>
+              <a:t>② 새 Kiro 세션을 실행합니다. 프롬프트에는 요구사항과 방금 본 실패 로그를 넣습니다. 매번 새 세션이라 Kiro는 이전 대화를 기억하지 못합니다. Controller가 넘겨주는 실패 로그가 유일한 기억입니다. 세션 하나는 300초가 넘으면 강제로 끝냅니다.</a:t>
+            </a:r>
+          </a:p>
+          <a:p>
+            <a:r>
+              <a:t>③ Kiro가 끝나면, 먼저 테스트 파일이나 verify.py, loop.py를 건드렸는지 확인합니다. 시험지를 고치는 부정행위죠. 건드렸으면 원래대로 되돌리고 바로 멈춥니다.</a:t>
+            </a:r>
+          </a:p>
+          <a:p>
+            <a:r>
+              <a:t>④ 그다음 Kiro가 "고쳤습니다"라고 한 말은 무시하고, verify.py를 직접 다시 돌립니다. 결과와 코드 변경은 .loop/ 폴더에 기록합니다.</a:t>
+            </a:r>
+          </a:p>
+          <a:p>
+            <a:r>
+              <a:t>⑤ PASS면 성공으로 끝. Kiro가 오류나 시간 초과로 실패했으면 멈춥니다. FAIL이면 그 로그를 들고 다음 회차로 갑니다.</a:t>
+            </a:r>
+          </a:p>
+          <a:p>
+            <a:r>
+              <a:t>5번 다 실패하면 실패로 끝냅니다.</a:t>
+            </a:r>
+          </a:p>
+          <a:p/>
+          <a:p>
+            <a:r>
+              <a:t>정리하면 끝나는 길은 네 가지입니다. PASS, 보호 파일 변조, Kiro 오류, 최대 횟수 초과. 모두 AI가 아니라 Controller가 정합니다.</a:t>
+            </a:r>
+          </a:p>
+          <a:p/>
+          <a:p>
+            <a:r>
+              <a:t>(하단) Controller는 AI가 아닙니다. 테스트 결과 PASS/FAIL만 보고 if문으로 결정합니다. 그래서 믿을 수 있습니다.</a:t>
+            </a:r>
+          </a:p>
+          <a:p/>
+          <a:p>
+            <a:r>
+              <a:t>[예상 질문]</a:t>
+            </a:r>
+          </a:p>
+          <a:p>
+            <a:r>
+              <a:t>Q. 왜 같은 세션을 이어가지 않고 매번 새 세션을 여나요?</a:t>
+            </a:r>
+          </a:p>
+          <a:p>
+            <a:r>
+              <a:t>A. 긴 세션은 실패한 시도와 오래된 추론이 쌓여 점점 흐려집니다. 매번 깨끗한 세션에서 시작하고, 필요한 정보(실패 로그)만 넘기는 게 더 안정적입니다. Geoffrey Huntley의 Ralph Loop도 같은 방식입니다.</a:t>
             </a:r>
           </a:p>
         </p:txBody>
@@ -5043,1210 +5042,7 @@
                   <a:srgbClr val="8397AB"/>
                 </a:solidFill>
               </a:rPr>
-              <a:t>AI Agent Loop · 2026.10.21                                     01 / 19</a:t>
-            </a:r>
-          </a:p>
-        </p:txBody>
-      </p:sp>
-    </p:spTree>
-  </p:cSld>
-  <p:clrMapOvr>
-    <a:masterClrMapping/>
-  </p:clrMapOvr>
-</p:sld>
-</file>
-
-<file path=ppt/slides/slide10.xml><?xml version="1.0" encoding="utf-8"?>
-<p:sld xmlns:a="http://schemas.openxmlformats.org/drawingml/2006/main" xmlns:p="http://schemas.openxmlformats.org/presentationml/2006/main" xmlns:r="http://schemas.openxmlformats.org/officeDocument/2006/relationships">
-  <p:cSld>
-    <p:bg>
-      <p:bgPr>
-        <a:solidFill>
-          <a:srgbClr val="0E1625"/>
-        </a:solidFill>
-        <a:effectLst/>
-      </p:bgPr>
-    </p:bg>
-    <p:spTree>
-      <p:nvGrpSpPr>
-        <p:cNvPr id="1" name=""/>
-        <p:cNvGrpSpPr/>
-        <p:nvPr/>
-      </p:nvGrpSpPr>
-      <p:grpSpPr/>
-      <p:sp>
-        <p:nvSpPr>
-          <p:cNvPr id="2" name="Rectangle 1"/>
-          <p:cNvSpPr/>
-          <p:nvPr/>
-        </p:nvSpPr>
-        <p:spPr>
-          <a:xfrm>
-            <a:off x="594360" y="658368"/>
-            <a:ext cx="82296" cy="585216"/>
-          </a:xfrm>
-          <a:prstGeom prst="rect">
-            <a:avLst/>
-          </a:prstGeom>
-          <a:solidFill>
-            <a:srgbClr val="31D3B1"/>
-          </a:solidFill>
-          <a:ln>
-            <a:noFill/>
-          </a:ln>
-        </p:spPr>
-        <p:style>
-          <a:lnRef idx="1">
-            <a:schemeClr val="accent1"/>
-          </a:lnRef>
-          <a:fillRef idx="3">
-            <a:schemeClr val="accent1"/>
-          </a:fillRef>
-          <a:effectRef idx="2">
-            <a:schemeClr val="accent1"/>
-          </a:effectRef>
-          <a:fontRef idx="minor">
-            <a:schemeClr val="lt1"/>
-          </a:fontRef>
-        </p:style>
-        <p:txBody>
-          <a:bodyPr rtlCol="0" anchor="ctr"/>
-          <a:lstStyle/>
-          <a:p>
-            <a:pPr algn="ctr"/>
-          </a:p>
-        </p:txBody>
-      </p:sp>
-      <p:sp>
-        <p:nvSpPr>
-          <p:cNvPr id="3" name="TextBox 2"/>
-          <p:cNvSpPr txBox="1"/>
-          <p:nvPr/>
-        </p:nvSpPr>
-        <p:spPr>
-          <a:xfrm>
-            <a:off x="868680" y="640080"/>
-            <a:ext cx="10515600" cy="731520"/>
-          </a:xfrm>
-          <a:prstGeom prst="rect">
-            <a:avLst/>
-          </a:prstGeom>
-          <a:noFill/>
-        </p:spPr>
-        <p:txBody>
-          <a:bodyPr wrap="square">
-            <a:spAutoFit/>
-          </a:bodyPr>
-          <a:lstStyle/>
-          <a:p>
-            <a:r>
-              <a:rPr sz="3200" b="1">
-                <a:solidFill>
-                  <a:srgbClr val="F5F8FD"/>
-                </a:solidFill>
-              </a:rPr>
-              <a:t>Controller(loop.py)는 무엇을 하나?</a:t>
-            </a:r>
-          </a:p>
-        </p:txBody>
-      </p:sp>
-      <p:sp>
-        <p:nvSpPr>
-          <p:cNvPr id="4" name="TextBox 3"/>
-          <p:cNvSpPr txBox="1"/>
-          <p:nvPr/>
-        </p:nvSpPr>
-        <p:spPr>
-          <a:xfrm>
-            <a:off x="868680" y="6492240"/>
-            <a:ext cx="10515600" cy="201168"/>
-          </a:xfrm>
-          <a:prstGeom prst="rect">
-            <a:avLst/>
-          </a:prstGeom>
-          <a:noFill/>
-        </p:spPr>
-        <p:txBody>
-          <a:bodyPr wrap="square">
-            <a:spAutoFit/>
-          </a:bodyPr>
-          <a:lstStyle/>
-          <a:p>
-            <a:r>
-              <a:rPr sz="1000" b="0">
-                <a:solidFill>
-                  <a:srgbClr val="8397AB"/>
-                </a:solidFill>
-              </a:rPr>
-              <a:t>AI Agent Loop · 2026.10.21                                     10 / 19</a:t>
-            </a:r>
-          </a:p>
-        </p:txBody>
-      </p:sp>
-      <p:sp>
-        <p:nvSpPr>
-          <p:cNvPr id="5" name="TextBox 4"/>
-          <p:cNvSpPr txBox="1"/>
-          <p:nvPr/>
-        </p:nvSpPr>
-        <p:spPr>
-          <a:xfrm>
-            <a:off x="868680" y="1325880"/>
-            <a:ext cx="10515600" cy="320040"/>
-          </a:xfrm>
-          <a:prstGeom prst="rect">
-            <a:avLst/>
-          </a:prstGeom>
-          <a:noFill/>
-        </p:spPr>
-        <p:txBody>
-          <a:bodyPr wrap="square">
-            <a:spAutoFit/>
-          </a:bodyPr>
-          <a:lstStyle/>
-          <a:p>
-            <a:r>
-              <a:rPr sz="1400" b="0">
-                <a:solidFill>
-                  <a:srgbClr val="8397AB"/>
-                </a:solidFill>
-              </a:rPr>
-              <a:t>감독관 = loop.py (AI 아님, if문)       작업자 = Kiro CLI (AI)</a:t>
-            </a:r>
-          </a:p>
-        </p:txBody>
-      </p:sp>
-      <p:sp>
-        <p:nvSpPr>
-          <p:cNvPr id="6" name="Rounded Rectangle 5"/>
-          <p:cNvSpPr/>
-          <p:nvPr/>
-        </p:nvSpPr>
-        <p:spPr>
-          <a:xfrm>
-            <a:off x="868680" y="1783080"/>
-            <a:ext cx="1828800" cy="1188720"/>
-          </a:xfrm>
-          <a:prstGeom prst="roundRect">
-            <a:avLst>
-              <a:gd name="adj" fmla="val 8000"/>
-            </a:avLst>
-          </a:prstGeom>
-          <a:solidFill>
-            <a:srgbClr val="162236"/>
-          </a:solidFill>
-          <a:ln w="15875">
-            <a:solidFill>
-              <a:srgbClr val="2A3B52"/>
-            </a:solidFill>
-          </a:ln>
-        </p:spPr>
-        <p:style>
-          <a:lnRef idx="1">
-            <a:schemeClr val="accent1"/>
-          </a:lnRef>
-          <a:fillRef idx="3">
-            <a:schemeClr val="accent1"/>
-          </a:fillRef>
-          <a:effectRef idx="2">
-            <a:schemeClr val="accent1"/>
-          </a:effectRef>
-          <a:fontRef idx="minor">
-            <a:schemeClr val="lt1"/>
-          </a:fontRef>
-        </p:style>
-        <p:txBody>
-          <a:bodyPr rtlCol="0" anchor="ctr" wrap="square" lIns="64008" rIns="64008"/>
-          <a:lstStyle/>
-          <a:p>
-            <a:pPr algn="ctr"/>
-            <a:r>
-              <a:rPr sz="1600" b="1">
-                <a:solidFill>
-                  <a:srgbClr val="F5F8FD"/>
-                </a:solidFill>
-              </a:rPr>
-              <a:t>① 검사</a:t>
-            </a:r>
-          </a:p>
-          <a:p>
-            <a:pPr algn="ctr"/>
-            <a:r>
-              <a:rPr sz="1400" b="0">
-                <a:solidFill>
-                  <a:srgbClr val="CFDEEB"/>
-                </a:solidFill>
-              </a:rPr>
-              <a:t>verify.py 실행</a:t>
-            </a:r>
-          </a:p>
-          <a:p>
-            <a:pPr algn="ctr"/>
-            <a:r>
-              <a:rPr sz="1200" b="0">
-                <a:solidFill>
-                  <a:srgbClr val="8397AB"/>
-                </a:solidFill>
-              </a:rPr>
-              <a:t>Java 컴파일+테스트</a:t>
-            </a:r>
-          </a:p>
-        </p:txBody>
-      </p:sp>
-      <p:sp>
-        <p:nvSpPr>
-          <p:cNvPr id="7" name="Rounded Rectangle 6"/>
-          <p:cNvSpPr/>
-          <p:nvPr/>
-        </p:nvSpPr>
-        <p:spPr>
-          <a:xfrm>
-            <a:off x="3040380" y="1783080"/>
-            <a:ext cx="1828800" cy="1188720"/>
-          </a:xfrm>
-          <a:prstGeom prst="roundRect">
-            <a:avLst>
-              <a:gd name="adj" fmla="val 8000"/>
-            </a:avLst>
-          </a:prstGeom>
-          <a:solidFill>
-            <a:srgbClr val="1E183D"/>
-          </a:solidFill>
-          <a:ln w="25400">
-            <a:solidFill>
-              <a:srgbClr val="7C5CFF"/>
-            </a:solidFill>
-          </a:ln>
-        </p:spPr>
-        <p:style>
-          <a:lnRef idx="1">
-            <a:schemeClr val="accent1"/>
-          </a:lnRef>
-          <a:fillRef idx="3">
-            <a:schemeClr val="accent1"/>
-          </a:fillRef>
-          <a:effectRef idx="2">
-            <a:schemeClr val="accent1"/>
-          </a:effectRef>
-          <a:fontRef idx="minor">
-            <a:schemeClr val="lt1"/>
-          </a:fontRef>
-        </p:style>
-        <p:txBody>
-          <a:bodyPr rtlCol="0" anchor="ctr" wrap="square" lIns="64008" rIns="64008"/>
-          <a:lstStyle/>
-          <a:p>
-            <a:pPr algn="ctr"/>
-            <a:r>
-              <a:rPr sz="1600" b="1">
-                <a:solidFill>
-                  <a:srgbClr val="F5F8FD"/>
-                </a:solidFill>
-              </a:rPr>
-              <a:t>② 작업 지시</a:t>
-            </a:r>
-          </a:p>
-          <a:p>
-            <a:pPr algn="ctr"/>
-            <a:r>
-              <a:rPr sz="1400" b="0">
-                <a:solidFill>
-                  <a:srgbClr val="CFDEEB"/>
-                </a:solidFill>
-              </a:rPr>
-              <a:t>새 Kiro 세션 실행</a:t>
-            </a:r>
-          </a:p>
-          <a:p>
-            <a:pPr algn="ctr"/>
-            <a:r>
-              <a:rPr sz="1200" b="0">
-                <a:solidFill>
-                  <a:srgbClr val="8397AB"/>
-                </a:solidFill>
-              </a:rPr>
-              <a:t>요구사항 + 실패 로그</a:t>
-            </a:r>
-          </a:p>
-        </p:txBody>
-      </p:sp>
-      <p:sp>
-        <p:nvSpPr>
-          <p:cNvPr id="8" name="Rounded Rectangle 7"/>
-          <p:cNvSpPr/>
-          <p:nvPr/>
-        </p:nvSpPr>
-        <p:spPr>
-          <a:xfrm>
-            <a:off x="5212080" y="1783080"/>
-            <a:ext cx="1828800" cy="1188720"/>
-          </a:xfrm>
-          <a:prstGeom prst="roundRect">
-            <a:avLst>
-              <a:gd name="adj" fmla="val 8000"/>
-            </a:avLst>
-          </a:prstGeom>
-          <a:solidFill>
-            <a:srgbClr val="162236"/>
-          </a:solidFill>
-          <a:ln w="15875">
-            <a:solidFill>
-              <a:srgbClr val="2A3B52"/>
-            </a:solidFill>
-          </a:ln>
-        </p:spPr>
-        <p:style>
-          <a:lnRef idx="1">
-            <a:schemeClr val="accent1"/>
-          </a:lnRef>
-          <a:fillRef idx="3">
-            <a:schemeClr val="accent1"/>
-          </a:fillRef>
-          <a:effectRef idx="2">
-            <a:schemeClr val="accent1"/>
-          </a:effectRef>
-          <a:fontRef idx="minor">
-            <a:schemeClr val="lt1"/>
-          </a:fontRef>
-        </p:style>
-        <p:txBody>
-          <a:bodyPr rtlCol="0" anchor="ctr" wrap="square" lIns="64008" rIns="64008"/>
-          <a:lstStyle/>
-          <a:p>
-            <a:pPr algn="ctr"/>
-            <a:r>
-              <a:rPr sz="1600" b="1">
-                <a:solidFill>
-                  <a:srgbClr val="F5F8FD"/>
-                </a:solidFill>
-              </a:rPr>
-              <a:t>③ 변조 검사</a:t>
-            </a:r>
-          </a:p>
-          <a:p>
-            <a:pPr algn="ctr"/>
-            <a:r>
-              <a:rPr sz="1400" b="0">
-                <a:solidFill>
-                  <a:srgbClr val="CFDEEB"/>
-                </a:solidFill>
-              </a:rPr>
-              <a:t>테스트·검증기</a:t>
-            </a:r>
-          </a:p>
-          <a:p>
-            <a:pPr algn="ctr"/>
-            <a:r>
-              <a:rPr sz="1200" b="0">
-                <a:solidFill>
-                  <a:srgbClr val="8397AB"/>
-                </a:solidFill>
-              </a:rPr>
-              <a:t>바뀌었으면 복원·중단</a:t>
-            </a:r>
-          </a:p>
-        </p:txBody>
-      </p:sp>
-      <p:sp>
-        <p:nvSpPr>
-          <p:cNvPr id="9" name="Rounded Rectangle 8"/>
-          <p:cNvSpPr/>
-          <p:nvPr/>
-        </p:nvSpPr>
-        <p:spPr>
-          <a:xfrm>
-            <a:off x="7383780" y="1783080"/>
-            <a:ext cx="1828800" cy="1188720"/>
-          </a:xfrm>
-          <a:prstGeom prst="roundRect">
-            <a:avLst>
-              <a:gd name="adj" fmla="val 8000"/>
-            </a:avLst>
-          </a:prstGeom>
-          <a:solidFill>
-            <a:srgbClr val="162236"/>
-          </a:solidFill>
-          <a:ln w="15875">
-            <a:solidFill>
-              <a:srgbClr val="2A3B52"/>
-            </a:solidFill>
-          </a:ln>
-        </p:spPr>
-        <p:style>
-          <a:lnRef idx="1">
-            <a:schemeClr val="accent1"/>
-          </a:lnRef>
-          <a:fillRef idx="3">
-            <a:schemeClr val="accent1"/>
-          </a:fillRef>
-          <a:effectRef idx="2">
-            <a:schemeClr val="accent1"/>
-          </a:effectRef>
-          <a:fontRef idx="minor">
-            <a:schemeClr val="lt1"/>
-          </a:fontRef>
-        </p:style>
-        <p:txBody>
-          <a:bodyPr rtlCol="0" anchor="ctr" wrap="square" lIns="64008" rIns="64008"/>
-          <a:lstStyle/>
-          <a:p>
-            <a:pPr algn="ctr"/>
-            <a:r>
-              <a:rPr sz="1600" b="1">
-                <a:solidFill>
-                  <a:srgbClr val="F5F8FD"/>
-                </a:solidFill>
-              </a:rPr>
-              <a:t>④ 재검사</a:t>
-            </a:r>
-          </a:p>
-          <a:p>
-            <a:pPr algn="ctr"/>
-            <a:r>
-              <a:rPr sz="1400" b="0">
-                <a:solidFill>
-                  <a:srgbClr val="CFDEEB"/>
-                </a:solidFill>
-              </a:rPr>
-              <a:t>verify.py 직접 실행</a:t>
-            </a:r>
-          </a:p>
-          <a:p>
-            <a:pPr algn="ctr"/>
-            <a:r>
-              <a:rPr sz="1200" b="0">
-                <a:solidFill>
-                  <a:srgbClr val="8397AB"/>
-                </a:solidFill>
-              </a:rPr>
-              <a:t>Kiro의 "고쳤다"는 무시</a:t>
-            </a:r>
-          </a:p>
-        </p:txBody>
-      </p:sp>
-      <p:sp>
-        <p:nvSpPr>
-          <p:cNvPr id="10" name="Rounded Rectangle 9"/>
-          <p:cNvSpPr/>
-          <p:nvPr/>
-        </p:nvSpPr>
-        <p:spPr>
-          <a:xfrm>
-            <a:off x="9555480" y="1783080"/>
-            <a:ext cx="1828800" cy="1188720"/>
-          </a:xfrm>
-          <a:prstGeom prst="roundRect">
-            <a:avLst>
-              <a:gd name="adj" fmla="val 8000"/>
-            </a:avLst>
-          </a:prstGeom>
-          <a:solidFill>
-            <a:srgbClr val="162236"/>
-          </a:solidFill>
-          <a:ln w="25400">
-            <a:solidFill>
-              <a:srgbClr val="31D3B1"/>
-            </a:solidFill>
-          </a:ln>
-        </p:spPr>
-        <p:style>
-          <a:lnRef idx="1">
-            <a:schemeClr val="accent1"/>
-          </a:lnRef>
-          <a:fillRef idx="3">
-            <a:schemeClr val="accent1"/>
-          </a:fillRef>
-          <a:effectRef idx="2">
-            <a:schemeClr val="accent1"/>
-          </a:effectRef>
-          <a:fontRef idx="minor">
-            <a:schemeClr val="lt1"/>
-          </a:fontRef>
-        </p:style>
-        <p:txBody>
-          <a:bodyPr rtlCol="0" anchor="ctr" wrap="square" lIns="64008" rIns="64008"/>
-          <a:lstStyle/>
-          <a:p>
-            <a:pPr algn="ctr"/>
-            <a:r>
-              <a:rPr sz="1600" b="1">
-                <a:solidFill>
-                  <a:srgbClr val="F5F8FD"/>
-                </a:solidFill>
-              </a:rPr>
-              <a:t>⑤ 판정</a:t>
-            </a:r>
-          </a:p>
-          <a:p>
-            <a:pPr algn="ctr"/>
-            <a:r>
-              <a:rPr sz="1400" b="1">
-                <a:solidFill>
-                  <a:srgbClr val="4ADE80"/>
-                </a:solidFill>
-              </a:rPr>
-              <a:t>PASS → 종료</a:t>
-            </a:r>
-          </a:p>
-          <a:p>
-            <a:pPr algn="ctr"/>
-            <a:r>
-              <a:rPr sz="1400" b="1">
-                <a:solidFill>
-                  <a:srgbClr val="FF6B6B"/>
-                </a:solidFill>
-              </a:rPr>
-              <a:t>FAIL → ②로</a:t>
-            </a:r>
-          </a:p>
-        </p:txBody>
-      </p:sp>
-      <p:cxnSp>
-        <p:nvCxnSpPr>
-          <p:cNvPr id="11" name="Connector 10"/>
-          <p:cNvCxnSpPr/>
-          <p:nvPr/>
-        </p:nvCxnSpPr>
-        <p:spPr>
-          <a:xfrm>
-            <a:off x="2697480" y="2377440"/>
-            <a:ext cx="342900" cy="0"/>
-          </a:xfrm>
-          <a:prstGeom prst="line">
-            <a:avLst/>
-          </a:prstGeom>
-          <a:ln w="25400">
-            <a:solidFill>
-              <a:srgbClr val="CFDEEB"/>
-            </a:solidFill>
-            <a:tailEnd type="triangle" w="med" len="med"/>
-          </a:ln>
-        </p:spPr>
-        <p:style>
-          <a:lnRef idx="2">
-            <a:schemeClr val="accent1"/>
-          </a:lnRef>
-          <a:fillRef idx="0">
-            <a:schemeClr val="accent1"/>
-          </a:fillRef>
-          <a:effectRef idx="1">
-            <a:schemeClr val="accent1"/>
-          </a:effectRef>
-          <a:fontRef idx="minor">
-            <a:schemeClr val="tx1"/>
-          </a:fontRef>
-        </p:style>
-      </p:cxnSp>
-      <p:cxnSp>
-        <p:nvCxnSpPr>
-          <p:cNvPr id="12" name="Connector 11"/>
-          <p:cNvCxnSpPr/>
-          <p:nvPr/>
-        </p:nvCxnSpPr>
-        <p:spPr>
-          <a:xfrm>
-            <a:off x="4869180" y="2377440"/>
-            <a:ext cx="342900" cy="0"/>
-          </a:xfrm>
-          <a:prstGeom prst="line">
-            <a:avLst/>
-          </a:prstGeom>
-          <a:ln w="25400">
-            <a:solidFill>
-              <a:srgbClr val="CFDEEB"/>
-            </a:solidFill>
-            <a:tailEnd type="triangle" w="med" len="med"/>
-          </a:ln>
-        </p:spPr>
-        <p:style>
-          <a:lnRef idx="2">
-            <a:schemeClr val="accent1"/>
-          </a:lnRef>
-          <a:fillRef idx="0">
-            <a:schemeClr val="accent1"/>
-          </a:fillRef>
-          <a:effectRef idx="1">
-            <a:schemeClr val="accent1"/>
-          </a:effectRef>
-          <a:fontRef idx="minor">
-            <a:schemeClr val="tx1"/>
-          </a:fontRef>
-        </p:style>
-      </p:cxnSp>
-      <p:cxnSp>
-        <p:nvCxnSpPr>
-          <p:cNvPr id="13" name="Connector 12"/>
-          <p:cNvCxnSpPr/>
-          <p:nvPr/>
-        </p:nvCxnSpPr>
-        <p:spPr>
-          <a:xfrm>
-            <a:off x="7040880" y="2377440"/>
-            <a:ext cx="342900" cy="0"/>
-          </a:xfrm>
-          <a:prstGeom prst="line">
-            <a:avLst/>
-          </a:prstGeom>
-          <a:ln w="25400">
-            <a:solidFill>
-              <a:srgbClr val="CFDEEB"/>
-            </a:solidFill>
-            <a:tailEnd type="triangle" w="med" len="med"/>
-          </a:ln>
-        </p:spPr>
-        <p:style>
-          <a:lnRef idx="2">
-            <a:schemeClr val="accent1"/>
-          </a:lnRef>
-          <a:fillRef idx="0">
-            <a:schemeClr val="accent1"/>
-          </a:fillRef>
-          <a:effectRef idx="1">
-            <a:schemeClr val="accent1"/>
-          </a:effectRef>
-          <a:fontRef idx="minor">
-            <a:schemeClr val="tx1"/>
-          </a:fontRef>
-        </p:style>
-      </p:cxnSp>
-      <p:cxnSp>
-        <p:nvCxnSpPr>
-          <p:cNvPr id="14" name="Connector 13"/>
-          <p:cNvCxnSpPr/>
-          <p:nvPr/>
-        </p:nvCxnSpPr>
-        <p:spPr>
-          <a:xfrm>
-            <a:off x="9212580" y="2377440"/>
-            <a:ext cx="342900" cy="0"/>
-          </a:xfrm>
-          <a:prstGeom prst="line">
-            <a:avLst/>
-          </a:prstGeom>
-          <a:ln w="25400">
-            <a:solidFill>
-              <a:srgbClr val="CFDEEB"/>
-            </a:solidFill>
-            <a:tailEnd type="triangle" w="med" len="med"/>
-          </a:ln>
-        </p:spPr>
-        <p:style>
-          <a:lnRef idx="2">
-            <a:schemeClr val="accent1"/>
-          </a:lnRef>
-          <a:fillRef idx="0">
-            <a:schemeClr val="accent1"/>
-          </a:fillRef>
-          <a:effectRef idx="1">
-            <a:schemeClr val="accent1"/>
-          </a:effectRef>
-          <a:fontRef idx="minor">
-            <a:schemeClr val="tx1"/>
-          </a:fontRef>
-        </p:style>
-      </p:cxnSp>
-      <p:cxnSp>
-        <p:nvCxnSpPr>
-          <p:cNvPr id="15" name="Connector 14"/>
-          <p:cNvCxnSpPr/>
-          <p:nvPr/>
-        </p:nvCxnSpPr>
-        <p:spPr>
-          <a:xfrm>
-            <a:off x="10469880" y="2971800"/>
-            <a:ext cx="0" cy="457200"/>
-          </a:xfrm>
-          <a:prstGeom prst="line">
-            <a:avLst/>
-          </a:prstGeom>
-          <a:ln w="25400">
-            <a:solidFill>
-              <a:srgbClr val="FF6B6B"/>
-            </a:solidFill>
-          </a:ln>
-        </p:spPr>
-        <p:style>
-          <a:lnRef idx="2">
-            <a:schemeClr val="accent1"/>
-          </a:lnRef>
-          <a:fillRef idx="0">
-            <a:schemeClr val="accent1"/>
-          </a:fillRef>
-          <a:effectRef idx="1">
-            <a:schemeClr val="accent1"/>
-          </a:effectRef>
-          <a:fontRef idx="minor">
-            <a:schemeClr val="tx1"/>
-          </a:fontRef>
-        </p:style>
-      </p:cxnSp>
-      <p:cxnSp>
-        <p:nvCxnSpPr>
-          <p:cNvPr id="16" name="Connector 15"/>
-          <p:cNvCxnSpPr/>
-          <p:nvPr/>
-        </p:nvCxnSpPr>
-        <p:spPr>
-          <a:xfrm flipH="1">
-            <a:off x="3954780" y="3429000"/>
-            <a:ext cx="6515100" cy="0"/>
-          </a:xfrm>
-          <a:prstGeom prst="line">
-            <a:avLst/>
-          </a:prstGeom>
-          <a:ln w="25400">
-            <a:solidFill>
-              <a:srgbClr val="FF6B6B"/>
-            </a:solidFill>
-          </a:ln>
-        </p:spPr>
-        <p:style>
-          <a:lnRef idx="2">
-            <a:schemeClr val="accent1"/>
-          </a:lnRef>
-          <a:fillRef idx="0">
-            <a:schemeClr val="accent1"/>
-          </a:fillRef>
-          <a:effectRef idx="1">
-            <a:schemeClr val="accent1"/>
-          </a:effectRef>
-          <a:fontRef idx="minor">
-            <a:schemeClr val="tx1"/>
-          </a:fontRef>
-        </p:style>
-      </p:cxnSp>
-      <p:cxnSp>
-        <p:nvCxnSpPr>
-          <p:cNvPr id="17" name="Connector 16"/>
-          <p:cNvCxnSpPr/>
-          <p:nvPr/>
-        </p:nvCxnSpPr>
-        <p:spPr>
-          <a:xfrm flipV="1">
-            <a:off x="3954780" y="2971800"/>
-            <a:ext cx="0" cy="457200"/>
-          </a:xfrm>
-          <a:prstGeom prst="line">
-            <a:avLst/>
-          </a:prstGeom>
-          <a:ln w="25400">
-            <a:solidFill>
-              <a:srgbClr val="FF6B6B"/>
-            </a:solidFill>
-            <a:tailEnd type="triangle" w="med" len="med"/>
-          </a:ln>
-        </p:spPr>
-        <p:style>
-          <a:lnRef idx="2">
-            <a:schemeClr val="accent1"/>
-          </a:lnRef>
-          <a:fillRef idx="0">
-            <a:schemeClr val="accent1"/>
-          </a:fillRef>
-          <a:effectRef idx="1">
-            <a:schemeClr val="accent1"/>
-          </a:effectRef>
-          <a:fontRef idx="minor">
-            <a:schemeClr val="tx1"/>
-          </a:fontRef>
-        </p:style>
-      </p:cxnSp>
-      <p:sp>
-        <p:nvSpPr>
-          <p:cNvPr id="18" name="TextBox 17"/>
-          <p:cNvSpPr txBox="1"/>
-          <p:nvPr/>
-        </p:nvSpPr>
-        <p:spPr>
-          <a:xfrm>
-            <a:off x="4046220" y="3456432"/>
-            <a:ext cx="6515100" cy="320040"/>
-          </a:xfrm>
-          <a:prstGeom prst="rect">
-            <a:avLst/>
-          </a:prstGeom>
-          <a:noFill/>
-        </p:spPr>
-        <p:txBody>
-          <a:bodyPr wrap="square">
-            <a:spAutoFit/>
-          </a:bodyPr>
-          <a:lstStyle/>
-          <a:p>
-            <a:r>
-              <a:rPr sz="1300" b="1">
-                <a:solidFill>
-                  <a:srgbClr val="FF6B6B"/>
-                </a:solidFill>
-              </a:rPr>
-              <a:t>FAIL: 실패 로그를 들고 새 Kiro 세션 시작 (사람 입력 없음)</a:t>
-            </a:r>
-          </a:p>
-        </p:txBody>
-      </p:sp>
-      <p:sp>
-        <p:nvSpPr>
-          <p:cNvPr id="19" name="Rounded Rectangle 18"/>
-          <p:cNvSpPr/>
-          <p:nvPr/>
-        </p:nvSpPr>
-        <p:spPr>
-          <a:xfrm>
-            <a:off x="868680" y="3886200"/>
-            <a:ext cx="4000500" cy="640080"/>
-          </a:xfrm>
-          <a:prstGeom prst="roundRect">
-            <a:avLst>
-              <a:gd name="adj" fmla="val 8000"/>
-            </a:avLst>
-          </a:prstGeom>
-          <a:solidFill>
-            <a:srgbClr val="0E1625"/>
-          </a:solidFill>
-          <a:ln w="15875">
-            <a:solidFill>
-              <a:srgbClr val="7C5CFF"/>
-            </a:solidFill>
-            <a:prstDash val="dash"/>
-          </a:ln>
-        </p:spPr>
-        <p:style>
-          <a:lnRef idx="1">
-            <a:schemeClr val="accent1"/>
-          </a:lnRef>
-          <a:fillRef idx="3">
-            <a:schemeClr val="accent1"/>
-          </a:fillRef>
-          <a:effectRef idx="2">
-            <a:schemeClr val="accent1"/>
-          </a:effectRef>
-          <a:fontRef idx="minor">
-            <a:schemeClr val="lt1"/>
-          </a:fontRef>
-        </p:style>
-        <p:txBody>
-          <a:bodyPr rtlCol="0" anchor="ctr" wrap="square" lIns="64008" rIns="64008"/>
-          <a:lstStyle/>
-          <a:p>
-            <a:pPr algn="ctr"/>
-            <a:r>
-              <a:rPr sz="1300" b="1">
-                <a:solidFill>
-                  <a:srgbClr val="7C5CFF"/>
-                </a:solidFill>
-              </a:rPr>
-              <a:t>Kiro 내부 (Inner Loop)</a:t>
-            </a:r>
-          </a:p>
-          <a:p>
-            <a:pPr algn="ctr"/>
-            <a:r>
-              <a:rPr sz="1300" b="0">
-                <a:solidFill>
-                  <a:srgbClr val="CFDEEB"/>
-                </a:solidFill>
-              </a:rPr>
-              <a:t>파일 읽기 → 수정 → "고쳤습니다" → 종료</a:t>
-            </a:r>
-          </a:p>
-        </p:txBody>
-      </p:sp>
-      <p:sp>
-        <p:nvSpPr>
-          <p:cNvPr id="20" name="Rounded Rectangle 19"/>
-          <p:cNvSpPr/>
-          <p:nvPr/>
-        </p:nvSpPr>
-        <p:spPr>
-          <a:xfrm>
-            <a:off x="868680" y="4709160"/>
-            <a:ext cx="3383280" cy="1005840"/>
-          </a:xfrm>
-          <a:prstGeom prst="roundRect">
-            <a:avLst>
-              <a:gd name="adj" fmla="val 8000"/>
-            </a:avLst>
-          </a:prstGeom>
-          <a:solidFill>
-            <a:srgbClr val="162236"/>
-          </a:solidFill>
-          <a:ln w="15875">
-            <a:solidFill>
-              <a:srgbClr val="2A3B52"/>
-            </a:solidFill>
-          </a:ln>
-        </p:spPr>
-        <p:style>
-          <a:lnRef idx="1">
-            <a:schemeClr val="accent1"/>
-          </a:lnRef>
-          <a:fillRef idx="3">
-            <a:schemeClr val="accent1"/>
-          </a:fillRef>
-          <a:effectRef idx="2">
-            <a:schemeClr val="accent1"/>
-          </a:effectRef>
-          <a:fontRef idx="minor">
-            <a:schemeClr val="lt1"/>
-          </a:fontRef>
-        </p:style>
-        <p:txBody>
-          <a:bodyPr rtlCol="0" anchor="ctr" wrap="square" lIns="64008" rIns="64008"/>
-          <a:lstStyle/>
-          <a:p>
-            <a:pPr algn="ctr"/>
-            <a:r>
-              <a:rPr sz="1400" b="1">
-                <a:solidFill>
-                  <a:srgbClr val="31D3B1"/>
-                </a:solidFill>
-              </a:rPr>
-              <a:t>종료 조건</a:t>
-            </a:r>
-          </a:p>
-          <a:p>
-            <a:pPr algn="ctr"/>
-            <a:r>
-              <a:rPr sz="1300" b="0">
-                <a:solidFill>
-                  <a:srgbClr val="CFDEEB"/>
-                </a:solidFill>
-              </a:rPr>
-              <a:t>PASS · 최대 5회 · 세션 300초</a:t>
-            </a:r>
-          </a:p>
-          <a:p>
-            <a:pPr algn="ctr"/>
-            <a:r>
-              <a:rPr sz="1300" b="0">
-                <a:solidFill>
-                  <a:srgbClr val="CFDEEB"/>
-                </a:solidFill>
-              </a:rPr>
-              <a:t>Kiro 오류 · 보호 파일 변조</a:t>
-            </a:r>
-          </a:p>
-        </p:txBody>
-      </p:sp>
-      <p:sp>
-        <p:nvSpPr>
-          <p:cNvPr id="21" name="Rounded Rectangle 20"/>
-          <p:cNvSpPr/>
-          <p:nvPr/>
-        </p:nvSpPr>
-        <p:spPr>
-          <a:xfrm>
-            <a:off x="4434840" y="4709160"/>
-            <a:ext cx="3383280" cy="1005840"/>
-          </a:xfrm>
-          <a:prstGeom prst="roundRect">
-            <a:avLst>
-              <a:gd name="adj" fmla="val 8000"/>
-            </a:avLst>
-          </a:prstGeom>
-          <a:solidFill>
-            <a:srgbClr val="162236"/>
-          </a:solidFill>
-          <a:ln w="15875">
-            <a:solidFill>
-              <a:srgbClr val="2A3B52"/>
-            </a:solidFill>
-          </a:ln>
-        </p:spPr>
-        <p:style>
-          <a:lnRef idx="1">
-            <a:schemeClr val="accent1"/>
-          </a:lnRef>
-          <a:fillRef idx="3">
-            <a:schemeClr val="accent1"/>
-          </a:fillRef>
-          <a:effectRef idx="2">
-            <a:schemeClr val="accent1"/>
-          </a:effectRef>
-          <a:fontRef idx="minor">
-            <a:schemeClr val="lt1"/>
-          </a:fontRef>
-        </p:style>
-        <p:txBody>
-          <a:bodyPr rtlCol="0" anchor="ctr" wrap="square" lIns="64008" rIns="64008"/>
-          <a:lstStyle/>
-          <a:p>
-            <a:pPr algn="ctr"/>
-            <a:r>
-              <a:rPr sz="1400" b="1">
-                <a:solidFill>
-                  <a:srgbClr val="31D3B1"/>
-                </a:solidFill>
-              </a:rPr>
-              <a:t>기록 .loop/</a:t>
-            </a:r>
-          </a:p>
-          <a:p>
-            <a:pPr algn="ctr"/>
-            <a:r>
-              <a:rPr sz="1300" b="0">
-                <a:solidFill>
-                  <a:srgbClr val="CFDEEB"/>
-                </a:solidFill>
-              </a:rPr>
-              <a:t>회차별 결과 · Kiro 로그</a:t>
-            </a:r>
-          </a:p>
-          <a:p>
-            <a:pPr algn="ctr"/>
-            <a:r>
-              <a:rPr sz="1300" b="0">
-                <a:solidFill>
-                  <a:srgbClr val="CFDEEB"/>
-                </a:solidFill>
-              </a:rPr>
-              <a:t>코드 diff · summary.json</a:t>
-            </a:r>
-          </a:p>
-        </p:txBody>
-      </p:sp>
-      <p:sp>
-        <p:nvSpPr>
-          <p:cNvPr id="22" name="Rounded Rectangle 21"/>
-          <p:cNvSpPr/>
-          <p:nvPr/>
-        </p:nvSpPr>
-        <p:spPr>
-          <a:xfrm>
-            <a:off x="8001000" y="4709160"/>
-            <a:ext cx="3383280" cy="1005840"/>
-          </a:xfrm>
-          <a:prstGeom prst="roundRect">
-            <a:avLst>
-              <a:gd name="adj" fmla="val 8000"/>
-            </a:avLst>
-          </a:prstGeom>
-          <a:solidFill>
-            <a:srgbClr val="162236"/>
-          </a:solidFill>
-          <a:ln w="15875">
-            <a:solidFill>
-              <a:srgbClr val="2A3B52"/>
-            </a:solidFill>
-          </a:ln>
-        </p:spPr>
-        <p:style>
-          <a:lnRef idx="1">
-            <a:schemeClr val="accent1"/>
-          </a:lnRef>
-          <a:fillRef idx="3">
-            <a:schemeClr val="accent1"/>
-          </a:fillRef>
-          <a:effectRef idx="2">
-            <a:schemeClr val="accent1"/>
-          </a:effectRef>
-          <a:fontRef idx="minor">
-            <a:schemeClr val="lt1"/>
-          </a:fontRef>
-        </p:style>
-        <p:txBody>
-          <a:bodyPr rtlCol="0" anchor="ctr" wrap="square" lIns="64008" rIns="64008"/>
-          <a:lstStyle/>
-          <a:p>
-            <a:pPr algn="ctr"/>
-            <a:r>
-              <a:rPr sz="1400" b="1">
-                <a:solidFill>
-                  <a:srgbClr val="31D3B1"/>
-                </a:solidFill>
-              </a:rPr>
-              <a:t>기억</a:t>
-            </a:r>
-          </a:p>
-          <a:p>
-            <a:pPr algn="ctr"/>
-            <a:r>
-              <a:rPr sz="1300" b="0">
-                <a:solidFill>
-                  <a:srgbClr val="CFDEEB"/>
-                </a:solidFill>
-              </a:rPr>
-              <a:t>Kiro는 매번 새 세션(기억 없음)</a:t>
-            </a:r>
-          </a:p>
-          <a:p>
-            <a:pPr algn="ctr"/>
-            <a:r>
-              <a:rPr sz="1300" b="0">
-                <a:solidFill>
-                  <a:srgbClr val="CFDEEB"/>
-                </a:solidFill>
-              </a:rPr>
-              <a:t>다음 세션에 넘기는 실패 로그가 기억</a:t>
-            </a:r>
-          </a:p>
-        </p:txBody>
-      </p:sp>
-      <p:cxnSp>
-        <p:nvCxnSpPr>
-          <p:cNvPr id="23" name="Connector 22"/>
-          <p:cNvCxnSpPr/>
-          <p:nvPr/>
-        </p:nvCxnSpPr>
-        <p:spPr>
-          <a:xfrm>
-            <a:off x="3497580" y="2971800"/>
-            <a:ext cx="0" cy="914400"/>
-          </a:xfrm>
-          <a:prstGeom prst="line">
-            <a:avLst/>
-          </a:prstGeom>
-          <a:ln w="25400">
-            <a:solidFill>
-              <a:srgbClr val="7C5CFF"/>
-            </a:solidFill>
-            <a:prstDash val="dash"/>
-          </a:ln>
-        </p:spPr>
-        <p:style>
-          <a:lnRef idx="2">
-            <a:schemeClr val="accent1"/>
-          </a:lnRef>
-          <a:fillRef idx="0">
-            <a:schemeClr val="accent1"/>
-          </a:fillRef>
-          <a:effectRef idx="1">
-            <a:schemeClr val="accent1"/>
-          </a:effectRef>
-          <a:fontRef idx="minor">
-            <a:schemeClr val="tx1"/>
-          </a:fontRef>
-        </p:style>
-      </p:cxnSp>
-      <p:sp>
-        <p:nvSpPr>
-          <p:cNvPr id="24" name="TextBox 23"/>
-          <p:cNvSpPr txBox="1"/>
-          <p:nvPr/>
-        </p:nvSpPr>
-        <p:spPr>
-          <a:xfrm>
-            <a:off x="868680" y="329184"/>
-            <a:ext cx="10515600" cy="274320"/>
-          </a:xfrm>
-          <a:prstGeom prst="rect">
-            <a:avLst/>
-          </a:prstGeom>
-          <a:noFill/>
-        </p:spPr>
-        <p:txBody>
-          <a:bodyPr wrap="square">
-            <a:spAutoFit/>
-          </a:bodyPr>
-          <a:lstStyle/>
-          <a:p>
-            <a:r>
-              <a:rPr sz="1100" b="1">
-                <a:solidFill>
-                  <a:srgbClr val="31D3B1"/>
-                </a:solidFill>
-              </a:rPr>
-              <a:t>PART 3 · 데모: Kiro로 Goal Loop 만들기</a:t>
+              <a:t>AI Agent Loop · 2026.10.21                                     01 / 18</a:t>
             </a:r>
           </a:p>
         </p:txBody>
@@ -6381,7 +5177,7 @@
                   <a:srgbClr val="8397AB"/>
                 </a:solidFill>
               </a:rPr>
-              <a:t>AI Agent Loop · 2026.10.21                                     11 / 19</a:t>
+              <a:t>AI Agent Loop · 2026.10.21                                     10 / 18</a:t>
             </a:r>
           </a:p>
         </p:txBody>
@@ -6820,7 +5616,7 @@
                   <a:srgbClr val="8397AB"/>
                 </a:solidFill>
               </a:rPr>
-              <a:t>AI Agent Loop · 2026.10.21                                     12 / 19</a:t>
+              <a:t>AI Agent Loop · 2026.10.21                                     11 / 18</a:t>
             </a:r>
           </a:p>
         </p:txBody>
@@ -7209,7 +6005,7 @@
                   <a:srgbClr val="8397AB"/>
                 </a:solidFill>
               </a:rPr>
-              <a:t>AI Agent Loop · 2026.10.21                                     13 / 19</a:t>
+              <a:t>AI Agent Loop · 2026.10.21                                     12 / 18</a:t>
             </a:r>
           </a:p>
         </p:txBody>
@@ -7622,7 +6418,7 @@
                   <a:srgbClr val="8397AB"/>
                 </a:solidFill>
               </a:rPr>
-              <a:t>AI Agent Loop · 2026.10.21                                     14 / 19</a:t>
+              <a:t>AI Agent Loop · 2026.10.21                                     13 / 18</a:t>
             </a:r>
           </a:p>
         </p:txBody>
@@ -8093,7 +6889,7 @@
                   <a:srgbClr val="8397AB"/>
                 </a:solidFill>
               </a:rPr>
-              <a:t>AI Agent Loop · 2026.10.21                                     15 / 19</a:t>
+              <a:t>AI Agent Loop · 2026.10.21                                     14 / 18</a:t>
             </a:r>
           </a:p>
         </p:txBody>
@@ -8755,7 +7551,7 @@
                   <a:srgbClr val="8397AB"/>
                 </a:solidFill>
               </a:rPr>
-              <a:t>AI Agent Loop · 2026.10.21                                     16 / 19</a:t>
+              <a:t>AI Agent Loop · 2026.10.21                                     15 / 18</a:t>
             </a:r>
           </a:p>
         </p:txBody>
@@ -9006,7 +7802,7 @@
                   <a:srgbClr val="8397AB"/>
                 </a:solidFill>
               </a:rPr>
-              <a:t>AI Agent Loop · 2026.10.21                                     17 / 19</a:t>
+              <a:t>AI Agent Loop · 2026.10.21                                     16 / 18</a:t>
             </a:r>
           </a:p>
         </p:txBody>
@@ -9174,7 +7970,7 @@
                   <a:srgbClr val="8397AB"/>
                 </a:solidFill>
               </a:rPr>
-              <a:t>AI Agent Loop · 2026.10.21                                     18 / 19</a:t>
+              <a:t>AI Agent Loop · 2026.10.21                                     17 / 18</a:t>
             </a:r>
           </a:p>
         </p:txBody>
@@ -9742,7 +8538,7 @@
                   <a:srgbClr val="8397AB"/>
                 </a:solidFill>
               </a:rPr>
-              <a:t>AI Agent Loop · 2026.10.21                                     19 / 19</a:t>
+              <a:t>AI Agent Loop · 2026.10.21                                     18 / 18</a:t>
             </a:r>
           </a:p>
         </p:txBody>
@@ -10108,7 +8904,7 @@
                   <a:srgbClr val="8397AB"/>
                 </a:solidFill>
               </a:rPr>
-              <a:t>AI Agent Loop · 2026.10.21                                     02 / 19</a:t>
+              <a:t>AI Agent Loop · 2026.10.21                                     02 / 18</a:t>
             </a:r>
           </a:p>
         </p:txBody>
@@ -10652,7 +9448,7 @@
                   <a:srgbClr val="8397AB"/>
                 </a:solidFill>
               </a:rPr>
-              <a:t>AI Agent Loop · 2026.10.21                                     03 / 19</a:t>
+              <a:t>AI Agent Loop · 2026.10.21                                     03 / 18</a:t>
             </a:r>
           </a:p>
         </p:txBody>
@@ -11209,7 +10005,7 @@
                   <a:srgbClr val="8397AB"/>
                 </a:solidFill>
               </a:rPr>
-              <a:t>AI Agent Loop · 2026.10.21                                     04 / 19</a:t>
+              <a:t>AI Agent Loop · 2026.10.21                                     04 / 18</a:t>
             </a:r>
           </a:p>
         </p:txBody>
@@ -12120,7 +10916,7 @@
                   <a:srgbClr val="8397AB"/>
                 </a:solidFill>
               </a:rPr>
-              <a:t>AI Agent Loop · 2026.10.21                                     05 / 19</a:t>
+              <a:t>AI Agent Loop · 2026.10.21                                     05 / 18</a:t>
             </a:r>
           </a:p>
         </p:txBody>
@@ -13451,7 +12247,7 @@
                   <a:srgbClr val="8397AB"/>
                 </a:solidFill>
               </a:rPr>
-              <a:t>AI Agent Loop · 2026.10.21                                     06 / 19</a:t>
+              <a:t>AI Agent Loop · 2026.10.21                                     06 / 18</a:t>
             </a:r>
           </a:p>
         </p:txBody>
@@ -14373,7 +13169,7 @@
                   <a:srgbClr val="8397AB"/>
                 </a:solidFill>
               </a:rPr>
-              <a:t>AI Agent Loop · 2026.10.21                                     07 / 19</a:t>
+              <a:t>AI Agent Loop · 2026.10.21                                     07 / 18</a:t>
             </a:r>
           </a:p>
         </p:txBody>
@@ -14948,7 +13744,7 @@
                   <a:srgbClr val="8397AB"/>
                 </a:solidFill>
               </a:rPr>
-              <a:t>AI Agent Loop · 2026.10.21                                     08 / 19</a:t>
+              <a:t>AI Agent Loop · 2026.10.21                                     08 / 18</a:t>
             </a:r>
           </a:p>
         </p:txBody>
@@ -16262,7 +15058,7 @@
                   <a:srgbClr val="8397AB"/>
                 </a:solidFill>
               </a:rPr>
-              <a:t>AI Agent Loop · 2026.10.21                                     09 / 19</a:t>
+              <a:t>AI Agent Loop · 2026.10.21                                     09 / 18</a:t>
             </a:r>
           </a:p>
         </p:txBody>

</xml_diff>

<commit_message>
Deck: cite Kyle Mistele's actual migration case on Demo 2; swyx pronunciation note
</commit_message>
<xml_diff>
--- a/docs/AI_Agent_Loop.pptx
+++ b/docs/AI_Agent_Loop.pptx
@@ -1803,6 +1803,47 @@
               <a:t>A. 맞습니다. 다른 점은 '얼마나 남았는지'를 숫자로 재는 센서가 하나 더 있다는 겁니다. 다음 장에서 보겠습니다.</a:t>
             </a:r>
           </a:p>
+          <a:p/>
+          <a:p>
+            <a:r>
+              <a:t>[배경: 이 데모의 원본 사례 — Kyle Mistele, AIEWF 2026 "Loop Engineering from First Principles"]</a:t>
+            </a:r>
+          </a:p>
+          <a:p>
+            <a:r>
+              <a:t>- Kyle이 실제로 보여준 예는 TypeScript 코드베이스의 RPC 프로시저를 Effect 라이브러리로 하나씩 옮기는 점진 마이그레이션이다.</a:t>
+            </a:r>
+          </a:p>
+          <a:p>
+            <a:r>
+              <a:t>- 센서: "아직 안 옮긴 프로시저를 찾는 간단한 규칙"(발표 10:05 부근). 우리 데모의 measure.py가 같은 역할.</a:t>
+            </a:r>
+          </a:p>
+          <a:p>
+            <a:r>
+              <a:t>- 실행기: 에이전트가 한 번에 하나씩, 저장소 안의 기존 패턴을 따라 옮긴다(12:26 "Give the actuator local patterns to follow").</a:t>
+            </a:r>
+          </a:p>
+          <a:p>
+            <a:r>
+              <a:t>- 검증: 새 인프라 대신 기존 CI를 쓴다(13:22). 우리 데모의 verify.py.</a:t>
+            </a:r>
+          </a:p>
+          <a:p>
+            <a:r>
+              <a:t>- 그가 강조한 점: 작고 쓸모 있는 변경을 고를 것(11:21), 리뷰 코멘트를 다음 루프의 지시로 남길 것(14:13), 사람의 리뷰가 막히면 변경 생산을 멈출 것(15:10), 신뢰와 리뷰 여력이 늘면 처리량을 올릴 것(16:17).</a:t>
+            </a:r>
+          </a:p>
+          <a:p>
+            <a:r>
+              <a:t>- 차이: Kyle은 PR 단위로 사람이 리뷰한다. 우리 데모는 리뷰 대신 테스트 + 센서로 반영 여부를 자동 판정하고, 2번 실패하면 사람에게 넘기는 것으로 축소했다.</a:t>
+            </a:r>
+          </a:p>
+          <a:p>
+            <a:r>
+              <a:t>- 참고: swyx의 예시가 아니다. swyx는 루프의 층(토큰 → … → 소프트웨어 팩토리)을 이야기했고, 이 데모는 그중 Goal 층에 해당한다.</a:t>
+            </a:r>
+          </a:p>
         </p:txBody>
       </p:sp>
       <p:sp>
@@ -2220,7 +2261,7 @@
           <a:lstStyle/>
           <a:p>
             <a:r>
-              <a:t>swyx 오프닝 키노트 "The Highest Loop". AI 작업 단위가 토큰 → 채팅 → 도구 호출 → 목표 → 자동화(cron) → 소프트웨어 팩토리로 넓어지고, 이를 loop stacking이라 부른다(“while 루프의 스택”). 가로축은 AI에게 한 번에 맡기는 작업 단위, 세로축은 추상화 수준. 핵심은 무조건 높이 쌓는 것이 아니다. "지금 어느 루프에서 일하고 있나?"를 알고, 목적에 맞는 층을 고르는 것이 AI 엔지니어링 역량이다. 생산성·규모가 필요하고 준비됐으면 한 층 위로, 무언가 깨지면 한 층 아래로 내려가 신뢰성을 잡는다. 오늘 데모는 Goal 층: 테스트 통과라는 목표가 달성될 때까지 반복한다. (축 표현은 발표 내용을 시각화하기 위한 해석이며 원본 슬라이드에 있는 그림은 아니다.)</a:t>
+              <a:t>swyx 오프닝 키노트 "The Highest Loop". AI 작업 단위가 토큰 → 채팅 → 도구 호출 → 목표 → 자동화(cron) → 소프트웨어 팩토리로 넓어지고, 이를 loop stacking이라 부른다(“while 루프의 스택”). 가로축은 AI에게 한 번에 맡기는 작업 단위, 세로축은 추상화 수준. 핵심은 무조건 높이 쌓는 것이 아니다. "지금 어느 루프에서 일하고 있나?"를 알고, 목적에 맞는 층을 고르는 것이 AI 엔지니어링 역량이다. 생산성·규모가 필요하고 준비됐으면 한 층 위로, 무언가 깨지면 한 층 아래로 내려가 신뢰성을 잡는다. 오늘 데모는 Goal 층: 테스트 통과라는 목표가 달성될 때까지 반복한다. (축 표현은 발표 내용을 시각화하기 위한 해석이며 원본 슬라이드에 있는 그림은 아니다.) (발음: swyx = "스윅스". 본명 Shawn Wang, AI Engineer 행사 공동 창립자.)</a:t>
             </a:r>
           </a:p>
         </p:txBody>
@@ -7849,7 +7890,7 @@
                   <a:srgbClr val="8397AB"/>
                 </a:solidFill>
               </a:rPr>
-              <a:t>구성: Kyle Mistele 발표의 점진적 마이그레이션 루프를 작게 재현 (발표자 구성)</a:t>
+              <a:t>구성: Kyle Mistele의 실제 사례(TypeScript RPC → Effect 점진 마이그레이션)를 Java 날짜 API로 작게 재현 (발표자 구성)</a:t>
             </a:r>
           </a:p>
         </p:txBody>

</xml_diff>

<commit_message>
Unify wording to '옛 날짜 API'; explain why java.time (not removal) on slide 14
</commit_message>
<xml_diff>
--- a/docs/AI_Agent_Loop.pptx
+++ b/docs/AI_Agent_Loop.pptx
@@ -1396,12 +1396,12 @@
           <a:p/>
           <a:p>
             <a:r>
-              <a:t>(왼쪽부터) 목표값은 낡은 API를 쓰는 파일 0개, 그리고 테스트 PASS입니다.</a:t>
-            </a:r>
-          </a:p>
-          <a:p>
-            <a:r>
-              <a:t>센서는 두 개입니다. measure.py가 낡은 API를 쓰는 파일이 몇 개 남았는지 세고, verify.py가 동작 테스트 28개를 돌립니다.</a:t>
+              <a:t>(왼쪽부터) 목표값은 옛 날짜 API를 쓰는 파일 0개, 그리고 테스트 PASS입니다.</a:t>
+            </a:r>
+          </a:p>
+          <a:p>
+            <a:r>
+              <a:t>센서는 두 개입니다. measure.py가 옛 날짜 API를 쓰는 파일이 몇 개 남았는지 세고, verify.py가 동작 테스트 28개를 돌립니다.</a:t>
             </a:r>
           </a:p>
           <a:p>
@@ -1417,7 +1417,7 @@
           <a:p/>
           <a:p>
             <a:r>
-              <a:t>(하단 규칙) 테스트가 통과하고 그 파일에 낡은 API가 없으면 반영합니다. 아니면 되돌리고, 실패 내용을 들고 같은 파일을 새 세션으로 다시 시킵니다. 두 번 실패하면 억지로 밀어붙이지 않고 사람에게 넘깁니다.</a:t>
+              <a:t>(하단 규칙) 테스트가 통과하고 그 파일에 옛 날짜 API가 없으면 반영합니다. 아니면 되돌리고, 실패 내용을 들고 같은 파일을 새 세션으로 다시 시킵니다. 두 번 실패하면 억지로 밀어붙이지 않고 사람에게 넘깁니다.</a:t>
             </a:r>
           </a:p>
           <a:p/>
@@ -1511,13 +1511,13 @@
           <a:p/>
           <a:p>
             <a:r>
-              <a:t>(큰 숫자) 낡은 API를 쓰는 파일이 6개에서 시작해서, loop 한 번마다 하나씩 줄어 0이 됐습니다. Kiro 세션 6개, 약 2분 반 걸렸고, 끝나고 나서 테스트 28개가 모두 통과했습니다.</a:t>
+              <a:t>(큰 숫자) 옛 날짜 API를 쓰는 파일이 6개에서 시작해서, loop 한 번마다 하나씩 줄어 0이 됐습니다. Kiro 세션 6개, 약 2분 반 걸렸고, 끝나고 나서 테스트 28개가 모두 통과했습니다.</a:t>
             </a:r>
           </a:p>
           <a:p/>
           <a:p>
             <a:r>
-              <a:t>(터미널) loop마다 같은 패턴입니다. 새 Kiro 세션을 열고, Kiro가 끝나면 컨트롤러가 Kiro 말을 믿지 않고 직접 잽니다. 테스트 PASS, 그 파일에서 낡은 API 사라짐, 그래서 반영. 6에서 5로.</a:t>
+              <a:t>(터미널) loop마다 같은 패턴입니다. 새 Kiro 세션을 열고, Kiro가 끝나면 컨트롤러가 Kiro 말을 믿지 않고 직접 잽니다. 테스트 PASS, 그 파일에서 옛 날짜 API 사라짐, 그래서 반영. 6에서 5로.</a:t>
             </a:r>
           </a:p>
           <a:p/>
@@ -1772,7 +1772,7 @@
           <a:p/>
           <a:p>
             <a:r>
-              <a:t>(왼쪽) 과제는 마이그레이션입니다. Java 클래스 6개가 오래된 날짜 API, Date나 Calendar, SimpleDateFormat을 쓰고 있는데, 이걸 java.time으로 옮기는 겁니다. 조건은 하나, 동작이 하나도 바뀌면 안 됩니다. 그리고 규칙은 loop 한 번에 파일 하나만입니다. Kyle Mistele가 발표에서 말한 '작게 고치고 다시 잰다'를 그대로 적용한 겁니다.</a:t>
+              <a:t>(왼쪽) 과제는 마이그레이션입니다. Java 클래스 6개가 옛 날짜 API, Date나 Calendar, SimpleDateFormat을 쓰고 있는데, 이걸 Java 8부터 표준이 된 java.time으로 옮기는 겁니다. 옛 API는 삭제 예정은 아니지만, SimpleDateFormat은 여러 스레드에서 같이 쓰면 깨지고 Date는 값이 바뀔 수 있어서 실수가 잦습니다. 그래서 많은 팀이 교체합니다. 조건은 하나, 동작이 하나도 바뀌면 안 됩니다. 그리고 규칙은 loop 한 번에 파일 하나만입니다. Kyle Mistele가 발표에서 말한 '작게 고치고 다시 잰다'를 그대로 적용한 겁니다.</a:t>
             </a:r>
           </a:p>
           <a:p/>
@@ -1842,6 +1842,17 @@
           <a:p>
             <a:r>
               <a:t>- 참고: swyx의 예시가 아니다. swyx는 루프의 층(토큰 → … → 소프트웨어 팩토리)을 이야기했고, 이 데모는 그중 Goal 층에 해당한다.</a:t>
+            </a:r>
+          </a:p>
+          <a:p/>
+          <a:p>
+            <a:r>
+              <a:t>Q. 옛 날짜 API는 곧 삭제되나요?</a:t>
+            </a:r>
+          </a:p>
+          <a:p>
+            <a:r>
+              <a:t>A. 아니요. 지금도 쓸 수 있고 일부 오래된 메서드만 deprecated입니다. 삭제가 아니라 더 안전한 표준(java.time)으로 바꾸는 작업입니다. 테스트도 지우지 않고, 오히려 테스트가 동작이 안 바뀌었는지 지켜봅니다.</a:t>
             </a:r>
           </a:p>
         </p:txBody>
@@ -7419,7 +7430,22 @@
                   <a:srgbClr val="F5F8FD"/>
                 </a:solidFill>
               </a:rPr>
-              <a:t>Java 클래스 6개가 쓰는 낡은 날짜 API(Date · Calendar · SimpleDateFormat)를 java.time으로 옮긴다</a:t>
+              <a:t>Java 클래스 6개가 쓰는 옛 날짜 API(Date · Calendar · SimpleDateFormat)를 새 표준 java.time으로 바꾼다</a:t>
+            </a:r>
+          </a:p>
+          <a:p>
+            <a:pPr algn="l">
+              <a:spcAft>
+                <a:spcPts val="800"/>
+              </a:spcAft>
+            </a:pPr>
+            <a:r>
+              <a:rPr sz="1200" b="0">
+                <a:solidFill>
+                  <a:srgbClr val="8397AB"/>
+                </a:solidFill>
+              </a:rPr>
+              <a:t>왜? Java 8(2014)부터 java.time이 표준. 옛 API는 스레드에 안전하지 않고 값이 바뀌는 등 실수가 잦다 (삭제 예정은 아님)</a:t>
             </a:r>
           </a:p>
           <a:p>
@@ -8419,7 +8445,7 @@
                   <a:srgbClr val="CFDEEB"/>
                 </a:solidFill>
               </a:rPr>
-              <a:t>Java 날짜 코드</a:t>
+              <a:t>옛 날짜 API 사용 중</a:t>
             </a:r>
           </a:p>
         </p:txBody>
@@ -9070,7 +9096,7 @@
                   <a:srgbClr val="CFDEEB"/>
                 </a:solidFill>
               </a:rPr>
-              <a:t>loop 1회 = 파일 하나:   테스트 PASS + 낡은 API 없음 → 반영   ·   아니면 되돌리고 실패 내용으로 재시도   ·   2번 실패 → 사람에게</a:t>
+              <a:t>loop 1회 = 파일 하나:   테스트 PASS + 옛 날짜 API 없음 → 반영   ·   아니면 되돌리고 실패 내용으로 재시도   ·   2번 실패 → 사람에게</a:t>
             </a:r>
           </a:p>
         </p:txBody>

</xml_diff>

<commit_message>
Wording: 'java.time으로 바꾼다' instead of '옮긴다' (code change, not file move)
</commit_message>
<xml_diff>
--- a/docs/AI_Agent_Loop.pptx
+++ b/docs/AI_Agent_Loop.pptx
@@ -1406,7 +1406,7 @@
           </a:p>
           <a:p>
             <a:r>
-              <a:t>남은 게 있으면 컨트롤러 migrate_loop.py가 파일 하나를 고르고, 새 Kiro 세션에 '이 파일 하나만 옮겨라'라고 지시합니다.</a:t>
+              <a:t>남은 게 있으면 컨트롤러 migrate_loop.py가 파일 하나를 고르고, 새 Kiro 세션에 '이 파일의 날짜 코드만 java.time으로 바꿔라'라고 지시합니다.</a:t>
             </a:r>
           </a:p>
           <a:p>
@@ -1772,7 +1772,7 @@
           <a:p/>
           <a:p>
             <a:r>
-              <a:t>(왼쪽) 과제는 마이그레이션입니다. Java 클래스 6개가 옛 날짜 API, Date나 Calendar, SimpleDateFormat을 쓰고 있는데, 이걸 Java 8부터 표준이 된 java.time으로 옮기는 겁니다. 옛 API는 삭제 예정은 아니지만, SimpleDateFormat은 여러 스레드에서 같이 쓰면 깨지고 Date는 값이 바뀔 수 있어서 실수가 잦습니다. 그래서 많은 팀이 교체합니다. 조건은 하나, 동작이 하나도 바뀌면 안 됩니다. 그리고 규칙은 loop 한 번에 파일 하나만입니다. Kyle Mistele가 발표에서 말한 '작게 고치고 다시 잰다'를 그대로 적용한 겁니다.</a:t>
+              <a:t>(왼쪽) 과제는 마이그레이션입니다. Java 클래스 6개가 옛 날짜 API, Date나 Calendar, SimpleDateFormat을 쓰고 있는데, 이걸 Java 8부터 표준이 된 java.time으로 바꾸는 겁니다. 파일을 옮기는 게 아니라 파일 안의 코드를 바꾸는 거예요. 옛 API는 삭제 예정은 아니지만, SimpleDateFormat은 여러 스레드에서 같이 쓰면 깨지고 Date는 값이 바뀔 수 있어서 실수가 잦습니다. 그래서 많은 팀이 교체합니다. 조건은 하나, 동작이 하나도 바뀌면 안 됩니다. 그리고 규칙은 loop 한 번에 파일 하나만입니다. Kyle Mistele가 발표에서 말한 '작게 고치고 다시 잰다'를 그대로 적용한 겁니다.</a:t>
             </a:r>
           </a:p>
           <a:p/>
@@ -1811,17 +1811,17 @@
           </a:p>
           <a:p>
             <a:r>
-              <a:t>- Kyle이 실제로 보여준 예는 TypeScript 코드베이스의 RPC 프로시저를 Effect 라이브러리로 하나씩 옮기는 점진 마이그레이션이다.</a:t>
-            </a:r>
-          </a:p>
-          <a:p>
-            <a:r>
-              <a:t>- 센서: "아직 안 옮긴 프로시저를 찾는 간단한 규칙"(발표 10:05 부근). 우리 데모의 measure.py가 같은 역할.</a:t>
-            </a:r>
-          </a:p>
-          <a:p>
-            <a:r>
-              <a:t>- 실행기: 에이전트가 한 번에 하나씩, 저장소 안의 기존 패턴을 따라 옮긴다(12:26 "Give the actuator local patterns to follow").</a:t>
+              <a:t>- Kyle이 실제로 보여준 예는 TypeScript 코드베이스의 RPC 프로시저를 Effect 라이브러리 방식으로 하나씩 바꾸는 점진 마이그레이션이다.</a:t>
+            </a:r>
+          </a:p>
+          <a:p>
+            <a:r>
+              <a:t>- 센서: "아직 안 바꾼 프로시저를 찾는 간단한 규칙"(발표 10:05 부근). 우리 데모의 measure.py가 같은 역할.</a:t>
+            </a:r>
+          </a:p>
+          <a:p>
+            <a:r>
+              <a:t>- 실행기: 에이전트가 한 번에 하나씩, 저장소 안의 기존 패턴을 따라 바꾼다(12:26 "Give the actuator local patterns to follow").</a:t>
             </a:r>
           </a:p>
           <a:p>
@@ -8368,7 +8368,7 @@
                   <a:srgbClr val="CFDEEB"/>
                 </a:solidFill>
               </a:rPr>
-              <a:t>파일 하나만 이전 (새 세션)</a:t>
+              <a:t>파일 하나씩 코드 교체 (새 세션)</a:t>
             </a:r>
           </a:p>
         </p:txBody>

</xml_diff>

<commit_message>
Slides 5-7: add guiding questions to PART 2 kicker
</commit_message>
<xml_diff>
--- a/docs/AI_Agent_Loop.pptx
+++ b/docs/AI_Agent_Loop.pptx
@@ -15086,7 +15086,7 @@
                   <a:srgbClr val="31D3B1"/>
                 </a:solidFill>
               </a:rPr>
-              <a:t>PART 2 · Loop는 어떻게 생겼나</a:t>
+              <a:t>PART 2 · Loop는 어떻게 생겼나 — ① 루프는 무엇으로 이루어지나?</a:t>
             </a:r>
           </a:p>
         </p:txBody>
@@ -16046,7 +16046,7 @@
                   <a:srgbClr val="31D3B1"/>
                 </a:solidFill>
               </a:rPr>
-              <a:t>PART 2 · Loop는 어떻게 생겼나</a:t>
+              <a:t>PART 2 · Loop는 어떻게 생겼나 — ② 그 부품을 누가 맡나?</a:t>
             </a:r>
           </a:p>
         </p:txBody>
@@ -16654,7 +16654,7 @@
                   <a:srgbClr val="31D3B1"/>
                 </a:solidFill>
               </a:rPr>
-              <a:t>PART 2 · Loop는 어떻게 생겼나</a:t>
+              <a:t>PART 2 · Loop는 어떻게 생겼나 — ③ 왜 떼어 놓아야 하나?</a:t>
             </a:r>
           </a:p>
         </p:txBody>

</xml_diff>